<commit_message>
Apply QA fixes: Wave 3 title contrast, outlet table margins
</commit_message>
<xml_diff>
--- a/eTeacher_Longevity_PR_Campaign.pptx
+++ b/eTeacher_Longevity_PR_Campaign.pptx
@@ -9501,7 +9501,7 @@
             <a:r>
               <a:rPr lang="en-US" sz="1500" b="1" dirty="0">
                 <a:solidFill>
-                  <a:srgbClr val="C08A2E"/>
+                  <a:srgbClr val="8A5A0F"/>
                 </a:solidFill>
                 <a:latin typeface="Georgia" pitchFamily="34" charset="0"/>
                 <a:ea typeface="Georgia" pitchFamily="34" charset="-122"/>
@@ -13796,18 +13796,18 @@
         </p:nvGraphicFramePr>
         <p:xfrm>
           <a:off x="640080" y="1600200"/>
-          <a:ext cx="11338560" cy="914400"/>
+          <a:ext cx="10908792" cy="914400"/>
         </p:xfrm>
         <a:graphic>
           <a:graphicData uri="http://schemas.openxmlformats.org/drawingml/2006/table">
             <a:tbl>
               <a:tblPr/>
               <a:tblGrid>
-                <a:gridCol w="3108960"/>
-                <a:gridCol w="2286000"/>
-                <a:gridCol w="2743200"/>
-                <a:gridCol w="1737360"/>
-                <a:gridCol w="1463040"/>
+                <a:gridCol w="2971800"/>
+                <a:gridCol w="2194560"/>
+                <a:gridCol w="2651760"/>
+                <a:gridCol w="1645920"/>
+                <a:gridCol w="1444752"/>
               </a:tblGrid>
               <a:tr h="411480">
                 <a:tc>

</xml_diff>

<commit_message>
Audit fixes: past-tense ranking throughout, Cambria heading font, press-trail chrono order, slide-7 eyebrow, slide-12 headline, slide-30 sign-off note
</commit_message>
<xml_diff>
--- a/eTeacher_Longevity_PR_Campaign.pptx
+++ b/eTeacher_Longevity_PR_Campaign.pptx
@@ -3547,9 +3547,9 @@
                 <a:solidFill>
                   <a:srgbClr val="FFFFFF"/>
                 </a:solidFill>
-                <a:latin typeface="Georgia" pitchFamily="34" charset="0"/>
-                <a:ea typeface="Georgia" pitchFamily="34" charset="-122"/>
-                <a:cs typeface="Georgia" pitchFamily="34" charset="-120"/>
+                <a:latin typeface="Cambria" pitchFamily="34" charset="0"/>
+                <a:ea typeface="Cambria" pitchFamily="34" charset="-122"/>
+                <a:cs typeface="Cambria" pitchFamily="34" charset="-120"/>
               </a:rPr>
               <a:t>The Longevity Communications Campaign</a:t>
             </a:r>
@@ -3861,9 +3861,9 @@
                 <a:solidFill>
                   <a:srgbClr val="0C2A43"/>
                 </a:solidFill>
-                <a:latin typeface="Georgia" pitchFamily="34" charset="0"/>
-                <a:ea typeface="Georgia" pitchFamily="34" charset="-122"/>
-                <a:cs typeface="Georgia" pitchFamily="34" charset="-120"/>
+                <a:latin typeface="Cambria" pitchFamily="34" charset="0"/>
+                <a:ea typeface="Cambria" pitchFamily="34" charset="-122"/>
+                <a:cs typeface="Cambria" pitchFamily="34" charset="-120"/>
               </a:rPr>
               <a:t>Longevity for Every Household: A Live Class, Small Groups, and a Glucose Monitor at Your Door</a:t>
             </a:r>
@@ -4431,9 +4431,9 @@
                 <a:solidFill>
                   <a:srgbClr val="FFFFFF"/>
                 </a:solidFill>
-                <a:latin typeface="Georgia" pitchFamily="34" charset="0"/>
-                <a:ea typeface="Georgia" pitchFamily="34" charset="-122"/>
-                <a:cs typeface="Georgia" pitchFamily="34" charset="-120"/>
+                <a:latin typeface="Cambria" pitchFamily="34" charset="0"/>
+                <a:ea typeface="Cambria" pitchFamily="34" charset="-122"/>
+                <a:cs typeface="Cambria" pitchFamily="34" charset="-120"/>
               </a:rPr>
               <a:t>Julie Gibson Clark Joins Longevity Life Academy</a:t>
             </a:r>
@@ -4640,7 +4640,7 @@
                 <a:ea typeface="Calibri" pitchFamily="34" charset="-122"/>
                 <a:cs typeface="Calibri" pitchFamily="34" charset="-120"/>
               </a:rPr>
-              <a:t>THE SIGNING ANNOUNCEMENT — WORLD'S #2 JOINS THE FACULTY</a:t>
+              <a:t>THE SIGNING ANNOUNCEMENT — THE WOMAN WHO OUT-AGED BRYAN JOHNSON JOINS THE FACULTY</a:t>
             </a:r>
             <a:endParaRPr lang="en-US" sz="1050" dirty="0"/>
           </a:p>
@@ -4731,11 +4731,11 @@
                 <a:solidFill>
                   <a:srgbClr val="0C2A43"/>
                 </a:solidFill>
-                <a:latin typeface="Georgia" pitchFamily="34" charset="0"/>
-                <a:ea typeface="Georgia" pitchFamily="34" charset="-122"/>
-                <a:cs typeface="Georgia" pitchFamily="34" charset="-120"/>
-              </a:rPr>
-              <a:t>World's #2-Ranked Longevity Figure Julie Gibson Clark Joins eTeacher's Longevity Life Academy Faculty</a:t>
+                <a:latin typeface="Cambria" pitchFamily="34" charset="0"/>
+                <a:ea typeface="Cambria" pitchFamily="34" charset="-122"/>
+                <a:cs typeface="Cambria" pitchFamily="34" charset="-120"/>
+              </a:rPr>
+              <a:t>Julie Gibson Clark — Who Out-Aged Bryan Johnson at the Rejuvenation Olympics — Joins eTeacher's Longevity Life Academy Faculty</a:t>
             </a:r>
             <a:endParaRPr lang="en-US" sz="2200" dirty="0"/>
           </a:p>
@@ -4866,7 +4866,7 @@
                 <a:ea typeface="Calibri" pitchFamily="34" charset="-122"/>
                 <a:cs typeface="Calibri" pitchFamily="34" charset="-120"/>
               </a:rPr>
-              <a:t>Her results are the headline. Gibson Clark, 56, a corporate recruiter and former structural engineer, posts a DunedinPACE score of 0.665 — meaning she ages roughly 65 days for every 100, about 34% slower than average — achieved on a routine costing around $100–150 a month, versus the roughly $2 million a year spent by the best-funded biohackers.
+              <a:t>Her results are the headline. Gibson Clark, 56, a corporate recruiter and former structural engineer, recorded a DunedinPACE score of 0.665 — meaning she ages roughly 65 days for every 100, about 34% slower than average — achieved on a routine costing around $100–150 a month, versus the roughly $2 million a year spent by the best-funded biohackers.
 </a:t>
             </a:r>
             <a:pPr indent="0" marL="0">
@@ -5518,9 +5518,9 @@
                 <a:solidFill>
                   <a:srgbClr val="0C2A43"/>
                 </a:solidFill>
-                <a:latin typeface="Georgia" pitchFamily="34" charset="0"/>
-                <a:ea typeface="Georgia" pitchFamily="34" charset="-122"/>
-                <a:cs typeface="Georgia" pitchFamily="34" charset="-120"/>
+                <a:latin typeface="Cambria" pitchFamily="34" charset="0"/>
+                <a:ea typeface="Cambria" pitchFamily="34" charset="-122"/>
+                <a:cs typeface="Cambria" pitchFamily="34" charset="-120"/>
               </a:rPr>
               <a:t>She Out-Aged a Man Spending $2 Million a Year — on About $12 a Day</a:t>
             </a:r>
@@ -6305,9 +6305,9 @@
                 <a:solidFill>
                   <a:srgbClr val="0C2A43"/>
                 </a:solidFill>
-                <a:latin typeface="Georgia" pitchFamily="34" charset="0"/>
-                <a:ea typeface="Georgia" pitchFamily="34" charset="-122"/>
-                <a:cs typeface="Georgia" pitchFamily="34" charset="-120"/>
+                <a:latin typeface="Cambria" pitchFamily="34" charset="0"/>
+                <a:ea typeface="Cambria" pitchFamily="34" charset="-122"/>
+                <a:cs typeface="Cambria" pitchFamily="34" charset="-120"/>
               </a:rPr>
               <a:t>“My Why Is My Son”: The Mom Who Slowed Her Aging Is Now Teaching America</a:t>
             </a:r>
@@ -7092,9 +7092,9 @@
                 <a:solidFill>
                   <a:srgbClr val="0C2A43"/>
                 </a:solidFill>
-                <a:latin typeface="Georgia" pitchFamily="34" charset="0"/>
-                <a:ea typeface="Georgia" pitchFamily="34" charset="-122"/>
-                <a:cs typeface="Georgia" pitchFamily="34" charset="-120"/>
+                <a:latin typeface="Cambria" pitchFamily="34" charset="0"/>
+                <a:ea typeface="Cambria" pitchFamily="34" charset="-122"/>
+                <a:cs typeface="Cambria" pitchFamily="34" charset="-120"/>
               </a:rPr>
               <a:t>What a 0.665 DunedinPACE Score Actually Proves — and Why Julie Gibson Clark Is Teaching It</a:t>
             </a:r>
@@ -7717,9 +7717,9 @@
                 <a:solidFill>
                   <a:srgbClr val="0C2A43"/>
                 </a:solidFill>
-                <a:latin typeface="Georgia" pitchFamily="34" charset="0"/>
-                <a:ea typeface="Georgia" pitchFamily="34" charset="-122"/>
-                <a:cs typeface="Georgia" pitchFamily="34" charset="-120"/>
+                <a:latin typeface="Cambria" pitchFamily="34" charset="0"/>
+                <a:ea typeface="Cambria" pitchFamily="34" charset="-122"/>
+                <a:cs typeface="Cambria" pitchFamily="34" charset="-120"/>
               </a:rPr>
               <a:t>Longevity Has a Class Problem. This Partnership Is Built to Fix It.</a:t>
             </a:r>
@@ -8504,9 +8504,9 @@
                 <a:solidFill>
                   <a:srgbClr val="0C2A43"/>
                 </a:solidFill>
-                <a:latin typeface="Georgia" pitchFamily="34" charset="0"/>
-                <a:ea typeface="Georgia" pitchFamily="34" charset="-122"/>
-                <a:cs typeface="Georgia" pitchFamily="34" charset="-120"/>
+                <a:latin typeface="Cambria" pitchFamily="34" charset="0"/>
+                <a:ea typeface="Cambria" pitchFamily="34" charset="-122"/>
+                <a:cs typeface="Cambria" pitchFamily="34" charset="-120"/>
               </a:rPr>
               <a:t>One Habit at a Time: What Julie Gibson Clark Will Teach Inside the Longevity Blueprint</a:t>
             </a:r>
@@ -8550,7 +8550,7 @@
                 <a:ea typeface="Calibri" pitchFamily="34" charset="-122"/>
                 <a:cs typeface="Calibri" pitchFamily="34" charset="-120"/>
               </a:rPr>
-              <a:t>The world's #2-ranked longevity figure joins Longevity Life Academy to teach strength, protein, and sleep as the trainable foundations of a longer life.</a:t>
+              <a:t>The recruiter who held the Rejuvenation Olympics #2 spot for over a year joins Longevity Life Academy to teach strength, protein, and sleep as the trainable foundations of a longer life.</a:t>
             </a:r>
             <a:endParaRPr lang="en-US" sz="1250" dirty="0"/>
           </a:p>
@@ -9129,9 +9129,9 @@
                 <a:solidFill>
                   <a:srgbClr val="0C2A43"/>
                 </a:solidFill>
-                <a:latin typeface="Georgia" pitchFamily="34" charset="0"/>
-                <a:ea typeface="Georgia" pitchFamily="34" charset="-122"/>
-                <a:cs typeface="Georgia" pitchFamily="34" charset="-120"/>
+                <a:latin typeface="Cambria" pitchFamily="34" charset="0"/>
+                <a:ea typeface="Cambria" pitchFamily="34" charset="-122"/>
+                <a:cs typeface="Cambria" pitchFamily="34" charset="-120"/>
               </a:rPr>
               <a:t>Meet the Single Mom Teaching America How to Age Slower — Live, Every Week</a:t>
             </a:r>
@@ -9704,9 +9704,9 @@
                 <a:solidFill>
                   <a:srgbClr val="FFFFFF"/>
                 </a:solidFill>
-                <a:latin typeface="Georgia" pitchFamily="34" charset="0"/>
-                <a:ea typeface="Georgia" pitchFamily="34" charset="-122"/>
-                <a:cs typeface="Georgia" pitchFamily="34" charset="-120"/>
+                <a:latin typeface="Cambria" pitchFamily="34" charset="0"/>
+                <a:ea typeface="Cambria" pitchFamily="34" charset="-122"/>
+                <a:cs typeface="Cambria" pitchFamily="34" charset="-120"/>
               </a:rPr>
               <a:t>The Longevity Hub App (Roadmap)</a:t>
             </a:r>
@@ -9937,9 +9937,9 @@
                 <a:solidFill>
                   <a:srgbClr val="0C2A43"/>
                 </a:solidFill>
-                <a:latin typeface="Georgia" pitchFamily="34" charset="0"/>
-                <a:ea typeface="Georgia" pitchFamily="34" charset="-122"/>
-                <a:cs typeface="Georgia" pitchFamily="34" charset="-120"/>
+                <a:latin typeface="Cambria" pitchFamily="34" charset="0"/>
+                <a:ea typeface="Cambria" pitchFamily="34" charset="-122"/>
+                <a:cs typeface="Cambria" pitchFamily="34" charset="-120"/>
               </a:rPr>
               <a:t>Why we release in waves, not all at once</a:t>
             </a:r>
@@ -10106,9 +10106,9 @@
                 <a:solidFill>
                   <a:srgbClr val="0C2A43"/>
                 </a:solidFill>
-                <a:latin typeface="Georgia" pitchFamily="34" charset="0"/>
-                <a:ea typeface="Georgia" pitchFamily="34" charset="-122"/>
-                <a:cs typeface="Georgia" pitchFamily="34" charset="-120"/>
+                <a:latin typeface="Cambria" pitchFamily="34" charset="0"/>
+                <a:ea typeface="Cambria" pitchFamily="34" charset="-122"/>
+                <a:cs typeface="Cambria" pitchFamily="34" charset="-120"/>
               </a:rPr>
               <a:t>Market Entry</a:t>
             </a:r>
@@ -10314,9 +10314,9 @@
                 <a:solidFill>
                   <a:srgbClr val="12395C"/>
                 </a:solidFill>
-                <a:latin typeface="Georgia" pitchFamily="34" charset="0"/>
-                <a:ea typeface="Georgia" pitchFamily="34" charset="-122"/>
-                <a:cs typeface="Georgia" pitchFamily="34" charset="-120"/>
+                <a:latin typeface="Cambria" pitchFamily="34" charset="0"/>
+                <a:ea typeface="Cambria" pitchFamily="34" charset="-122"/>
+                <a:cs typeface="Cambria" pitchFamily="34" charset="-120"/>
               </a:rPr>
               <a:t>Star Power</a:t>
             </a:r>
@@ -10522,9 +10522,9 @@
                 <a:solidFill>
                   <a:srgbClr val="8A5A0F"/>
                 </a:solidFill>
-                <a:latin typeface="Georgia" pitchFamily="34" charset="0"/>
-                <a:ea typeface="Georgia" pitchFamily="34" charset="-122"/>
-                <a:cs typeface="Georgia" pitchFamily="34" charset="-120"/>
+                <a:latin typeface="Cambria" pitchFamily="34" charset="0"/>
+                <a:ea typeface="Cambria" pitchFamily="34" charset="-122"/>
+                <a:cs typeface="Cambria" pitchFamily="34" charset="-120"/>
               </a:rPr>
               <a:t>Product</a:t>
             </a:r>
@@ -10730,9 +10730,9 @@
                 <a:solidFill>
                   <a:srgbClr val="6E4A12"/>
                 </a:solidFill>
-                <a:latin typeface="Georgia" pitchFamily="34" charset="0"/>
-                <a:ea typeface="Georgia" pitchFamily="34" charset="-122"/>
-                <a:cs typeface="Georgia" pitchFamily="34" charset="-120"/>
+                <a:latin typeface="Cambria" pitchFamily="34" charset="0"/>
+                <a:ea typeface="Cambria" pitchFamily="34" charset="-122"/>
+                <a:cs typeface="Cambria" pitchFamily="34" charset="-120"/>
               </a:rPr>
               <a:t>Expansion</a:t>
             </a:r>
@@ -11169,9 +11169,9 @@
                 <a:solidFill>
                   <a:srgbClr val="0C2A43"/>
                 </a:solidFill>
-                <a:latin typeface="Georgia" pitchFamily="34" charset="0"/>
-                <a:ea typeface="Georgia" pitchFamily="34" charset="-122"/>
-                <a:cs typeface="Georgia" pitchFamily="34" charset="-120"/>
+                <a:latin typeface="Cambria" pitchFamily="34" charset="0"/>
+                <a:ea typeface="Cambria" pitchFamily="34" charset="-122"/>
+                <a:cs typeface="Cambria" pitchFamily="34" charset="-120"/>
               </a:rPr>
               <a:t>eTeacher to Launch the Longevity Hub: A Planned AI Tutor and Daily-Ritual Engine for Healthspan</a:t>
             </a:r>
@@ -11789,9 +11789,9 @@
                 <a:solidFill>
                   <a:srgbClr val="0C2A43"/>
                 </a:solidFill>
-                <a:latin typeface="Georgia" pitchFamily="34" charset="0"/>
-                <a:ea typeface="Georgia" pitchFamily="34" charset="-122"/>
-                <a:cs typeface="Georgia" pitchFamily="34" charset="-120"/>
+                <a:latin typeface="Cambria" pitchFamily="34" charset="0"/>
+                <a:ea typeface="Cambria" pitchFamily="34" charset="-122"/>
+                <a:cs typeface="Cambria" pitchFamily="34" charset="-120"/>
               </a:rPr>
               <a:t>Longevity Fails Without Consistency. eTeacher's Planned App Attacks the Persistence Problem With AI.</a:t>
             </a:r>
@@ -12359,9 +12359,9 @@
                 <a:solidFill>
                   <a:srgbClr val="FFFFFF"/>
                 </a:solidFill>
-                <a:latin typeface="Georgia" pitchFamily="34" charset="0"/>
-                <a:ea typeface="Georgia" pitchFamily="34" charset="-122"/>
-                <a:cs typeface="Georgia" pitchFamily="34" charset="-120"/>
+                <a:latin typeface="Cambria" pitchFamily="34" charset="0"/>
+                <a:ea typeface="Cambria" pitchFamily="34" charset="-122"/>
+                <a:cs typeface="Cambria" pitchFamily="34" charset="-120"/>
               </a:rPr>
               <a:t>Six New Longevity Courses (Roadmap)</a:t>
             </a:r>
@@ -12659,9 +12659,9 @@
                 <a:solidFill>
                   <a:srgbClr val="0C2A43"/>
                 </a:solidFill>
-                <a:latin typeface="Georgia" pitchFamily="34" charset="0"/>
-                <a:ea typeface="Georgia" pitchFamily="34" charset="-122"/>
-                <a:cs typeface="Georgia" pitchFamily="34" charset="-120"/>
+                <a:latin typeface="Cambria" pitchFamily="34" charset="0"/>
+                <a:ea typeface="Cambria" pitchFamily="34" charset="-122"/>
+                <a:cs typeface="Cambria" pitchFamily="34" charset="-120"/>
               </a:rPr>
               <a:t>eTeacher to Add Six New Longevity Courses Following Its Q2 Longevity Life Academy Debut</a:t>
             </a:r>
@@ -13279,9 +13279,9 @@
                 <a:solidFill>
                   <a:srgbClr val="0C2A43"/>
                 </a:solidFill>
-                <a:latin typeface="Georgia" pitchFamily="34" charset="0"/>
-                <a:ea typeface="Georgia" pitchFamily="34" charset="-122"/>
-                <a:cs typeface="Georgia" pitchFamily="34" charset="-120"/>
+                <a:latin typeface="Cambria" pitchFamily="34" charset="0"/>
+                <a:ea typeface="Cambria" pitchFamily="34" charset="-122"/>
+                <a:cs typeface="Cambria" pitchFamily="34" charset="-120"/>
               </a:rPr>
               <a:t>“Train Your Brain Like You Train Your Body”: Inside eTeacher's Planned Longevity Learning Journey</a:t>
             </a:r>
@@ -13849,9 +13849,9 @@
                 <a:solidFill>
                   <a:srgbClr val="FFFFFF"/>
                 </a:solidFill>
-                <a:latin typeface="Georgia" pitchFamily="34" charset="0"/>
-                <a:ea typeface="Georgia" pitchFamily="34" charset="-122"/>
-                <a:cs typeface="Georgia" pitchFamily="34" charset="-120"/>
+                <a:latin typeface="Cambria" pitchFamily="34" charset="0"/>
+                <a:ea typeface="Cambria" pitchFamily="34" charset="-122"/>
+                <a:cs typeface="Cambria" pitchFamily="34" charset="-120"/>
               </a:rPr>
               <a:t>How we actually get listed</a:t>
             </a:r>
@@ -14043,9 +14043,9 @@
                 <a:solidFill>
                   <a:srgbClr val="0C2A43"/>
                 </a:solidFill>
-                <a:latin typeface="Georgia" pitchFamily="34" charset="0"/>
-                <a:ea typeface="Georgia" pitchFamily="34" charset="-122"/>
-                <a:cs typeface="Georgia" pitchFamily="34" charset="-120"/>
+                <a:latin typeface="Cambria" pitchFamily="34" charset="0"/>
+                <a:ea typeface="Cambria" pitchFamily="34" charset="-122"/>
+                <a:cs typeface="Cambria" pitchFamily="34" charset="-120"/>
               </a:rPr>
               <a:t>The placement process, step by step</a:t>
             </a:r>
@@ -14131,9 +14131,9 @@
                 <a:solidFill>
                   <a:srgbClr val="C08A2E"/>
                 </a:solidFill>
-                <a:latin typeface="Georgia" pitchFamily="34" charset="0"/>
-                <a:ea typeface="Georgia" pitchFamily="34" charset="-122"/>
-                <a:cs typeface="Georgia" pitchFamily="34" charset="-120"/>
+                <a:latin typeface="Cambria" pitchFamily="34" charset="0"/>
+                <a:ea typeface="Cambria" pitchFamily="34" charset="-122"/>
+                <a:cs typeface="Cambria" pitchFamily="34" charset="-120"/>
               </a:rPr>
               <a:t>01</a:t>
             </a:r>
@@ -14173,9 +14173,9 @@
                 <a:solidFill>
                   <a:srgbClr val="0C2A43"/>
                 </a:solidFill>
-                <a:latin typeface="Georgia" pitchFamily="34" charset="0"/>
-                <a:ea typeface="Georgia" pitchFamily="34" charset="-122"/>
-                <a:cs typeface="Georgia" pitchFamily="34" charset="-120"/>
+                <a:latin typeface="Cambria" pitchFamily="34" charset="0"/>
+                <a:ea typeface="Cambria" pitchFamily="34" charset="-122"/>
+                <a:cs typeface="Cambria" pitchFamily="34" charset="-120"/>
               </a:rPr>
               <a:t>Wire distribution</a:t>
             </a:r>
@@ -14342,9 +14342,9 @@
                 <a:solidFill>
                   <a:srgbClr val="C08A2E"/>
                 </a:solidFill>
-                <a:latin typeface="Georgia" pitchFamily="34" charset="0"/>
-                <a:ea typeface="Georgia" pitchFamily="34" charset="-122"/>
-                <a:cs typeface="Georgia" pitchFamily="34" charset="-120"/>
+                <a:latin typeface="Cambria" pitchFamily="34" charset="0"/>
+                <a:ea typeface="Cambria" pitchFamily="34" charset="-122"/>
+                <a:cs typeface="Cambria" pitchFamily="34" charset="-120"/>
               </a:rPr>
               <a:t>02</a:t>
             </a:r>
@@ -14384,9 +14384,9 @@
                 <a:solidFill>
                   <a:srgbClr val="0C2A43"/>
                 </a:solidFill>
-                <a:latin typeface="Georgia" pitchFamily="34" charset="0"/>
-                <a:ea typeface="Georgia" pitchFamily="34" charset="-122"/>
-                <a:cs typeface="Georgia" pitchFamily="34" charset="-120"/>
+                <a:latin typeface="Cambria" pitchFamily="34" charset="0"/>
+                <a:ea typeface="Cambria" pitchFamily="34" charset="-122"/>
+                <a:cs typeface="Cambria" pitchFamily="34" charset="-120"/>
               </a:rPr>
               <a:t>Embargo &amp; exclusive</a:t>
             </a:r>
@@ -14553,9 +14553,9 @@
                 <a:solidFill>
                   <a:srgbClr val="C08A2E"/>
                 </a:solidFill>
-                <a:latin typeface="Georgia" pitchFamily="34" charset="0"/>
-                <a:ea typeface="Georgia" pitchFamily="34" charset="-122"/>
-                <a:cs typeface="Georgia" pitchFamily="34" charset="-120"/>
+                <a:latin typeface="Cambria" pitchFamily="34" charset="0"/>
+                <a:ea typeface="Cambria" pitchFamily="34" charset="-122"/>
+                <a:cs typeface="Cambria" pitchFamily="34" charset="-120"/>
               </a:rPr>
               <a:t>03</a:t>
             </a:r>
@@ -14595,9 +14595,9 @@
                 <a:solidFill>
                   <a:srgbClr val="0C2A43"/>
                 </a:solidFill>
-                <a:latin typeface="Georgia" pitchFamily="34" charset="0"/>
-                <a:ea typeface="Georgia" pitchFamily="34" charset="-122"/>
-                <a:cs typeface="Georgia" pitchFamily="34" charset="-120"/>
+                <a:latin typeface="Cambria" pitchFamily="34" charset="0"/>
+                <a:ea typeface="Cambria" pitchFamily="34" charset="-122"/>
+                <a:cs typeface="Cambria" pitchFamily="34" charset="-120"/>
               </a:rPr>
               <a:t>Direct pitching</a:t>
             </a:r>
@@ -14764,9 +14764,9 @@
                 <a:solidFill>
                   <a:srgbClr val="C08A2E"/>
                 </a:solidFill>
-                <a:latin typeface="Georgia" pitchFamily="34" charset="0"/>
-                <a:ea typeface="Georgia" pitchFamily="34" charset="-122"/>
-                <a:cs typeface="Georgia" pitchFamily="34" charset="-120"/>
+                <a:latin typeface="Cambria" pitchFamily="34" charset="0"/>
+                <a:ea typeface="Cambria" pitchFamily="34" charset="-122"/>
+                <a:cs typeface="Cambria" pitchFamily="34" charset="-120"/>
               </a:rPr>
               <a:t>04</a:t>
             </a:r>
@@ -14806,9 +14806,9 @@
                 <a:solidFill>
                   <a:srgbClr val="0C2A43"/>
                 </a:solidFill>
-                <a:latin typeface="Georgia" pitchFamily="34" charset="0"/>
-                <a:ea typeface="Georgia" pitchFamily="34" charset="-122"/>
-                <a:cs typeface="Georgia" pitchFamily="34" charset="-120"/>
+                <a:latin typeface="Cambria" pitchFamily="34" charset="0"/>
+                <a:ea typeface="Cambria" pitchFamily="34" charset="-122"/>
+                <a:cs typeface="Cambria" pitchFamily="34" charset="-120"/>
               </a:rPr>
               <a:t>Broadcast &amp; podcast</a:t>
             </a:r>
@@ -14975,9 +14975,9 @@
                 <a:solidFill>
                   <a:srgbClr val="C08A2E"/>
                 </a:solidFill>
-                <a:latin typeface="Georgia" pitchFamily="34" charset="0"/>
-                <a:ea typeface="Georgia" pitchFamily="34" charset="-122"/>
-                <a:cs typeface="Georgia" pitchFamily="34" charset="-120"/>
+                <a:latin typeface="Cambria" pitchFamily="34" charset="0"/>
+                <a:ea typeface="Cambria" pitchFamily="34" charset="-122"/>
+                <a:cs typeface="Cambria" pitchFamily="34" charset="-120"/>
               </a:rPr>
               <a:t>05</a:t>
             </a:r>
@@ -15017,9 +15017,9 @@
                 <a:solidFill>
                   <a:srgbClr val="0C2A43"/>
                 </a:solidFill>
-                <a:latin typeface="Georgia" pitchFamily="34" charset="0"/>
-                <a:ea typeface="Georgia" pitchFamily="34" charset="-122"/>
-                <a:cs typeface="Georgia" pitchFamily="34" charset="-120"/>
+                <a:latin typeface="Cambria" pitchFamily="34" charset="0"/>
+                <a:ea typeface="Cambria" pitchFamily="34" charset="-122"/>
+                <a:cs typeface="Cambria" pitchFamily="34" charset="-120"/>
               </a:rPr>
               <a:t>Amplify &amp; repurpose</a:t>
             </a:r>
@@ -15253,9 +15253,9 @@
                 <a:solidFill>
                   <a:srgbClr val="0C2A43"/>
                 </a:solidFill>
-                <a:latin typeface="Georgia" pitchFamily="34" charset="0"/>
-                <a:ea typeface="Georgia" pitchFamily="34" charset="-122"/>
-                <a:cs typeface="Georgia" pitchFamily="34" charset="-120"/>
+                <a:latin typeface="Cambria" pitchFamily="34" charset="0"/>
+                <a:ea typeface="Cambria" pitchFamily="34" charset="-122"/>
+                <a:cs typeface="Cambria" pitchFamily="34" charset="-120"/>
               </a:rPr>
               <a:t>Target outlets: reach, realistic odds, and timing</a:t>
             </a:r>
@@ -17874,9 +17874,9 @@
                 <a:solidFill>
                   <a:srgbClr val="0C2A43"/>
                 </a:solidFill>
-                <a:latin typeface="Georgia" pitchFamily="34" charset="0"/>
-                <a:ea typeface="Georgia" pitchFamily="34" charset="-122"/>
-                <a:cs typeface="Georgia" pitchFamily="34" charset="-120"/>
+                <a:latin typeface="Cambria" pitchFamily="34" charset="0"/>
+                <a:ea typeface="Cambria" pitchFamily="34" charset="-122"/>
+                <a:cs typeface="Cambria" pitchFamily="34" charset="-120"/>
               </a:rPr>
               <a:t>We are not starting from zero</a:t>
             </a:r>
@@ -17982,9 +17982,9 @@
                 <a:solidFill>
                   <a:srgbClr val="0C2A43"/>
                 </a:solidFill>
-                <a:latin typeface="Georgia" pitchFamily="34" charset="0"/>
-                <a:ea typeface="Georgia" pitchFamily="34" charset="-122"/>
-                <a:cs typeface="Georgia" pitchFamily="34" charset="-120"/>
+                <a:latin typeface="Cambria" pitchFamily="34" charset="0"/>
+                <a:ea typeface="Cambria" pitchFamily="34" charset="-122"/>
+                <a:cs typeface="Cambria" pitchFamily="34" charset="-120"/>
               </a:rPr>
               <a:t>TheMarker (Haaretz)</a:t>
             </a:r>
@@ -18129,11 +18129,11 @@
                 <a:solidFill>
                   <a:srgbClr val="0C2A43"/>
                 </a:solidFill>
-                <a:latin typeface="Georgia" pitchFamily="34" charset="0"/>
-                <a:ea typeface="Georgia" pitchFamily="34" charset="-122"/>
-                <a:cs typeface="Georgia" pitchFamily="34" charset="-120"/>
-              </a:rPr>
-              <a:t>GlobeNewswire</a:t>
+                <a:latin typeface="Cambria" pitchFamily="34" charset="0"/>
+                <a:ea typeface="Cambria" pitchFamily="34" charset="-122"/>
+                <a:cs typeface="Cambria" pitchFamily="34" charset="-120"/>
+              </a:rPr>
+              <a:t>LinkedIn thought-leadership</a:t>
             </a:r>
             <a:endParaRPr lang="en-US" sz="1300" dirty="0"/>
           </a:p>
@@ -18172,7 +18172,7 @@
                 <a:ea typeface="Calibri" pitchFamily="34" charset="-122"/>
                 <a:cs typeface="Calibri" pitchFamily="34" charset="-120"/>
               </a:rPr>
-              <a:t>Oct 2020</a:t>
+              <a:t>2025–26</a:t>
             </a:r>
             <a:endParaRPr lang="en-US" sz="1200" dirty="0"/>
           </a:p>
@@ -18214,7 +18214,7 @@
                 <a:ea typeface="Calibri" pitchFamily="34" charset="-122"/>
                 <a:cs typeface="Calibri" pitchFamily="34" charset="-120"/>
               </a:rPr>
-              <a:t>eTeacher strengthens partnership with Nuvei; launch of Langaroo.com.</a:t>
+              <a:t>IAC Summit, “AI for All,” NYC EdTech at Columbia University.</a:t>
             </a:r>
             <a:endParaRPr lang="en-US" sz="1150" dirty="0"/>
           </a:p>
@@ -18276,11 +18276,11 @@
                 <a:solidFill>
                   <a:srgbClr val="0C2A43"/>
                 </a:solidFill>
-                <a:latin typeface="Georgia" pitchFamily="34" charset="0"/>
-                <a:ea typeface="Georgia" pitchFamily="34" charset="-122"/>
-                <a:cs typeface="Georgia" pitchFamily="34" charset="-120"/>
-              </a:rPr>
-              <a:t>PRWeb / PR Newswire</a:t>
+                <a:latin typeface="Cambria" pitchFamily="34" charset="0"/>
+                <a:ea typeface="Cambria" pitchFamily="34" charset="-122"/>
+                <a:cs typeface="Cambria" pitchFamily="34" charset="-120"/>
+              </a:rPr>
+              <a:t>GlobeNewswire</a:t>
             </a:r>
             <a:endParaRPr lang="en-US" sz="1300" dirty="0"/>
           </a:p>
@@ -18319,7 +18319,7 @@
                 <a:ea typeface="Calibri" pitchFamily="34" charset="-122"/>
                 <a:cs typeface="Calibri" pitchFamily="34" charset="-120"/>
               </a:rPr>
-              <a:t>Mar 2017</a:t>
+              <a:t>Oct 2020</a:t>
             </a:r>
             <a:endParaRPr lang="en-US" sz="1200" dirty="0"/>
           </a:p>
@@ -18361,7 +18361,7 @@
                 <a:ea typeface="Calibri" pitchFamily="34" charset="-122"/>
                 <a:cs typeface="Calibri" pitchFamily="34" charset="-120"/>
               </a:rPr>
-              <a:t>eTeacher Group selects FrontGate Media as its North America agency.</a:t>
+              <a:t>eTeacher strengthens partnership with Nuvei; launch of Langaroo.com.</a:t>
             </a:r>
             <a:endParaRPr lang="en-US" sz="1150" dirty="0"/>
           </a:p>
@@ -18423,11 +18423,11 @@
                 <a:solidFill>
                   <a:srgbClr val="0C2A43"/>
                 </a:solidFill>
-                <a:latin typeface="Georgia" pitchFamily="34" charset="0"/>
-                <a:ea typeface="Georgia" pitchFamily="34" charset="-122"/>
-                <a:cs typeface="Georgia" pitchFamily="34" charset="-120"/>
-              </a:rPr>
-              <a:t>LinkedIn thought-leadership</a:t>
+                <a:latin typeface="Cambria" pitchFamily="34" charset="0"/>
+                <a:ea typeface="Cambria" pitchFamily="34" charset="-122"/>
+                <a:cs typeface="Cambria" pitchFamily="34" charset="-120"/>
+              </a:rPr>
+              <a:t>PRWeb / PR Newswire</a:t>
             </a:r>
             <a:endParaRPr lang="en-US" sz="1300" dirty="0"/>
           </a:p>
@@ -18466,7 +18466,7 @@
                 <a:ea typeface="Calibri" pitchFamily="34" charset="-122"/>
                 <a:cs typeface="Calibri" pitchFamily="34" charset="-120"/>
               </a:rPr>
-              <a:t>2025–26</a:t>
+              <a:t>Mar 2017</a:t>
             </a:r>
             <a:endParaRPr lang="en-US" sz="1200" dirty="0"/>
           </a:p>
@@ -18508,7 +18508,7 @@
                 <a:ea typeface="Calibri" pitchFamily="34" charset="-122"/>
                 <a:cs typeface="Calibri" pitchFamily="34" charset="-120"/>
               </a:rPr>
-              <a:t>IAC Summit, “AI for All,” NYC EdTech at Columbia University.</a:t>
+              <a:t>eTeacher Group selects FrontGate Media as its North America agency.</a:t>
             </a:r>
             <a:endParaRPr lang="en-US" sz="1150" dirty="0"/>
           </a:p>
@@ -18751,9 +18751,9 @@
                 <a:solidFill>
                   <a:srgbClr val="0C2A43"/>
                 </a:solidFill>
-                <a:latin typeface="Georgia" pitchFamily="34" charset="0"/>
-                <a:ea typeface="Georgia" pitchFamily="34" charset="-122"/>
-                <a:cs typeface="Georgia" pitchFamily="34" charset="-120"/>
+                <a:latin typeface="Cambria" pitchFamily="34" charset="0"/>
+                <a:ea typeface="Cambria" pitchFamily="34" charset="-122"/>
+                <a:cs typeface="Cambria" pitchFamily="34" charset="-120"/>
               </a:rPr>
               <a:t>The 90-day rollout calendar</a:t>
             </a:r>
@@ -18919,9 +18919,9 @@
                 <a:solidFill>
                   <a:srgbClr val="0C2A43"/>
                 </a:solidFill>
-                <a:latin typeface="Georgia" pitchFamily="34" charset="0"/>
-                <a:ea typeface="Georgia" pitchFamily="34" charset="-122"/>
-                <a:cs typeface="Georgia" pitchFamily="34" charset="-120"/>
+                <a:latin typeface="Cambria" pitchFamily="34" charset="0"/>
+                <a:ea typeface="Cambria" pitchFamily="34" charset="-122"/>
+                <a:cs typeface="Cambria" pitchFamily="34" charset="-120"/>
               </a:rPr>
               <a:t>Wave 1</a:t>
             </a:r>
@@ -18958,9 +18958,9 @@
                 <a:solidFill>
                   <a:srgbClr val="0C2A43"/>
                 </a:solidFill>
-                <a:latin typeface="Georgia" pitchFamily="34" charset="0"/>
-                <a:ea typeface="Georgia" pitchFamily="34" charset="-122"/>
-                <a:cs typeface="Georgia" pitchFamily="34" charset="-120"/>
+                <a:latin typeface="Cambria" pitchFamily="34" charset="0"/>
+                <a:ea typeface="Cambria" pitchFamily="34" charset="-122"/>
+                <a:cs typeface="Cambria" pitchFamily="34" charset="-120"/>
               </a:rPr>
               <a:t>Market entry</a:t>
             </a:r>
@@ -19145,9 +19145,9 @@
                 <a:solidFill>
                   <a:srgbClr val="C08A2E"/>
                 </a:solidFill>
-                <a:latin typeface="Georgia" pitchFamily="34" charset="0"/>
-                <a:ea typeface="Georgia" pitchFamily="34" charset="-122"/>
-                <a:cs typeface="Georgia" pitchFamily="34" charset="-120"/>
+                <a:latin typeface="Cambria" pitchFamily="34" charset="0"/>
+                <a:ea typeface="Cambria" pitchFamily="34" charset="-122"/>
+                <a:cs typeface="Cambria" pitchFamily="34" charset="-120"/>
               </a:rPr>
               <a:t>Wave 2</a:t>
             </a:r>
@@ -19184,9 +19184,9 @@
                 <a:solidFill>
                   <a:srgbClr val="0C2A43"/>
                 </a:solidFill>
-                <a:latin typeface="Georgia" pitchFamily="34" charset="0"/>
-                <a:ea typeface="Georgia" pitchFamily="34" charset="-122"/>
-                <a:cs typeface="Georgia" pitchFamily="34" charset="-120"/>
+                <a:latin typeface="Cambria" pitchFamily="34" charset="0"/>
+                <a:ea typeface="Cambria" pitchFamily="34" charset="-122"/>
+                <a:cs typeface="Cambria" pitchFamily="34" charset="-120"/>
               </a:rPr>
               <a:t>Julie joins</a:t>
             </a:r>
@@ -19371,9 +19371,9 @@
                 <a:solidFill>
                   <a:srgbClr val="12395C"/>
                 </a:solidFill>
-                <a:latin typeface="Georgia" pitchFamily="34" charset="0"/>
-                <a:ea typeface="Georgia" pitchFamily="34" charset="-122"/>
-                <a:cs typeface="Georgia" pitchFamily="34" charset="-120"/>
+                <a:latin typeface="Cambria" pitchFamily="34" charset="0"/>
+                <a:ea typeface="Cambria" pitchFamily="34" charset="-122"/>
+                <a:cs typeface="Cambria" pitchFamily="34" charset="-120"/>
               </a:rPr>
               <a:t>Wave 3</a:t>
             </a:r>
@@ -19410,9 +19410,9 @@
                 <a:solidFill>
                   <a:srgbClr val="0C2A43"/>
                 </a:solidFill>
-                <a:latin typeface="Georgia" pitchFamily="34" charset="0"/>
-                <a:ea typeface="Georgia" pitchFamily="34" charset="-122"/>
-                <a:cs typeface="Georgia" pitchFamily="34" charset="-120"/>
+                <a:latin typeface="Cambria" pitchFamily="34" charset="0"/>
+                <a:ea typeface="Cambria" pitchFamily="34" charset="-122"/>
+                <a:cs typeface="Cambria" pitchFamily="34" charset="-120"/>
               </a:rPr>
               <a:t>Hub app</a:t>
             </a:r>
@@ -19597,9 +19597,9 @@
                 <a:solidFill>
                   <a:srgbClr val="6E4A12"/>
                 </a:solidFill>
-                <a:latin typeface="Georgia" pitchFamily="34" charset="0"/>
-                <a:ea typeface="Georgia" pitchFamily="34" charset="-122"/>
-                <a:cs typeface="Georgia" pitchFamily="34" charset="-120"/>
+                <a:latin typeface="Cambria" pitchFamily="34" charset="0"/>
+                <a:ea typeface="Cambria" pitchFamily="34" charset="-122"/>
+                <a:cs typeface="Cambria" pitchFamily="34" charset="-120"/>
               </a:rPr>
               <a:t>Wave 4</a:t>
             </a:r>
@@ -19636,9 +19636,9 @@
                 <a:solidFill>
                   <a:srgbClr val="0C2A43"/>
                 </a:solidFill>
-                <a:latin typeface="Georgia" pitchFamily="34" charset="0"/>
-                <a:ea typeface="Georgia" pitchFamily="34" charset="-122"/>
-                <a:cs typeface="Georgia" pitchFamily="34" charset="-120"/>
+                <a:latin typeface="Cambria" pitchFamily="34" charset="0"/>
+                <a:ea typeface="Cambria" pitchFamily="34" charset="-122"/>
+                <a:cs typeface="Cambria" pitchFamily="34" charset="-120"/>
               </a:rPr>
               <a:t>6 courses</a:t>
             </a:r>
@@ -19909,9 +19909,9 @@
                 <a:solidFill>
                   <a:srgbClr val="0C2A43"/>
                 </a:solidFill>
-                <a:latin typeface="Georgia" pitchFamily="34" charset="0"/>
-                <a:ea typeface="Georgia" pitchFamily="34" charset="-122"/>
-                <a:cs typeface="Georgia" pitchFamily="34" charset="-120"/>
+                <a:latin typeface="Cambria" pitchFamily="34" charset="0"/>
+                <a:ea typeface="Cambria" pitchFamily="34" charset="-122"/>
+                <a:cs typeface="Cambria" pitchFamily="34" charset="-120"/>
               </a:rPr>
               <a:t>Every quote sounds like the person saying it</a:t>
             </a:r>
@@ -20442,6 +20442,41 @@
                 <a:ea typeface="Calibri" pitchFamily="34" charset="-122"/>
                 <a:cs typeface="Calibri" pitchFamily="34" charset="-120"/>
                 <a:hlinkClick r:id="rId3" invalidUrl="" action="" tgtFrame="" tooltip="" history="1" highlightClick="0" endSnd="0">
+                  <a:extLst>
+                    <a:ext uri="{A12FA001-AC4F-418D-AE19-62706E023703}">
+                      <ahyp:hlinkClr xmlns:ahyp="http://schemas.microsoft.com/office/drawing/2018/hyperlinkcolor" val="tx"/>
+                    </a:ext>
+                  </a:extLst>
+                </a:hlinkClick>
+              </a:rPr>
+              <a:t>NOVOS</a:t>
+            </a:r>
+            <a:pPr algn="l" indent="0" marL="0">
+              <a:buNone/>
+            </a:pPr>
+            <a:r>
+              <a:rPr lang="en-US" sz="800" dirty="0">
+                <a:solidFill>
+                  <a:srgbClr val="9AA4AF"/>
+                </a:solidFill>
+                <a:latin typeface="Calibri" pitchFamily="34" charset="0"/>
+                <a:ea typeface="Calibri" pitchFamily="34" charset="-122"/>
+                <a:cs typeface="Calibri" pitchFamily="34" charset="-120"/>
+              </a:rPr>
+              <a:t>  ·  </a:t>
+            </a:r>
+            <a:pPr algn="l" indent="0" marL="0">
+              <a:buNone/>
+            </a:pPr>
+            <a:r>
+              <a:rPr lang="en-US" sz="800" u="sng" dirty="0">
+                <a:solidFill>
+                  <a:srgbClr val="5C6672"/>
+                </a:solidFill>
+                <a:latin typeface="Calibri" pitchFamily="34" charset="0"/>
+                <a:ea typeface="Calibri" pitchFamily="34" charset="-122"/>
+                <a:cs typeface="Calibri" pitchFamily="34" charset="-120"/>
+                <a:hlinkClick r:id="rId4" invalidUrl="" action="" tgtFrame="" tooltip="" history="1" highlightClick="0" endSnd="0">
                   <a:extLst>
                     <a:ext uri="{A12FA001-AC4F-418D-AE19-62706E023703}">
                       <ahyp:hlinkClr xmlns:ahyp="http://schemas.microsoft.com/office/drawing/2018/hyperlinkcolor" val="tx"/>
@@ -20614,9 +20649,9 @@
                 <a:solidFill>
                   <a:srgbClr val="FFFFFF"/>
                 </a:solidFill>
-                <a:latin typeface="Georgia" pitchFamily="34" charset="0"/>
-                <a:ea typeface="Georgia" pitchFamily="34" charset="-122"/>
-                <a:cs typeface="Georgia" pitchFamily="34" charset="-120"/>
+                <a:latin typeface="Cambria" pitchFamily="34" charset="0"/>
+                <a:ea typeface="Cambria" pitchFamily="34" charset="-122"/>
+                <a:cs typeface="Cambria" pitchFamily="34" charset="-120"/>
               </a:rPr>
               <a:t>Your approval turns this into coverage</a:t>
             </a:r>
@@ -20678,7 +20713,7 @@
                 <a:ea typeface="Calibri" pitchFamily="34" charset="-122"/>
                 <a:cs typeface="Calibri" pitchFamily="34" charset="-120"/>
               </a:rPr>
-              <a:t>2.  Confirm the Julie Gibson Clark quotes and finalize her instructor agreement and title.
+              <a:t>2.  Confirm the Julie Gibson Clark quotes and finalize her instructor agreement and title. Note: her #2 ranking is stated in the past tense throughout — she held #2 for over a year before a 2024 rule change — so every claim stays accurate if a reporter checks the live leaderboard.
 </a:t>
             </a:r>
             <a:pPr indent="0" marL="0">
@@ -20897,9 +20932,9 @@
                 <a:solidFill>
                   <a:srgbClr val="FFFFFF"/>
                 </a:solidFill>
-                <a:latin typeface="Georgia" pitchFamily="34" charset="0"/>
-                <a:ea typeface="Georgia" pitchFamily="34" charset="-122"/>
-                <a:cs typeface="Georgia" pitchFamily="34" charset="-120"/>
+                <a:latin typeface="Cambria" pitchFamily="34" charset="0"/>
+                <a:ea typeface="Cambria" pitchFamily="34" charset="-122"/>
+                <a:cs typeface="Cambria" pitchFamily="34" charset="-120"/>
               </a:rPr>
               <a:t>eTeacher Enters the Longevity Market</a:t>
             </a:r>
@@ -21197,9 +21232,9 @@
                 <a:solidFill>
                   <a:srgbClr val="0C2A43"/>
                 </a:solidFill>
-                <a:latin typeface="Georgia" pitchFamily="34" charset="0"/>
-                <a:ea typeface="Georgia" pitchFamily="34" charset="-122"/>
-                <a:cs typeface="Georgia" pitchFamily="34" charset="-120"/>
+                <a:latin typeface="Cambria" pitchFamily="34" charset="0"/>
+                <a:ea typeface="Cambria" pitchFamily="34" charset="-122"/>
+                <a:cs typeface="Cambria" pitchFamily="34" charset="-120"/>
               </a:rPr>
               <a:t>eTeacher Group Enters the $8 Trillion Longevity Market with Longevity Life Academy, Its Fifth Online School</a:t>
             </a:r>
@@ -21817,9 +21852,9 @@
                 <a:solidFill>
                   <a:srgbClr val="0C2A43"/>
                 </a:solidFill>
-                <a:latin typeface="Georgia" pitchFamily="34" charset="0"/>
-                <a:ea typeface="Georgia" pitchFamily="34" charset="-122"/>
-                <a:cs typeface="Georgia" pitchFamily="34" charset="-120"/>
+                <a:latin typeface="Cambria" pitchFamily="34" charset="0"/>
+                <a:ea typeface="Cambria" pitchFamily="34" charset="-122"/>
+                <a:cs typeface="Cambria" pitchFamily="34" charset="-120"/>
               </a:rPr>
               <a:t>From Biblical Hebrew to Healthspan: eTeacher Applies Its Live-Plus-AI Method to Longevity</a:t>
             </a:r>
@@ -22346,7 +22381,7 @@
                 <a:ea typeface="Calibri" pitchFamily="34" charset="-122"/>
                 <a:cs typeface="Calibri" pitchFamily="34" charset="-120"/>
               </a:rPr>
-              <a:t>BUSINESS / MARKET-ENTRY — POSITIONING BETWEEN CONCIERGE CLINICS AND SOCIAL ADVICE</a:t>
+              <a:t>BUSINESS / MARKET-ENTRY — THE GAP BETWEEN $2M CLINICS AND FREE ADVICE</a:t>
             </a:r>
             <a:endParaRPr lang="en-US" sz="1050" dirty="0"/>
           </a:p>
@@ -22437,9 +22472,9 @@
                 <a:solidFill>
                   <a:srgbClr val="0C2A43"/>
                 </a:solidFill>
-                <a:latin typeface="Georgia" pitchFamily="34" charset="0"/>
-                <a:ea typeface="Georgia" pitchFamily="34" charset="-122"/>
-                <a:cs typeface="Georgia" pitchFamily="34" charset="-120"/>
+                <a:latin typeface="Cambria" pitchFamily="34" charset="0"/>
+                <a:ea typeface="Cambria" pitchFamily="34" charset="-122"/>
+                <a:cs typeface="Cambria" pitchFamily="34" charset="-120"/>
               </a:rPr>
               <a:t>An Israeli EdTech Veteran Bets on Longevity — Targeting the Gap Between $2M Clinics and Free Advice</a:t>
             </a:r>
@@ -23057,9 +23092,9 @@
                 <a:solidFill>
                   <a:srgbClr val="0C2A43"/>
                 </a:solidFill>
-                <a:latin typeface="Georgia" pitchFamily="34" charset="0"/>
-                <a:ea typeface="Georgia" pitchFamily="34" charset="-122"/>
-                <a:cs typeface="Georgia" pitchFamily="34" charset="-120"/>
+                <a:latin typeface="Cambria" pitchFamily="34" charset="0"/>
+                <a:ea typeface="Cambria" pitchFamily="34" charset="-122"/>
+                <a:cs typeface="Cambria" pitchFamily="34" charset="-120"/>
               </a:rPr>
               <a:t>Longevity Life Academy Puts a Continuous Glucose Monitor in Every Student's Hands</a:t>
             </a:r>
@@ -23677,9 +23712,9 @@
                 <a:solidFill>
                   <a:srgbClr val="0C2A43"/>
                 </a:solidFill>
-                <a:latin typeface="Georgia" pitchFamily="34" charset="0"/>
-                <a:ea typeface="Georgia" pitchFamily="34" charset="-122"/>
-                <a:cs typeface="Georgia" pitchFamily="34" charset="-120"/>
+                <a:latin typeface="Cambria" pitchFamily="34" charset="0"/>
+                <a:ea typeface="Cambria" pitchFamily="34" charset="-122"/>
+                <a:cs typeface="Cambria" pitchFamily="34" charset="-120"/>
               </a:rPr>
               <a:t>After 25 Years, Israel's eTeacher Takes Its Live-Learning Model Into Longevity</a:t>
             </a:r>

</xml_diff>

<commit_message>
Compress timeline: real dates, Wave 1 live Mon Jul 13, full 8-week rollout wrapping early Sep
</commit_message>
<xml_diff>
--- a/eTeacher_Longevity_PR_Campaign.pptx
+++ b/eTeacher_Longevity_PR_Campaign.pptx
@@ -18755,7 +18755,7 @@
                 <a:ea typeface="Cambria" pitchFamily="34" charset="-122"/>
                 <a:cs typeface="Cambria" pitchFamily="34" charset="-120"/>
               </a:rPr>
-              <a:t>The 90-day rollout calendar</a:t>
+              <a:t>The 8-week rollout calendar</a:t>
             </a:r>
             <a:endParaRPr lang="en-US" sz="2600" dirty="0"/>
           </a:p>
@@ -18837,7 +18837,7 @@
                 <a:ea typeface="Calibri" pitchFamily="34" charset="-122"/>
                 <a:cs typeface="Calibri" pitchFamily="34" charset="-120"/>
               </a:rPr>
-              <a:t>WEEKS 1–2</a:t>
+              <a:t>MON JUL 13</a:t>
             </a:r>
             <a:endParaRPr lang="en-US" sz="1100" dirty="0"/>
           </a:p>
@@ -19063,7 +19063,7 @@
                 <a:ea typeface="Calibri" pitchFamily="34" charset="-122"/>
                 <a:cs typeface="Calibri" pitchFamily="34" charset="-120"/>
               </a:rPr>
-              <a:t>WEEKS 5–6</a:t>
+              <a:t>THU JUL 30</a:t>
             </a:r>
             <a:endParaRPr lang="en-US" sz="1100" dirty="0"/>
           </a:p>
@@ -19289,7 +19289,7 @@
                 <a:ea typeface="Calibri" pitchFamily="34" charset="-122"/>
                 <a:cs typeface="Calibri" pitchFamily="34" charset="-120"/>
               </a:rPr>
-              <a:t>WEEKS 9–10</a:t>
+              <a:t>MON AUG 17</a:t>
             </a:r>
             <a:endParaRPr lang="en-US" sz="1100" dirty="0"/>
           </a:p>
@@ -19515,7 +19515,7 @@
                 <a:ea typeface="Calibri" pitchFamily="34" charset="-122"/>
                 <a:cs typeface="Calibri" pitchFamily="34" charset="-120"/>
               </a:rPr>
-              <a:t>WEEKS 12–13</a:t>
+              <a:t>THU SEP 3</a:t>
             </a:r>
             <a:endParaRPr lang="en-US" sz="1100" dirty="0"/>
           </a:p>
@@ -19744,7 +19744,7 @@
                 <a:ea typeface="Calibri" pitchFamily="34" charset="-122"/>
                 <a:cs typeface="Calibri" pitchFamily="34" charset="-120"/>
               </a:rPr>
-              <a:t>The compounding effect:  </a:t>
+              <a:t>Why ~2.5 weeks apart:  </a:t>
             </a:r>
             <a:pPr indent="0" marL="0">
               <a:lnSpc>
@@ -19761,7 +19761,7 @@
                 <a:ea typeface="Calibri" pitchFamily="34" charset="-122"/>
                 <a:cs typeface="Calibri" pitchFamily="34" charset="-120"/>
               </a:rPr>
-              <a:t>spacing waves 3–4 weeks apart lets each earn coverage before the next begins — building a rising, self-reinforcing narrative rather than a single spike.</a:t>
+              <a:t>tight enough to go live Monday and wrap by early September, spaced enough that each wave earns its coverage before the next — a rising narrative, not a single spike.</a:t>
             </a:r>
             <a:endParaRPr lang="en-US" sz="1200" dirty="0"/>
           </a:p>
@@ -20767,7 +20767,7 @@
                 <a:ea typeface="Calibri" pitchFamily="34" charset="-122"/>
                 <a:cs typeface="Calibri" pitchFamily="34" charset="-120"/>
               </a:rPr>
-              <a:t>5.  Lock the calendar: Wave 1 wire date sets the 90-day rollout in motion.</a:t>
+              <a:t>5.  Lock the calendar: approve quotes this week so Wave 1 wires Monday, July 13 — the full four-wave program then runs about eight weeks, wrapping by early September.</a:t>
             </a:r>
             <a:endParaRPr lang="en-US" sz="1400" dirty="0"/>
           </a:p>

</xml_diff>

<commit_message>
Audit fixes: resolve slide-26 timeframe contradiction (2.5wk), fix quote-box corner artifact on 10 slides, shorten slide-12 eyebrow to one line
</commit_message>
<xml_diff>
--- a/eTeacher_Longevity_PR_Campaign.pptx
+++ b/eTeacher_Longevity_PR_Campaign.pptx
@@ -4140,8 +4140,8 @@
         </p:nvSpPr>
         <p:spPr>
           <a:xfrm>
-            <a:off x="640080" y="5285232"/>
-            <a:ext cx="73152" cy="1005840"/>
+            <a:off x="640080" y="5340096"/>
+            <a:ext cx="73152" cy="896112"/>
           </a:xfrm>
           <a:prstGeom prst="rect">
             <a:avLst/>
@@ -4640,7 +4640,7 @@
                 <a:ea typeface="Calibri" pitchFamily="34" charset="-122"/>
                 <a:cs typeface="Calibri" pitchFamily="34" charset="-120"/>
               </a:rPr>
-              <a:t>THE SIGNING ANNOUNCEMENT — THE WOMAN WHO OUT-AGED BRYAN JOHNSON JOINS THE FACULTY</a:t>
+              <a:t>THE SIGNING ANNOUNCEMENT — JULIE JOINS THE FACULTY</a:t>
             </a:r>
             <a:endParaRPr lang="en-US" sz="1050" dirty="0"/>
           </a:p>
@@ -5010,8 +5010,8 @@
         </p:nvSpPr>
         <p:spPr>
           <a:xfrm>
-            <a:off x="640080" y="5138928"/>
-            <a:ext cx="73152" cy="1152144"/>
+            <a:off x="640080" y="5193792"/>
+            <a:ext cx="73152" cy="1042416"/>
           </a:xfrm>
           <a:prstGeom prst="rect">
             <a:avLst/>
@@ -5177,8 +5177,8 @@
         </p:nvSpPr>
         <p:spPr>
           <a:xfrm>
-            <a:off x="6233008" y="5138928"/>
-            <a:ext cx="73152" cy="1152144"/>
+            <a:off x="6233008" y="5193792"/>
+            <a:ext cx="73152" cy="1042416"/>
           </a:xfrm>
           <a:prstGeom prst="rect">
             <a:avLst/>
@@ -5797,8 +5797,8 @@
         </p:nvSpPr>
         <p:spPr>
           <a:xfrm>
-            <a:off x="640080" y="5138928"/>
-            <a:ext cx="73152" cy="1152144"/>
+            <a:off x="640080" y="5193792"/>
+            <a:ext cx="73152" cy="1042416"/>
           </a:xfrm>
           <a:prstGeom prst="rect">
             <a:avLst/>
@@ -5964,8 +5964,8 @@
         </p:nvSpPr>
         <p:spPr>
           <a:xfrm>
-            <a:off x="6233008" y="5138928"/>
-            <a:ext cx="73152" cy="1152144"/>
+            <a:off x="6233008" y="5193792"/>
+            <a:ext cx="73152" cy="1042416"/>
           </a:xfrm>
           <a:prstGeom prst="rect">
             <a:avLst/>
@@ -6584,8 +6584,8 @@
         </p:nvSpPr>
         <p:spPr>
           <a:xfrm>
-            <a:off x="640080" y="5138928"/>
-            <a:ext cx="73152" cy="1152144"/>
+            <a:off x="640080" y="5193792"/>
+            <a:ext cx="73152" cy="1042416"/>
           </a:xfrm>
           <a:prstGeom prst="rect">
             <a:avLst/>
@@ -6751,8 +6751,8 @@
         </p:nvSpPr>
         <p:spPr>
           <a:xfrm>
-            <a:off x="6233008" y="5138928"/>
-            <a:ext cx="73152" cy="1152144"/>
+            <a:off x="6233008" y="5193792"/>
+            <a:ext cx="73152" cy="1042416"/>
           </a:xfrm>
           <a:prstGeom prst="rect">
             <a:avLst/>
@@ -7376,8 +7376,8 @@
         </p:nvSpPr>
         <p:spPr>
           <a:xfrm>
-            <a:off x="640080" y="5285232"/>
-            <a:ext cx="73152" cy="1005840"/>
+            <a:off x="640080" y="5340096"/>
+            <a:ext cx="73152" cy="896112"/>
           </a:xfrm>
           <a:prstGeom prst="rect">
             <a:avLst/>
@@ -7996,8 +7996,8 @@
         </p:nvSpPr>
         <p:spPr>
           <a:xfrm>
-            <a:off x="640080" y="5138928"/>
-            <a:ext cx="73152" cy="1152144"/>
+            <a:off x="640080" y="5193792"/>
+            <a:ext cx="73152" cy="1042416"/>
           </a:xfrm>
           <a:prstGeom prst="rect">
             <a:avLst/>
@@ -8163,8 +8163,8 @@
         </p:nvSpPr>
         <p:spPr>
           <a:xfrm>
-            <a:off x="6233008" y="5138928"/>
-            <a:ext cx="73152" cy="1152144"/>
+            <a:off x="6233008" y="5193792"/>
+            <a:ext cx="73152" cy="1042416"/>
           </a:xfrm>
           <a:prstGeom prst="rect">
             <a:avLst/>
@@ -8788,8 +8788,8 @@
         </p:nvSpPr>
         <p:spPr>
           <a:xfrm>
-            <a:off x="640080" y="5285232"/>
-            <a:ext cx="73152" cy="1005840"/>
+            <a:off x="640080" y="5340096"/>
+            <a:ext cx="73152" cy="896112"/>
           </a:xfrm>
           <a:prstGeom prst="rect">
             <a:avLst/>
@@ -9413,8 +9413,8 @@
         </p:nvSpPr>
         <p:spPr>
           <a:xfrm>
-            <a:off x="640080" y="5285232"/>
-            <a:ext cx="73152" cy="1005840"/>
+            <a:off x="640080" y="5340096"/>
+            <a:ext cx="73152" cy="896112"/>
           </a:xfrm>
           <a:prstGeom prst="rect">
             <a:avLst/>
@@ -11448,8 +11448,8 @@
         </p:nvSpPr>
         <p:spPr>
           <a:xfrm>
-            <a:off x="640080" y="5285232"/>
-            <a:ext cx="73152" cy="1005840"/>
+            <a:off x="640080" y="5340096"/>
+            <a:ext cx="73152" cy="896112"/>
           </a:xfrm>
           <a:prstGeom prst="rect">
             <a:avLst/>
@@ -12068,8 +12068,8 @@
         </p:nvSpPr>
         <p:spPr>
           <a:xfrm>
-            <a:off x="640080" y="5285232"/>
-            <a:ext cx="73152" cy="1005840"/>
+            <a:off x="640080" y="5340096"/>
+            <a:ext cx="73152" cy="896112"/>
           </a:xfrm>
           <a:prstGeom prst="rect">
             <a:avLst/>
@@ -12938,8 +12938,8 @@
         </p:nvSpPr>
         <p:spPr>
           <a:xfrm>
-            <a:off x="640080" y="5285232"/>
-            <a:ext cx="73152" cy="1005840"/>
+            <a:off x="640080" y="5340096"/>
+            <a:ext cx="73152" cy="896112"/>
           </a:xfrm>
           <a:prstGeom prst="rect">
             <a:avLst/>
@@ -13558,8 +13558,8 @@
         </p:nvSpPr>
         <p:spPr>
           <a:xfrm>
-            <a:off x="640080" y="5285232"/>
-            <a:ext cx="73152" cy="1005840"/>
+            <a:off x="640080" y="5340096"/>
+            <a:ext cx="73152" cy="896112"/>
           </a:xfrm>
           <a:prstGeom prst="rect">
             <a:avLst/>
@@ -15105,7 +15105,7 @@
                 <a:ea typeface="Calibri" pitchFamily="34" charset="-122"/>
                 <a:cs typeface="Calibri" pitchFamily="34" charset="-120"/>
               </a:rPr>
-              <a:t>Timeframe: each wave runs on a ~2-week cycle — wire + exclusive day 1, direct pitching days 1–5, broadcast/podcast days 3–10, amplification days 5–14. Waves are spaced 3–4 weeks apart to compound coverage.</a:t>
+              <a:t>Timeframe: each wave runs on a ~2-week cycle — wire + exclusive day 1, direct pitching days 1–5, broadcast/podcast days 3–10, amplification days 5–14. Waves are spaced about 2.5 weeks apart so each earns coverage before the next begins.</a:t>
             </a:r>
             <a:endParaRPr lang="en-US" sz="1150" dirty="0"/>
           </a:p>
@@ -21511,8 +21511,8 @@
         </p:nvSpPr>
         <p:spPr>
           <a:xfrm>
-            <a:off x="640080" y="5285232"/>
-            <a:ext cx="73152" cy="1005840"/>
+            <a:off x="640080" y="5340096"/>
+            <a:ext cx="73152" cy="896112"/>
           </a:xfrm>
           <a:prstGeom prst="rect">
             <a:avLst/>
@@ -22131,8 +22131,8 @@
         </p:nvSpPr>
         <p:spPr>
           <a:xfrm>
-            <a:off x="640080" y="5285232"/>
-            <a:ext cx="73152" cy="1005840"/>
+            <a:off x="640080" y="5340096"/>
+            <a:ext cx="73152" cy="896112"/>
           </a:xfrm>
           <a:prstGeom prst="rect">
             <a:avLst/>
@@ -22751,8 +22751,8 @@
         </p:nvSpPr>
         <p:spPr>
           <a:xfrm>
-            <a:off x="640080" y="5285232"/>
-            <a:ext cx="73152" cy="1005840"/>
+            <a:off x="640080" y="5340096"/>
+            <a:ext cx="73152" cy="896112"/>
           </a:xfrm>
           <a:prstGeom prst="rect">
             <a:avLst/>
@@ -23371,8 +23371,8 @@
         </p:nvSpPr>
         <p:spPr>
           <a:xfrm>
-            <a:off x="640080" y="5285232"/>
-            <a:ext cx="73152" cy="1005840"/>
+            <a:off x="640080" y="5340096"/>
+            <a:ext cx="73152" cy="896112"/>
           </a:xfrm>
           <a:prstGeom prst="rect">
             <a:avLst/>
@@ -23991,8 +23991,8 @@
         </p:nvSpPr>
         <p:spPr>
           <a:xfrm>
-            <a:off x="640080" y="5285232"/>
-            <a:ext cx="73152" cy="1005840"/>
+            <a:off x="640080" y="5340096"/>
+            <a:ext cx="73152" cy="896112"/>
           </a:xfrm>
           <a:prstGeom prst="rect">
             <a:avLst/>

</xml_diff>

<commit_message>
Bolder launch messaging: clearer cover, CHAPTER N OF 4 labels, bigger bold headlines + angle lines, simplified wave titles/subtitles
</commit_message>
<xml_diff>
--- a/eTeacher_Longevity_PR_Campaign.pptx
+++ b/eTeacher_Longevity_PR_Campaign.pptx
@@ -3523,8 +3523,8 @@
         </p:nvSpPr>
         <p:spPr>
           <a:xfrm>
-            <a:off x="640080" y="1920240"/>
-            <a:ext cx="10911535" cy="1280160"/>
+            <a:off x="640080" y="1874520"/>
+            <a:ext cx="10911535" cy="1463040"/>
           </a:xfrm>
           <a:prstGeom prst="rect">
             <a:avLst/>
@@ -3551,7 +3551,7 @@
                 <a:ea typeface="Cambria" pitchFamily="34" charset="-122"/>
                 <a:cs typeface="Cambria" pitchFamily="34" charset="-120"/>
               </a:rPr>
-              <a:t>The Longevity Communications Campaign</a:t>
+              <a:t>eTeacher Launches Longevity Life Academy</a:t>
             </a:r>
             <a:endParaRPr lang="en-US" sz="4600" dirty="0"/>
           </a:p>
@@ -3565,8 +3565,8 @@
         </p:nvSpPr>
         <p:spPr>
           <a:xfrm>
-            <a:off x="640080" y="3383280"/>
-            <a:ext cx="9601200" cy="1097280"/>
+            <a:off x="640080" y="3611880"/>
+            <a:ext cx="9875520" cy="1097280"/>
           </a:xfrm>
           <a:prstGeom prst="rect">
             <a:avLst/>
@@ -3585,7 +3585,7 @@
               <a:buNone/>
             </a:pPr>
             <a:r>
-              <a:rPr lang="en-US" sz="1600" dirty="0">
+              <a:rPr lang="en-US" sz="1700" dirty="0">
                 <a:solidFill>
                   <a:srgbClr val="C9D3DD"/>
                 </a:solidFill>
@@ -3593,9 +3593,9 @@
                 <a:ea typeface="Calibri" pitchFamily="34" charset="-122"/>
                 <a:cs typeface="Calibri" pitchFamily="34" charset="-120"/>
               </a:rPr>
-              <a:t>A phased, multi-wave PR program to establish eTeacher as the leader in accessible longevity education — building cumulative impact across 17 placements, four narrative waves, and a defined outlet strategy.</a:t>
-            </a:r>
-            <a:endParaRPr lang="en-US" sz="1600" dirty="0"/>
+              <a:t>The PR launch campaign for Israel's leading EdTech group — four chapters, 17 stories, one clear message: accessible, science-backed longevity education is here.</a:t>
+            </a:r>
+            <a:endParaRPr lang="en-US" sz="1700" dirty="0"/>
           </a:p>
         </p:txBody>
       </p:sp>
@@ -3837,8 +3837,8 @@
         </p:nvSpPr>
         <p:spPr>
           <a:xfrm>
-            <a:off x="640080" y="640080"/>
-            <a:ext cx="10911535" cy="841248"/>
+            <a:off x="640080" y="603504"/>
+            <a:ext cx="10911535" cy="896112"/>
           </a:xfrm>
           <a:prstGeom prst="rect">
             <a:avLst/>
@@ -3852,12 +3852,12 @@
           <a:p>
             <a:pPr indent="0" marL="0">
               <a:lnSpc>
-                <a:spcPct val="98000"/>
+                <a:spcPct val="96000"/>
               </a:lnSpc>
               <a:buNone/>
             </a:pPr>
             <a:r>
-              <a:rPr lang="en-US" sz="2200" b="1" dirty="0">
+              <a:rPr lang="en-US" sz="2600" b="1" dirty="0">
                 <a:solidFill>
                   <a:srgbClr val="0C2A43"/>
                 </a:solidFill>
@@ -3867,7 +3867,7 @@
               </a:rPr>
               <a:t>Longevity for Every Household: A Live Class, Small Groups, and a Glucose Monitor at Your Door</a:t>
             </a:r>
-            <a:endParaRPr lang="en-US" sz="2200" dirty="0"/>
+            <a:endParaRPr lang="en-US" sz="2600" dirty="0"/>
           </a:p>
         </p:txBody>
       </p:sp>
@@ -3879,8 +3879,8 @@
         </p:nvSpPr>
         <p:spPr>
           <a:xfrm>
-            <a:off x="640080" y="1517904"/>
-            <a:ext cx="10911535" cy="530352"/>
+            <a:off x="640080" y="1572768"/>
+            <a:ext cx="10911535" cy="512064"/>
           </a:xfrm>
           <a:prstGeom prst="rect">
             <a:avLst/>
@@ -3894,14 +3894,14 @@
           <a:p>
             <a:pPr indent="0" marL="0">
               <a:lnSpc>
-                <a:spcPct val="112000"/>
+                <a:spcPct val="110000"/>
               </a:lnSpc>
               <a:buNone/>
             </a:pPr>
             <a:r>
-              <a:rPr lang="en-US" sz="1250" i="1" dirty="0">
-                <a:solidFill>
-                  <a:srgbClr val="5C6672"/>
+              <a:rPr lang="en-US" sz="1350" b="1" i="1" dirty="0">
+                <a:solidFill>
+                  <a:srgbClr val="1A1F26"/>
                 </a:solidFill>
                 <a:latin typeface="Calibri" pitchFamily="34" charset="0"/>
                 <a:ea typeface="Calibri" pitchFamily="34" charset="-122"/>
@@ -3909,7 +3909,7 @@
               </a:rPr>
               <a:t>Longevity Life Academy wants to make the science of healthy aging as approachable as a weekly class — for 8–15 students at a time, glucose monitor included.</a:t>
             </a:r>
-            <a:endParaRPr lang="en-US" sz="1250" dirty="0"/>
+            <a:endParaRPr lang="en-US" sz="1350" dirty="0"/>
           </a:p>
         </p:txBody>
       </p:sp>
@@ -3921,7 +3921,7 @@
         </p:nvSpPr>
         <p:spPr>
           <a:xfrm>
-            <a:off x="640080" y="2139696"/>
+            <a:off x="640080" y="2194560"/>
             <a:ext cx="10911535" cy="0"/>
           </a:xfrm>
           <a:prstGeom prst="line">
@@ -4371,8 +4371,8 @@
         </p:nvSpPr>
         <p:spPr>
           <a:xfrm>
-            <a:off x="640080" y="2377440"/>
-            <a:ext cx="10911535" cy="457200"/>
+            <a:off x="640080" y="1965960"/>
+            <a:ext cx="10911535" cy="365760"/>
           </a:xfrm>
           <a:prstGeom prst="rect">
             <a:avLst/>
@@ -4388,7 +4388,7 @@
               <a:buNone/>
             </a:pPr>
             <a:r>
-              <a:rPr lang="en-US" sz="1600" b="1" spc="300" kern="0" dirty="0">
+              <a:rPr lang="en-US" sz="1500" b="1" spc="400" kern="0" dirty="0">
                 <a:solidFill>
                   <a:srgbClr val="C08A2E"/>
                 </a:solidFill>
@@ -4396,9 +4396,9 @@
                 <a:ea typeface="Calibri" pitchFamily="34" charset="-122"/>
                 <a:cs typeface="Calibri" pitchFamily="34" charset="-120"/>
               </a:rPr>
-              <a:t>WAVE 2</a:t>
-            </a:r>
-            <a:endParaRPr lang="en-US" sz="1600" dirty="0"/>
+              <a:t>CHAPTER 2 OF 4</a:t>
+            </a:r>
+            <a:endParaRPr lang="en-US" sz="1500" dirty="0"/>
           </a:p>
         </p:txBody>
       </p:sp>
@@ -4410,8 +4410,8 @@
         </p:nvSpPr>
         <p:spPr>
           <a:xfrm>
-            <a:off x="640080" y="2880360"/>
-            <a:ext cx="10911535" cy="914400"/>
+            <a:off x="640080" y="2514600"/>
+            <a:ext cx="10911535" cy="1463040"/>
           </a:xfrm>
           <a:prstGeom prst="rect">
             <a:avLst/>
@@ -4424,10 +4424,13 @@
           <a:lstStyle/>
           <a:p>
             <a:pPr indent="0" marL="0">
-              <a:buNone/>
-            </a:pPr>
-            <a:r>
-              <a:rPr lang="en-US" sz="3400" b="1" dirty="0">
+              <a:lnSpc>
+                <a:spcPct val="100000"/>
+              </a:lnSpc>
+              <a:buNone/>
+            </a:pPr>
+            <a:r>
+              <a:rPr lang="en-US" sz="4200" b="1" dirty="0">
                 <a:solidFill>
                   <a:srgbClr val="FFFFFF"/>
                 </a:solidFill>
@@ -4435,9 +4438,9 @@
                 <a:ea typeface="Cambria" pitchFamily="34" charset="-122"/>
                 <a:cs typeface="Cambria" pitchFamily="34" charset="-120"/>
               </a:rPr>
-              <a:t>Julie Gibson Clark Joins Longevity Life Academy</a:t>
-            </a:r>
-            <a:endParaRPr lang="en-US" sz="3400" dirty="0"/>
+              <a:t>Julie Joins eTeacher's Longevity Life Academy</a:t>
+            </a:r>
+            <a:endParaRPr lang="en-US" sz="4200" dirty="0"/>
           </a:p>
         </p:txBody>
       </p:sp>
@@ -4449,8 +4452,8 @@
         </p:nvSpPr>
         <p:spPr>
           <a:xfrm>
-            <a:off x="640080" y="3977640"/>
-            <a:ext cx="10058400" cy="914400"/>
+            <a:off x="640080" y="4297680"/>
+            <a:ext cx="10241280" cy="914400"/>
           </a:xfrm>
           <a:prstGeom prst="rect">
             <a:avLst/>
@@ -4469,7 +4472,7 @@
               <a:buNone/>
             </a:pPr>
             <a:r>
-              <a:rPr lang="en-US" sz="1500" dirty="0">
+              <a:rPr lang="en-US" sz="1700" dirty="0">
                 <a:solidFill>
                   <a:srgbClr val="C9D3DD"/>
                 </a:solidFill>
@@ -4477,9 +4480,9 @@
                 <a:ea typeface="Calibri" pitchFamily="34" charset="-122"/>
                 <a:cs typeface="Calibri" pitchFamily="34" charset="-120"/>
               </a:rPr>
-              <a:t>Seven distinct stories leveraging Julie's existing press: the single mom who out-aged the billionaires now teaches live for eTeacher.</a:t>
-            </a:r>
-            <a:endParaRPr lang="en-US" sz="1500" dirty="0"/>
+              <a:t>One message: the single mom who out-aged the billionaires now teaches live for eTeacher.</a:t>
+            </a:r>
+            <a:endParaRPr lang="en-US" sz="1700" dirty="0"/>
           </a:p>
         </p:txBody>
       </p:sp>
@@ -4491,7 +4494,7 @@
         </p:nvSpPr>
         <p:spPr>
           <a:xfrm>
-            <a:off x="640080" y="5029200"/>
+            <a:off x="640080" y="5394960"/>
             <a:ext cx="3657600" cy="365760"/>
           </a:xfrm>
           <a:prstGeom prst="rect">
@@ -4707,8 +4710,8 @@
         </p:nvSpPr>
         <p:spPr>
           <a:xfrm>
-            <a:off x="640080" y="640080"/>
-            <a:ext cx="10911535" cy="841248"/>
+            <a:off x="640080" y="603504"/>
+            <a:ext cx="10911535" cy="896112"/>
           </a:xfrm>
           <a:prstGeom prst="rect">
             <a:avLst/>
@@ -4722,12 +4725,12 @@
           <a:p>
             <a:pPr indent="0" marL="0">
               <a:lnSpc>
-                <a:spcPct val="98000"/>
+                <a:spcPct val="96000"/>
               </a:lnSpc>
               <a:buNone/>
             </a:pPr>
             <a:r>
-              <a:rPr lang="en-US" sz="2200" b="1" dirty="0">
+              <a:rPr lang="en-US" sz="2600" b="1" dirty="0">
                 <a:solidFill>
                   <a:srgbClr val="0C2A43"/>
                 </a:solidFill>
@@ -4737,7 +4740,7 @@
               </a:rPr>
               <a:t>Julie Gibson Clark — Who Out-Aged Bryan Johnson at the Rejuvenation Olympics — Joins eTeacher's Longevity Life Academy Faculty</a:t>
             </a:r>
-            <a:endParaRPr lang="en-US" sz="2200" dirty="0"/>
+            <a:endParaRPr lang="en-US" sz="2600" dirty="0"/>
           </a:p>
         </p:txBody>
       </p:sp>
@@ -4749,8 +4752,8 @@
         </p:nvSpPr>
         <p:spPr>
           <a:xfrm>
-            <a:off x="640080" y="1517904"/>
-            <a:ext cx="10911535" cy="530352"/>
+            <a:off x="640080" y="1572768"/>
+            <a:ext cx="10911535" cy="512064"/>
           </a:xfrm>
           <a:prstGeom prst="rect">
             <a:avLst/>
@@ -4764,14 +4767,14 @@
           <a:p>
             <a:pPr indent="0" marL="0">
               <a:lnSpc>
-                <a:spcPct val="112000"/>
+                <a:spcPct val="110000"/>
               </a:lnSpc>
               <a:buNone/>
             </a:pPr>
             <a:r>
-              <a:rPr lang="en-US" sz="1250" i="1" dirty="0">
-                <a:solidFill>
-                  <a:srgbClr val="5C6672"/>
+              <a:rPr lang="en-US" sz="1350" b="1" i="1" dirty="0">
+                <a:solidFill>
+                  <a:srgbClr val="1A1F26"/>
                 </a:solidFill>
                 <a:latin typeface="Calibri" pitchFamily="34" charset="0"/>
                 <a:ea typeface="Calibri" pitchFamily="34" charset="-122"/>
@@ -4779,7 +4782,7 @@
               </a:rPr>
               <a:t>The Phoenix single mom who held second place on the Rejuvenation Olympics for over a year — ahead of Bryan Johnson — will teach live cohorts inside the 18-week Longevity Blueprint.</a:t>
             </a:r>
-            <a:endParaRPr lang="en-US" sz="1250" dirty="0"/>
+            <a:endParaRPr lang="en-US" sz="1350" dirty="0"/>
           </a:p>
         </p:txBody>
       </p:sp>
@@ -4791,7 +4794,7 @@
         </p:nvSpPr>
         <p:spPr>
           <a:xfrm>
-            <a:off x="640080" y="2139696"/>
+            <a:off x="640080" y="2194560"/>
             <a:ext cx="10911535" cy="0"/>
           </a:xfrm>
           <a:prstGeom prst="line">
@@ -5494,8 +5497,8 @@
         </p:nvSpPr>
         <p:spPr>
           <a:xfrm>
-            <a:off x="640080" y="640080"/>
-            <a:ext cx="10911535" cy="841248"/>
+            <a:off x="640080" y="603504"/>
+            <a:ext cx="10911535" cy="896112"/>
           </a:xfrm>
           <a:prstGeom prst="rect">
             <a:avLst/>
@@ -5509,12 +5512,12 @@
           <a:p>
             <a:pPr indent="0" marL="0">
               <a:lnSpc>
-                <a:spcPct val="98000"/>
+                <a:spcPct val="96000"/>
               </a:lnSpc>
               <a:buNone/>
             </a:pPr>
             <a:r>
-              <a:rPr lang="en-US" sz="2200" b="1" dirty="0">
+              <a:rPr lang="en-US" sz="2600" b="1" dirty="0">
                 <a:solidFill>
                   <a:srgbClr val="0C2A43"/>
                 </a:solidFill>
@@ -5524,7 +5527,7 @@
               </a:rPr>
               <a:t>She Out-Aged a Man Spending $2 Million a Year — on About $12 a Day</a:t>
             </a:r>
-            <a:endParaRPr lang="en-US" sz="2200" dirty="0"/>
+            <a:endParaRPr lang="en-US" sz="2600" dirty="0"/>
           </a:p>
         </p:txBody>
       </p:sp>
@@ -5536,8 +5539,8 @@
         </p:nvSpPr>
         <p:spPr>
           <a:xfrm>
-            <a:off x="640080" y="1517904"/>
-            <a:ext cx="10911535" cy="530352"/>
+            <a:off x="640080" y="1572768"/>
+            <a:ext cx="10911535" cy="512064"/>
           </a:xfrm>
           <a:prstGeom prst="rect">
             <a:avLst/>
@@ -5551,14 +5554,14 @@
           <a:p>
             <a:pPr indent="0" marL="0">
               <a:lnSpc>
-                <a:spcPct val="112000"/>
+                <a:spcPct val="110000"/>
               </a:lnSpc>
               <a:buNone/>
             </a:pPr>
             <a:r>
-              <a:rPr lang="en-US" sz="1250" i="1" dirty="0">
-                <a:solidFill>
-                  <a:srgbClr val="5C6672"/>
+              <a:rPr lang="en-US" sz="1350" b="1" i="1" dirty="0">
+                <a:solidFill>
+                  <a:srgbClr val="1A1F26"/>
                 </a:solidFill>
                 <a:latin typeface="Calibri" pitchFamily="34" charset="0"/>
                 <a:ea typeface="Calibri" pitchFamily="34" charset="-122"/>
@@ -5566,7 +5569,7 @@
               </a:rPr>
               <a:t>Julie Gibson Clark's budget longevity results ranked her #2 in the world; now she's teaching the method inside a course that starts at $289 a month.</a:t>
             </a:r>
-            <a:endParaRPr lang="en-US" sz="1250" dirty="0"/>
+            <a:endParaRPr lang="en-US" sz="1350" dirty="0"/>
           </a:p>
         </p:txBody>
       </p:sp>
@@ -5578,7 +5581,7 @@
         </p:nvSpPr>
         <p:spPr>
           <a:xfrm>
-            <a:off x="640080" y="2139696"/>
+            <a:off x="640080" y="2194560"/>
             <a:ext cx="10911535" cy="0"/>
           </a:xfrm>
           <a:prstGeom prst="line">
@@ -6281,8 +6284,8 @@
         </p:nvSpPr>
         <p:spPr>
           <a:xfrm>
-            <a:off x="640080" y="640080"/>
-            <a:ext cx="10911535" cy="841248"/>
+            <a:off x="640080" y="603504"/>
+            <a:ext cx="10911535" cy="896112"/>
           </a:xfrm>
           <a:prstGeom prst="rect">
             <a:avLst/>
@@ -6296,12 +6299,12 @@
           <a:p>
             <a:pPr indent="0" marL="0">
               <a:lnSpc>
-                <a:spcPct val="98000"/>
+                <a:spcPct val="96000"/>
               </a:lnSpc>
               <a:buNone/>
             </a:pPr>
             <a:r>
-              <a:rPr lang="en-US" sz="2200" b="1" dirty="0">
+              <a:rPr lang="en-US" sz="2600" b="1" dirty="0">
                 <a:solidFill>
                   <a:srgbClr val="0C2A43"/>
                 </a:solidFill>
@@ -6311,7 +6314,7 @@
               </a:rPr>
               <a:t>“My Why Is My Son”: The Mom Who Slowed Her Aging Is Now Teaching America</a:t>
             </a:r>
-            <a:endParaRPr lang="en-US" sz="2200" dirty="0"/>
+            <a:endParaRPr lang="en-US" sz="2600" dirty="0"/>
           </a:p>
         </p:txBody>
       </p:sp>
@@ -6323,8 +6326,8 @@
         </p:nvSpPr>
         <p:spPr>
           <a:xfrm>
-            <a:off x="640080" y="1517904"/>
-            <a:ext cx="10911535" cy="530352"/>
+            <a:off x="640080" y="1572768"/>
+            <a:ext cx="10911535" cy="512064"/>
           </a:xfrm>
           <a:prstGeom prst="rect">
             <a:avLst/>
@@ -6338,14 +6341,14 @@
           <a:p>
             <a:pPr indent="0" marL="0">
               <a:lnSpc>
-                <a:spcPct val="112000"/>
+                <a:spcPct val="110000"/>
               </a:lnSpc>
               <a:buNone/>
             </a:pPr>
             <a:r>
-              <a:rPr lang="en-US" sz="1250" i="1" dirty="0">
-                <a:solidFill>
-                  <a:srgbClr val="5C6672"/>
+              <a:rPr lang="en-US" sz="1350" b="1" i="1" dirty="0">
+                <a:solidFill>
+                  <a:srgbClr val="1A1F26"/>
                 </a:solidFill>
                 <a:latin typeface="Calibri" pitchFamily="34" charset="0"/>
                 <a:ea typeface="Calibri" pitchFamily="34" charset="-122"/>
@@ -6353,7 +6356,7 @@
               </a:rPr>
               <a:t>Julie Gibson Clark's motivation was never a leaderboard — it was being there for her son. Now she's helping thousands find their own why.</a:t>
             </a:r>
-            <a:endParaRPr lang="en-US" sz="1250" dirty="0"/>
+            <a:endParaRPr lang="en-US" sz="1350" dirty="0"/>
           </a:p>
         </p:txBody>
       </p:sp>
@@ -6365,7 +6368,7 @@
         </p:nvSpPr>
         <p:spPr>
           <a:xfrm>
-            <a:off x="640080" y="2139696"/>
+            <a:off x="640080" y="2194560"/>
             <a:ext cx="10911535" cy="0"/>
           </a:xfrm>
           <a:prstGeom prst="line">
@@ -7068,8 +7071,8 @@
         </p:nvSpPr>
         <p:spPr>
           <a:xfrm>
-            <a:off x="640080" y="640080"/>
-            <a:ext cx="10911535" cy="841248"/>
+            <a:off x="640080" y="603504"/>
+            <a:ext cx="10911535" cy="896112"/>
           </a:xfrm>
           <a:prstGeom prst="rect">
             <a:avLst/>
@@ -7083,12 +7086,12 @@
           <a:p>
             <a:pPr indent="0" marL="0">
               <a:lnSpc>
-                <a:spcPct val="98000"/>
+                <a:spcPct val="96000"/>
               </a:lnSpc>
               <a:buNone/>
             </a:pPr>
             <a:r>
-              <a:rPr lang="en-US" sz="2200" b="1" dirty="0">
+              <a:rPr lang="en-US" sz="2600" b="1" dirty="0">
                 <a:solidFill>
                   <a:srgbClr val="0C2A43"/>
                 </a:solidFill>
@@ -7098,7 +7101,7 @@
               </a:rPr>
               <a:t>What a 0.665 DunedinPACE Score Actually Proves — and Why Julie Gibson Clark Is Teaching It</a:t>
             </a:r>
-            <a:endParaRPr lang="en-US" sz="2200" dirty="0"/>
+            <a:endParaRPr lang="en-US" sz="2600" dirty="0"/>
           </a:p>
         </p:txBody>
       </p:sp>
@@ -7110,8 +7113,8 @@
         </p:nvSpPr>
         <p:spPr>
           <a:xfrm>
-            <a:off x="640080" y="1517904"/>
-            <a:ext cx="10911535" cy="530352"/>
+            <a:off x="640080" y="1572768"/>
+            <a:ext cx="10911535" cy="512064"/>
           </a:xfrm>
           <a:prstGeom prst="rect">
             <a:avLst/>
@@ -7125,14 +7128,14 @@
           <a:p>
             <a:pPr indent="0" marL="0">
               <a:lnSpc>
-                <a:spcPct val="112000"/>
+                <a:spcPct val="110000"/>
               </a:lnSpc>
               <a:buNone/>
             </a:pPr>
             <a:r>
-              <a:rPr lang="en-US" sz="1250" i="1" dirty="0">
-                <a:solidFill>
-                  <a:srgbClr val="5C6672"/>
+              <a:rPr lang="en-US" sz="1350" b="1" i="1" dirty="0">
+                <a:solidFill>
+                  <a:srgbClr val="1A1F26"/>
                 </a:solidFill>
                 <a:latin typeface="Calibri" pitchFamily="34" charset="0"/>
                 <a:ea typeface="Calibri" pitchFamily="34" charset="-122"/>
@@ -7140,7 +7143,7 @@
               </a:rPr>
               <a:t>Her biomarker data suggests she ages about 34% slower than average; at Longevity Life Academy she'll teach the strength, protein, and VO2-max fundamentals behind it.</a:t>
             </a:r>
-            <a:endParaRPr lang="en-US" sz="1250" dirty="0"/>
+            <a:endParaRPr lang="en-US" sz="1350" dirty="0"/>
           </a:p>
         </p:txBody>
       </p:sp>
@@ -7152,7 +7155,7 @@
         </p:nvSpPr>
         <p:spPr>
           <a:xfrm>
-            <a:off x="640080" y="2139696"/>
+            <a:off x="640080" y="2194560"/>
             <a:ext cx="10911535" cy="0"/>
           </a:xfrm>
           <a:prstGeom prst="line">
@@ -7693,8 +7696,8 @@
         </p:nvSpPr>
         <p:spPr>
           <a:xfrm>
-            <a:off x="640080" y="640080"/>
-            <a:ext cx="10911535" cy="841248"/>
+            <a:off x="640080" y="603504"/>
+            <a:ext cx="10911535" cy="896112"/>
           </a:xfrm>
           <a:prstGeom prst="rect">
             <a:avLst/>
@@ -7708,12 +7711,12 @@
           <a:p>
             <a:pPr indent="0" marL="0">
               <a:lnSpc>
-                <a:spcPct val="98000"/>
+                <a:spcPct val="96000"/>
               </a:lnSpc>
               <a:buNone/>
             </a:pPr>
             <a:r>
-              <a:rPr lang="en-US" sz="2200" b="1" dirty="0">
+              <a:rPr lang="en-US" sz="2600" b="1" dirty="0">
                 <a:solidFill>
                   <a:srgbClr val="0C2A43"/>
                 </a:solidFill>
@@ -7723,7 +7726,7 @@
               </a:rPr>
               <a:t>Longevity Has a Class Problem. This Partnership Is Built to Fix It.</a:t>
             </a:r>
-            <a:endParaRPr lang="en-US" sz="2200" dirty="0"/>
+            <a:endParaRPr lang="en-US" sz="2600" dirty="0"/>
           </a:p>
         </p:txBody>
       </p:sp>
@@ -7735,8 +7738,8 @@
         </p:nvSpPr>
         <p:spPr>
           <a:xfrm>
-            <a:off x="640080" y="1517904"/>
-            <a:ext cx="10911535" cy="530352"/>
+            <a:off x="640080" y="1572768"/>
+            <a:ext cx="10911535" cy="512064"/>
           </a:xfrm>
           <a:prstGeom prst="rect">
             <a:avLst/>
@@ -7750,14 +7753,14 @@
           <a:p>
             <a:pPr indent="0" marL="0">
               <a:lnSpc>
-                <a:spcPct val="112000"/>
+                <a:spcPct val="110000"/>
               </a:lnSpc>
               <a:buNone/>
             </a:pPr>
             <a:r>
-              <a:rPr lang="en-US" sz="1250" i="1" dirty="0">
-                <a:solidFill>
-                  <a:srgbClr val="5C6672"/>
+              <a:rPr lang="en-US" sz="1350" b="1" i="1" dirty="0">
+                <a:solidFill>
+                  <a:srgbClr val="1A1F26"/>
                 </a:solidFill>
                 <a:latin typeface="Calibri" pitchFamily="34" charset="0"/>
                 <a:ea typeface="Calibri" pitchFamily="34" charset="-122"/>
@@ -7765,7 +7768,7 @@
               </a:rPr>
               <a:t>An accessible-longevity advocate on $12 a day and a 25-year education company are betting healthspan can be democratized — in an $8 trillion market that mostly serves the wealthy.</a:t>
             </a:r>
-            <a:endParaRPr lang="en-US" sz="1250" dirty="0"/>
+            <a:endParaRPr lang="en-US" sz="1350" dirty="0"/>
           </a:p>
         </p:txBody>
       </p:sp>
@@ -7777,7 +7780,7 @@
         </p:nvSpPr>
         <p:spPr>
           <a:xfrm>
-            <a:off x="640080" y="2139696"/>
+            <a:off x="640080" y="2194560"/>
             <a:ext cx="10911535" cy="0"/>
           </a:xfrm>
           <a:prstGeom prst="line">
@@ -8480,8 +8483,8 @@
         </p:nvSpPr>
         <p:spPr>
           <a:xfrm>
-            <a:off x="640080" y="640080"/>
-            <a:ext cx="10911535" cy="841248"/>
+            <a:off x="640080" y="603504"/>
+            <a:ext cx="10911535" cy="896112"/>
           </a:xfrm>
           <a:prstGeom prst="rect">
             <a:avLst/>
@@ -8495,12 +8498,12 @@
           <a:p>
             <a:pPr indent="0" marL="0">
               <a:lnSpc>
-                <a:spcPct val="98000"/>
+                <a:spcPct val="96000"/>
               </a:lnSpc>
               <a:buNone/>
             </a:pPr>
             <a:r>
-              <a:rPr lang="en-US" sz="2200" b="1" dirty="0">
+              <a:rPr lang="en-US" sz="2600" b="1" dirty="0">
                 <a:solidFill>
                   <a:srgbClr val="0C2A43"/>
                 </a:solidFill>
@@ -8510,7 +8513,7 @@
               </a:rPr>
               <a:t>One Habit at a Time: What Julie Gibson Clark Will Teach Inside the Longevity Blueprint</a:t>
             </a:r>
-            <a:endParaRPr lang="en-US" sz="2200" dirty="0"/>
+            <a:endParaRPr lang="en-US" sz="2600" dirty="0"/>
           </a:p>
         </p:txBody>
       </p:sp>
@@ -8522,8 +8525,8 @@
         </p:nvSpPr>
         <p:spPr>
           <a:xfrm>
-            <a:off x="640080" y="1517904"/>
-            <a:ext cx="10911535" cy="530352"/>
+            <a:off x="640080" y="1572768"/>
+            <a:ext cx="10911535" cy="512064"/>
           </a:xfrm>
           <a:prstGeom prst="rect">
             <a:avLst/>
@@ -8537,14 +8540,14 @@
           <a:p>
             <a:pPr indent="0" marL="0">
               <a:lnSpc>
-                <a:spcPct val="112000"/>
+                <a:spcPct val="110000"/>
               </a:lnSpc>
               <a:buNone/>
             </a:pPr>
             <a:r>
-              <a:rPr lang="en-US" sz="1250" i="1" dirty="0">
-                <a:solidFill>
-                  <a:srgbClr val="5C6672"/>
+              <a:rPr lang="en-US" sz="1350" b="1" i="1" dirty="0">
+                <a:solidFill>
+                  <a:srgbClr val="1A1F26"/>
                 </a:solidFill>
                 <a:latin typeface="Calibri" pitchFamily="34" charset="0"/>
                 <a:ea typeface="Calibri" pitchFamily="34" charset="-122"/>
@@ -8552,7 +8555,7 @@
               </a:rPr>
               <a:t>The recruiter who held the Rejuvenation Olympics #2 spot for over a year joins Longevity Life Academy to teach strength, protein, and sleep as the trainable foundations of a longer life.</a:t>
             </a:r>
-            <a:endParaRPr lang="en-US" sz="1250" dirty="0"/>
+            <a:endParaRPr lang="en-US" sz="1350" dirty="0"/>
           </a:p>
         </p:txBody>
       </p:sp>
@@ -8564,7 +8567,7 @@
         </p:nvSpPr>
         <p:spPr>
           <a:xfrm>
-            <a:off x="640080" y="2139696"/>
+            <a:off x="640080" y="2194560"/>
             <a:ext cx="10911535" cy="0"/>
           </a:xfrm>
           <a:prstGeom prst="line">
@@ -9105,8 +9108,8 @@
         </p:nvSpPr>
         <p:spPr>
           <a:xfrm>
-            <a:off x="640080" y="640080"/>
-            <a:ext cx="10911535" cy="841248"/>
+            <a:off x="640080" y="603504"/>
+            <a:ext cx="10911535" cy="896112"/>
           </a:xfrm>
           <a:prstGeom prst="rect">
             <a:avLst/>
@@ -9120,12 +9123,12 @@
           <a:p>
             <a:pPr indent="0" marL="0">
               <a:lnSpc>
-                <a:spcPct val="98000"/>
+                <a:spcPct val="96000"/>
               </a:lnSpc>
               <a:buNone/>
             </a:pPr>
             <a:r>
-              <a:rPr lang="en-US" sz="2200" b="1" dirty="0">
+              <a:rPr lang="en-US" sz="2600" b="1" dirty="0">
                 <a:solidFill>
                   <a:srgbClr val="0C2A43"/>
                 </a:solidFill>
@@ -9135,7 +9138,7 @@
               </a:rPr>
               <a:t>Meet the Single Mom Teaching America How to Age Slower — Live, Every Week</a:t>
             </a:r>
-            <a:endParaRPr lang="en-US" sz="2200" dirty="0"/>
+            <a:endParaRPr lang="en-US" sz="2600" dirty="0"/>
           </a:p>
         </p:txBody>
       </p:sp>
@@ -9147,8 +9150,8 @@
         </p:nvSpPr>
         <p:spPr>
           <a:xfrm>
-            <a:off x="640080" y="1517904"/>
-            <a:ext cx="10911535" cy="530352"/>
+            <a:off x="640080" y="1572768"/>
+            <a:ext cx="10911535" cy="512064"/>
           </a:xfrm>
           <a:prstGeom prst="rect">
             <a:avLst/>
@@ -9162,14 +9165,14 @@
           <a:p>
             <a:pPr indent="0" marL="0">
               <a:lnSpc>
-                <a:spcPct val="112000"/>
+                <a:spcPct val="110000"/>
               </a:lnSpc>
               <a:buNone/>
             </a:pPr>
             <a:r>
-              <a:rPr lang="en-US" sz="1250" i="1" dirty="0">
-                <a:solidFill>
-                  <a:srgbClr val="5C6672"/>
+              <a:rPr lang="en-US" sz="1350" b="1" i="1" dirty="0">
+                <a:solidFill>
+                  <a:srgbClr val="1A1F26"/>
                 </a:solidFill>
                 <a:latin typeface="Calibri" pitchFamily="34" charset="0"/>
                 <a:ea typeface="Calibri" pitchFamily="34" charset="-122"/>
@@ -9177,7 +9180,7 @@
               </a:rPr>
               <a:t>A ready-made morning-show segment: a $12-a-day routine that beat a $2-million budget, a glucose-monitor demo, and daily rituals viewers can start today.</a:t>
             </a:r>
-            <a:endParaRPr lang="en-US" sz="1250" dirty="0"/>
+            <a:endParaRPr lang="en-US" sz="1350" dirty="0"/>
           </a:p>
         </p:txBody>
       </p:sp>
@@ -9189,7 +9192,7 @@
         </p:nvSpPr>
         <p:spPr>
           <a:xfrm>
-            <a:off x="640080" y="2139696"/>
+            <a:off x="640080" y="2194560"/>
             <a:ext cx="10911535" cy="0"/>
           </a:xfrm>
           <a:prstGeom prst="line">
@@ -9644,8 +9647,8 @@
         </p:nvSpPr>
         <p:spPr>
           <a:xfrm>
-            <a:off x="640080" y="2377440"/>
-            <a:ext cx="10911535" cy="457200"/>
+            <a:off x="640080" y="1965960"/>
+            <a:ext cx="10911535" cy="365760"/>
           </a:xfrm>
           <a:prstGeom prst="rect">
             <a:avLst/>
@@ -9661,7 +9664,7 @@
               <a:buNone/>
             </a:pPr>
             <a:r>
-              <a:rPr lang="en-US" sz="1600" b="1" spc="300" kern="0" dirty="0">
+              <a:rPr lang="en-US" sz="1500" b="1" spc="400" kern="0" dirty="0">
                 <a:solidFill>
                   <a:srgbClr val="C08A2E"/>
                 </a:solidFill>
@@ -9669,9 +9672,9 @@
                 <a:ea typeface="Calibri" pitchFamily="34" charset="-122"/>
                 <a:cs typeface="Calibri" pitchFamily="34" charset="-120"/>
               </a:rPr>
-              <a:t>WAVE 3</a:t>
-            </a:r>
-            <a:endParaRPr lang="en-US" sz="1600" dirty="0"/>
+              <a:t>CHAPTER 3 OF 4</a:t>
+            </a:r>
+            <a:endParaRPr lang="en-US" sz="1500" dirty="0"/>
           </a:p>
         </p:txBody>
       </p:sp>
@@ -9683,8 +9686,8 @@
         </p:nvSpPr>
         <p:spPr>
           <a:xfrm>
-            <a:off x="640080" y="2880360"/>
-            <a:ext cx="10911535" cy="914400"/>
+            <a:off x="640080" y="2514600"/>
+            <a:ext cx="10911535" cy="1463040"/>
           </a:xfrm>
           <a:prstGeom prst="rect">
             <a:avLst/>
@@ -9697,10 +9700,13 @@
           <a:lstStyle/>
           <a:p>
             <a:pPr indent="0" marL="0">
-              <a:buNone/>
-            </a:pPr>
-            <a:r>
-              <a:rPr lang="en-US" sz="3400" b="1" dirty="0">
+              <a:lnSpc>
+                <a:spcPct val="100000"/>
+              </a:lnSpc>
+              <a:buNone/>
+            </a:pPr>
+            <a:r>
+              <a:rPr lang="en-US" sz="4200" b="1" dirty="0">
                 <a:solidFill>
                   <a:srgbClr val="FFFFFF"/>
                 </a:solidFill>
@@ -9710,7 +9716,7 @@
               </a:rPr>
               <a:t>The Longevity Hub App (Roadmap)</a:t>
             </a:r>
-            <a:endParaRPr lang="en-US" sz="3400" dirty="0"/>
+            <a:endParaRPr lang="en-US" sz="4200" dirty="0"/>
           </a:p>
         </p:txBody>
       </p:sp>
@@ -9722,8 +9728,8 @@
         </p:nvSpPr>
         <p:spPr>
           <a:xfrm>
-            <a:off x="640080" y="3977640"/>
-            <a:ext cx="10058400" cy="914400"/>
+            <a:off x="640080" y="4297680"/>
+            <a:ext cx="10241280" cy="914400"/>
           </a:xfrm>
           <a:prstGeom prst="rect">
             <a:avLst/>
@@ -9742,7 +9748,7 @@
               <a:buNone/>
             </a:pPr>
             <a:r>
-              <a:rPr lang="en-US" sz="1500" dirty="0">
+              <a:rPr lang="en-US" sz="1700" dirty="0">
                 <a:solidFill>
                   <a:srgbClr val="C9D3DD"/>
                 </a:solidFill>
@@ -9750,9 +9756,9 @@
                 <a:ea typeface="Calibri" pitchFamily="34" charset="-122"/>
                 <a:cs typeface="Calibri" pitchFamily="34" charset="-120"/>
               </a:rPr>
-              <a:t>eTeacher's longevity practice, coming to your pocket: a planned AI tutor, bite-size daily rituals, tracking, and lifestyle guidance — the 'gym for the brain' applied to healthspan.</a:t>
-            </a:r>
-            <a:endParaRPr lang="en-US" sz="1500" dirty="0"/>
+              <a:t>One message: eTeacher's longevity practice, in your pocket — a planned AI tutor and daily rituals, the 'gym for the brain' for healthspan.</a:t>
+            </a:r>
+            <a:endParaRPr lang="en-US" sz="1700" dirty="0"/>
           </a:p>
         </p:txBody>
       </p:sp>
@@ -9764,7 +9770,7 @@
         </p:nvSpPr>
         <p:spPr>
           <a:xfrm>
-            <a:off x="640080" y="5029200"/>
+            <a:off x="640080" y="5394960"/>
             <a:ext cx="3657600" cy="365760"/>
           </a:xfrm>
           <a:prstGeom prst="rect">
@@ -11145,8 +11151,8 @@
         </p:nvSpPr>
         <p:spPr>
           <a:xfrm>
-            <a:off x="640080" y="640080"/>
-            <a:ext cx="10911535" cy="841248"/>
+            <a:off x="640080" y="603504"/>
+            <a:ext cx="10911535" cy="896112"/>
           </a:xfrm>
           <a:prstGeom prst="rect">
             <a:avLst/>
@@ -11160,12 +11166,12 @@
           <a:p>
             <a:pPr indent="0" marL="0">
               <a:lnSpc>
-                <a:spcPct val="98000"/>
+                <a:spcPct val="96000"/>
               </a:lnSpc>
               <a:buNone/>
             </a:pPr>
             <a:r>
-              <a:rPr lang="en-US" sz="2200" b="1" dirty="0">
+              <a:rPr lang="en-US" sz="2600" b="1" dirty="0">
                 <a:solidFill>
                   <a:srgbClr val="0C2A43"/>
                 </a:solidFill>
@@ -11175,7 +11181,7 @@
               </a:rPr>
               <a:t>eTeacher to Launch the Longevity Hub: A Planned AI Tutor and Daily-Ritual Engine for Healthspan</a:t>
             </a:r>
-            <a:endParaRPr lang="en-US" sz="2200" dirty="0"/>
+            <a:endParaRPr lang="en-US" sz="2600" dirty="0"/>
           </a:p>
         </p:txBody>
       </p:sp>
@@ -11187,8 +11193,8 @@
         </p:nvSpPr>
         <p:spPr>
           <a:xfrm>
-            <a:off x="640080" y="1517904"/>
-            <a:ext cx="10911535" cy="530352"/>
+            <a:off x="640080" y="1572768"/>
+            <a:ext cx="10911535" cy="512064"/>
           </a:xfrm>
           <a:prstGeom prst="rect">
             <a:avLst/>
@@ -11202,14 +11208,14 @@
           <a:p>
             <a:pPr indent="0" marL="0">
               <a:lnSpc>
-                <a:spcPct val="112000"/>
+                <a:spcPct val="110000"/>
               </a:lnSpc>
               <a:buNone/>
             </a:pPr>
             <a:r>
-              <a:rPr lang="en-US" sz="1250" i="1" dirty="0">
-                <a:solidFill>
-                  <a:srgbClr val="5C6672"/>
+              <a:rPr lang="en-US" sz="1350" b="1" i="1" dirty="0">
+                <a:solidFill>
+                  <a:srgbClr val="1A1F26"/>
                 </a:solidFill>
                 <a:latin typeface="Calibri" pitchFamily="34" charset="0"/>
                 <a:ea typeface="Calibri" pitchFamily="34" charset="-122"/>
@@ -11217,7 +11223,7 @@
               </a:rPr>
               <a:t>The upcoming companion app will turn the 18-week Longevity Blueprint into simple, trackable daily rituals — guided by an AI longevity tutor built on eTeacher's “gym for the brain” model.</a:t>
             </a:r>
-            <a:endParaRPr lang="en-US" sz="1250" dirty="0"/>
+            <a:endParaRPr lang="en-US" sz="1350" dirty="0"/>
           </a:p>
         </p:txBody>
       </p:sp>
@@ -11229,7 +11235,7 @@
         </p:nvSpPr>
         <p:spPr>
           <a:xfrm>
-            <a:off x="640080" y="2139696"/>
+            <a:off x="640080" y="2194560"/>
             <a:ext cx="10911535" cy="0"/>
           </a:xfrm>
           <a:prstGeom prst="line">
@@ -11765,8 +11771,8 @@
         </p:nvSpPr>
         <p:spPr>
           <a:xfrm>
-            <a:off x="640080" y="640080"/>
-            <a:ext cx="10911535" cy="841248"/>
+            <a:off x="640080" y="603504"/>
+            <a:ext cx="10911535" cy="896112"/>
           </a:xfrm>
           <a:prstGeom prst="rect">
             <a:avLst/>
@@ -11780,12 +11786,12 @@
           <a:p>
             <a:pPr indent="0" marL="0">
               <a:lnSpc>
-                <a:spcPct val="98000"/>
+                <a:spcPct val="96000"/>
               </a:lnSpc>
               <a:buNone/>
             </a:pPr>
             <a:r>
-              <a:rPr lang="en-US" sz="2200" b="1" dirty="0">
+              <a:rPr lang="en-US" sz="2600" b="1" dirty="0">
                 <a:solidFill>
                   <a:srgbClr val="0C2A43"/>
                 </a:solidFill>
@@ -11795,7 +11801,7 @@
               </a:rPr>
               <a:t>Longevity Fails Without Consistency. eTeacher's Planned App Attacks the Persistence Problem With AI.</a:t>
             </a:r>
-            <a:endParaRPr lang="en-US" sz="2200" dirty="0"/>
+            <a:endParaRPr lang="en-US" sz="2600" dirty="0"/>
           </a:p>
         </p:txBody>
       </p:sp>
@@ -11807,8 +11813,8 @@
         </p:nvSpPr>
         <p:spPr>
           <a:xfrm>
-            <a:off x="640080" y="1517904"/>
-            <a:ext cx="10911535" cy="530352"/>
+            <a:off x="640080" y="1572768"/>
+            <a:ext cx="10911535" cy="512064"/>
           </a:xfrm>
           <a:prstGeom prst="rect">
             <a:avLst/>
@@ -11822,14 +11828,14 @@
           <a:p>
             <a:pPr indent="0" marL="0">
               <a:lnSpc>
-                <a:spcPct val="112000"/>
+                <a:spcPct val="110000"/>
               </a:lnSpc>
               <a:buNone/>
             </a:pPr>
             <a:r>
-              <a:rPr lang="en-US" sz="1250" i="1" dirty="0">
-                <a:solidFill>
-                  <a:srgbClr val="5C6672"/>
+              <a:rPr lang="en-US" sz="1350" b="1" i="1" dirty="0">
+                <a:solidFill>
+                  <a:srgbClr val="1A1F26"/>
                 </a:solidFill>
                 <a:latin typeface="Calibri" pitchFamily="34" charset="0"/>
                 <a:ea typeface="Calibri" pitchFamily="34" charset="-122"/>
@@ -11837,7 +11843,7 @@
               </a:rPr>
               <a:t>The upcoming Longevity Hub will break healthspan into daily micro-rituals — because the science only works if you actually stick with it.</a:t>
             </a:r>
-            <a:endParaRPr lang="en-US" sz="1250" dirty="0"/>
+            <a:endParaRPr lang="en-US" sz="1350" dirty="0"/>
           </a:p>
         </p:txBody>
       </p:sp>
@@ -11849,7 +11855,7 @@
         </p:nvSpPr>
         <p:spPr>
           <a:xfrm>
-            <a:off x="640080" y="2139696"/>
+            <a:off x="640080" y="2194560"/>
             <a:ext cx="10911535" cy="0"/>
           </a:xfrm>
           <a:prstGeom prst="line">
@@ -12299,8 +12305,8 @@
         </p:nvSpPr>
         <p:spPr>
           <a:xfrm>
-            <a:off x="640080" y="2377440"/>
-            <a:ext cx="10911535" cy="457200"/>
+            <a:off x="640080" y="1965960"/>
+            <a:ext cx="10911535" cy="365760"/>
           </a:xfrm>
           <a:prstGeom prst="rect">
             <a:avLst/>
@@ -12316,7 +12322,7 @@
               <a:buNone/>
             </a:pPr>
             <a:r>
-              <a:rPr lang="en-US" sz="1600" b="1" spc="300" kern="0" dirty="0">
+              <a:rPr lang="en-US" sz="1500" b="1" spc="400" kern="0" dirty="0">
                 <a:solidFill>
                   <a:srgbClr val="C08A2E"/>
                 </a:solidFill>
@@ -12324,9 +12330,9 @@
                 <a:ea typeface="Calibri" pitchFamily="34" charset="-122"/>
                 <a:cs typeface="Calibri" pitchFamily="34" charset="-120"/>
               </a:rPr>
-              <a:t>WAVE 4</a:t>
-            </a:r>
-            <a:endParaRPr lang="en-US" sz="1600" dirty="0"/>
+              <a:t>CHAPTER 4 OF 4</a:t>
+            </a:r>
+            <a:endParaRPr lang="en-US" sz="1500" dirty="0"/>
           </a:p>
         </p:txBody>
       </p:sp>
@@ -12338,8 +12344,8 @@
         </p:nvSpPr>
         <p:spPr>
           <a:xfrm>
-            <a:off x="640080" y="2880360"/>
-            <a:ext cx="10911535" cy="914400"/>
+            <a:off x="640080" y="2514600"/>
+            <a:ext cx="10911535" cy="1463040"/>
           </a:xfrm>
           <a:prstGeom prst="rect">
             <a:avLst/>
@@ -12352,10 +12358,13 @@
           <a:lstStyle/>
           <a:p>
             <a:pPr indent="0" marL="0">
-              <a:buNone/>
-            </a:pPr>
-            <a:r>
-              <a:rPr lang="en-US" sz="3400" b="1" dirty="0">
+              <a:lnSpc>
+                <a:spcPct val="100000"/>
+              </a:lnSpc>
+              <a:buNone/>
+            </a:pPr>
+            <a:r>
+              <a:rPr lang="en-US" sz="4200" b="1" dirty="0">
                 <a:solidFill>
                   <a:srgbClr val="FFFFFF"/>
                 </a:solidFill>
@@ -12365,7 +12374,7 @@
               </a:rPr>
               <a:t>Six New Longevity Courses (Roadmap)</a:t>
             </a:r>
-            <a:endParaRPr lang="en-US" sz="3400" dirty="0"/>
+            <a:endParaRPr lang="en-US" sz="4200" dirty="0"/>
           </a:p>
         </p:txBody>
       </p:sp>
@@ -12377,8 +12386,8 @@
         </p:nvSpPr>
         <p:spPr>
           <a:xfrm>
-            <a:off x="640080" y="3977640"/>
-            <a:ext cx="10058400" cy="914400"/>
+            <a:off x="640080" y="4297680"/>
+            <a:ext cx="10241280" cy="914400"/>
           </a:xfrm>
           <a:prstGeom prst="rect">
             <a:avLst/>
@@ -12397,7 +12406,7 @@
               <a:buNone/>
             </a:pPr>
             <a:r>
-              <a:rPr lang="en-US" sz="1500" dirty="0">
+              <a:rPr lang="en-US" sz="1700" dirty="0">
                 <a:solidFill>
                   <a:srgbClr val="C9D3DD"/>
                 </a:solidFill>
@@ -12405,9 +12414,9 @@
                 <a:ea typeface="Calibri" pitchFamily="34" charset="-122"/>
                 <a:cs typeface="Calibri" pitchFamily="34" charset="-120"/>
               </a:rPr>
-              <a:t>Following the Q2 launch of Longevity Life Academy, eTeacher plans to expand the curriculum into a full longevity college.</a:t>
-            </a:r>
-            <a:endParaRPr lang="en-US" sz="1500" dirty="0"/>
+              <a:t>One message: eTeacher is building a full longevity college — not a single course.</a:t>
+            </a:r>
+            <a:endParaRPr lang="en-US" sz="1700" dirty="0"/>
           </a:p>
         </p:txBody>
       </p:sp>
@@ -12419,7 +12428,7 @@
         </p:nvSpPr>
         <p:spPr>
           <a:xfrm>
-            <a:off x="640080" y="5029200"/>
+            <a:off x="640080" y="5394960"/>
             <a:ext cx="3657600" cy="365760"/>
           </a:xfrm>
           <a:prstGeom prst="rect">
@@ -12635,8 +12644,8 @@
         </p:nvSpPr>
         <p:spPr>
           <a:xfrm>
-            <a:off x="640080" y="640080"/>
-            <a:ext cx="10911535" cy="841248"/>
+            <a:off x="640080" y="603504"/>
+            <a:ext cx="10911535" cy="896112"/>
           </a:xfrm>
           <a:prstGeom prst="rect">
             <a:avLst/>
@@ -12650,12 +12659,12 @@
           <a:p>
             <a:pPr indent="0" marL="0">
               <a:lnSpc>
-                <a:spcPct val="98000"/>
+                <a:spcPct val="96000"/>
               </a:lnSpc>
               <a:buNone/>
             </a:pPr>
             <a:r>
-              <a:rPr lang="en-US" sz="2200" b="1" dirty="0">
+              <a:rPr lang="en-US" sz="2600" b="1" dirty="0">
                 <a:solidFill>
                   <a:srgbClr val="0C2A43"/>
                 </a:solidFill>
@@ -12665,7 +12674,7 @@
               </a:rPr>
               <a:t>eTeacher to Add Six New Longevity Courses Following Its Q2 Longevity Life Academy Debut</a:t>
             </a:r>
-            <a:endParaRPr lang="en-US" sz="2200" dirty="0"/>
+            <a:endParaRPr lang="en-US" sz="2600" dirty="0"/>
           </a:p>
         </p:txBody>
       </p:sp>
@@ -12677,8 +12686,8 @@
         </p:nvSpPr>
         <p:spPr>
           <a:xfrm>
-            <a:off x="640080" y="1517904"/>
-            <a:ext cx="10911535" cy="530352"/>
+            <a:off x="640080" y="1572768"/>
+            <a:ext cx="10911535" cy="512064"/>
           </a:xfrm>
           <a:prstGeom prst="rect">
             <a:avLst/>
@@ -12692,14 +12701,14 @@
           <a:p>
             <a:pPr indent="0" marL="0">
               <a:lnSpc>
-                <a:spcPct val="112000"/>
+                <a:spcPct val="110000"/>
               </a:lnSpc>
               <a:buNone/>
             </a:pPr>
             <a:r>
-              <a:rPr lang="en-US" sz="1250" i="1" dirty="0">
-                <a:solidFill>
-                  <a:srgbClr val="5C6672"/>
+              <a:rPr lang="en-US" sz="1350" b="1" i="1" dirty="0">
+                <a:solidFill>
+                  <a:srgbClr val="1A1F26"/>
                 </a:solidFill>
                 <a:latin typeface="Calibri" pitchFamily="34" charset="0"/>
                 <a:ea typeface="Calibri" pitchFamily="34" charset="-122"/>
@@ -12707,7 +12716,7 @@
               </a:rPr>
               <a:t>The planned expansion turns a single flagship course into a full longevity curriculum — six new programs spanning metabolic health, movement, biomarkers, and brain training.</a:t>
             </a:r>
-            <a:endParaRPr lang="en-US" sz="1250" dirty="0"/>
+            <a:endParaRPr lang="en-US" sz="1350" dirty="0"/>
           </a:p>
         </p:txBody>
       </p:sp>
@@ -12719,7 +12728,7 @@
         </p:nvSpPr>
         <p:spPr>
           <a:xfrm>
-            <a:off x="640080" y="2139696"/>
+            <a:off x="640080" y="2194560"/>
             <a:ext cx="10911535" cy="0"/>
           </a:xfrm>
           <a:prstGeom prst="line">
@@ -13255,8 +13264,8 @@
         </p:nvSpPr>
         <p:spPr>
           <a:xfrm>
-            <a:off x="640080" y="640080"/>
-            <a:ext cx="10911535" cy="841248"/>
+            <a:off x="640080" y="603504"/>
+            <a:ext cx="10911535" cy="896112"/>
           </a:xfrm>
           <a:prstGeom prst="rect">
             <a:avLst/>
@@ -13270,12 +13279,12 @@
           <a:p>
             <a:pPr indent="0" marL="0">
               <a:lnSpc>
-                <a:spcPct val="98000"/>
+                <a:spcPct val="96000"/>
               </a:lnSpc>
               <a:buNone/>
             </a:pPr>
             <a:r>
-              <a:rPr lang="en-US" sz="2200" b="1" dirty="0">
+              <a:rPr lang="en-US" sz="2600" b="1" dirty="0">
                 <a:solidFill>
                   <a:srgbClr val="0C2A43"/>
                 </a:solidFill>
@@ -13285,7 +13294,7 @@
               </a:rPr>
               <a:t>“Train Your Brain Like You Train Your Body”: Inside eTeacher's Planned Longevity Learning Journey</a:t>
             </a:r>
-            <a:endParaRPr lang="en-US" sz="2200" dirty="0"/>
+            <a:endParaRPr lang="en-US" sz="2600" dirty="0"/>
           </a:p>
         </p:txBody>
       </p:sp>
@@ -13297,8 +13306,8 @@
         </p:nvSpPr>
         <p:spPr>
           <a:xfrm>
-            <a:off x="640080" y="1517904"/>
-            <a:ext cx="10911535" cy="530352"/>
+            <a:off x="640080" y="1572768"/>
+            <a:ext cx="10911535" cy="512064"/>
           </a:xfrm>
           <a:prstGeom prst="rect">
             <a:avLst/>
@@ -13312,14 +13321,14 @@
           <a:p>
             <a:pPr indent="0" marL="0">
               <a:lnSpc>
-                <a:spcPct val="112000"/>
+                <a:spcPct val="110000"/>
               </a:lnSpc>
               <a:buNone/>
             </a:pPr>
             <a:r>
-              <a:rPr lang="en-US" sz="1250" i="1" dirty="0">
-                <a:solidFill>
-                  <a:srgbClr val="5C6672"/>
+              <a:rPr lang="en-US" sz="1350" b="1" i="1" dirty="0">
+                <a:solidFill>
+                  <a:srgbClr val="1A1F26"/>
                 </a:solidFill>
                 <a:latin typeface="Calibri" pitchFamily="34" charset="0"/>
                 <a:ea typeface="Calibri" pitchFamily="34" charset="-122"/>
@@ -13327,7 +13336,7 @@
               </a:rPr>
               <a:t>The upcoming curriculum treats memory, focus, emotional health, and relationships as trainable longevity levers — turning a single course into a multi-phase journey.</a:t>
             </a:r>
-            <a:endParaRPr lang="en-US" sz="1250" dirty="0"/>
+            <a:endParaRPr lang="en-US" sz="1350" dirty="0"/>
           </a:p>
         </p:txBody>
       </p:sp>
@@ -13339,7 +13348,7 @@
         </p:nvSpPr>
         <p:spPr>
           <a:xfrm>
-            <a:off x="640080" y="2139696"/>
+            <a:off x="640080" y="2194560"/>
             <a:ext cx="10911535" cy="0"/>
           </a:xfrm>
           <a:prstGeom prst="line">
@@ -20872,8 +20881,8 @@
         </p:nvSpPr>
         <p:spPr>
           <a:xfrm>
-            <a:off x="640080" y="2377440"/>
-            <a:ext cx="10911535" cy="457200"/>
+            <a:off x="640080" y="1965960"/>
+            <a:ext cx="10911535" cy="365760"/>
           </a:xfrm>
           <a:prstGeom prst="rect">
             <a:avLst/>
@@ -20889,7 +20898,7 @@
               <a:buNone/>
             </a:pPr>
             <a:r>
-              <a:rPr lang="en-US" sz="1600" b="1" spc="300" kern="0" dirty="0">
+              <a:rPr lang="en-US" sz="1500" b="1" spc="400" kern="0" dirty="0">
                 <a:solidFill>
                   <a:srgbClr val="C08A2E"/>
                 </a:solidFill>
@@ -20897,9 +20906,9 @@
                 <a:ea typeface="Calibri" pitchFamily="34" charset="-122"/>
                 <a:cs typeface="Calibri" pitchFamily="34" charset="-120"/>
               </a:rPr>
-              <a:t>WAVE 1</a:t>
-            </a:r>
-            <a:endParaRPr lang="en-US" sz="1600" dirty="0"/>
+              <a:t>CHAPTER 1 OF 4</a:t>
+            </a:r>
+            <a:endParaRPr lang="en-US" sz="1500" dirty="0"/>
           </a:p>
         </p:txBody>
       </p:sp>
@@ -20911,8 +20920,8 @@
         </p:nvSpPr>
         <p:spPr>
           <a:xfrm>
-            <a:off x="640080" y="2880360"/>
-            <a:ext cx="10911535" cy="914400"/>
+            <a:off x="640080" y="2514600"/>
+            <a:ext cx="10911535" cy="1463040"/>
           </a:xfrm>
           <a:prstGeom prst="rect">
             <a:avLst/>
@@ -20925,10 +20934,13 @@
           <a:lstStyle/>
           <a:p>
             <a:pPr indent="0" marL="0">
-              <a:buNone/>
-            </a:pPr>
-            <a:r>
-              <a:rPr lang="en-US" sz="3400" b="1" dirty="0">
+              <a:lnSpc>
+                <a:spcPct val="100000"/>
+              </a:lnSpc>
+              <a:buNone/>
+            </a:pPr>
+            <a:r>
+              <a:rPr lang="en-US" sz="4200" b="1" dirty="0">
                 <a:solidFill>
                   <a:srgbClr val="FFFFFF"/>
                 </a:solidFill>
@@ -20936,9 +20948,9 @@
                 <a:ea typeface="Cambria" pitchFamily="34" charset="-122"/>
                 <a:cs typeface="Cambria" pitchFamily="34" charset="-120"/>
               </a:rPr>
-              <a:t>eTeacher Enters the Longevity Market</a:t>
-            </a:r>
-            <a:endParaRPr lang="en-US" sz="3400" dirty="0"/>
+              <a:t>eTeacher Launches Longevity Life Academy</a:t>
+            </a:r>
+            <a:endParaRPr lang="en-US" sz="4200" dirty="0"/>
           </a:p>
         </p:txBody>
       </p:sp>
@@ -20950,8 +20962,8 @@
         </p:nvSpPr>
         <p:spPr>
           <a:xfrm>
-            <a:off x="640080" y="3977640"/>
-            <a:ext cx="10058400" cy="914400"/>
+            <a:off x="640080" y="4297680"/>
+            <a:ext cx="10241280" cy="914400"/>
           </a:xfrm>
           <a:prstGeom prst="rect">
             <a:avLst/>
@@ -20970,7 +20982,7 @@
               <a:buNone/>
             </a:pPr>
             <a:r>
-              <a:rPr lang="en-US" sz="1500" dirty="0">
+              <a:rPr lang="en-US" sz="1700" dirty="0">
                 <a:solidFill>
                   <a:srgbClr val="C9D3DD"/>
                 </a:solidFill>
@@ -20978,9 +20990,9 @@
                 <a:ea typeface="Calibri" pitchFamily="34" charset="-122"/>
                 <a:cs typeface="Calibri" pitchFamily="34" charset="-120"/>
               </a:rPr>
-              <a:t>Six genuinely distinct stories, one message: Israel's leading EdTech group is bringing live, science-backed longevity education to American households.</a:t>
-            </a:r>
-            <a:endParaRPr lang="en-US" sz="1500" dirty="0"/>
+              <a:t>One message: Israel's leading EdTech group brings live, science-backed longevity education to American homes.</a:t>
+            </a:r>
+            <a:endParaRPr lang="en-US" sz="1700" dirty="0"/>
           </a:p>
         </p:txBody>
       </p:sp>
@@ -20992,7 +21004,7 @@
         </p:nvSpPr>
         <p:spPr>
           <a:xfrm>
-            <a:off x="640080" y="5029200"/>
+            <a:off x="640080" y="5394960"/>
             <a:ext cx="3657600" cy="365760"/>
           </a:xfrm>
           <a:prstGeom prst="rect">
@@ -21208,8 +21220,8 @@
         </p:nvSpPr>
         <p:spPr>
           <a:xfrm>
-            <a:off x="640080" y="640080"/>
-            <a:ext cx="10911535" cy="841248"/>
+            <a:off x="640080" y="603504"/>
+            <a:ext cx="10911535" cy="896112"/>
           </a:xfrm>
           <a:prstGeom prst="rect">
             <a:avLst/>
@@ -21223,12 +21235,12 @@
           <a:p>
             <a:pPr indent="0" marL="0">
               <a:lnSpc>
-                <a:spcPct val="98000"/>
+                <a:spcPct val="96000"/>
               </a:lnSpc>
               <a:buNone/>
             </a:pPr>
             <a:r>
-              <a:rPr lang="en-US" sz="2200" b="1" dirty="0">
+              <a:rPr lang="en-US" sz="2600" b="1" dirty="0">
                 <a:solidFill>
                   <a:srgbClr val="0C2A43"/>
                 </a:solidFill>
@@ -21238,7 +21250,7 @@
               </a:rPr>
               <a:t>eTeacher Group Enters the $8 Trillion Longevity Market with Longevity Life Academy, Its Fifth Online School</a:t>
             </a:r>
-            <a:endParaRPr lang="en-US" sz="2200" dirty="0"/>
+            <a:endParaRPr lang="en-US" sz="2600" dirty="0"/>
           </a:p>
         </p:txBody>
       </p:sp>
@@ -21250,8 +21262,8 @@
         </p:nvSpPr>
         <p:spPr>
           <a:xfrm>
-            <a:off x="640080" y="1517904"/>
-            <a:ext cx="10911535" cy="530352"/>
+            <a:off x="640080" y="1572768"/>
+            <a:ext cx="10911535" cy="512064"/>
           </a:xfrm>
           <a:prstGeom prst="rect">
             <a:avLst/>
@@ -21265,14 +21277,14 @@
           <a:p>
             <a:pPr indent="0" marL="0">
               <a:lnSpc>
-                <a:spcPct val="112000"/>
+                <a:spcPct val="110000"/>
               </a:lnSpc>
               <a:buNone/>
             </a:pPr>
             <a:r>
-              <a:rPr lang="en-US" sz="1250" i="1" dirty="0">
-                <a:solidFill>
-                  <a:srgbClr val="5C6672"/>
+              <a:rPr lang="en-US" sz="1350" b="1" i="1" dirty="0">
+                <a:solidFill>
+                  <a:srgbClr val="1A1F26"/>
                 </a:solidFill>
                 <a:latin typeface="Calibri" pitchFamily="34" charset="0"/>
                 <a:ea typeface="Calibri" pitchFamily="34" charset="-122"/>
@@ -21280,7 +21292,7 @@
               </a:rPr>
               <a:t>After 25 years and 400,000+ courses delivered to students across nearly 200 countries, the Israeli EdTech veteran launches an 18-week live longevity program — with a glucose monitor shipped to every student.</a:t>
             </a:r>
-            <a:endParaRPr lang="en-US" sz="1250" dirty="0"/>
+            <a:endParaRPr lang="en-US" sz="1350" dirty="0"/>
           </a:p>
         </p:txBody>
       </p:sp>
@@ -21292,7 +21304,7 @@
         </p:nvSpPr>
         <p:spPr>
           <a:xfrm>
-            <a:off x="640080" y="2139696"/>
+            <a:off x="640080" y="2194560"/>
             <a:ext cx="10911535" cy="0"/>
           </a:xfrm>
           <a:prstGeom prst="line">
@@ -21828,8 +21840,8 @@
         </p:nvSpPr>
         <p:spPr>
           <a:xfrm>
-            <a:off x="640080" y="640080"/>
-            <a:ext cx="10911535" cy="841248"/>
+            <a:off x="640080" y="603504"/>
+            <a:ext cx="10911535" cy="896112"/>
           </a:xfrm>
           <a:prstGeom prst="rect">
             <a:avLst/>
@@ -21843,12 +21855,12 @@
           <a:p>
             <a:pPr indent="0" marL="0">
               <a:lnSpc>
-                <a:spcPct val="98000"/>
+                <a:spcPct val="96000"/>
               </a:lnSpc>
               <a:buNone/>
             </a:pPr>
             <a:r>
-              <a:rPr lang="en-US" sz="2200" b="1" dirty="0">
+              <a:rPr lang="en-US" sz="2600" b="1" dirty="0">
                 <a:solidFill>
                   <a:srgbClr val="0C2A43"/>
                 </a:solidFill>
@@ -21858,7 +21870,7 @@
               </a:rPr>
               <a:t>From Biblical Hebrew to Healthspan: eTeacher Applies Its Live-Plus-AI Method to Longevity</a:t>
             </a:r>
-            <a:endParaRPr lang="en-US" sz="2200" dirty="0"/>
+            <a:endParaRPr lang="en-US" sz="2600" dirty="0"/>
           </a:p>
         </p:txBody>
       </p:sp>
@@ -21870,8 +21882,8 @@
         </p:nvSpPr>
         <p:spPr>
           <a:xfrm>
-            <a:off x="640080" y="1517904"/>
-            <a:ext cx="10911535" cy="530352"/>
+            <a:off x="640080" y="1572768"/>
+            <a:ext cx="10911535" cy="512064"/>
           </a:xfrm>
           <a:prstGeom prst="rect">
             <a:avLst/>
@@ -21885,14 +21897,14 @@
           <a:p>
             <a:pPr indent="0" marL="0">
               <a:lnSpc>
-                <a:spcPct val="112000"/>
+                <a:spcPct val="110000"/>
               </a:lnSpc>
               <a:buNone/>
             </a:pPr>
             <a:r>
-              <a:rPr lang="en-US" sz="1250" i="1" dirty="0">
-                <a:solidFill>
-                  <a:srgbClr val="5C6672"/>
+              <a:rPr lang="en-US" sz="1350" b="1" i="1" dirty="0">
+                <a:solidFill>
+                  <a:srgbClr val="1A1F26"/>
                 </a:solidFill>
                 <a:latin typeface="Calibri" pitchFamily="34" charset="0"/>
                 <a:ea typeface="Calibri" pitchFamily="34" charset="-122"/>
@@ -21900,7 +21912,7 @@
               </a:rPr>
               <a:t>The company that taught languages to 400,000+ learners is betting its small-class, “gym for the brain” model can crack the hardest problem in wellness — sticking with it.</a:t>
             </a:r>
-            <a:endParaRPr lang="en-US" sz="1250" dirty="0"/>
+            <a:endParaRPr lang="en-US" sz="1350" dirty="0"/>
           </a:p>
         </p:txBody>
       </p:sp>
@@ -21912,7 +21924,7 @@
         </p:nvSpPr>
         <p:spPr>
           <a:xfrm>
-            <a:off x="640080" y="2139696"/>
+            <a:off x="640080" y="2194560"/>
             <a:ext cx="10911535" cy="0"/>
           </a:xfrm>
           <a:prstGeom prst="line">
@@ -22448,8 +22460,8 @@
         </p:nvSpPr>
         <p:spPr>
           <a:xfrm>
-            <a:off x="640080" y="640080"/>
-            <a:ext cx="10911535" cy="841248"/>
+            <a:off x="640080" y="603504"/>
+            <a:ext cx="10911535" cy="896112"/>
           </a:xfrm>
           <a:prstGeom prst="rect">
             <a:avLst/>
@@ -22463,12 +22475,12 @@
           <a:p>
             <a:pPr indent="0" marL="0">
               <a:lnSpc>
-                <a:spcPct val="98000"/>
+                <a:spcPct val="96000"/>
               </a:lnSpc>
               <a:buNone/>
             </a:pPr>
             <a:r>
-              <a:rPr lang="en-US" sz="2200" b="1" dirty="0">
+              <a:rPr lang="en-US" sz="2600" b="1" dirty="0">
                 <a:solidFill>
                   <a:srgbClr val="0C2A43"/>
                 </a:solidFill>
@@ -22478,7 +22490,7 @@
               </a:rPr>
               <a:t>An Israeli EdTech Veteran Bets on Longevity — Targeting the Gap Between $2M Clinics and Free Advice</a:t>
             </a:r>
-            <a:endParaRPr lang="en-US" sz="2200" dirty="0"/>
+            <a:endParaRPr lang="en-US" sz="2600" dirty="0"/>
           </a:p>
         </p:txBody>
       </p:sp>
@@ -22490,8 +22502,8 @@
         </p:nvSpPr>
         <p:spPr>
           <a:xfrm>
-            <a:off x="640080" y="1517904"/>
-            <a:ext cx="10911535" cy="530352"/>
+            <a:off x="640080" y="1572768"/>
+            <a:ext cx="10911535" cy="512064"/>
           </a:xfrm>
           <a:prstGeom prst="rect">
             <a:avLst/>
@@ -22505,14 +22517,14 @@
           <a:p>
             <a:pPr indent="0" marL="0">
               <a:lnSpc>
-                <a:spcPct val="112000"/>
+                <a:spcPct val="110000"/>
               </a:lnSpc>
               <a:buNone/>
             </a:pPr>
             <a:r>
-              <a:rPr lang="en-US" sz="1250" i="1" dirty="0">
-                <a:solidFill>
-                  <a:srgbClr val="5C6672"/>
+              <a:rPr lang="en-US" sz="1350" b="1" i="1" dirty="0">
+                <a:solidFill>
+                  <a:srgbClr val="1A1F26"/>
                 </a:solidFill>
                 <a:latin typeface="Calibri" pitchFamily="34" charset="0"/>
                 <a:ea typeface="Calibri" pitchFamily="34" charset="-122"/>
@@ -22520,7 +22532,7 @@
               </a:rPr>
               <a:t>With 70% of its customers already in the US, eTeacher is positioning Longevity Life Academy in the underserved middle of an $8 trillion market, starting at $289 a month.</a:t>
             </a:r>
-            <a:endParaRPr lang="en-US" sz="1250" dirty="0"/>
+            <a:endParaRPr lang="en-US" sz="1350" dirty="0"/>
           </a:p>
         </p:txBody>
       </p:sp>
@@ -22532,7 +22544,7 @@
         </p:nvSpPr>
         <p:spPr>
           <a:xfrm>
-            <a:off x="640080" y="2139696"/>
+            <a:off x="640080" y="2194560"/>
             <a:ext cx="10911535" cy="0"/>
           </a:xfrm>
           <a:prstGeom prst="line">
@@ -23068,8 +23080,8 @@
         </p:nvSpPr>
         <p:spPr>
           <a:xfrm>
-            <a:off x="640080" y="640080"/>
-            <a:ext cx="10911535" cy="841248"/>
+            <a:off x="640080" y="603504"/>
+            <a:ext cx="10911535" cy="896112"/>
           </a:xfrm>
           <a:prstGeom prst="rect">
             <a:avLst/>
@@ -23083,12 +23095,12 @@
           <a:p>
             <a:pPr indent="0" marL="0">
               <a:lnSpc>
-                <a:spcPct val="98000"/>
+                <a:spcPct val="96000"/>
               </a:lnSpc>
               <a:buNone/>
             </a:pPr>
             <a:r>
-              <a:rPr lang="en-US" sz="2200" b="1" dirty="0">
+              <a:rPr lang="en-US" sz="2600" b="1" dirty="0">
                 <a:solidFill>
                   <a:srgbClr val="0C2A43"/>
                 </a:solidFill>
@@ -23098,7 +23110,7 @@
               </a:rPr>
               <a:t>Longevity Life Academy Puts a Continuous Glucose Monitor in Every Student's Hands</a:t>
             </a:r>
-            <a:endParaRPr lang="en-US" sz="2200" dirty="0"/>
+            <a:endParaRPr lang="en-US" sz="2600" dirty="0"/>
           </a:p>
         </p:txBody>
       </p:sp>
@@ -23110,8 +23122,8 @@
         </p:nvSpPr>
         <p:spPr>
           <a:xfrm>
-            <a:off x="640080" y="1517904"/>
-            <a:ext cx="10911535" cy="530352"/>
+            <a:off x="640080" y="1572768"/>
+            <a:ext cx="10911535" cy="512064"/>
           </a:xfrm>
           <a:prstGeom prst="rect">
             <a:avLst/>
@@ -23125,14 +23137,14 @@
           <a:p>
             <a:pPr indent="0" marL="0">
               <a:lnSpc>
-                <a:spcPct val="112000"/>
+                <a:spcPct val="110000"/>
               </a:lnSpc>
               <a:buNone/>
             </a:pPr>
             <a:r>
-              <a:rPr lang="en-US" sz="1250" i="1" dirty="0">
-                <a:solidFill>
-                  <a:srgbClr val="5C6672"/>
+              <a:rPr lang="en-US" sz="1350" b="1" i="1" dirty="0">
+                <a:solidFill>
+                  <a:srgbClr val="1A1F26"/>
                 </a:solidFill>
                 <a:latin typeface="Calibri" pitchFamily="34" charset="0"/>
                 <a:ea typeface="Calibri" pitchFamily="34" charset="-122"/>
@@ -23140,7 +23152,7 @@
               </a:rPr>
               <a:t>eTeacher's new school makes personal biomarker data — not generic advice — the core of an 18-week, six-pillar curriculum.</a:t>
             </a:r>
-            <a:endParaRPr lang="en-US" sz="1250" dirty="0"/>
+            <a:endParaRPr lang="en-US" sz="1350" dirty="0"/>
           </a:p>
         </p:txBody>
       </p:sp>
@@ -23152,7 +23164,7 @@
         </p:nvSpPr>
         <p:spPr>
           <a:xfrm>
-            <a:off x="640080" y="2139696"/>
+            <a:off x="640080" y="2194560"/>
             <a:ext cx="10911535" cy="0"/>
           </a:xfrm>
           <a:prstGeom prst="line">
@@ -23688,8 +23700,8 @@
         </p:nvSpPr>
         <p:spPr>
           <a:xfrm>
-            <a:off x="640080" y="640080"/>
-            <a:ext cx="10911535" cy="841248"/>
+            <a:off x="640080" y="603504"/>
+            <a:ext cx="10911535" cy="896112"/>
           </a:xfrm>
           <a:prstGeom prst="rect">
             <a:avLst/>
@@ -23703,12 +23715,12 @@
           <a:p>
             <a:pPr indent="0" marL="0">
               <a:lnSpc>
-                <a:spcPct val="98000"/>
+                <a:spcPct val="96000"/>
               </a:lnSpc>
               <a:buNone/>
             </a:pPr>
             <a:r>
-              <a:rPr lang="en-US" sz="2200" b="1" dirty="0">
+              <a:rPr lang="en-US" sz="2600" b="1" dirty="0">
                 <a:solidFill>
                   <a:srgbClr val="0C2A43"/>
                 </a:solidFill>
@@ -23718,7 +23730,7 @@
               </a:rPr>
               <a:t>After 25 Years, Israel's eTeacher Takes Its Live-Learning Model Into Longevity</a:t>
             </a:r>
-            <a:endParaRPr lang="en-US" sz="2200" dirty="0"/>
+            <a:endParaRPr lang="en-US" sz="2600" dirty="0"/>
           </a:p>
         </p:txBody>
       </p:sp>
@@ -23730,8 +23742,8 @@
         </p:nvSpPr>
         <p:spPr>
           <a:xfrm>
-            <a:off x="640080" y="1517904"/>
-            <a:ext cx="10911535" cy="530352"/>
+            <a:off x="640080" y="1572768"/>
+            <a:ext cx="10911535" cy="512064"/>
           </a:xfrm>
           <a:prstGeom prst="rect">
             <a:avLst/>
@@ -23745,14 +23757,14 @@
           <a:p>
             <a:pPr indent="0" marL="0">
               <a:lnSpc>
-                <a:spcPct val="112000"/>
+                <a:spcPct val="110000"/>
               </a:lnSpc>
               <a:buNone/>
             </a:pPr>
             <a:r>
-              <a:rPr lang="en-US" sz="1250" i="1" dirty="0">
-                <a:solidFill>
-                  <a:srgbClr val="5C6672"/>
+              <a:rPr lang="en-US" sz="1350" b="1" i="1" dirty="0">
+                <a:solidFill>
+                  <a:srgbClr val="1A1F26"/>
                 </a:solidFill>
                 <a:latin typeface="Calibri" pitchFamily="34" charset="0"/>
                 <a:ea typeface="Calibri" pitchFamily="34" charset="-122"/>
@@ -23760,7 +23772,7 @@
               </a:rPr>
               <a:t>The company behind five global online schools — and an ambition to become the “Wiz of edtech” — brings Israeli education technology to the world's fastest-growing wellness market.</a:t>
             </a:r>
-            <a:endParaRPr lang="en-US" sz="1250" dirty="0"/>
+            <a:endParaRPr lang="en-US" sz="1350" dirty="0"/>
           </a:p>
         </p:txBody>
       </p:sp>
@@ -23772,7 +23784,7 @@
         </p:nvSpPr>
         <p:spPr>
           <a:xfrm>
-            <a:off x="640080" y="2139696"/>
+            <a:off x="640080" y="2194560"/>
             <a:ext cx="10911535" cy="0"/>
           </a:xfrm>
           <a:prstGeom prst="line">

</xml_diff>

<commit_message>
Rewrite opening plan into clear 6-part numbered narrative with MAP slide
</commit_message>
<xml_diff>
--- a/eTeacher_Longevity_PR_Campaign.pptx
+++ b/eTeacher_Longevity_PR_Campaign.pptx
@@ -3998,47 +3998,8 @@
         </p:nvSpPr>
         <p:spPr>
           <a:xfrm>
-            <a:off x="640080" y="457200"/>
-            <a:ext cx="10911535" cy="274320"/>
-          </a:xfrm>
-          <a:prstGeom prst="rect">
-            <a:avLst/>
-          </a:prstGeom>
-          <a:noFill/>
-          <a:ln/>
-        </p:spPr>
-        <p:txBody>
-          <a:bodyPr wrap="square" rtlCol="0" anchor="ctr"/>
-          <a:lstStyle/>
-          <a:p>
-            <a:pPr indent="0" marL="0">
-              <a:buNone/>
-            </a:pPr>
-            <a:r>
-              <a:rPr lang="en-US" sz="1200" b="1" spc="300" kern="0" dirty="0">
-                <a:solidFill>
-                  <a:srgbClr val="C08A2E"/>
-                </a:solidFill>
-                <a:latin typeface="Calibri" pitchFamily="34" charset="0"/>
-                <a:ea typeface="Calibri" pitchFamily="34" charset="-122"/>
-                <a:cs typeface="Calibri" pitchFamily="34" charset="-120"/>
-              </a:rPr>
-              <a:t>THE PLAYBOOK</a:t>
-            </a:r>
-            <a:endParaRPr lang="en-US" sz="1200" dirty="0"/>
-          </a:p>
-        </p:txBody>
-      </p:sp>
-      <p:sp>
-        <p:nvSpPr>
-          <p:cNvPr id="3" name="Text 1"/>
-          <p:cNvSpPr/>
-          <p:nvPr/>
-        </p:nvSpPr>
-        <p:spPr>
-          <a:xfrm>
-            <a:off x="640080" y="749808"/>
-            <a:ext cx="10911535" cy="822960"/>
+            <a:off x="640080" y="786384"/>
+            <a:ext cx="10911535" cy="731520"/>
           </a:xfrm>
           <a:prstGeom prst="rect">
             <a:avLst/>
@@ -4065,7 +4026,7 @@
                 <a:ea typeface="Cambria" pitchFamily="34" charset="-122"/>
                 <a:cs typeface="Cambria" pitchFamily="34" charset="-120"/>
               </a:rPr>
-              <a:t>Every wave runs the same 14-day play</a:t>
+              <a:t>Part 5 — The playbook: one 14-day play, run 4 times</a:t>
             </a:r>
             <a:endParaRPr lang="en-US" sz="2600" dirty="0"/>
           </a:p>
@@ -4073,13 +4034,66 @@
       </p:sp>
       <p:sp>
         <p:nvSpPr>
+          <p:cNvPr id="3" name="Text 1"/>
+          <p:cNvSpPr/>
+          <p:nvPr/>
+        </p:nvSpPr>
+        <p:spPr>
+          <a:xfrm>
+            <a:off x="640080" y="457200"/>
+            <a:ext cx="10911535" cy="274320"/>
+          </a:xfrm>
+          <a:prstGeom prst="rect">
+            <a:avLst/>
+          </a:prstGeom>
+          <a:noFill/>
+          <a:ln/>
+        </p:spPr>
+        <p:txBody>
+          <a:bodyPr wrap="square" rtlCol="0" anchor="ctr"/>
+          <a:lstStyle/>
+          <a:p>
+            <a:pPr indent="0" marL="0">
+              <a:buNone/>
+            </a:pPr>
+            <a:r>
+              <a:rPr lang="en-US" sz="1100" b="1" spc="200" kern="0" dirty="0">
+                <a:solidFill>
+                  <a:srgbClr val="C08A2E"/>
+                </a:solidFill>
+                <a:latin typeface="Calibri" pitchFamily="34" charset="0"/>
+                <a:ea typeface="Calibri" pitchFamily="34" charset="-122"/>
+                <a:cs typeface="Calibri" pitchFamily="34" charset="-120"/>
+              </a:rPr>
+              <a:t>THE LAUNCH PLAN</a:t>
+            </a:r>
+            <a:pPr indent="0" marL="0">
+              <a:buNone/>
+            </a:pPr>
+            <a:r>
+              <a:rPr lang="en-US" sz="1100" b="1" spc="200" kern="0" dirty="0">
+                <a:solidFill>
+                  <a:srgbClr val="5C6672"/>
+                </a:solidFill>
+                <a:latin typeface="Calibri" pitchFamily="34" charset="0"/>
+                <a:ea typeface="Calibri" pitchFamily="34" charset="-122"/>
+                <a:cs typeface="Calibri" pitchFamily="34" charset="-120"/>
+              </a:rPr>
+              <a:t>     PART 5 OF 6</a:t>
+            </a:r>
+            <a:endParaRPr lang="en-US" sz="1100" dirty="0"/>
+          </a:p>
+        </p:txBody>
+      </p:sp>
+      <p:sp>
+        <p:nvSpPr>
           <p:cNvPr id="4" name="Text 2"/>
           <p:cNvSpPr/>
           <p:nvPr/>
         </p:nvSpPr>
         <p:spPr>
           <a:xfrm>
-            <a:off x="640080" y="1572768"/>
+            <a:off x="640080" y="1536192"/>
             <a:ext cx="10911535" cy="457200"/>
           </a:xfrm>
           <a:prstGeom prst="rect">
@@ -4089,7 +4103,7 @@
           <a:ln/>
         </p:spPr>
         <p:txBody>
-          <a:bodyPr wrap="square" rtlCol="0" anchor="ctr"/>
+          <a:bodyPr wrap="square" rtlCol="0" anchor="t"/>
           <a:lstStyle/>
           <a:p>
             <a:pPr indent="0" marL="0">
@@ -4099,7 +4113,24 @@
               <a:buNone/>
             </a:pPr>
             <a:r>
-              <a:rPr lang="en-US" sz="1400" dirty="0">
+              <a:rPr lang="en-US" sz="1350" b="1" dirty="0">
+                <a:solidFill>
+                  <a:srgbClr val="C08A2E"/>
+                </a:solidFill>
+                <a:latin typeface="Calibri" pitchFamily="34" charset="0"/>
+                <a:ea typeface="Calibri" pitchFamily="34" charset="-122"/>
+                <a:cs typeface="Calibri" pitchFamily="34" charset="-120"/>
+              </a:rPr>
+              <a:t>THIS ANSWERS:  </a:t>
+            </a:r>
+            <a:pPr indent="0" marL="0">
+              <a:lnSpc>
+                <a:spcPct val="115000"/>
+              </a:lnSpc>
+              <a:buNone/>
+            </a:pPr>
+            <a:r>
+              <a:rPr lang="en-US" sz="1350" dirty="0">
                 <a:solidFill>
                   <a:srgbClr val="1A1F26"/>
                 </a:solidFill>
@@ -4107,9 +4138,9 @@
                 <a:ea typeface="Calibri" pitchFamily="34" charset="-122"/>
                 <a:cs typeface="Calibri" pitchFamily="34" charset="-120"/>
               </a:rPr>
-              <a:t>One repeatable checklist per wave. Copy-paste it four times and change the story. This is the whole operating system.</a:t>
-            </a:r>
-            <a:endParaRPr lang="en-US" sz="1400" dirty="0"/>
+              <a:t>Exactly what happens, day by day, every time a wave goes live.</a:t>
+            </a:r>
+            <a:endParaRPr lang="en-US" sz="1350" dirty="0"/>
           </a:p>
         </p:txBody>
       </p:sp>
@@ -4121,8 +4152,8 @@
         </p:nvSpPr>
         <p:spPr>
           <a:xfrm>
-            <a:off x="640080" y="2194560"/>
-            <a:ext cx="2036003" cy="3200400"/>
+            <a:off x="640080" y="2286000"/>
+            <a:ext cx="2036003" cy="3108960"/>
           </a:xfrm>
           <a:prstGeom prst="roundRect">
             <a:avLst>
@@ -4148,7 +4179,7 @@
         </p:nvSpPr>
         <p:spPr>
           <a:xfrm>
-            <a:off x="640080" y="2194560"/>
+            <a:off x="640080" y="2286000"/>
             <a:ext cx="2036003" cy="868680"/>
           </a:xfrm>
           <a:prstGeom prst="roundRect">
@@ -4170,7 +4201,7 @@
         </p:nvSpPr>
         <p:spPr>
           <a:xfrm>
-            <a:off x="731520" y="2304288"/>
+            <a:off x="731520" y="2395728"/>
             <a:ext cx="1853123" cy="365760"/>
           </a:xfrm>
           <a:prstGeom prst="rect">
@@ -4209,7 +4240,7 @@
         </p:nvSpPr>
         <p:spPr>
           <a:xfrm>
-            <a:off x="731520" y="2651760"/>
+            <a:off x="731520" y="2743200"/>
             <a:ext cx="1853123" cy="365760"/>
           </a:xfrm>
           <a:prstGeom prst="rect">
@@ -4248,8 +4279,8 @@
         </p:nvSpPr>
         <p:spPr>
           <a:xfrm>
-            <a:off x="786384" y="3200400"/>
-            <a:ext cx="1743395" cy="2103120"/>
+            <a:off x="786384" y="3291840"/>
+            <a:ext cx="1743395" cy="2011680"/>
           </a:xfrm>
           <a:prstGeom prst="rect">
             <a:avLst/>
@@ -4290,8 +4321,8 @@
         </p:nvSpPr>
         <p:spPr>
           <a:xfrm>
-            <a:off x="2858963" y="2194560"/>
-            <a:ext cx="2036003" cy="3200400"/>
+            <a:off x="2858963" y="2286000"/>
+            <a:ext cx="2036003" cy="3108960"/>
           </a:xfrm>
           <a:prstGeom prst="roundRect">
             <a:avLst>
@@ -4317,7 +4348,7 @@
         </p:nvSpPr>
         <p:spPr>
           <a:xfrm>
-            <a:off x="2858963" y="2194560"/>
+            <a:off x="2858963" y="2286000"/>
             <a:ext cx="2036003" cy="868680"/>
           </a:xfrm>
           <a:prstGeom prst="roundRect">
@@ -4339,7 +4370,7 @@
         </p:nvSpPr>
         <p:spPr>
           <a:xfrm>
-            <a:off x="2950403" y="2304288"/>
+            <a:off x="2950403" y="2395728"/>
             <a:ext cx="1853123" cy="365760"/>
           </a:xfrm>
           <a:prstGeom prst="rect">
@@ -4378,7 +4409,7 @@
         </p:nvSpPr>
         <p:spPr>
           <a:xfrm>
-            <a:off x="2950403" y="2651760"/>
+            <a:off x="2950403" y="2743200"/>
             <a:ext cx="1853123" cy="365760"/>
           </a:xfrm>
           <a:prstGeom prst="rect">
@@ -4417,8 +4448,8 @@
         </p:nvSpPr>
         <p:spPr>
           <a:xfrm>
-            <a:off x="3005267" y="3200400"/>
-            <a:ext cx="1743395" cy="2103120"/>
+            <a:off x="3005267" y="3291840"/>
+            <a:ext cx="1743395" cy="2011680"/>
           </a:xfrm>
           <a:prstGeom prst="rect">
             <a:avLst/>
@@ -4459,8 +4490,8 @@
         </p:nvSpPr>
         <p:spPr>
           <a:xfrm>
-            <a:off x="5077846" y="2194560"/>
-            <a:ext cx="2036003" cy="3200400"/>
+            <a:off x="5077846" y="2286000"/>
+            <a:ext cx="2036003" cy="3108960"/>
           </a:xfrm>
           <a:prstGeom prst="roundRect">
             <a:avLst>
@@ -4486,7 +4517,7 @@
         </p:nvSpPr>
         <p:spPr>
           <a:xfrm>
-            <a:off x="5077846" y="2194560"/>
+            <a:off x="5077846" y="2286000"/>
             <a:ext cx="2036003" cy="868680"/>
           </a:xfrm>
           <a:prstGeom prst="roundRect">
@@ -4508,7 +4539,7 @@
         </p:nvSpPr>
         <p:spPr>
           <a:xfrm>
-            <a:off x="5169286" y="2304288"/>
+            <a:off x="5169286" y="2395728"/>
             <a:ext cx="1853123" cy="365760"/>
           </a:xfrm>
           <a:prstGeom prst="rect">
@@ -4547,7 +4578,7 @@
         </p:nvSpPr>
         <p:spPr>
           <a:xfrm>
-            <a:off x="5169286" y="2651760"/>
+            <a:off x="5169286" y="2743200"/>
             <a:ext cx="1853123" cy="365760"/>
           </a:xfrm>
           <a:prstGeom prst="rect">
@@ -4586,8 +4617,8 @@
         </p:nvSpPr>
         <p:spPr>
           <a:xfrm>
-            <a:off x="5224150" y="3200400"/>
-            <a:ext cx="1743395" cy="2103120"/>
+            <a:off x="5224150" y="3291840"/>
+            <a:ext cx="1743395" cy="2011680"/>
           </a:xfrm>
           <a:prstGeom prst="rect">
             <a:avLst/>
@@ -4628,8 +4659,8 @@
         </p:nvSpPr>
         <p:spPr>
           <a:xfrm>
-            <a:off x="7296729" y="2194560"/>
-            <a:ext cx="2036003" cy="3200400"/>
+            <a:off x="7296729" y="2286000"/>
+            <a:ext cx="2036003" cy="3108960"/>
           </a:xfrm>
           <a:prstGeom prst="roundRect">
             <a:avLst>
@@ -4655,7 +4686,7 @@
         </p:nvSpPr>
         <p:spPr>
           <a:xfrm>
-            <a:off x="7296729" y="2194560"/>
+            <a:off x="7296729" y="2286000"/>
             <a:ext cx="2036003" cy="868680"/>
           </a:xfrm>
           <a:prstGeom prst="roundRect">
@@ -4677,7 +4708,7 @@
         </p:nvSpPr>
         <p:spPr>
           <a:xfrm>
-            <a:off x="7388169" y="2304288"/>
+            <a:off x="7388169" y="2395728"/>
             <a:ext cx="1853123" cy="365760"/>
           </a:xfrm>
           <a:prstGeom prst="rect">
@@ -4716,7 +4747,7 @@
         </p:nvSpPr>
         <p:spPr>
           <a:xfrm>
-            <a:off x="7388169" y="2651760"/>
+            <a:off x="7388169" y="2743200"/>
             <a:ext cx="1853123" cy="365760"/>
           </a:xfrm>
           <a:prstGeom prst="rect">
@@ -4755,8 +4786,8 @@
         </p:nvSpPr>
         <p:spPr>
           <a:xfrm>
-            <a:off x="7443033" y="3200400"/>
-            <a:ext cx="1743395" cy="2103120"/>
+            <a:off x="7443033" y="3291840"/>
+            <a:ext cx="1743395" cy="2011680"/>
           </a:xfrm>
           <a:prstGeom prst="rect">
             <a:avLst/>
@@ -4797,8 +4828,8 @@
         </p:nvSpPr>
         <p:spPr>
           <a:xfrm>
-            <a:off x="9515612" y="2194560"/>
-            <a:ext cx="2036003" cy="3200400"/>
+            <a:off x="9515612" y="2286000"/>
+            <a:ext cx="2036003" cy="3108960"/>
           </a:xfrm>
           <a:prstGeom prst="roundRect">
             <a:avLst>
@@ -4824,7 +4855,7 @@
         </p:nvSpPr>
         <p:spPr>
           <a:xfrm>
-            <a:off x="9515612" y="2194560"/>
+            <a:off x="9515612" y="2286000"/>
             <a:ext cx="2036003" cy="868680"/>
           </a:xfrm>
           <a:prstGeom prst="roundRect">
@@ -4846,7 +4877,7 @@
         </p:nvSpPr>
         <p:spPr>
           <a:xfrm>
-            <a:off x="9607052" y="2304288"/>
+            <a:off x="9607052" y="2395728"/>
             <a:ext cx="1853123" cy="365760"/>
           </a:xfrm>
           <a:prstGeom prst="rect">
@@ -4885,7 +4916,7 @@
         </p:nvSpPr>
         <p:spPr>
           <a:xfrm>
-            <a:off x="9607052" y="2651760"/>
+            <a:off x="9607052" y="2743200"/>
             <a:ext cx="1853123" cy="365760"/>
           </a:xfrm>
           <a:prstGeom prst="rect">
@@ -4924,8 +4955,8 @@
         </p:nvSpPr>
         <p:spPr>
           <a:xfrm>
-            <a:off x="9661916" y="3200400"/>
-            <a:ext cx="1743395" cy="2103120"/>
+            <a:off x="9661916" y="3291840"/>
+            <a:ext cx="1743395" cy="2011680"/>
           </a:xfrm>
           <a:prstGeom prst="rect">
             <a:avLst/>
@@ -4966,7 +4997,7 @@
         </p:nvSpPr>
         <p:spPr>
           <a:xfrm>
-            <a:off x="640080" y="5623560"/>
+            <a:off x="640080" y="5715000"/>
             <a:ext cx="10911535" cy="457200"/>
           </a:xfrm>
           <a:prstGeom prst="rect">
@@ -5116,7 +5147,7 @@
               <a:buNone/>
             </a:pPr>
             <a:r>
-              <a:rPr lang="en-US" sz="1500" b="1" spc="300" kern="0" dirty="0">
+              <a:rPr lang="en-US" sz="1300" b="1" spc="200" kern="0" dirty="0">
                 <a:solidFill>
                   <a:srgbClr val="C08A2E"/>
                 </a:solidFill>
@@ -5124,9 +5155,23 @@
                 <a:ea typeface="Calibri" pitchFamily="34" charset="-122"/>
                 <a:cs typeface="Calibri" pitchFamily="34" charset="-120"/>
               </a:rPr>
-              <a:t>DOING IT ALONE  ·  THIS WEEK’S ACTION ITEMS</a:t>
-            </a:r>
-            <a:endParaRPr lang="en-US" sz="1500" dirty="0"/>
+              <a:t>THE LAUNCH PLAN</a:t>
+            </a:r>
+            <a:pPr indent="0" marL="0">
+              <a:buNone/>
+            </a:pPr>
+            <a:r>
+              <a:rPr lang="en-US" sz="1300" b="1" spc="200" kern="0" dirty="0">
+                <a:solidFill>
+                  <a:srgbClr val="9AA4AF"/>
+                </a:solidFill>
+                <a:latin typeface="Calibri" pitchFamily="34" charset="0"/>
+                <a:ea typeface="Calibri" pitchFamily="34" charset="-122"/>
+                <a:cs typeface="Calibri" pitchFamily="34" charset="-120"/>
+              </a:rPr>
+              <a:t>     PART 6 OF 6  ·  DO NOW</a:t>
+            </a:r>
+            <a:endParaRPr lang="en-US" sz="1300" dirty="0"/>
           </a:p>
         </p:txBody>
       </p:sp>
@@ -5155,7 +5200,7 @@
               <a:buNone/>
             </a:pPr>
             <a:r>
-              <a:rPr lang="en-US" sz="3000" b="1" dirty="0">
+              <a:rPr lang="en-US" sz="2800" b="1" dirty="0">
                 <a:solidFill>
                   <a:srgbClr val="FFFFFF"/>
                 </a:solidFill>
@@ -5163,9 +5208,9 @@
                 <a:ea typeface="Cambria" pitchFamily="34" charset="-122"/>
                 <a:cs typeface="Cambria" pitchFamily="34" charset="-120"/>
               </a:rPr>
-              <a:t>The 7 things to do before Wave 1 goes live</a:t>
-            </a:r>
-            <a:endParaRPr lang="en-US" sz="3000" dirty="0"/>
+              <a:t>Part 6 — The 7 things to finish before Wave 1 goes live</a:t>
+            </a:r>
+            <a:endParaRPr lang="en-US" sz="2800" dirty="0"/>
           </a:p>
         </p:txBody>
       </p:sp>
@@ -20787,7 +20832,7 @@
         </p:nvSpPr>
         <p:spPr>
           <a:xfrm>
-            <a:off x="640080" y="640080"/>
+            <a:off x="640080" y="548640"/>
             <a:ext cx="10911535" cy="365760"/>
           </a:xfrm>
           <a:prstGeom prst="rect">
@@ -20804,7 +20849,7 @@
               <a:buNone/>
             </a:pPr>
             <a:r>
-              <a:rPr lang="en-US" sz="1500" b="1" spc="300" kern="0" dirty="0">
+              <a:rPr lang="en-US" sz="1400" b="1" spc="300" kern="0" dirty="0">
                 <a:solidFill>
                   <a:srgbClr val="C08A2E"/>
                 </a:solidFill>
@@ -20812,9 +20857,9 @@
                 <a:ea typeface="Calibri" pitchFamily="34" charset="-122"/>
                 <a:cs typeface="Calibri" pitchFamily="34" charset="-120"/>
               </a:rPr>
-              <a:t>THE PLAN  ·  ON ONE PAGE</a:t>
-            </a:r>
-            <a:endParaRPr lang="en-US" sz="1500" dirty="0"/>
+              <a:t>THE LAUNCH PLAN  ·  READ THIS FIRST</a:t>
+            </a:r>
+            <a:endParaRPr lang="en-US" sz="1400" dirty="0"/>
           </a:p>
         </p:txBody>
       </p:sp>
@@ -20826,8 +20871,8 @@
         </p:nvSpPr>
         <p:spPr>
           <a:xfrm>
-            <a:off x="640080" y="1097280"/>
-            <a:ext cx="10911535" cy="914400"/>
+            <a:off x="640080" y="987552"/>
+            <a:ext cx="10911535" cy="822960"/>
           </a:xfrm>
           <a:prstGeom prst="rect">
             <a:avLst/>
@@ -20846,7 +20891,7 @@
               <a:buNone/>
             </a:pPr>
             <a:r>
-              <a:rPr lang="en-US" sz="3000" b="1" dirty="0">
+              <a:rPr lang="en-US" sz="2700" b="1" dirty="0">
                 <a:solidFill>
                   <a:srgbClr val="FFFFFF"/>
                 </a:solidFill>
@@ -20854,9 +20899,9 @@
                 <a:ea typeface="Cambria" pitchFamily="34" charset="-122"/>
                 <a:cs typeface="Cambria" pitchFamily="34" charset="-120"/>
               </a:rPr>
-              <a:t>Launch Longevity Life Academy in the press — solo, no agency</a:t>
-            </a:r>
-            <a:endParaRPr lang="en-US" sz="3000" dirty="0"/>
+              <a:t>Get Longevity Life Academy into the press — solo, no agency, in 8 weeks</a:t>
+            </a:r>
+            <a:endParaRPr lang="en-US" sz="2700" dirty="0"/>
           </a:p>
         </p:txBody>
       </p:sp>
@@ -20868,12 +20913,12 @@
         </p:nvSpPr>
         <p:spPr>
           <a:xfrm>
-            <a:off x="640080" y="2331720"/>
-            <a:ext cx="5272888" cy="1417320"/>
+            <a:off x="640080" y="1874520"/>
+            <a:ext cx="10911535" cy="658368"/>
           </a:xfrm>
           <a:prstGeom prst="roundRect">
             <a:avLst>
-              <a:gd name="adj" fmla="val 3871"/>
+              <a:gd name="adj" fmla="val 8333"/>
             </a:avLst>
           </a:prstGeom>
           <a:solidFill>
@@ -20895,8 +20940,8 @@
         </p:nvSpPr>
         <p:spPr>
           <a:xfrm>
-            <a:off x="896112" y="2478024"/>
-            <a:ext cx="4815688" cy="274320"/>
+            <a:off x="896112" y="1874520"/>
+            <a:ext cx="10399471" cy="658368"/>
           </a:xfrm>
           <a:prstGeom prst="rect">
             <a:avLst/>
@@ -20909,10 +20954,13 @@
           <a:lstStyle/>
           <a:p>
             <a:pPr indent="0" marL="0">
-              <a:buNone/>
-            </a:pPr>
-            <a:r>
-              <a:rPr lang="en-US" sz="1200" b="1" spc="150" kern="0" dirty="0">
+              <a:lnSpc>
+                <a:spcPct val="105000"/>
+              </a:lnSpc>
+              <a:buNone/>
+            </a:pPr>
+            <a:r>
+              <a:rPr lang="en-US" sz="1400" b="1" dirty="0">
                 <a:solidFill>
                   <a:srgbClr val="C08A2E"/>
                 </a:solidFill>
@@ -20920,7 +20968,63 @@
                 <a:ea typeface="Calibri" pitchFamily="34" charset="-122"/>
                 <a:cs typeface="Calibri" pitchFamily="34" charset="-120"/>
               </a:rPr>
-              <a:t>THE GOAL</a:t>
+              <a:t>THE GOAL:   </a:t>
+            </a:r>
+            <a:pPr indent="0" marL="0">
+              <a:lnSpc>
+                <a:spcPct val="105000"/>
+              </a:lnSpc>
+              <a:buNone/>
+            </a:pPr>
+            <a:r>
+              <a:rPr lang="en-US" sz="1400" dirty="0">
+                <a:solidFill>
+                  <a:srgbClr val="DCE3EA"/>
+                </a:solidFill>
+                <a:latin typeface="Calibri" pitchFamily="34" charset="0"/>
+                <a:ea typeface="Calibri" pitchFamily="34" charset="-122"/>
+                <a:cs typeface="Calibri" pitchFamily="34" charset="-120"/>
+              </a:rPr>
+              <a:t>1 guaranteed wire pickup per wave + 3–6 earned stories over 4 waves — run by one person for under $700.</a:t>
+            </a:r>
+            <a:endParaRPr lang="en-US" sz="1400" dirty="0"/>
+          </a:p>
+        </p:txBody>
+      </p:sp>
+      <p:sp>
+        <p:nvSpPr>
+          <p:cNvPr id="7" name="Text 5"/>
+          <p:cNvSpPr/>
+          <p:nvPr/>
+        </p:nvSpPr>
+        <p:spPr>
+          <a:xfrm>
+            <a:off x="640080" y="2697480"/>
+            <a:ext cx="10911535" cy="292608"/>
+          </a:xfrm>
+          <a:prstGeom prst="rect">
+            <a:avLst/>
+          </a:prstGeom>
+          <a:noFill/>
+          <a:ln/>
+        </p:spPr>
+        <p:txBody>
+          <a:bodyPr wrap="square" rtlCol="0" anchor="ctr"/>
+          <a:lstStyle/>
+          <a:p>
+            <a:pPr indent="0" marL="0">
+              <a:buNone/>
+            </a:pPr>
+            <a:r>
+              <a:rPr lang="en-US" sz="1200" b="1" spc="100" kern="0" dirty="0">
+                <a:solidFill>
+                  <a:srgbClr val="9AA4AF"/>
+                </a:solidFill>
+                <a:latin typeface="Calibri" pitchFamily="34" charset="0"/>
+                <a:ea typeface="Calibri" pitchFamily="34" charset="-122"/>
+                <a:cs typeface="Calibri" pitchFamily="34" charset="-120"/>
+              </a:rPr>
+              <a:t>The next 6 parts, in order:</a:t>
             </a:r>
             <a:endParaRPr lang="en-US" sz="1200" dirty="0"/>
           </a:p>
@@ -20928,14 +21032,112 @@
       </p:sp>
       <p:sp>
         <p:nvSpPr>
-          <p:cNvPr id="7" name="Text 5"/>
-          <p:cNvSpPr/>
-          <p:nvPr/>
-        </p:nvSpPr>
-        <p:spPr>
-          <a:xfrm>
-            <a:off x="896112" y="2807208"/>
-            <a:ext cx="4815688" cy="822960"/>
+          <p:cNvPr id="8" name="Shape 6"/>
+          <p:cNvSpPr/>
+          <p:nvPr/>
+        </p:nvSpPr>
+        <p:spPr>
+          <a:xfrm>
+            <a:off x="640080" y="3163824"/>
+            <a:ext cx="548640" cy="548640"/>
+          </a:xfrm>
+          <a:prstGeom prst="ellipse">
+            <a:avLst/>
+          </a:prstGeom>
+          <a:solidFill>
+            <a:srgbClr val="C08A2E"/>
+          </a:solidFill>
+          <a:ln/>
+        </p:spPr>
+      </p:sp>
+      <p:sp>
+        <p:nvSpPr>
+          <p:cNvPr id="9" name="Text 7"/>
+          <p:cNvSpPr/>
+          <p:nvPr/>
+        </p:nvSpPr>
+        <p:spPr>
+          <a:xfrm>
+            <a:off x="640080" y="3163824"/>
+            <a:ext cx="548640" cy="548640"/>
+          </a:xfrm>
+          <a:prstGeom prst="rect">
+            <a:avLst/>
+          </a:prstGeom>
+          <a:noFill/>
+          <a:ln/>
+        </p:spPr>
+        <p:txBody>
+          <a:bodyPr wrap="square" rtlCol="0" anchor="ctr"/>
+          <a:lstStyle/>
+          <a:p>
+            <a:pPr algn="ctr" indent="0" marL="0">
+              <a:buNone/>
+            </a:pPr>
+            <a:r>
+              <a:rPr lang="en-US" sz="2200" b="1" dirty="0">
+                <a:solidFill>
+                  <a:srgbClr val="0C2A43"/>
+                </a:solidFill>
+                <a:latin typeface="Cambria" pitchFamily="34" charset="0"/>
+                <a:ea typeface="Cambria" pitchFamily="34" charset="-122"/>
+                <a:cs typeface="Cambria" pitchFamily="34" charset="-120"/>
+              </a:rPr>
+              <a:t>1</a:t>
+            </a:r>
+            <a:endParaRPr lang="en-US" sz="2200" dirty="0"/>
+          </a:p>
+        </p:txBody>
+      </p:sp>
+      <p:sp>
+        <p:nvSpPr>
+          <p:cNvPr id="10" name="Text 8"/>
+          <p:cNvSpPr/>
+          <p:nvPr/>
+        </p:nvSpPr>
+        <p:spPr>
+          <a:xfrm>
+            <a:off x="1389888" y="3090672"/>
+            <a:ext cx="4523080" cy="347472"/>
+          </a:xfrm>
+          <a:prstGeom prst="rect">
+            <a:avLst/>
+          </a:prstGeom>
+          <a:noFill/>
+          <a:ln/>
+        </p:spPr>
+        <p:txBody>
+          <a:bodyPr wrap="square" rtlCol="0" anchor="ctr"/>
+          <a:lstStyle/>
+          <a:p>
+            <a:pPr indent="0" marL="0">
+              <a:buNone/>
+            </a:pPr>
+            <a:r>
+              <a:rPr lang="en-US" sz="1600" b="1" dirty="0">
+                <a:solidFill>
+                  <a:srgbClr val="FFFFFF"/>
+                </a:solidFill>
+                <a:latin typeface="Cambria" pitchFamily="34" charset="0"/>
+                <a:ea typeface="Cambria" pitchFamily="34" charset="-122"/>
+                <a:cs typeface="Cambria" pitchFamily="34" charset="-120"/>
+              </a:rPr>
+              <a:t>WHERE we play</a:t>
+            </a:r>
+            <a:endParaRPr lang="en-US" sz="1600" dirty="0"/>
+          </a:p>
+        </p:txBody>
+      </p:sp>
+      <p:sp>
+        <p:nvSpPr>
+          <p:cNvPr id="11" name="Text 9"/>
+          <p:cNvSpPr/>
+          <p:nvPr/>
+        </p:nvSpPr>
+        <p:spPr>
+          <a:xfrm>
+            <a:off x="1389888" y="3438144"/>
+            <a:ext cx="4523080" cy="566928"/>
           </a:xfrm>
           <a:prstGeom prst="rect">
             <a:avLst/>
@@ -20949,62 +21151,55 @@
           <a:p>
             <a:pPr indent="0" marL="0">
               <a:lnSpc>
-                <a:spcPct val="112000"/>
+                <a:spcPct val="110000"/>
               </a:lnSpc>
               <a:buNone/>
             </a:pPr>
             <a:r>
-              <a:rPr lang="en-US" sz="1350" dirty="0">
-                <a:solidFill>
-                  <a:srgbClr val="DCE3EA"/>
-                </a:solidFill>
-                <a:latin typeface="Calibri" pitchFamily="34" charset="0"/>
-                <a:ea typeface="Calibri" pitchFamily="34" charset="-122"/>
-                <a:cs typeface="Calibri" pitchFamily="34" charset="-120"/>
-              </a:rPr>
-              <a:t>Own the story “Israel’s leading EdTech launches accessible longevity education,” then carry it into “Julie joins.”</a:t>
-            </a:r>
-            <a:endParaRPr lang="en-US" sz="1350" dirty="0"/>
-          </a:p>
-        </p:txBody>
-      </p:sp>
-      <p:sp>
-        <p:nvSpPr>
-          <p:cNvPr id="8" name="Shape 6"/>
-          <p:cNvSpPr/>
-          <p:nvPr/>
-        </p:nvSpPr>
-        <p:spPr>
-          <a:xfrm>
-            <a:off x="6278728" y="2331720"/>
-            <a:ext cx="5272888" cy="1417320"/>
-          </a:xfrm>
-          <a:prstGeom prst="roundRect">
-            <a:avLst>
-              <a:gd name="adj" fmla="val 3871"/>
-            </a:avLst>
+              <a:rPr lang="en-US" sz="1150" dirty="0">
+                <a:solidFill>
+                  <a:srgbClr val="C9D3DD"/>
+                </a:solidFill>
+                <a:latin typeface="Calibri" pitchFamily="34" charset="0"/>
+                <a:ea typeface="Calibri" pitchFamily="34" charset="-122"/>
+                <a:cs typeface="Calibri" pitchFamily="34" charset="-120"/>
+              </a:rPr>
+              <a:t>Two separate pushes: the U.S. (consumer/health) and Israel (business).</a:t>
+            </a:r>
+            <a:endParaRPr lang="en-US" sz="1150" dirty="0"/>
+          </a:p>
+        </p:txBody>
+      </p:sp>
+      <p:sp>
+        <p:nvSpPr>
+          <p:cNvPr id="12" name="Shape 10"/>
+          <p:cNvSpPr/>
+          <p:nvPr/>
+        </p:nvSpPr>
+        <p:spPr>
+          <a:xfrm>
+            <a:off x="6278728" y="3163824"/>
+            <a:ext cx="548640" cy="548640"/>
+          </a:xfrm>
+          <a:prstGeom prst="ellipse">
+            <a:avLst/>
           </a:prstGeom>
           <a:solidFill>
-            <a:srgbClr val="12395C"/>
+            <a:srgbClr val="C08A2E"/>
           </a:solidFill>
-          <a:ln w="12700">
-            <a:solidFill>
-              <a:srgbClr val="27506F"/>
-            </a:solidFill>
-            <a:prstDash val="solid"/>
-          </a:ln>
-        </p:spPr>
-      </p:sp>
-      <p:sp>
-        <p:nvSpPr>
-          <p:cNvPr id="9" name="Text 7"/>
-          <p:cNvSpPr/>
-          <p:nvPr/>
-        </p:nvSpPr>
-        <p:spPr>
-          <a:xfrm>
-            <a:off x="6534760" y="2478024"/>
-            <a:ext cx="4815688" cy="274320"/>
+          <a:ln/>
+        </p:spPr>
+      </p:sp>
+      <p:sp>
+        <p:nvSpPr>
+          <p:cNvPr id="13" name="Text 11"/>
+          <p:cNvSpPr/>
+          <p:nvPr/>
+        </p:nvSpPr>
+        <p:spPr>
+          <a:xfrm>
+            <a:off x="6278728" y="3163824"/>
+            <a:ext cx="548640" cy="548640"/>
           </a:xfrm>
           <a:prstGeom prst="rect">
             <a:avLst/>
@@ -21016,34 +21211,73 @@
           <a:bodyPr wrap="square" rtlCol="0" anchor="ctr"/>
           <a:lstStyle/>
           <a:p>
-            <a:pPr indent="0" marL="0">
-              <a:buNone/>
-            </a:pPr>
-            <a:r>
-              <a:rPr lang="en-US" sz="1200" b="1" spc="150" kern="0" dirty="0">
-                <a:solidFill>
-                  <a:srgbClr val="C08A2E"/>
-                </a:solidFill>
-                <a:latin typeface="Calibri" pitchFamily="34" charset="0"/>
-                <a:ea typeface="Calibri" pitchFamily="34" charset="-122"/>
-                <a:cs typeface="Calibri" pitchFamily="34" charset="-120"/>
-              </a:rPr>
-              <a:t>WHERE WE WANT TO BE</a:t>
-            </a:r>
-            <a:endParaRPr lang="en-US" sz="1200" dirty="0"/>
-          </a:p>
-        </p:txBody>
-      </p:sp>
-      <p:sp>
-        <p:nvSpPr>
-          <p:cNvPr id="10" name="Text 8"/>
-          <p:cNvSpPr/>
-          <p:nvPr/>
-        </p:nvSpPr>
-        <p:spPr>
-          <a:xfrm>
-            <a:off x="6534760" y="2807208"/>
-            <a:ext cx="4815688" cy="822960"/>
+            <a:pPr algn="ctr" indent="0" marL="0">
+              <a:buNone/>
+            </a:pPr>
+            <a:r>
+              <a:rPr lang="en-US" sz="2200" b="1" dirty="0">
+                <a:solidFill>
+                  <a:srgbClr val="0C2A43"/>
+                </a:solidFill>
+                <a:latin typeface="Cambria" pitchFamily="34" charset="0"/>
+                <a:ea typeface="Cambria" pitchFamily="34" charset="-122"/>
+                <a:cs typeface="Cambria" pitchFamily="34" charset="-120"/>
+              </a:rPr>
+              <a:t>2</a:t>
+            </a:r>
+            <a:endParaRPr lang="en-US" sz="2200" dirty="0"/>
+          </a:p>
+        </p:txBody>
+      </p:sp>
+      <p:sp>
+        <p:nvSpPr>
+          <p:cNvPr id="14" name="Text 12"/>
+          <p:cNvSpPr/>
+          <p:nvPr/>
+        </p:nvSpPr>
+        <p:spPr>
+          <a:xfrm>
+            <a:off x="7028536" y="3090672"/>
+            <a:ext cx="4523080" cy="347472"/>
+          </a:xfrm>
+          <a:prstGeom prst="rect">
+            <a:avLst/>
+          </a:prstGeom>
+          <a:noFill/>
+          <a:ln/>
+        </p:spPr>
+        <p:txBody>
+          <a:bodyPr wrap="square" rtlCol="0" anchor="ctr"/>
+          <a:lstStyle/>
+          <a:p>
+            <a:pPr indent="0" marL="0">
+              <a:buNone/>
+            </a:pPr>
+            <a:r>
+              <a:rPr lang="en-US" sz="1600" b="1" dirty="0">
+                <a:solidFill>
+                  <a:srgbClr val="FFFFFF"/>
+                </a:solidFill>
+                <a:latin typeface="Cambria" pitchFamily="34" charset="0"/>
+                <a:ea typeface="Cambria" pitchFamily="34" charset="-122"/>
+                <a:cs typeface="Cambria" pitchFamily="34" charset="-120"/>
+              </a:rPr>
+              <a:t>HOW we get coverage</a:t>
+            </a:r>
+            <a:endParaRPr lang="en-US" sz="1600" dirty="0"/>
+          </a:p>
+        </p:txBody>
+      </p:sp>
+      <p:sp>
+        <p:nvSpPr>
+          <p:cNvPr id="15" name="Text 13"/>
+          <p:cNvSpPr/>
+          <p:nvPr/>
+        </p:nvSpPr>
+        <p:spPr>
+          <a:xfrm>
+            <a:off x="7028536" y="3438144"/>
+            <a:ext cx="4523080" cy="566928"/>
           </a:xfrm>
           <a:prstGeom prst="rect">
             <a:avLst/>
@@ -21057,62 +21291,55 @@
           <a:p>
             <a:pPr indent="0" marL="0">
               <a:lnSpc>
-                <a:spcPct val="112000"/>
+                <a:spcPct val="110000"/>
               </a:lnSpc>
               <a:buNone/>
             </a:pPr>
             <a:r>
-              <a:rPr lang="en-US" sz="1350" dirty="0">
-                <a:solidFill>
-                  <a:srgbClr val="DCE3EA"/>
-                </a:solidFill>
-                <a:latin typeface="Calibri" pitchFamily="34" charset="0"/>
-                <a:ea typeface="Calibri" pitchFamily="34" charset="-122"/>
-                <a:cs typeface="Calibri" pitchFamily="34" charset="-120"/>
-              </a:rPr>
-              <a:t>Cited on a paid wire (guaranteed), plus 3–6 earned pickups across US consumer/health + Israeli business press over 8 weeks.</a:t>
-            </a:r>
-            <a:endParaRPr lang="en-US" sz="1350" dirty="0"/>
-          </a:p>
-        </p:txBody>
-      </p:sp>
-      <p:sp>
-        <p:nvSpPr>
-          <p:cNvPr id="11" name="Shape 9"/>
-          <p:cNvSpPr/>
-          <p:nvPr/>
-        </p:nvSpPr>
-        <p:spPr>
-          <a:xfrm>
-            <a:off x="640080" y="3931920"/>
-            <a:ext cx="5272888" cy="1417320"/>
-          </a:xfrm>
-          <a:prstGeom prst="roundRect">
-            <a:avLst>
-              <a:gd name="adj" fmla="val 3871"/>
-            </a:avLst>
+              <a:rPr lang="en-US" sz="1150" dirty="0">
+                <a:solidFill>
+                  <a:srgbClr val="C9D3DD"/>
+                </a:solidFill>
+                <a:latin typeface="Calibri" pitchFamily="34" charset="0"/>
+                <a:ea typeface="Calibri" pitchFamily="34" charset="-122"/>
+                <a:cs typeface="Calibri" pitchFamily="34" charset="-120"/>
+              </a:rPr>
+              <a:t>The free tactics and the paid wires that actually land stories.</a:t>
+            </a:r>
+            <a:endParaRPr lang="en-US" sz="1150" dirty="0"/>
+          </a:p>
+        </p:txBody>
+      </p:sp>
+      <p:sp>
+        <p:nvSpPr>
+          <p:cNvPr id="16" name="Shape 14"/>
+          <p:cNvSpPr/>
+          <p:nvPr/>
+        </p:nvSpPr>
+        <p:spPr>
+          <a:xfrm>
+            <a:off x="640080" y="4215384"/>
+            <a:ext cx="548640" cy="548640"/>
+          </a:xfrm>
+          <a:prstGeom prst="ellipse">
+            <a:avLst/>
           </a:prstGeom>
           <a:solidFill>
-            <a:srgbClr val="12395C"/>
+            <a:srgbClr val="C08A2E"/>
           </a:solidFill>
-          <a:ln w="12700">
-            <a:solidFill>
-              <a:srgbClr val="27506F"/>
-            </a:solidFill>
-            <a:prstDash val="solid"/>
-          </a:ln>
-        </p:spPr>
-      </p:sp>
-      <p:sp>
-        <p:nvSpPr>
-          <p:cNvPr id="12" name="Text 10"/>
-          <p:cNvSpPr/>
-          <p:nvPr/>
-        </p:nvSpPr>
-        <p:spPr>
-          <a:xfrm>
-            <a:off x="896112" y="4078224"/>
-            <a:ext cx="4815688" cy="274320"/>
+          <a:ln/>
+        </p:spPr>
+      </p:sp>
+      <p:sp>
+        <p:nvSpPr>
+          <p:cNvPr id="17" name="Text 15"/>
+          <p:cNvSpPr/>
+          <p:nvPr/>
+        </p:nvSpPr>
+        <p:spPr>
+          <a:xfrm>
+            <a:off x="640080" y="4215384"/>
+            <a:ext cx="548640" cy="548640"/>
           </a:xfrm>
           <a:prstGeom prst="rect">
             <a:avLst/>
@@ -21124,34 +21351,73 @@
           <a:bodyPr wrap="square" rtlCol="0" anchor="ctr"/>
           <a:lstStyle/>
           <a:p>
-            <a:pPr indent="0" marL="0">
-              <a:buNone/>
-            </a:pPr>
-            <a:r>
-              <a:rPr lang="en-US" sz="1200" b="1" spc="150" kern="0" dirty="0">
-                <a:solidFill>
-                  <a:srgbClr val="C08A2E"/>
-                </a:solidFill>
-                <a:latin typeface="Calibri" pitchFamily="34" charset="0"/>
-                <a:ea typeface="Calibri" pitchFamily="34" charset="-122"/>
-                <a:cs typeface="Calibri" pitchFamily="34" charset="-120"/>
-              </a:rPr>
-              <a:t>WHO RUNS IT</a:t>
-            </a:r>
-            <a:endParaRPr lang="en-US" sz="1200" dirty="0"/>
-          </a:p>
-        </p:txBody>
-      </p:sp>
-      <p:sp>
-        <p:nvSpPr>
-          <p:cNvPr id="13" name="Text 11"/>
-          <p:cNvSpPr/>
-          <p:nvPr/>
-        </p:nvSpPr>
-        <p:spPr>
-          <a:xfrm>
-            <a:off x="896112" y="4407408"/>
-            <a:ext cx="4815688" cy="822960"/>
+            <a:pPr algn="ctr" indent="0" marL="0">
+              <a:buNone/>
+            </a:pPr>
+            <a:r>
+              <a:rPr lang="en-US" sz="2200" b="1" dirty="0">
+                <a:solidFill>
+                  <a:srgbClr val="0C2A43"/>
+                </a:solidFill>
+                <a:latin typeface="Cambria" pitchFamily="34" charset="0"/>
+                <a:ea typeface="Cambria" pitchFamily="34" charset="-122"/>
+                <a:cs typeface="Cambria" pitchFamily="34" charset="-120"/>
+              </a:rPr>
+              <a:t>3</a:t>
+            </a:r>
+            <a:endParaRPr lang="en-US" sz="2200" dirty="0"/>
+          </a:p>
+        </p:txBody>
+      </p:sp>
+      <p:sp>
+        <p:nvSpPr>
+          <p:cNvPr id="18" name="Text 16"/>
+          <p:cNvSpPr/>
+          <p:nvPr/>
+        </p:nvSpPr>
+        <p:spPr>
+          <a:xfrm>
+            <a:off x="1389888" y="4142232"/>
+            <a:ext cx="4523080" cy="347472"/>
+          </a:xfrm>
+          <a:prstGeom prst="rect">
+            <a:avLst/>
+          </a:prstGeom>
+          <a:noFill/>
+          <a:ln/>
+        </p:spPr>
+        <p:txBody>
+          <a:bodyPr wrap="square" rtlCol="0" anchor="ctr"/>
+          <a:lstStyle/>
+          <a:p>
+            <a:pPr indent="0" marL="0">
+              <a:buNone/>
+            </a:pPr>
+            <a:r>
+              <a:rPr lang="en-US" sz="1600" b="1" dirty="0">
+                <a:solidFill>
+                  <a:srgbClr val="FFFFFF"/>
+                </a:solidFill>
+                <a:latin typeface="Cambria" pitchFamily="34" charset="0"/>
+                <a:ea typeface="Cambria" pitchFamily="34" charset="-122"/>
+                <a:cs typeface="Cambria" pitchFamily="34" charset="-120"/>
+              </a:rPr>
+              <a:t>WHAT it costs</a:t>
+            </a:r>
+            <a:endParaRPr lang="en-US" sz="1600" dirty="0"/>
+          </a:p>
+        </p:txBody>
+      </p:sp>
+      <p:sp>
+        <p:nvSpPr>
+          <p:cNvPr id="19" name="Text 17"/>
+          <p:cNvSpPr/>
+          <p:nvPr/>
+        </p:nvSpPr>
+        <p:spPr>
+          <a:xfrm>
+            <a:off x="1389888" y="4489704"/>
+            <a:ext cx="4523080" cy="566928"/>
           </a:xfrm>
           <a:prstGeom prst="rect">
             <a:avLst/>
@@ -21165,62 +21431,55 @@
           <a:p>
             <a:pPr indent="0" marL="0">
               <a:lnSpc>
-                <a:spcPct val="112000"/>
+                <a:spcPct val="110000"/>
               </a:lnSpc>
               <a:buNone/>
             </a:pPr>
             <a:r>
-              <a:rPr lang="en-US" sz="1350" dirty="0">
-                <a:solidFill>
-                  <a:srgbClr val="DCE3EA"/>
-                </a:solidFill>
-                <a:latin typeface="Calibri" pitchFamily="34" charset="0"/>
-                <a:ea typeface="Calibri" pitchFamily="34" charset="-122"/>
-                <a:cs typeface="Calibri" pitchFamily="34" charset="-120"/>
-              </a:rPr>
-              <a:t>One person — Omri — using paid wire distribution for certainty and free journalist platforms for earned reach.</a:t>
-            </a:r>
-            <a:endParaRPr lang="en-US" sz="1350" dirty="0"/>
-          </a:p>
-        </p:txBody>
-      </p:sp>
-      <p:sp>
-        <p:nvSpPr>
-          <p:cNvPr id="14" name="Shape 12"/>
-          <p:cNvSpPr/>
-          <p:nvPr/>
-        </p:nvSpPr>
-        <p:spPr>
-          <a:xfrm>
-            <a:off x="6278728" y="3931920"/>
-            <a:ext cx="5272888" cy="1417320"/>
-          </a:xfrm>
-          <a:prstGeom prst="roundRect">
-            <a:avLst>
-              <a:gd name="adj" fmla="val 3871"/>
-            </a:avLst>
+              <a:rPr lang="en-US" sz="1150" dirty="0">
+                <a:solidFill>
+                  <a:srgbClr val="C9D3DD"/>
+                </a:solidFill>
+                <a:latin typeface="Calibri" pitchFamily="34" charset="0"/>
+                <a:ea typeface="Calibri" pitchFamily="34" charset="-122"/>
+                <a:cs typeface="Calibri" pitchFamily="34" charset="-120"/>
+              </a:rPr>
+              <a:t>Two budgets — a lean ~$700 plan and a premium option.</a:t>
+            </a:r>
+            <a:endParaRPr lang="en-US" sz="1150" dirty="0"/>
+          </a:p>
+        </p:txBody>
+      </p:sp>
+      <p:sp>
+        <p:nvSpPr>
+          <p:cNvPr id="20" name="Shape 18"/>
+          <p:cNvSpPr/>
+          <p:nvPr/>
+        </p:nvSpPr>
+        <p:spPr>
+          <a:xfrm>
+            <a:off x="6278728" y="4215384"/>
+            <a:ext cx="548640" cy="548640"/>
+          </a:xfrm>
+          <a:prstGeom prst="ellipse">
+            <a:avLst/>
           </a:prstGeom>
           <a:solidFill>
-            <a:srgbClr val="12395C"/>
+            <a:srgbClr val="C08A2E"/>
           </a:solidFill>
-          <a:ln w="12700">
-            <a:solidFill>
-              <a:srgbClr val="27506F"/>
-            </a:solidFill>
-            <a:prstDash val="solid"/>
-          </a:ln>
-        </p:spPr>
-      </p:sp>
-      <p:sp>
-        <p:nvSpPr>
-          <p:cNvPr id="15" name="Text 13"/>
-          <p:cNvSpPr/>
-          <p:nvPr/>
-        </p:nvSpPr>
-        <p:spPr>
-          <a:xfrm>
-            <a:off x="6534760" y="4078224"/>
-            <a:ext cx="4815688" cy="274320"/>
+          <a:ln/>
+        </p:spPr>
+      </p:sp>
+      <p:sp>
+        <p:nvSpPr>
+          <p:cNvPr id="21" name="Text 19"/>
+          <p:cNvSpPr/>
+          <p:nvPr/>
+        </p:nvSpPr>
+        <p:spPr>
+          <a:xfrm>
+            <a:off x="6278728" y="4215384"/>
+            <a:ext cx="548640" cy="548640"/>
           </a:xfrm>
           <a:prstGeom prst="rect">
             <a:avLst/>
@@ -21232,34 +21491,73 @@
           <a:bodyPr wrap="square" rtlCol="0" anchor="ctr"/>
           <a:lstStyle/>
           <a:p>
-            <a:pPr indent="0" marL="0">
-              <a:buNone/>
-            </a:pPr>
-            <a:r>
-              <a:rPr lang="en-US" sz="1200" b="1" spc="150" kern="0" dirty="0">
-                <a:solidFill>
-                  <a:srgbClr val="C08A2E"/>
-                </a:solidFill>
-                <a:latin typeface="Calibri" pitchFamily="34" charset="0"/>
-                <a:ea typeface="Calibri" pitchFamily="34" charset="-122"/>
-                <a:cs typeface="Calibri" pitchFamily="34" charset="-120"/>
-              </a:rPr>
-              <a:t>THE BET</a:t>
-            </a:r>
-            <a:endParaRPr lang="en-US" sz="1200" dirty="0"/>
-          </a:p>
-        </p:txBody>
-      </p:sp>
-      <p:sp>
-        <p:nvSpPr>
-          <p:cNvPr id="16" name="Text 14"/>
-          <p:cNvSpPr/>
-          <p:nvPr/>
-        </p:nvSpPr>
-        <p:spPr>
-          <a:xfrm>
-            <a:off x="6534760" y="4407408"/>
-            <a:ext cx="4815688" cy="822960"/>
+            <a:pPr algn="ctr" indent="0" marL="0">
+              <a:buNone/>
+            </a:pPr>
+            <a:r>
+              <a:rPr lang="en-US" sz="2200" b="1" dirty="0">
+                <a:solidFill>
+                  <a:srgbClr val="0C2A43"/>
+                </a:solidFill>
+                <a:latin typeface="Cambria" pitchFamily="34" charset="0"/>
+                <a:ea typeface="Cambria" pitchFamily="34" charset="-122"/>
+                <a:cs typeface="Cambria" pitchFamily="34" charset="-120"/>
+              </a:rPr>
+              <a:t>4</a:t>
+            </a:r>
+            <a:endParaRPr lang="en-US" sz="2200" dirty="0"/>
+          </a:p>
+        </p:txBody>
+      </p:sp>
+      <p:sp>
+        <p:nvSpPr>
+          <p:cNvPr id="22" name="Text 20"/>
+          <p:cNvSpPr/>
+          <p:nvPr/>
+        </p:nvSpPr>
+        <p:spPr>
+          <a:xfrm>
+            <a:off x="7028536" y="4142232"/>
+            <a:ext cx="4523080" cy="347472"/>
+          </a:xfrm>
+          <a:prstGeom prst="rect">
+            <a:avLst/>
+          </a:prstGeom>
+          <a:noFill/>
+          <a:ln/>
+        </p:spPr>
+        <p:txBody>
+          <a:bodyPr wrap="square" rtlCol="0" anchor="ctr"/>
+          <a:lstStyle/>
+          <a:p>
+            <a:pPr indent="0" marL="0">
+              <a:buNone/>
+            </a:pPr>
+            <a:r>
+              <a:rPr lang="en-US" sz="1600" b="1" dirty="0">
+                <a:solidFill>
+                  <a:srgbClr val="FFFFFF"/>
+                </a:solidFill>
+                <a:latin typeface="Cambria" pitchFamily="34" charset="0"/>
+                <a:ea typeface="Cambria" pitchFamily="34" charset="-122"/>
+                <a:cs typeface="Cambria" pitchFamily="34" charset="-120"/>
+              </a:rPr>
+              <a:t>The ODDS</a:t>
+            </a:r>
+            <a:endParaRPr lang="en-US" sz="1600" dirty="0"/>
+          </a:p>
+        </p:txBody>
+      </p:sp>
+      <p:sp>
+        <p:nvSpPr>
+          <p:cNvPr id="23" name="Text 21"/>
+          <p:cNvSpPr/>
+          <p:nvPr/>
+        </p:nvSpPr>
+        <p:spPr>
+          <a:xfrm>
+            <a:off x="7028536" y="4489704"/>
+            <a:ext cx="4523080" cy="566928"/>
           </a:xfrm>
           <a:prstGeom prst="rect">
             <a:avLst/>
@@ -21273,28 +21571,308 @@
           <a:p>
             <a:pPr indent="0" marL="0">
               <a:lnSpc>
-                <a:spcPct val="112000"/>
+                <a:spcPct val="110000"/>
               </a:lnSpc>
               <a:buNone/>
             </a:pPr>
             <a:r>
-              <a:rPr lang="en-US" sz="1350" dirty="0">
-                <a:solidFill>
-                  <a:srgbClr val="DCE3EA"/>
-                </a:solidFill>
-                <a:latin typeface="Calibri" pitchFamily="34" charset="0"/>
-                <a:ea typeface="Calibri" pitchFamily="34" charset="-122"/>
-                <a:cs typeface="Calibri" pitchFamily="34" charset="-120"/>
-              </a:rPr>
-              <a:t>Two strong hooks (a 25-year EdTech leader + a real longevity story in Julie) beat a big agency retainer for this launch.</a:t>
-            </a:r>
-            <a:endParaRPr lang="en-US" sz="1350" dirty="0"/>
-          </a:p>
-        </p:txBody>
-      </p:sp>
-      <p:sp>
-        <p:nvSpPr>
-          <p:cNvPr id="17" name="Text 15"/>
+              <a:rPr lang="en-US" sz="1150" dirty="0">
+                <a:solidFill>
+                  <a:srgbClr val="C9D3DD"/>
+                </a:solidFill>
+                <a:latin typeface="Calibri" pitchFamily="34" charset="0"/>
+                <a:ea typeface="Calibri" pitchFamily="34" charset="-122"/>
+                <a:cs typeface="Calibri" pitchFamily="34" charset="-120"/>
+              </a:rPr>
+              <a:t>What’s guaranteed, what’s likely, and what’s a long shot — honestly.</a:t>
+            </a:r>
+            <a:endParaRPr lang="en-US" sz="1150" dirty="0"/>
+          </a:p>
+        </p:txBody>
+      </p:sp>
+      <p:sp>
+        <p:nvSpPr>
+          <p:cNvPr id="24" name="Shape 22"/>
+          <p:cNvSpPr/>
+          <p:nvPr/>
+        </p:nvSpPr>
+        <p:spPr>
+          <a:xfrm>
+            <a:off x="640080" y="5266944"/>
+            <a:ext cx="548640" cy="548640"/>
+          </a:xfrm>
+          <a:prstGeom prst="ellipse">
+            <a:avLst/>
+          </a:prstGeom>
+          <a:solidFill>
+            <a:srgbClr val="C08A2E"/>
+          </a:solidFill>
+          <a:ln/>
+        </p:spPr>
+      </p:sp>
+      <p:sp>
+        <p:nvSpPr>
+          <p:cNvPr id="25" name="Text 23"/>
+          <p:cNvSpPr/>
+          <p:nvPr/>
+        </p:nvSpPr>
+        <p:spPr>
+          <a:xfrm>
+            <a:off x="640080" y="5266944"/>
+            <a:ext cx="548640" cy="548640"/>
+          </a:xfrm>
+          <a:prstGeom prst="rect">
+            <a:avLst/>
+          </a:prstGeom>
+          <a:noFill/>
+          <a:ln/>
+        </p:spPr>
+        <p:txBody>
+          <a:bodyPr wrap="square" rtlCol="0" anchor="ctr"/>
+          <a:lstStyle/>
+          <a:p>
+            <a:pPr algn="ctr" indent="0" marL="0">
+              <a:buNone/>
+            </a:pPr>
+            <a:r>
+              <a:rPr lang="en-US" sz="2200" b="1" dirty="0">
+                <a:solidFill>
+                  <a:srgbClr val="0C2A43"/>
+                </a:solidFill>
+                <a:latin typeface="Cambria" pitchFamily="34" charset="0"/>
+                <a:ea typeface="Cambria" pitchFamily="34" charset="-122"/>
+                <a:cs typeface="Cambria" pitchFamily="34" charset="-120"/>
+              </a:rPr>
+              <a:t>5</a:t>
+            </a:r>
+            <a:endParaRPr lang="en-US" sz="2200" dirty="0"/>
+          </a:p>
+        </p:txBody>
+      </p:sp>
+      <p:sp>
+        <p:nvSpPr>
+          <p:cNvPr id="26" name="Text 24"/>
+          <p:cNvSpPr/>
+          <p:nvPr/>
+        </p:nvSpPr>
+        <p:spPr>
+          <a:xfrm>
+            <a:off x="1389888" y="5193792"/>
+            <a:ext cx="4523080" cy="347472"/>
+          </a:xfrm>
+          <a:prstGeom prst="rect">
+            <a:avLst/>
+          </a:prstGeom>
+          <a:noFill/>
+          <a:ln/>
+        </p:spPr>
+        <p:txBody>
+          <a:bodyPr wrap="square" rtlCol="0" anchor="ctr"/>
+          <a:lstStyle/>
+          <a:p>
+            <a:pPr indent="0" marL="0">
+              <a:buNone/>
+            </a:pPr>
+            <a:r>
+              <a:rPr lang="en-US" sz="1600" b="1" dirty="0">
+                <a:solidFill>
+                  <a:srgbClr val="FFFFFF"/>
+                </a:solidFill>
+                <a:latin typeface="Cambria" pitchFamily="34" charset="0"/>
+                <a:ea typeface="Cambria" pitchFamily="34" charset="-122"/>
+                <a:cs typeface="Cambria" pitchFamily="34" charset="-120"/>
+              </a:rPr>
+              <a:t>The PLAYBOOK</a:t>
+            </a:r>
+            <a:endParaRPr lang="en-US" sz="1600" dirty="0"/>
+          </a:p>
+        </p:txBody>
+      </p:sp>
+      <p:sp>
+        <p:nvSpPr>
+          <p:cNvPr id="27" name="Text 25"/>
+          <p:cNvSpPr/>
+          <p:nvPr/>
+        </p:nvSpPr>
+        <p:spPr>
+          <a:xfrm>
+            <a:off x="1389888" y="5541264"/>
+            <a:ext cx="4523080" cy="566928"/>
+          </a:xfrm>
+          <a:prstGeom prst="rect">
+            <a:avLst/>
+          </a:prstGeom>
+          <a:noFill/>
+          <a:ln/>
+        </p:spPr>
+        <p:txBody>
+          <a:bodyPr wrap="square" rtlCol="0" anchor="t"/>
+          <a:lstStyle/>
+          <a:p>
+            <a:pPr indent="0" marL="0">
+              <a:lnSpc>
+                <a:spcPct val="110000"/>
+              </a:lnSpc>
+              <a:buNone/>
+            </a:pPr>
+            <a:r>
+              <a:rPr lang="en-US" sz="1150" dirty="0">
+                <a:solidFill>
+                  <a:srgbClr val="C9D3DD"/>
+                </a:solidFill>
+                <a:latin typeface="Calibri" pitchFamily="34" charset="0"/>
+                <a:ea typeface="Calibri" pitchFamily="34" charset="-122"/>
+                <a:cs typeface="Calibri" pitchFamily="34" charset="-120"/>
+              </a:rPr>
+              <a:t>The exact 14-day checklist we repeat for each of the four waves.</a:t>
+            </a:r>
+            <a:endParaRPr lang="en-US" sz="1150" dirty="0"/>
+          </a:p>
+        </p:txBody>
+      </p:sp>
+      <p:sp>
+        <p:nvSpPr>
+          <p:cNvPr id="28" name="Shape 26"/>
+          <p:cNvSpPr/>
+          <p:nvPr/>
+        </p:nvSpPr>
+        <p:spPr>
+          <a:xfrm>
+            <a:off x="6278728" y="5266944"/>
+            <a:ext cx="548640" cy="548640"/>
+          </a:xfrm>
+          <a:prstGeom prst="ellipse">
+            <a:avLst/>
+          </a:prstGeom>
+          <a:solidFill>
+            <a:srgbClr val="C08A2E"/>
+          </a:solidFill>
+          <a:ln/>
+        </p:spPr>
+      </p:sp>
+      <p:sp>
+        <p:nvSpPr>
+          <p:cNvPr id="29" name="Text 27"/>
+          <p:cNvSpPr/>
+          <p:nvPr/>
+        </p:nvSpPr>
+        <p:spPr>
+          <a:xfrm>
+            <a:off x="6278728" y="5266944"/>
+            <a:ext cx="548640" cy="548640"/>
+          </a:xfrm>
+          <a:prstGeom prst="rect">
+            <a:avLst/>
+          </a:prstGeom>
+          <a:noFill/>
+          <a:ln/>
+        </p:spPr>
+        <p:txBody>
+          <a:bodyPr wrap="square" rtlCol="0" anchor="ctr"/>
+          <a:lstStyle/>
+          <a:p>
+            <a:pPr algn="ctr" indent="0" marL="0">
+              <a:buNone/>
+            </a:pPr>
+            <a:r>
+              <a:rPr lang="en-US" sz="2200" b="1" dirty="0">
+                <a:solidFill>
+                  <a:srgbClr val="0C2A43"/>
+                </a:solidFill>
+                <a:latin typeface="Cambria" pitchFamily="34" charset="0"/>
+                <a:ea typeface="Cambria" pitchFamily="34" charset="-122"/>
+                <a:cs typeface="Cambria" pitchFamily="34" charset="-120"/>
+              </a:rPr>
+              <a:t>6</a:t>
+            </a:r>
+            <a:endParaRPr lang="en-US" sz="2200" dirty="0"/>
+          </a:p>
+        </p:txBody>
+      </p:sp>
+      <p:sp>
+        <p:nvSpPr>
+          <p:cNvPr id="30" name="Text 28"/>
+          <p:cNvSpPr/>
+          <p:nvPr/>
+        </p:nvSpPr>
+        <p:spPr>
+          <a:xfrm>
+            <a:off x="7028536" y="5193792"/>
+            <a:ext cx="4523080" cy="347472"/>
+          </a:xfrm>
+          <a:prstGeom prst="rect">
+            <a:avLst/>
+          </a:prstGeom>
+          <a:noFill/>
+          <a:ln/>
+        </p:spPr>
+        <p:txBody>
+          <a:bodyPr wrap="square" rtlCol="0" anchor="ctr"/>
+          <a:lstStyle/>
+          <a:p>
+            <a:pPr indent="0" marL="0">
+              <a:buNone/>
+            </a:pPr>
+            <a:r>
+              <a:rPr lang="en-US" sz="1600" b="1" dirty="0">
+                <a:solidFill>
+                  <a:srgbClr val="FFFFFF"/>
+                </a:solidFill>
+                <a:latin typeface="Cambria" pitchFamily="34" charset="0"/>
+                <a:ea typeface="Cambria" pitchFamily="34" charset="-122"/>
+                <a:cs typeface="Cambria" pitchFamily="34" charset="-120"/>
+              </a:rPr>
+              <a:t>DO NOW</a:t>
+            </a:r>
+            <a:endParaRPr lang="en-US" sz="1600" dirty="0"/>
+          </a:p>
+        </p:txBody>
+      </p:sp>
+      <p:sp>
+        <p:nvSpPr>
+          <p:cNvPr id="31" name="Text 29"/>
+          <p:cNvSpPr/>
+          <p:nvPr/>
+        </p:nvSpPr>
+        <p:spPr>
+          <a:xfrm>
+            <a:off x="7028536" y="5541264"/>
+            <a:ext cx="4523080" cy="566928"/>
+          </a:xfrm>
+          <a:prstGeom prst="rect">
+            <a:avLst/>
+          </a:prstGeom>
+          <a:noFill/>
+          <a:ln/>
+        </p:spPr>
+        <p:txBody>
+          <a:bodyPr wrap="square" rtlCol="0" anchor="t"/>
+          <a:lstStyle/>
+          <a:p>
+            <a:pPr indent="0" marL="0">
+              <a:lnSpc>
+                <a:spcPct val="110000"/>
+              </a:lnSpc>
+              <a:buNone/>
+            </a:pPr>
+            <a:r>
+              <a:rPr lang="en-US" sz="1150" dirty="0">
+                <a:solidFill>
+                  <a:srgbClr val="C9D3DD"/>
+                </a:solidFill>
+                <a:latin typeface="Calibri" pitchFamily="34" charset="0"/>
+                <a:ea typeface="Calibri" pitchFamily="34" charset="-122"/>
+                <a:cs typeface="Calibri" pitchFamily="34" charset="-120"/>
+              </a:rPr>
+              <a:t>The 7 things to finish this week before Wave 1 goes live.</a:t>
+            </a:r>
+            <a:endParaRPr lang="en-US" sz="1150" dirty="0"/>
+          </a:p>
+        </p:txBody>
+      </p:sp>
+      <p:sp>
+        <p:nvSpPr>
+          <p:cNvPr id="32" name="Text 30"/>
           <p:cNvSpPr/>
           <p:nvPr/>
         </p:nvSpPr>
@@ -21371,47 +21949,8 @@
         </p:nvSpPr>
         <p:spPr>
           <a:xfrm>
-            <a:off x="640080" y="457200"/>
-            <a:ext cx="10911535" cy="274320"/>
-          </a:xfrm>
-          <a:prstGeom prst="rect">
-            <a:avLst/>
-          </a:prstGeom>
-          <a:noFill/>
-          <a:ln/>
-        </p:spPr>
-        <p:txBody>
-          <a:bodyPr wrap="square" rtlCol="0" anchor="ctr"/>
-          <a:lstStyle/>
-          <a:p>
-            <a:pPr indent="0" marL="0">
-              <a:buNone/>
-            </a:pPr>
-            <a:r>
-              <a:rPr lang="en-US" sz="1200" b="1" spc="300" kern="0" dirty="0">
-                <a:solidFill>
-                  <a:srgbClr val="C08A2E"/>
-                </a:solidFill>
-                <a:latin typeface="Calibri" pitchFamily="34" charset="0"/>
-                <a:ea typeface="Calibri" pitchFamily="34" charset="-122"/>
-                <a:cs typeface="Calibri" pitchFamily="34" charset="-120"/>
-              </a:rPr>
-              <a:t>WHERE WE PLAY</a:t>
-            </a:r>
-            <a:endParaRPr lang="en-US" sz="1200" dirty="0"/>
-          </a:p>
-        </p:txBody>
-      </p:sp>
-      <p:sp>
-        <p:nvSpPr>
-          <p:cNvPr id="3" name="Text 1"/>
-          <p:cNvSpPr/>
-          <p:nvPr/>
-        </p:nvSpPr>
-        <p:spPr>
-          <a:xfrm>
-            <a:off x="640080" y="749808"/>
-            <a:ext cx="10911535" cy="822960"/>
+            <a:off x="640080" y="786384"/>
+            <a:ext cx="10911535" cy="731520"/>
           </a:xfrm>
           <a:prstGeom prst="rect">
             <a:avLst/>
@@ -21438,7 +21977,7 @@
                 <a:ea typeface="Cambria" pitchFamily="34" charset="-122"/>
                 <a:cs typeface="Cambria" pitchFamily="34" charset="-120"/>
               </a:rPr>
-              <a:t>Two fronts: a U.S. push and an Israel push</a:t>
+              <a:t>Part 1 — Where: a U.S. push and an Israel push</a:t>
             </a:r>
             <a:endParaRPr lang="en-US" sz="2600" dirty="0"/>
           </a:p>
@@ -21446,13 +21985,66 @@
       </p:sp>
       <p:sp>
         <p:nvSpPr>
+          <p:cNvPr id="3" name="Text 1"/>
+          <p:cNvSpPr/>
+          <p:nvPr/>
+        </p:nvSpPr>
+        <p:spPr>
+          <a:xfrm>
+            <a:off x="640080" y="457200"/>
+            <a:ext cx="10911535" cy="274320"/>
+          </a:xfrm>
+          <a:prstGeom prst="rect">
+            <a:avLst/>
+          </a:prstGeom>
+          <a:noFill/>
+          <a:ln/>
+        </p:spPr>
+        <p:txBody>
+          <a:bodyPr wrap="square" rtlCol="0" anchor="ctr"/>
+          <a:lstStyle/>
+          <a:p>
+            <a:pPr indent="0" marL="0">
+              <a:buNone/>
+            </a:pPr>
+            <a:r>
+              <a:rPr lang="en-US" sz="1100" b="1" spc="200" kern="0" dirty="0">
+                <a:solidFill>
+                  <a:srgbClr val="C08A2E"/>
+                </a:solidFill>
+                <a:latin typeface="Calibri" pitchFamily="34" charset="0"/>
+                <a:ea typeface="Calibri" pitchFamily="34" charset="-122"/>
+                <a:cs typeface="Calibri" pitchFamily="34" charset="-120"/>
+              </a:rPr>
+              <a:t>THE LAUNCH PLAN</a:t>
+            </a:r>
+            <a:pPr indent="0" marL="0">
+              <a:buNone/>
+            </a:pPr>
+            <a:r>
+              <a:rPr lang="en-US" sz="1100" b="1" spc="200" kern="0" dirty="0">
+                <a:solidFill>
+                  <a:srgbClr val="5C6672"/>
+                </a:solidFill>
+                <a:latin typeface="Calibri" pitchFamily="34" charset="0"/>
+                <a:ea typeface="Calibri" pitchFamily="34" charset="-122"/>
+                <a:cs typeface="Calibri" pitchFamily="34" charset="-120"/>
+              </a:rPr>
+              <a:t>     PART 1 OF 6</a:t>
+            </a:r>
+            <a:endParaRPr lang="en-US" sz="1100" dirty="0"/>
+          </a:p>
+        </p:txBody>
+      </p:sp>
+      <p:sp>
+        <p:nvSpPr>
           <p:cNvPr id="4" name="Text 2"/>
           <p:cNvSpPr/>
           <p:nvPr/>
         </p:nvSpPr>
         <p:spPr>
           <a:xfrm>
-            <a:off x="640080" y="1572768"/>
+            <a:off x="640080" y="1536192"/>
             <a:ext cx="10911535" cy="457200"/>
           </a:xfrm>
           <a:prstGeom prst="rect">
@@ -21462,7 +22054,7 @@
           <a:ln/>
         </p:spPr>
         <p:txBody>
-          <a:bodyPr wrap="square" rtlCol="0" anchor="ctr"/>
+          <a:bodyPr wrap="square" rtlCol="0" anchor="t"/>
           <a:lstStyle/>
           <a:p>
             <a:pPr indent="0" marL="0">
@@ -21472,7 +22064,24 @@
               <a:buNone/>
             </a:pPr>
             <a:r>
-              <a:rPr lang="en-US" sz="1400" dirty="0">
+              <a:rPr lang="en-US" sz="1350" b="1" dirty="0">
+                <a:solidFill>
+                  <a:srgbClr val="C08A2E"/>
+                </a:solidFill>
+                <a:latin typeface="Calibri" pitchFamily="34" charset="0"/>
+                <a:ea typeface="Calibri" pitchFamily="34" charset="-122"/>
+                <a:cs typeface="Calibri" pitchFamily="34" charset="-120"/>
+              </a:rPr>
+              <a:t>THIS ANSWERS:  </a:t>
+            </a:r>
+            <a:pPr indent="0" marL="0">
+              <a:lnSpc>
+                <a:spcPct val="115000"/>
+              </a:lnSpc>
+              <a:buNone/>
+            </a:pPr>
+            <a:r>
+              <a:rPr lang="en-US" sz="1350" dirty="0">
                 <a:solidFill>
                   <a:srgbClr val="1A1F26"/>
                 </a:solidFill>
@@ -21480,9 +22089,9 @@
                 <a:ea typeface="Calibri" pitchFamily="34" charset="-122"/>
                 <a:cs typeface="Calibri" pitchFamily="34" charset="-120"/>
               </a:rPr>
-              <a:t>The audience and the outlets are different in each country — so we run two clearly separated efforts with different angles.</a:t>
-            </a:r>
-            <a:endParaRPr lang="en-US" sz="1400" dirty="0"/>
+              <a:t>Which countries, which audiences, and which outlets we target.</a:t>
+            </a:r>
+            <a:endParaRPr lang="en-US" sz="1350" dirty="0"/>
           </a:p>
         </p:txBody>
       </p:sp>
@@ -21494,12 +22103,12 @@
         </p:nvSpPr>
         <p:spPr>
           <a:xfrm>
-            <a:off x="640080" y="2148840"/>
-            <a:ext cx="5272888" cy="3794760"/>
+            <a:off x="640080" y="2240280"/>
+            <a:ext cx="5272888" cy="3703320"/>
           </a:xfrm>
           <a:prstGeom prst="roundRect">
             <a:avLst>
-              <a:gd name="adj" fmla="val 1446"/>
+              <a:gd name="adj" fmla="val 1481"/>
             </a:avLst>
           </a:prstGeom>
           <a:solidFill>
@@ -21521,7 +22130,7 @@
         </p:nvSpPr>
         <p:spPr>
           <a:xfrm>
-            <a:off x="640080" y="2148840"/>
+            <a:off x="640080" y="2240280"/>
             <a:ext cx="5272888" cy="566928"/>
           </a:xfrm>
           <a:prstGeom prst="rect">
@@ -21541,7 +22150,7 @@
         </p:nvSpPr>
         <p:spPr>
           <a:xfrm>
-            <a:off x="868680" y="2148840"/>
+            <a:off x="868680" y="2240280"/>
             <a:ext cx="4815688" cy="566928"/>
           </a:xfrm>
           <a:prstGeom prst="rect">
@@ -21580,7 +22189,7 @@
         </p:nvSpPr>
         <p:spPr>
           <a:xfrm>
-            <a:off x="868680" y="2834640"/>
+            <a:off x="868680" y="2926080"/>
             <a:ext cx="4815688" cy="530352"/>
           </a:xfrm>
           <a:prstGeom prst="rect">
@@ -21622,7 +22231,7 @@
         </p:nvSpPr>
         <p:spPr>
           <a:xfrm>
-            <a:off x="868680" y="3429000"/>
+            <a:off x="868680" y="3520440"/>
             <a:ext cx="4815688" cy="658368"/>
           </a:xfrm>
           <a:prstGeom prst="rect">
@@ -21664,7 +22273,7 @@
         </p:nvSpPr>
         <p:spPr>
           <a:xfrm>
-            <a:off x="868680" y="4142232"/>
+            <a:off x="868680" y="4206240"/>
             <a:ext cx="4815688" cy="219456"/>
           </a:xfrm>
           <a:prstGeom prst="rect">
@@ -21703,7 +22312,7 @@
         </p:nvSpPr>
         <p:spPr>
           <a:xfrm>
-            <a:off x="868680" y="4379976"/>
+            <a:off x="868680" y="4434840"/>
             <a:ext cx="4815688" cy="1005840"/>
           </a:xfrm>
           <a:prstGeom prst="rect">
@@ -21844,12 +22453,12 @@
         </p:nvSpPr>
         <p:spPr>
           <a:xfrm>
-            <a:off x="6278728" y="2148840"/>
-            <a:ext cx="5272888" cy="3794760"/>
+            <a:off x="6278728" y="2240280"/>
+            <a:ext cx="5272888" cy="3703320"/>
           </a:xfrm>
           <a:prstGeom prst="roundRect">
             <a:avLst>
-              <a:gd name="adj" fmla="val 1446"/>
+              <a:gd name="adj" fmla="val 1481"/>
             </a:avLst>
           </a:prstGeom>
           <a:solidFill>
@@ -21871,7 +22480,7 @@
         </p:nvSpPr>
         <p:spPr>
           <a:xfrm>
-            <a:off x="6278728" y="2148840"/>
+            <a:off x="6278728" y="2240280"/>
             <a:ext cx="5272888" cy="566928"/>
           </a:xfrm>
           <a:prstGeom prst="rect">
@@ -21891,7 +22500,7 @@
         </p:nvSpPr>
         <p:spPr>
           <a:xfrm>
-            <a:off x="6507328" y="2148840"/>
+            <a:off x="6507328" y="2240280"/>
             <a:ext cx="4815688" cy="566928"/>
           </a:xfrm>
           <a:prstGeom prst="rect">
@@ -21930,7 +22539,7 @@
         </p:nvSpPr>
         <p:spPr>
           <a:xfrm>
-            <a:off x="6507328" y="2834640"/>
+            <a:off x="6507328" y="2926080"/>
             <a:ext cx="4815688" cy="530352"/>
           </a:xfrm>
           <a:prstGeom prst="rect">
@@ -21972,7 +22581,7 @@
         </p:nvSpPr>
         <p:spPr>
           <a:xfrm>
-            <a:off x="6507328" y="3429000"/>
+            <a:off x="6507328" y="3520440"/>
             <a:ext cx="4815688" cy="658368"/>
           </a:xfrm>
           <a:prstGeom prst="rect">
@@ -22014,7 +22623,7 @@
         </p:nvSpPr>
         <p:spPr>
           <a:xfrm>
-            <a:off x="6507328" y="4142232"/>
+            <a:off x="6507328" y="4206240"/>
             <a:ext cx="4815688" cy="219456"/>
           </a:xfrm>
           <a:prstGeom prst="rect">
@@ -22053,7 +22662,7 @@
         </p:nvSpPr>
         <p:spPr>
           <a:xfrm>
-            <a:off x="6507328" y="4379976"/>
+            <a:off x="6507328" y="4434840"/>
             <a:ext cx="4815688" cy="1005840"/>
           </a:xfrm>
           <a:prstGeom prst="rect">
@@ -22265,47 +22874,8 @@
         </p:nvSpPr>
         <p:spPr>
           <a:xfrm>
-            <a:off x="640080" y="457200"/>
-            <a:ext cx="10911535" cy="274320"/>
-          </a:xfrm>
-          <a:prstGeom prst="rect">
-            <a:avLst/>
-          </a:prstGeom>
-          <a:noFill/>
-          <a:ln/>
-        </p:spPr>
-        <p:txBody>
-          <a:bodyPr wrap="square" rtlCol="0" anchor="ctr"/>
-          <a:lstStyle/>
-          <a:p>
-            <a:pPr indent="0" marL="0">
-              <a:buNone/>
-            </a:pPr>
-            <a:r>
-              <a:rPr lang="en-US" sz="1200" b="1" spc="300" kern="0" dirty="0">
-                <a:solidFill>
-                  <a:srgbClr val="C08A2E"/>
-                </a:solidFill>
-                <a:latin typeface="Calibri" pitchFamily="34" charset="0"/>
-                <a:ea typeface="Calibri" pitchFamily="34" charset="-122"/>
-                <a:cs typeface="Calibri" pitchFamily="34" charset="-120"/>
-              </a:rPr>
-              <a:t>WHAT WE CAN DO FOR FREE</a:t>
-            </a:r>
-            <a:endParaRPr lang="en-US" sz="1200" dirty="0"/>
-          </a:p>
-        </p:txBody>
-      </p:sp>
-      <p:sp>
-        <p:nvSpPr>
-          <p:cNvPr id="3" name="Text 1"/>
-          <p:cNvSpPr/>
-          <p:nvPr/>
-        </p:nvSpPr>
-        <p:spPr>
-          <a:xfrm>
-            <a:off x="640080" y="749808"/>
-            <a:ext cx="10911535" cy="822960"/>
+            <a:off x="640080" y="786384"/>
+            <a:ext cx="10911535" cy="731520"/>
           </a:xfrm>
           <a:prstGeom prst="rect">
             <a:avLst/>
@@ -22332,7 +22902,7 @@
                 <a:ea typeface="Cambria" pitchFamily="34" charset="-122"/>
                 <a:cs typeface="Cambria" pitchFamily="34" charset="-120"/>
               </a:rPr>
-              <a:t>Free earned media — and how likely each is</a:t>
+              <a:t>Part 2 — How, step 1: free earned media</a:t>
             </a:r>
             <a:endParaRPr lang="en-US" sz="2600" dirty="0"/>
           </a:p>
@@ -22340,13 +22910,66 @@
       </p:sp>
       <p:sp>
         <p:nvSpPr>
+          <p:cNvPr id="3" name="Text 1"/>
+          <p:cNvSpPr/>
+          <p:nvPr/>
+        </p:nvSpPr>
+        <p:spPr>
+          <a:xfrm>
+            <a:off x="640080" y="457200"/>
+            <a:ext cx="10911535" cy="274320"/>
+          </a:xfrm>
+          <a:prstGeom prst="rect">
+            <a:avLst/>
+          </a:prstGeom>
+          <a:noFill/>
+          <a:ln/>
+        </p:spPr>
+        <p:txBody>
+          <a:bodyPr wrap="square" rtlCol="0" anchor="ctr"/>
+          <a:lstStyle/>
+          <a:p>
+            <a:pPr indent="0" marL="0">
+              <a:buNone/>
+            </a:pPr>
+            <a:r>
+              <a:rPr lang="en-US" sz="1100" b="1" spc="200" kern="0" dirty="0">
+                <a:solidFill>
+                  <a:srgbClr val="C08A2E"/>
+                </a:solidFill>
+                <a:latin typeface="Calibri" pitchFamily="34" charset="0"/>
+                <a:ea typeface="Calibri" pitchFamily="34" charset="-122"/>
+                <a:cs typeface="Calibri" pitchFamily="34" charset="-120"/>
+              </a:rPr>
+              <a:t>THE LAUNCH PLAN</a:t>
+            </a:r>
+            <a:pPr indent="0" marL="0">
+              <a:buNone/>
+            </a:pPr>
+            <a:r>
+              <a:rPr lang="en-US" sz="1100" b="1" spc="200" kern="0" dirty="0">
+                <a:solidFill>
+                  <a:srgbClr val="5C6672"/>
+                </a:solidFill>
+                <a:latin typeface="Calibri" pitchFamily="34" charset="0"/>
+                <a:ea typeface="Calibri" pitchFamily="34" charset="-122"/>
+                <a:cs typeface="Calibri" pitchFamily="34" charset="-120"/>
+              </a:rPr>
+              <a:t>     PART 2 OF 6</a:t>
+            </a:r>
+            <a:endParaRPr lang="en-US" sz="1100" dirty="0"/>
+          </a:p>
+        </p:txBody>
+      </p:sp>
+      <p:sp>
+        <p:nvSpPr>
           <p:cNvPr id="4" name="Text 2"/>
           <p:cNvSpPr/>
           <p:nvPr/>
         </p:nvSpPr>
         <p:spPr>
           <a:xfrm>
-            <a:off x="640080" y="1572768"/>
+            <a:off x="640080" y="1536192"/>
             <a:ext cx="10911535" cy="457200"/>
           </a:xfrm>
           <a:prstGeom prst="rect">
@@ -22356,7 +22979,7 @@
           <a:ln/>
         </p:spPr>
         <p:txBody>
-          <a:bodyPr wrap="square" rtlCol="0" anchor="ctr"/>
+          <a:bodyPr wrap="square" rtlCol="0" anchor="t"/>
           <a:lstStyle/>
           <a:p>
             <a:pPr indent="0" marL="0">
@@ -22366,7 +22989,24 @@
               <a:buNone/>
             </a:pPr>
             <a:r>
-              <a:rPr lang="en-US" sz="1400" dirty="0">
+              <a:rPr lang="en-US" sz="1350" b="1" dirty="0">
+                <a:solidFill>
+                  <a:srgbClr val="C08A2E"/>
+                </a:solidFill>
+                <a:latin typeface="Calibri" pitchFamily="34" charset="0"/>
+                <a:ea typeface="Calibri" pitchFamily="34" charset="-122"/>
+                <a:cs typeface="Calibri" pitchFamily="34" charset="-120"/>
+              </a:rPr>
+              <a:t>THIS ANSWERS:  </a:t>
+            </a:r>
+            <a:pPr indent="0" marL="0">
+              <a:lnSpc>
+                <a:spcPct val="115000"/>
+              </a:lnSpc>
+              <a:buNone/>
+            </a:pPr>
+            <a:r>
+              <a:rPr lang="en-US" sz="1350" dirty="0">
                 <a:solidFill>
                   <a:srgbClr val="1A1F26"/>
                 </a:solidFill>
@@ -22374,9 +23014,9 @@
                 <a:ea typeface="Calibri" pitchFamily="34" charset="-122"/>
                 <a:cs typeface="Calibri" pitchFamily="34" charset="-120"/>
               </a:rPr>
-              <a:t>These cost only time. They will not guarantee coverage, but stacked together they realistically produce a few real pickups.</a:t>
-            </a:r>
-            <a:endParaRPr lang="en-US" sz="1400" dirty="0"/>
+              <a:t>The no-cost tactics that win coverage — and how likely each is to work.</a:t>
+            </a:r>
+            <a:endParaRPr lang="en-US" sz="1350" dirty="0"/>
           </a:p>
         </p:txBody>
       </p:sp>
@@ -22395,7 +23035,7 @@
           </p:nvPr>
         </p:nvGraphicFramePr>
         <p:xfrm>
-          <a:off x="640080" y="2103120"/>
+          <a:off x="640080" y="2194560"/>
           <a:ext cx="10698480" cy="914400"/>
         </p:xfrm>
         <a:graphic>
@@ -24272,47 +24912,8 @@
         </p:nvSpPr>
         <p:spPr>
           <a:xfrm>
-            <a:off x="640080" y="457200"/>
-            <a:ext cx="10911535" cy="274320"/>
-          </a:xfrm>
-          <a:prstGeom prst="rect">
-            <a:avLst/>
-          </a:prstGeom>
-          <a:noFill/>
-          <a:ln/>
-        </p:spPr>
-        <p:txBody>
-          <a:bodyPr wrap="square" rtlCol="0" anchor="ctr"/>
-          <a:lstStyle/>
-          <a:p>
-            <a:pPr indent="0" marL="0">
-              <a:buNone/>
-            </a:pPr>
-            <a:r>
-              <a:rPr lang="en-US" sz="1200" b="1" spc="300" kern="0" dirty="0">
-                <a:solidFill>
-                  <a:srgbClr val="C08A2E"/>
-                </a:solidFill>
-                <a:latin typeface="Calibri" pitchFamily="34" charset="0"/>
-                <a:ea typeface="Calibri" pitchFamily="34" charset="-122"/>
-                <a:cs typeface="Calibri" pitchFamily="34" charset="-120"/>
-              </a:rPr>
-              <a:t>WHAT COSTS MONEY</a:t>
-            </a:r>
-            <a:endParaRPr lang="en-US" sz="1200" dirty="0"/>
-          </a:p>
-        </p:txBody>
-      </p:sp>
-      <p:sp>
-        <p:nvSpPr>
-          <p:cNvPr id="3" name="Text 1"/>
-          <p:cNvSpPr/>
-          <p:nvPr/>
-        </p:nvSpPr>
-        <p:spPr>
-          <a:xfrm>
-            <a:off x="640080" y="749808"/>
-            <a:ext cx="10911535" cy="822960"/>
+            <a:off x="640080" y="786384"/>
+            <a:ext cx="10911535" cy="731520"/>
           </a:xfrm>
           <a:prstGeom prst="rect">
             <a:avLst/>
@@ -24339,7 +24940,7 @@
                 <a:ea typeface="Cambria" pitchFamily="34" charset="-122"/>
                 <a:cs typeface="Cambria" pitchFamily="34" charset="-120"/>
               </a:rPr>
-              <a:t>Paid distribution — what it buys and what it costs</a:t>
+              <a:t>Part 2 — How, step 2: paid distribution</a:t>
             </a:r>
             <a:endParaRPr lang="en-US" sz="2600" dirty="0"/>
           </a:p>
@@ -24347,13 +24948,66 @@
       </p:sp>
       <p:sp>
         <p:nvSpPr>
+          <p:cNvPr id="3" name="Text 1"/>
+          <p:cNvSpPr/>
+          <p:nvPr/>
+        </p:nvSpPr>
+        <p:spPr>
+          <a:xfrm>
+            <a:off x="640080" y="457200"/>
+            <a:ext cx="10911535" cy="274320"/>
+          </a:xfrm>
+          <a:prstGeom prst="rect">
+            <a:avLst/>
+          </a:prstGeom>
+          <a:noFill/>
+          <a:ln/>
+        </p:spPr>
+        <p:txBody>
+          <a:bodyPr wrap="square" rtlCol="0" anchor="ctr"/>
+          <a:lstStyle/>
+          <a:p>
+            <a:pPr indent="0" marL="0">
+              <a:buNone/>
+            </a:pPr>
+            <a:r>
+              <a:rPr lang="en-US" sz="1100" b="1" spc="200" kern="0" dirty="0">
+                <a:solidFill>
+                  <a:srgbClr val="C08A2E"/>
+                </a:solidFill>
+                <a:latin typeface="Calibri" pitchFamily="34" charset="0"/>
+                <a:ea typeface="Calibri" pitchFamily="34" charset="-122"/>
+                <a:cs typeface="Calibri" pitchFamily="34" charset="-120"/>
+              </a:rPr>
+              <a:t>THE LAUNCH PLAN</a:t>
+            </a:r>
+            <a:pPr indent="0" marL="0">
+              <a:buNone/>
+            </a:pPr>
+            <a:r>
+              <a:rPr lang="en-US" sz="1100" b="1" spc="200" kern="0" dirty="0">
+                <a:solidFill>
+                  <a:srgbClr val="5C6672"/>
+                </a:solidFill>
+                <a:latin typeface="Calibri" pitchFamily="34" charset="0"/>
+                <a:ea typeface="Calibri" pitchFamily="34" charset="-122"/>
+                <a:cs typeface="Calibri" pitchFamily="34" charset="-120"/>
+              </a:rPr>
+              <a:t>     PART 2 OF 6</a:t>
+            </a:r>
+            <a:endParaRPr lang="en-US" sz="1100" dirty="0"/>
+          </a:p>
+        </p:txBody>
+      </p:sp>
+      <p:sp>
+        <p:nvSpPr>
           <p:cNvPr id="4" name="Text 2"/>
           <p:cNvSpPr/>
           <p:nvPr/>
         </p:nvSpPr>
         <p:spPr>
           <a:xfrm>
-            <a:off x="640080" y="1572768"/>
+            <a:off x="640080" y="1536192"/>
             <a:ext cx="10911535" cy="457200"/>
           </a:xfrm>
           <a:prstGeom prst="rect">
@@ -24363,7 +25017,7 @@
           <a:ln/>
         </p:spPr>
         <p:txBody>
-          <a:bodyPr wrap="square" rtlCol="0" anchor="ctr"/>
+          <a:bodyPr wrap="square" rtlCol="0" anchor="t"/>
           <a:lstStyle/>
           <a:p>
             <a:pPr indent="0" marL="0">
@@ -24373,7 +25027,24 @@
               <a:buNone/>
             </a:pPr>
             <a:r>
-              <a:rPr lang="en-US" sz="1400" dirty="0">
+              <a:rPr lang="en-US" sz="1350" b="1" dirty="0">
+                <a:solidFill>
+                  <a:srgbClr val="C08A2E"/>
+                </a:solidFill>
+                <a:latin typeface="Calibri" pitchFamily="34" charset="0"/>
+                <a:ea typeface="Calibri" pitchFamily="34" charset="-122"/>
+                <a:cs typeface="Calibri" pitchFamily="34" charset="-120"/>
+              </a:rPr>
+              <a:t>THIS ANSWERS:  </a:t>
+            </a:r>
+            <a:pPr indent="0" marL="0">
+              <a:lnSpc>
+                <a:spcPct val="115000"/>
+              </a:lnSpc>
+              <a:buNone/>
+            </a:pPr>
+            <a:r>
+              <a:rPr lang="en-US" sz="1350" dirty="0">
                 <a:solidFill>
                   <a:srgbClr val="1A1F26"/>
                 </a:solidFill>
@@ -24381,9 +25052,9 @@
                 <a:ea typeface="Calibri" pitchFamily="34" charset="-122"/>
                 <a:cs typeface="Calibri" pitchFamily="34" charset="-120"/>
               </a:rPr>
-              <a:t>Paid wires are the ONE guaranteed placement. They don’t create a Forbes feature — they create a citable, indexed release that syndicates automatically.</a:t>
-            </a:r>
-            <a:endParaRPr lang="en-US" sz="1400" dirty="0"/>
+              <a:t>The paid wires that guarantee one placement per wave — and what each costs.</a:t>
+            </a:r>
+            <a:endParaRPr lang="en-US" sz="1350" dirty="0"/>
           </a:p>
         </p:txBody>
       </p:sp>
@@ -24402,7 +25073,7 @@
           </p:nvPr>
         </p:nvGraphicFramePr>
         <p:xfrm>
-          <a:off x="640080" y="2103120"/>
+          <a:off x="640080" y="2194560"/>
           <a:ext cx="10881360" cy="914400"/>
         </p:xfrm>
         <a:graphic>
@@ -26279,47 +26950,8 @@
         </p:nvSpPr>
         <p:spPr>
           <a:xfrm>
-            <a:off x="640080" y="457200"/>
-            <a:ext cx="10911535" cy="274320"/>
-          </a:xfrm>
-          <a:prstGeom prst="rect">
-            <a:avLst/>
-          </a:prstGeom>
-          <a:noFill/>
-          <a:ln/>
-        </p:spPr>
-        <p:txBody>
-          <a:bodyPr wrap="square" rtlCol="0" anchor="ctr"/>
-          <a:lstStyle/>
-          <a:p>
-            <a:pPr indent="0" marL="0">
-              <a:buNone/>
-            </a:pPr>
-            <a:r>
-              <a:rPr lang="en-US" sz="1200" b="1" spc="300" kern="0" dirty="0">
-                <a:solidFill>
-                  <a:srgbClr val="C08A2E"/>
-                </a:solidFill>
-                <a:latin typeface="Calibri" pitchFamily="34" charset="0"/>
-                <a:ea typeface="Calibri" pitchFamily="34" charset="-122"/>
-                <a:cs typeface="Calibri" pitchFamily="34" charset="-120"/>
-              </a:rPr>
-              <a:t>THE BUDGET</a:t>
-            </a:r>
-            <a:endParaRPr lang="en-US" sz="1200" dirty="0"/>
-          </a:p>
-        </p:txBody>
-      </p:sp>
-      <p:sp>
-        <p:nvSpPr>
-          <p:cNvPr id="3" name="Text 1"/>
-          <p:cNvSpPr/>
-          <p:nvPr/>
-        </p:nvSpPr>
-        <p:spPr>
-          <a:xfrm>
-            <a:off x="640080" y="749808"/>
-            <a:ext cx="10911535" cy="822960"/>
+            <a:off x="640080" y="786384"/>
+            <a:ext cx="10911535" cy="731520"/>
           </a:xfrm>
           <a:prstGeom prst="rect">
             <a:avLst/>
@@ -26346,7 +26978,7 @@
                 <a:ea typeface="Cambria" pitchFamily="34" charset="-122"/>
                 <a:cs typeface="Cambria" pitchFamily="34" charset="-120"/>
               </a:rPr>
-              <a:t>Two budgets: lean solo vs. premium launch</a:t>
+              <a:t>Part 3 — What it costs: lean vs. premium</a:t>
             </a:r>
             <a:endParaRPr lang="en-US" sz="2600" dirty="0"/>
           </a:p>
@@ -26354,13 +26986,66 @@
       </p:sp>
       <p:sp>
         <p:nvSpPr>
+          <p:cNvPr id="3" name="Text 1"/>
+          <p:cNvSpPr/>
+          <p:nvPr/>
+        </p:nvSpPr>
+        <p:spPr>
+          <a:xfrm>
+            <a:off x="640080" y="457200"/>
+            <a:ext cx="10911535" cy="274320"/>
+          </a:xfrm>
+          <a:prstGeom prst="rect">
+            <a:avLst/>
+          </a:prstGeom>
+          <a:noFill/>
+          <a:ln/>
+        </p:spPr>
+        <p:txBody>
+          <a:bodyPr wrap="square" rtlCol="0" anchor="ctr"/>
+          <a:lstStyle/>
+          <a:p>
+            <a:pPr indent="0" marL="0">
+              <a:buNone/>
+            </a:pPr>
+            <a:r>
+              <a:rPr lang="en-US" sz="1100" b="1" spc="200" kern="0" dirty="0">
+                <a:solidFill>
+                  <a:srgbClr val="C08A2E"/>
+                </a:solidFill>
+                <a:latin typeface="Calibri" pitchFamily="34" charset="0"/>
+                <a:ea typeface="Calibri" pitchFamily="34" charset="-122"/>
+                <a:cs typeface="Calibri" pitchFamily="34" charset="-120"/>
+              </a:rPr>
+              <a:t>THE LAUNCH PLAN</a:t>
+            </a:r>
+            <a:pPr indent="0" marL="0">
+              <a:buNone/>
+            </a:pPr>
+            <a:r>
+              <a:rPr lang="en-US" sz="1100" b="1" spc="200" kern="0" dirty="0">
+                <a:solidFill>
+                  <a:srgbClr val="5C6672"/>
+                </a:solidFill>
+                <a:latin typeface="Calibri" pitchFamily="34" charset="0"/>
+                <a:ea typeface="Calibri" pitchFamily="34" charset="-122"/>
+                <a:cs typeface="Calibri" pitchFamily="34" charset="-120"/>
+              </a:rPr>
+              <a:t>     PART 3 OF 6</a:t>
+            </a:r>
+            <a:endParaRPr lang="en-US" sz="1100" dirty="0"/>
+          </a:p>
+        </p:txBody>
+      </p:sp>
+      <p:sp>
+        <p:nvSpPr>
           <p:cNvPr id="4" name="Text 2"/>
           <p:cNvSpPr/>
           <p:nvPr/>
         </p:nvSpPr>
         <p:spPr>
           <a:xfrm>
-            <a:off x="640080" y="1572768"/>
+            <a:off x="640080" y="1536192"/>
             <a:ext cx="10911535" cy="457200"/>
           </a:xfrm>
           <a:prstGeom prst="rect">
@@ -26370,7 +27055,7 @@
           <a:ln/>
         </p:spPr>
         <p:txBody>
-          <a:bodyPr wrap="square" rtlCol="0" anchor="ctr"/>
+          <a:bodyPr wrap="square" rtlCol="0" anchor="t"/>
           <a:lstStyle/>
           <a:p>
             <a:pPr indent="0" marL="0">
@@ -26380,7 +27065,24 @@
               <a:buNone/>
             </a:pPr>
             <a:r>
-              <a:rPr lang="en-US" sz="1400" dirty="0">
+              <a:rPr lang="en-US" sz="1350" b="1" dirty="0">
+                <a:solidFill>
+                  <a:srgbClr val="C08A2E"/>
+                </a:solidFill>
+                <a:latin typeface="Calibri" pitchFamily="34" charset="0"/>
+                <a:ea typeface="Calibri" pitchFamily="34" charset="-122"/>
+                <a:cs typeface="Calibri" pitchFamily="34" charset="-120"/>
+              </a:rPr>
+              <a:t>THIS ANSWERS:  </a:t>
+            </a:r>
+            <a:pPr indent="0" marL="0">
+              <a:lnSpc>
+                <a:spcPct val="115000"/>
+              </a:lnSpc>
+              <a:buNone/>
+            </a:pPr>
+            <a:r>
+              <a:rPr lang="en-US" sz="1350" dirty="0">
                 <a:solidFill>
                   <a:srgbClr val="1A1F26"/>
                 </a:solidFill>
@@ -26388,9 +27090,9 @@
                 <a:ea typeface="Calibri" pitchFamily="34" charset="-122"/>
                 <a:cs typeface="Calibri" pitchFamily="34" charset="-120"/>
               </a:rPr>
-              <a:t>Everything below is optional spend on top of free tactics. You can run the entire campaign on the lean plan.</a:t>
-            </a:r>
-            <a:endParaRPr lang="en-US" sz="1400" dirty="0"/>
+              <a:t>The total spend for all four waves — and where the extra money goes.</a:t>
+            </a:r>
+            <a:endParaRPr lang="en-US" sz="1350" dirty="0"/>
           </a:p>
         </p:txBody>
       </p:sp>
@@ -26402,12 +27104,12 @@
         </p:nvSpPr>
         <p:spPr>
           <a:xfrm>
-            <a:off x="640080" y="2148840"/>
-            <a:ext cx="5272888" cy="3520440"/>
+            <a:off x="640080" y="2240280"/>
+            <a:ext cx="5272888" cy="3429000"/>
           </a:xfrm>
           <a:prstGeom prst="roundRect">
             <a:avLst>
-              <a:gd name="adj" fmla="val 1558"/>
+              <a:gd name="adj" fmla="val 1600"/>
             </a:avLst>
           </a:prstGeom>
           <a:solidFill>
@@ -26429,7 +27131,7 @@
         </p:nvSpPr>
         <p:spPr>
           <a:xfrm>
-            <a:off x="640080" y="2148840"/>
+            <a:off x="640080" y="2240280"/>
             <a:ext cx="5272888" cy="502920"/>
           </a:xfrm>
           <a:prstGeom prst="rect">
@@ -26449,7 +27151,7 @@
         </p:nvSpPr>
         <p:spPr>
           <a:xfrm>
-            <a:off x="868680" y="2148840"/>
+            <a:off x="868680" y="2240280"/>
             <a:ext cx="4815688" cy="502920"/>
           </a:xfrm>
           <a:prstGeom prst="rect">
@@ -26488,7 +27190,7 @@
         </p:nvSpPr>
         <p:spPr>
           <a:xfrm>
-            <a:off x="868680" y="2770632"/>
+            <a:off x="868680" y="2843784"/>
             <a:ext cx="4815688" cy="640080"/>
           </a:xfrm>
           <a:prstGeom prst="rect">
@@ -26505,7 +27207,7 @@
               <a:buNone/>
             </a:pPr>
             <a:r>
-              <a:rPr lang="en-US" sz="4000" b="1" dirty="0">
+              <a:rPr lang="en-US" sz="3800" b="1" dirty="0">
                 <a:solidFill>
                   <a:srgbClr val="0C2A43"/>
                 </a:solidFill>
@@ -26515,7 +27217,7 @@
               </a:rPr>
               <a:t>~$450–$700</a:t>
             </a:r>
-            <a:endParaRPr lang="en-US" sz="4000" dirty="0"/>
+            <a:endParaRPr lang="en-US" sz="3800" dirty="0"/>
           </a:p>
         </p:txBody>
       </p:sp>
@@ -26527,7 +27229,7 @@
         </p:nvSpPr>
         <p:spPr>
           <a:xfrm>
-            <a:off x="868680" y="3447288"/>
+            <a:off x="868680" y="3502152"/>
             <a:ext cx="4815688" cy="274320"/>
           </a:xfrm>
           <a:prstGeom prst="rect">
@@ -26544,7 +27246,7 @@
               <a:buNone/>
             </a:pPr>
             <a:r>
-              <a:rPr lang="en-US" sz="1200" dirty="0">
+              <a:rPr lang="en-US" sz="1150" dirty="0">
                 <a:solidFill>
                   <a:srgbClr val="5C6672"/>
                 </a:solidFill>
@@ -26552,9 +27254,9 @@
                 <a:ea typeface="Calibri" pitchFamily="34" charset="-122"/>
                 <a:cs typeface="Calibri" pitchFamily="34" charset="-120"/>
               </a:rPr>
-              <a:t>total, all 4 waves</a:t>
-            </a:r>
-            <a:endParaRPr lang="en-US" sz="1200" dirty="0"/>
+              <a:t>total, all 4 waves — our recommendation</a:t>
+            </a:r>
+            <a:endParaRPr lang="en-US" sz="1150" dirty="0"/>
           </a:p>
         </p:txBody>
       </p:sp>
@@ -26566,7 +27268,7 @@
         </p:nvSpPr>
         <p:spPr>
           <a:xfrm>
-            <a:off x="868680" y="3840480"/>
+            <a:off x="868680" y="3867912"/>
             <a:ext cx="3672688" cy="329184"/>
           </a:xfrm>
           <a:prstGeom prst="rect">
@@ -26605,7 +27307,7 @@
         </p:nvSpPr>
         <p:spPr>
           <a:xfrm>
-            <a:off x="4495648" y="3840480"/>
+            <a:off x="4495648" y="3867912"/>
             <a:ext cx="1188720" cy="329184"/>
           </a:xfrm>
           <a:prstGeom prst="rect">
@@ -26644,7 +27346,7 @@
         </p:nvSpPr>
         <p:spPr>
           <a:xfrm>
-            <a:off x="868680" y="4206240"/>
+            <a:off x="868680" y="4233672"/>
             <a:ext cx="3672688" cy="329184"/>
           </a:xfrm>
           <a:prstGeom prst="rect">
@@ -26683,7 +27385,7 @@
         </p:nvSpPr>
         <p:spPr>
           <a:xfrm>
-            <a:off x="4495648" y="4206240"/>
+            <a:off x="4495648" y="4233672"/>
             <a:ext cx="1188720" cy="329184"/>
           </a:xfrm>
           <a:prstGeom prst="rect">
@@ -26722,7 +27424,7 @@
         </p:nvSpPr>
         <p:spPr>
           <a:xfrm>
-            <a:off x="868680" y="4572000"/>
+            <a:off x="868680" y="4599432"/>
             <a:ext cx="3672688" cy="329184"/>
           </a:xfrm>
           <a:prstGeom prst="rect">
@@ -26761,7 +27463,7 @@
         </p:nvSpPr>
         <p:spPr>
           <a:xfrm>
-            <a:off x="4495648" y="4572000"/>
+            <a:off x="4495648" y="4599432"/>
             <a:ext cx="1188720" cy="329184"/>
           </a:xfrm>
           <a:prstGeom prst="rect">
@@ -26800,7 +27502,7 @@
         </p:nvSpPr>
         <p:spPr>
           <a:xfrm>
-            <a:off x="868680" y="4937760"/>
+            <a:off x="868680" y="4965192"/>
             <a:ext cx="3672688" cy="329184"/>
           </a:xfrm>
           <a:prstGeom prst="rect">
@@ -26839,7 +27541,7 @@
         </p:nvSpPr>
         <p:spPr>
           <a:xfrm>
-            <a:off x="4495648" y="4937760"/>
+            <a:off x="4495648" y="4965192"/>
             <a:ext cx="1188720" cy="329184"/>
           </a:xfrm>
           <a:prstGeom prst="rect">
@@ -26878,7 +27580,7 @@
         </p:nvSpPr>
         <p:spPr>
           <a:xfrm>
-            <a:off x="868680" y="5276088"/>
+            <a:off x="868680" y="5294376"/>
             <a:ext cx="4815688" cy="320040"/>
           </a:xfrm>
           <a:prstGeom prst="rect">
@@ -26917,12 +27619,12 @@
         </p:nvSpPr>
         <p:spPr>
           <a:xfrm>
-            <a:off x="6278728" y="2148840"/>
-            <a:ext cx="5272888" cy="3520440"/>
+            <a:off x="6278728" y="2240280"/>
+            <a:ext cx="5272888" cy="3429000"/>
           </a:xfrm>
           <a:prstGeom prst="roundRect">
             <a:avLst>
-              <a:gd name="adj" fmla="val 1558"/>
+              <a:gd name="adj" fmla="val 1600"/>
             </a:avLst>
           </a:prstGeom>
           <a:solidFill>
@@ -26944,7 +27646,7 @@
         </p:nvSpPr>
         <p:spPr>
           <a:xfrm>
-            <a:off x="6278728" y="2148840"/>
+            <a:off x="6278728" y="2240280"/>
             <a:ext cx="5272888" cy="502920"/>
           </a:xfrm>
           <a:prstGeom prst="rect">
@@ -26964,7 +27666,7 @@
         </p:nvSpPr>
         <p:spPr>
           <a:xfrm>
-            <a:off x="6507328" y="2148840"/>
+            <a:off x="6507328" y="2240280"/>
             <a:ext cx="4815688" cy="502920"/>
           </a:xfrm>
           <a:prstGeom prst="rect">
@@ -27003,7 +27705,7 @@
         </p:nvSpPr>
         <p:spPr>
           <a:xfrm>
-            <a:off x="6507328" y="2770632"/>
+            <a:off x="6507328" y="2843784"/>
             <a:ext cx="4815688" cy="640080"/>
           </a:xfrm>
           <a:prstGeom prst="rect">
@@ -27020,7 +27722,7 @@
               <a:buNone/>
             </a:pPr>
             <a:r>
-              <a:rPr lang="en-US" sz="4000" b="1" dirty="0">
+              <a:rPr lang="en-US" sz="3800" b="1" dirty="0">
                 <a:solidFill>
                   <a:srgbClr val="6E4A12"/>
                 </a:solidFill>
@@ -27030,7 +27732,7 @@
               </a:rPr>
               <a:t>~$3,500–$5,000</a:t>
             </a:r>
-            <a:endParaRPr lang="en-US" sz="4000" dirty="0"/>
+            <a:endParaRPr lang="en-US" sz="3800" dirty="0"/>
           </a:p>
         </p:txBody>
       </p:sp>
@@ -27042,7 +27744,7 @@
         </p:nvSpPr>
         <p:spPr>
           <a:xfrm>
-            <a:off x="6507328" y="3447288"/>
+            <a:off x="6507328" y="3502152"/>
             <a:ext cx="4815688" cy="274320"/>
           </a:xfrm>
           <a:prstGeom prst="rect">
@@ -27059,7 +27761,7 @@
               <a:buNone/>
             </a:pPr>
             <a:r>
-              <a:rPr lang="en-US" sz="1200" dirty="0">
+              <a:rPr lang="en-US" sz="1150" dirty="0">
                 <a:solidFill>
                   <a:srgbClr val="5C6672"/>
                 </a:solidFill>
@@ -27067,9 +27769,9 @@
                 <a:ea typeface="Calibri" pitchFamily="34" charset="-122"/>
                 <a:cs typeface="Calibri" pitchFamily="34" charset="-120"/>
               </a:rPr>
-              <a:t>total, all 4 waves</a:t>
-            </a:r>
-            <a:endParaRPr lang="en-US" sz="1200" dirty="0"/>
+              <a:t>total, all 4 waves — optional upgrade</a:t>
+            </a:r>
+            <a:endParaRPr lang="en-US" sz="1150" dirty="0"/>
           </a:p>
         </p:txBody>
       </p:sp>
@@ -27081,7 +27783,7 @@
         </p:nvSpPr>
         <p:spPr>
           <a:xfrm>
-            <a:off x="6507328" y="3840480"/>
+            <a:off x="6507328" y="3867912"/>
             <a:ext cx="3672688" cy="329184"/>
           </a:xfrm>
           <a:prstGeom prst="rect">
@@ -27120,7 +27822,7 @@
         </p:nvSpPr>
         <p:spPr>
           <a:xfrm>
-            <a:off x="10134295" y="3840480"/>
+            <a:off x="10134295" y="3867912"/>
             <a:ext cx="1188720" cy="329184"/>
           </a:xfrm>
           <a:prstGeom prst="rect">
@@ -27159,7 +27861,7 @@
         </p:nvSpPr>
         <p:spPr>
           <a:xfrm>
-            <a:off x="6507328" y="4206240"/>
+            <a:off x="6507328" y="4233672"/>
             <a:ext cx="3672688" cy="329184"/>
           </a:xfrm>
           <a:prstGeom prst="rect">
@@ -27198,7 +27900,7 @@
         </p:nvSpPr>
         <p:spPr>
           <a:xfrm>
-            <a:off x="10134295" y="4206240"/>
+            <a:off x="10134295" y="4233672"/>
             <a:ext cx="1188720" cy="329184"/>
           </a:xfrm>
           <a:prstGeom prst="rect">
@@ -27237,7 +27939,7 @@
         </p:nvSpPr>
         <p:spPr>
           <a:xfrm>
-            <a:off x="6507328" y="4572000"/>
+            <a:off x="6507328" y="4599432"/>
             <a:ext cx="3672688" cy="329184"/>
           </a:xfrm>
           <a:prstGeom prst="rect">
@@ -27276,7 +27978,7 @@
         </p:nvSpPr>
         <p:spPr>
           <a:xfrm>
-            <a:off x="10134295" y="4572000"/>
+            <a:off x="10134295" y="4599432"/>
             <a:ext cx="1188720" cy="329184"/>
           </a:xfrm>
           <a:prstGeom prst="rect">
@@ -27315,7 +28017,7 @@
         </p:nvSpPr>
         <p:spPr>
           <a:xfrm>
-            <a:off x="6507328" y="4937760"/>
+            <a:off x="6507328" y="4965192"/>
             <a:ext cx="3672688" cy="329184"/>
           </a:xfrm>
           <a:prstGeom prst="rect">
@@ -27354,7 +28056,7 @@
         </p:nvSpPr>
         <p:spPr>
           <a:xfrm>
-            <a:off x="10134295" y="4937760"/>
+            <a:off x="10134295" y="4965192"/>
             <a:ext cx="1188720" cy="329184"/>
           </a:xfrm>
           <a:prstGeom prst="rect">
@@ -27393,7 +28095,7 @@
         </p:nvSpPr>
         <p:spPr>
           <a:xfrm>
-            <a:off x="6507328" y="5276088"/>
+            <a:off x="6507328" y="5294376"/>
             <a:ext cx="4815688" cy="320040"/>
           </a:xfrm>
           <a:prstGeom prst="rect">
@@ -27432,7 +28134,7 @@
         </p:nvSpPr>
         <p:spPr>
           <a:xfrm>
-            <a:off x="640080" y="5852160"/>
+            <a:off x="640080" y="5897880"/>
             <a:ext cx="10911535" cy="457200"/>
           </a:xfrm>
           <a:prstGeom prst="rect">
@@ -27545,47 +28247,8 @@
         </p:nvSpPr>
         <p:spPr>
           <a:xfrm>
-            <a:off x="640080" y="457200"/>
-            <a:ext cx="10911535" cy="274320"/>
-          </a:xfrm>
-          <a:prstGeom prst="rect">
-            <a:avLst/>
-          </a:prstGeom>
-          <a:noFill/>
-          <a:ln/>
-        </p:spPr>
-        <p:txBody>
-          <a:bodyPr wrap="square" rtlCol="0" anchor="ctr"/>
-          <a:lstStyle/>
-          <a:p>
-            <a:pPr indent="0" marL="0">
-              <a:buNone/>
-            </a:pPr>
-            <a:r>
-              <a:rPr lang="en-US" sz="1200" b="1" spc="300" kern="0" dirty="0">
-                <a:solidFill>
-                  <a:srgbClr val="C08A2E"/>
-                </a:solidFill>
-                <a:latin typeface="Calibri" pitchFamily="34" charset="0"/>
-                <a:ea typeface="Calibri" pitchFamily="34" charset="-122"/>
-                <a:cs typeface="Calibri" pitchFamily="34" charset="-120"/>
-              </a:rPr>
-              <a:t>HONEST ODDS</a:t>
-            </a:r>
-            <a:endParaRPr lang="en-US" sz="1200" dirty="0"/>
-          </a:p>
-        </p:txBody>
-      </p:sp>
-      <p:sp>
-        <p:nvSpPr>
-          <p:cNvPr id="3" name="Text 1"/>
-          <p:cNvSpPr/>
-          <p:nvPr/>
-        </p:nvSpPr>
-        <p:spPr>
-          <a:xfrm>
-            <a:off x="640080" y="749808"/>
-            <a:ext cx="10911535" cy="822960"/>
+            <a:off x="640080" y="786384"/>
+            <a:ext cx="10911535" cy="731520"/>
           </a:xfrm>
           <a:prstGeom prst="rect">
             <a:avLst/>
@@ -27612,7 +28275,7 @@
                 <a:ea typeface="Cambria" pitchFamily="34" charset="-122"/>
                 <a:cs typeface="Cambria" pitchFamily="34" charset="-120"/>
               </a:rPr>
-              <a:t>What’s guaranteed, what’s likely, what’s a stretch</a:t>
+              <a:t>Part 4 — The odds: guaranteed, likely, stretch</a:t>
             </a:r>
             <a:endParaRPr lang="en-US" sz="2600" dirty="0"/>
           </a:p>
@@ -27620,18 +28283,130 @@
       </p:sp>
       <p:sp>
         <p:nvSpPr>
-          <p:cNvPr id="4" name="Shape 2"/>
-          <p:cNvSpPr/>
-          <p:nvPr/>
-        </p:nvSpPr>
-        <p:spPr>
-          <a:xfrm>
-            <a:off x="640080" y="1874520"/>
-            <a:ext cx="10911535" cy="914400"/>
+          <p:cNvPr id="3" name="Text 1"/>
+          <p:cNvSpPr/>
+          <p:nvPr/>
+        </p:nvSpPr>
+        <p:spPr>
+          <a:xfrm>
+            <a:off x="640080" y="457200"/>
+            <a:ext cx="10911535" cy="274320"/>
+          </a:xfrm>
+          <a:prstGeom prst="rect">
+            <a:avLst/>
+          </a:prstGeom>
+          <a:noFill/>
+          <a:ln/>
+        </p:spPr>
+        <p:txBody>
+          <a:bodyPr wrap="square" rtlCol="0" anchor="ctr"/>
+          <a:lstStyle/>
+          <a:p>
+            <a:pPr indent="0" marL="0">
+              <a:buNone/>
+            </a:pPr>
+            <a:r>
+              <a:rPr lang="en-US" sz="1100" b="1" spc="200" kern="0" dirty="0">
+                <a:solidFill>
+                  <a:srgbClr val="C08A2E"/>
+                </a:solidFill>
+                <a:latin typeface="Calibri" pitchFamily="34" charset="0"/>
+                <a:ea typeface="Calibri" pitchFamily="34" charset="-122"/>
+                <a:cs typeface="Calibri" pitchFamily="34" charset="-120"/>
+              </a:rPr>
+              <a:t>THE LAUNCH PLAN</a:t>
+            </a:r>
+            <a:pPr indent="0" marL="0">
+              <a:buNone/>
+            </a:pPr>
+            <a:r>
+              <a:rPr lang="en-US" sz="1100" b="1" spc="200" kern="0" dirty="0">
+                <a:solidFill>
+                  <a:srgbClr val="5C6672"/>
+                </a:solidFill>
+                <a:latin typeface="Calibri" pitchFamily="34" charset="0"/>
+                <a:ea typeface="Calibri" pitchFamily="34" charset="-122"/>
+                <a:cs typeface="Calibri" pitchFamily="34" charset="-120"/>
+              </a:rPr>
+              <a:t>     PART 4 OF 6</a:t>
+            </a:r>
+            <a:endParaRPr lang="en-US" sz="1100" dirty="0"/>
+          </a:p>
+        </p:txBody>
+      </p:sp>
+      <p:sp>
+        <p:nvSpPr>
+          <p:cNvPr id="4" name="Text 2"/>
+          <p:cNvSpPr/>
+          <p:nvPr/>
+        </p:nvSpPr>
+        <p:spPr>
+          <a:xfrm>
+            <a:off x="640080" y="1536192"/>
+            <a:ext cx="10911535" cy="457200"/>
+          </a:xfrm>
+          <a:prstGeom prst="rect">
+            <a:avLst/>
+          </a:prstGeom>
+          <a:noFill/>
+          <a:ln/>
+        </p:spPr>
+        <p:txBody>
+          <a:bodyPr wrap="square" rtlCol="0" anchor="t"/>
+          <a:lstStyle/>
+          <a:p>
+            <a:pPr indent="0" marL="0">
+              <a:lnSpc>
+                <a:spcPct val="115000"/>
+              </a:lnSpc>
+              <a:buNone/>
+            </a:pPr>
+            <a:r>
+              <a:rPr lang="en-US" sz="1350" b="1" dirty="0">
+                <a:solidFill>
+                  <a:srgbClr val="C08A2E"/>
+                </a:solidFill>
+                <a:latin typeface="Calibri" pitchFamily="34" charset="0"/>
+                <a:ea typeface="Calibri" pitchFamily="34" charset="-122"/>
+                <a:cs typeface="Calibri" pitchFamily="34" charset="-120"/>
+              </a:rPr>
+              <a:t>THIS ANSWERS:  </a:t>
+            </a:r>
+            <a:pPr indent="0" marL="0">
+              <a:lnSpc>
+                <a:spcPct val="115000"/>
+              </a:lnSpc>
+              <a:buNone/>
+            </a:pPr>
+            <a:r>
+              <a:rPr lang="en-US" sz="1350" dirty="0">
+                <a:solidFill>
+                  <a:srgbClr val="1A1F26"/>
+                </a:solidFill>
+                <a:latin typeface="Calibri" pitchFamily="34" charset="0"/>
+                <a:ea typeface="Calibri" pitchFamily="34" charset="-122"/>
+                <a:cs typeface="Calibri" pitchFamily="34" charset="-120"/>
+              </a:rPr>
+              <a:t>What this plan will realistically deliver — stated honestly, no hype.</a:t>
+            </a:r>
+            <a:endParaRPr lang="en-US" sz="1350" dirty="0"/>
+          </a:p>
+        </p:txBody>
+      </p:sp>
+      <p:sp>
+        <p:nvSpPr>
+          <p:cNvPr id="5" name="Shape 3"/>
+          <p:cNvSpPr/>
+          <p:nvPr/>
+        </p:nvSpPr>
+        <p:spPr>
+          <a:xfrm>
+            <a:off x="640080" y="2212848"/>
+            <a:ext cx="10911535" cy="822960"/>
           </a:xfrm>
           <a:prstGeom prst="roundRect">
             <a:avLst>
-              <a:gd name="adj" fmla="val 5000"/>
+              <a:gd name="adj" fmla="val 5556"/>
             </a:avLst>
           </a:prstGeom>
           <a:solidFill>
@@ -27647,18 +28422,18 @@
       </p:sp>
       <p:sp>
         <p:nvSpPr>
-          <p:cNvPr id="5" name="Shape 3"/>
-          <p:cNvSpPr/>
-          <p:nvPr/>
-        </p:nvSpPr>
-        <p:spPr>
-          <a:xfrm>
-            <a:off x="640080" y="1874520"/>
-            <a:ext cx="1691640" cy="914400"/>
+          <p:cNvPr id="6" name="Shape 4"/>
+          <p:cNvSpPr/>
+          <p:nvPr/>
+        </p:nvSpPr>
+        <p:spPr>
+          <a:xfrm>
+            <a:off x="640080" y="2212848"/>
+            <a:ext cx="1691640" cy="822960"/>
           </a:xfrm>
           <a:prstGeom prst="roundRect">
             <a:avLst>
-              <a:gd name="adj" fmla="val 5000"/>
+              <a:gd name="adj" fmla="val 5556"/>
             </a:avLst>
           </a:prstGeom>
           <a:solidFill>
@@ -27669,14 +28444,14 @@
       </p:sp>
       <p:sp>
         <p:nvSpPr>
-          <p:cNvPr id="6" name="Text 4"/>
-          <p:cNvSpPr/>
-          <p:nvPr/>
-        </p:nvSpPr>
-        <p:spPr>
-          <a:xfrm>
-            <a:off x="640080" y="1874520"/>
-            <a:ext cx="1691640" cy="914400"/>
+          <p:cNvPr id="7" name="Text 5"/>
+          <p:cNvSpPr/>
+          <p:nvPr/>
+        </p:nvSpPr>
+        <p:spPr>
+          <a:xfrm>
+            <a:off x="640080" y="2212848"/>
+            <a:ext cx="1691640" cy="822960"/>
           </a:xfrm>
           <a:prstGeom prst="rect">
             <a:avLst/>
@@ -27708,14 +28483,14 @@
       </p:sp>
       <p:sp>
         <p:nvSpPr>
-          <p:cNvPr id="7" name="Text 5"/>
-          <p:cNvSpPr/>
-          <p:nvPr/>
-        </p:nvSpPr>
-        <p:spPr>
-          <a:xfrm>
-            <a:off x="2560320" y="1984248"/>
-            <a:ext cx="3840480" cy="365760"/>
+          <p:cNvPr id="8" name="Text 6"/>
+          <p:cNvSpPr/>
+          <p:nvPr/>
+        </p:nvSpPr>
+        <p:spPr>
+          <a:xfrm>
+            <a:off x="2560320" y="2304288"/>
+            <a:ext cx="3840480" cy="347472"/>
           </a:xfrm>
           <a:prstGeom prst="rect">
             <a:avLst/>
@@ -27747,14 +28522,14 @@
       </p:sp>
       <p:sp>
         <p:nvSpPr>
-          <p:cNvPr id="8" name="Text 6"/>
-          <p:cNvSpPr/>
-          <p:nvPr/>
-        </p:nvSpPr>
-        <p:spPr>
-          <a:xfrm>
-            <a:off x="2560320" y="2377440"/>
-            <a:ext cx="3840480" cy="320040"/>
+          <p:cNvPr id="9" name="Text 7"/>
+          <p:cNvSpPr/>
+          <p:nvPr/>
+        </p:nvSpPr>
+        <p:spPr>
+          <a:xfrm>
+            <a:off x="2560320" y="2670048"/>
+            <a:ext cx="3840480" cy="292608"/>
           </a:xfrm>
           <a:prstGeom prst="rect">
             <a:avLst/>
@@ -27786,14 +28561,14 @@
       </p:sp>
       <p:sp>
         <p:nvSpPr>
-          <p:cNvPr id="9" name="Text 7"/>
-          <p:cNvSpPr/>
-          <p:nvPr/>
-        </p:nvSpPr>
-        <p:spPr>
-          <a:xfrm>
-            <a:off x="6583680" y="1965960"/>
-            <a:ext cx="4785055" cy="777240"/>
+          <p:cNvPr id="10" name="Text 8"/>
+          <p:cNvSpPr/>
+          <p:nvPr/>
+        </p:nvSpPr>
+        <p:spPr>
+          <a:xfrm>
+            <a:off x="6583680" y="2286000"/>
+            <a:ext cx="4785055" cy="713232"/>
           </a:xfrm>
           <a:prstGeom prst="rect">
             <a:avLst/>
@@ -27807,12 +28582,12 @@
           <a:p>
             <a:pPr indent="0" marL="0">
               <a:lnSpc>
-                <a:spcPct val="112000"/>
+                <a:spcPct val="110000"/>
               </a:lnSpc>
               <a:buNone/>
             </a:pPr>
             <a:r>
-              <a:rPr lang="en-US" sz="1150" dirty="0">
+              <a:rPr lang="en-US" sz="1100" dirty="0">
                 <a:solidFill>
                   <a:srgbClr val="1A1F26"/>
                 </a:solidFill>
@@ -27822,24 +28597,24 @@
               </a:rPr>
               <a:t>Every wave appears on the wire + auto-syndications (AP News, Google News). We control this.</a:t>
             </a:r>
-            <a:endParaRPr lang="en-US" sz="1150" dirty="0"/>
-          </a:p>
-        </p:txBody>
-      </p:sp>
-      <p:sp>
-        <p:nvSpPr>
-          <p:cNvPr id="10" name="Shape 8"/>
-          <p:cNvSpPr/>
-          <p:nvPr/>
-        </p:nvSpPr>
-        <p:spPr>
-          <a:xfrm>
-            <a:off x="640080" y="2926080"/>
-            <a:ext cx="10911535" cy="914400"/>
+            <a:endParaRPr lang="en-US" sz="1100" dirty="0"/>
+          </a:p>
+        </p:txBody>
+      </p:sp>
+      <p:sp>
+        <p:nvSpPr>
+          <p:cNvPr id="11" name="Shape 9"/>
+          <p:cNvSpPr/>
+          <p:nvPr/>
+        </p:nvSpPr>
+        <p:spPr>
+          <a:xfrm>
+            <a:off x="640080" y="3145536"/>
+            <a:ext cx="10911535" cy="822960"/>
           </a:xfrm>
           <a:prstGeom prst="roundRect">
             <a:avLst>
-              <a:gd name="adj" fmla="val 5000"/>
+              <a:gd name="adj" fmla="val 5556"/>
             </a:avLst>
           </a:prstGeom>
           <a:solidFill>
@@ -27855,18 +28630,18 @@
       </p:sp>
       <p:sp>
         <p:nvSpPr>
-          <p:cNvPr id="11" name="Shape 9"/>
-          <p:cNvSpPr/>
-          <p:nvPr/>
-        </p:nvSpPr>
-        <p:spPr>
-          <a:xfrm>
-            <a:off x="640080" y="2926080"/>
-            <a:ext cx="1691640" cy="914400"/>
+          <p:cNvPr id="12" name="Shape 10"/>
+          <p:cNvSpPr/>
+          <p:nvPr/>
+        </p:nvSpPr>
+        <p:spPr>
+          <a:xfrm>
+            <a:off x="640080" y="3145536"/>
+            <a:ext cx="1691640" cy="822960"/>
           </a:xfrm>
           <a:prstGeom prst="roundRect">
             <a:avLst>
-              <a:gd name="adj" fmla="val 5000"/>
+              <a:gd name="adj" fmla="val 5556"/>
             </a:avLst>
           </a:prstGeom>
           <a:solidFill>
@@ -27877,14 +28652,14 @@
       </p:sp>
       <p:sp>
         <p:nvSpPr>
-          <p:cNvPr id="12" name="Text 10"/>
-          <p:cNvSpPr/>
-          <p:nvPr/>
-        </p:nvSpPr>
-        <p:spPr>
-          <a:xfrm>
-            <a:off x="640080" y="2926080"/>
-            <a:ext cx="1691640" cy="914400"/>
+          <p:cNvPr id="13" name="Text 11"/>
+          <p:cNvSpPr/>
+          <p:nvPr/>
+        </p:nvSpPr>
+        <p:spPr>
+          <a:xfrm>
+            <a:off x="640080" y="3145536"/>
+            <a:ext cx="1691640" cy="822960"/>
           </a:xfrm>
           <a:prstGeom prst="rect">
             <a:avLst/>
@@ -27916,14 +28691,14 @@
       </p:sp>
       <p:sp>
         <p:nvSpPr>
-          <p:cNvPr id="13" name="Text 11"/>
-          <p:cNvSpPr/>
-          <p:nvPr/>
-        </p:nvSpPr>
-        <p:spPr>
-          <a:xfrm>
-            <a:off x="2560320" y="3035808"/>
-            <a:ext cx="3840480" cy="365760"/>
+          <p:cNvPr id="14" name="Text 12"/>
+          <p:cNvSpPr/>
+          <p:nvPr/>
+        </p:nvSpPr>
+        <p:spPr>
+          <a:xfrm>
+            <a:off x="2560320" y="3236976"/>
+            <a:ext cx="3840480" cy="347472"/>
           </a:xfrm>
           <a:prstGeom prst="rect">
             <a:avLst/>
@@ -27955,14 +28730,14 @@
       </p:sp>
       <p:sp>
         <p:nvSpPr>
-          <p:cNvPr id="14" name="Text 12"/>
-          <p:cNvSpPr/>
-          <p:nvPr/>
-        </p:nvSpPr>
-        <p:spPr>
-          <a:xfrm>
-            <a:off x="2560320" y="3429000"/>
-            <a:ext cx="3840480" cy="320040"/>
+          <p:cNvPr id="15" name="Text 13"/>
+          <p:cNvSpPr/>
+          <p:nvPr/>
+        </p:nvSpPr>
+        <p:spPr>
+          <a:xfrm>
+            <a:off x="2560320" y="3602736"/>
+            <a:ext cx="3840480" cy="292608"/>
           </a:xfrm>
           <a:prstGeom prst="rect">
             <a:avLst/>
@@ -27994,14 +28769,14 @@
       </p:sp>
       <p:sp>
         <p:nvSpPr>
-          <p:cNvPr id="15" name="Text 13"/>
-          <p:cNvSpPr/>
-          <p:nvPr/>
-        </p:nvSpPr>
-        <p:spPr>
-          <a:xfrm>
-            <a:off x="6583680" y="3017520"/>
-            <a:ext cx="4785055" cy="777240"/>
+          <p:cNvPr id="16" name="Text 14"/>
+          <p:cNvSpPr/>
+          <p:nvPr/>
+        </p:nvSpPr>
+        <p:spPr>
+          <a:xfrm>
+            <a:off x="6583680" y="3218688"/>
+            <a:ext cx="4785055" cy="713232"/>
           </a:xfrm>
           <a:prstGeom prst="rect">
             <a:avLst/>
@@ -28015,12 +28790,12 @@
           <a:p>
             <a:pPr indent="0" marL="0">
               <a:lnSpc>
-                <a:spcPct val="112000"/>
+                <a:spcPct val="110000"/>
               </a:lnSpc>
               <a:buNone/>
             </a:pPr>
             <a:r>
-              <a:rPr lang="en-US" sz="1150" dirty="0">
+              <a:rPr lang="en-US" sz="1100" dirty="0">
                 <a:solidFill>
                   <a:srgbClr val="1A1F26"/>
                 </a:solidFill>
@@ -28030,24 +28805,24 @@
               </a:rPr>
               <a:t>Across 8 weeks, with two strong hooks, expect 3–6 real earned stories — mostly US health/consumer + Israeli business.</a:t>
             </a:r>
-            <a:endParaRPr lang="en-US" sz="1150" dirty="0"/>
-          </a:p>
-        </p:txBody>
-      </p:sp>
-      <p:sp>
-        <p:nvSpPr>
-          <p:cNvPr id="16" name="Shape 14"/>
-          <p:cNvSpPr/>
-          <p:nvPr/>
-        </p:nvSpPr>
-        <p:spPr>
-          <a:xfrm>
-            <a:off x="640080" y="3977640"/>
-            <a:ext cx="10911535" cy="914400"/>
+            <a:endParaRPr lang="en-US" sz="1100" dirty="0"/>
+          </a:p>
+        </p:txBody>
+      </p:sp>
+      <p:sp>
+        <p:nvSpPr>
+          <p:cNvPr id="17" name="Shape 15"/>
+          <p:cNvSpPr/>
+          <p:nvPr/>
+        </p:nvSpPr>
+        <p:spPr>
+          <a:xfrm>
+            <a:off x="640080" y="4078224"/>
+            <a:ext cx="10911535" cy="822960"/>
           </a:xfrm>
           <a:prstGeom prst="roundRect">
             <a:avLst>
-              <a:gd name="adj" fmla="val 5000"/>
+              <a:gd name="adj" fmla="val 5556"/>
             </a:avLst>
           </a:prstGeom>
           <a:solidFill>
@@ -28063,18 +28838,18 @@
       </p:sp>
       <p:sp>
         <p:nvSpPr>
-          <p:cNvPr id="17" name="Shape 15"/>
-          <p:cNvSpPr/>
-          <p:nvPr/>
-        </p:nvSpPr>
-        <p:spPr>
-          <a:xfrm>
-            <a:off x="640080" y="3977640"/>
-            <a:ext cx="1691640" cy="914400"/>
+          <p:cNvPr id="18" name="Shape 16"/>
+          <p:cNvSpPr/>
+          <p:nvPr/>
+        </p:nvSpPr>
+        <p:spPr>
+          <a:xfrm>
+            <a:off x="640080" y="4078224"/>
+            <a:ext cx="1691640" cy="822960"/>
           </a:xfrm>
           <a:prstGeom prst="roundRect">
             <a:avLst>
-              <a:gd name="adj" fmla="val 5000"/>
+              <a:gd name="adj" fmla="val 5556"/>
             </a:avLst>
           </a:prstGeom>
           <a:solidFill>
@@ -28085,14 +28860,14 @@
       </p:sp>
       <p:sp>
         <p:nvSpPr>
-          <p:cNvPr id="18" name="Text 16"/>
-          <p:cNvSpPr/>
-          <p:nvPr/>
-        </p:nvSpPr>
-        <p:spPr>
-          <a:xfrm>
-            <a:off x="640080" y="3977640"/>
-            <a:ext cx="1691640" cy="914400"/>
+          <p:cNvPr id="19" name="Text 17"/>
+          <p:cNvSpPr/>
+          <p:nvPr/>
+        </p:nvSpPr>
+        <p:spPr>
+          <a:xfrm>
+            <a:off x="640080" y="4078224"/>
+            <a:ext cx="1691640" cy="822960"/>
           </a:xfrm>
           <a:prstGeom prst="rect">
             <a:avLst/>
@@ -28124,14 +28899,14 @@
       </p:sp>
       <p:sp>
         <p:nvSpPr>
-          <p:cNvPr id="19" name="Text 17"/>
-          <p:cNvSpPr/>
-          <p:nvPr/>
-        </p:nvSpPr>
-        <p:spPr>
-          <a:xfrm>
-            <a:off x="2560320" y="4087368"/>
-            <a:ext cx="3840480" cy="365760"/>
+          <p:cNvPr id="20" name="Text 18"/>
+          <p:cNvSpPr/>
+          <p:nvPr/>
+        </p:nvSpPr>
+        <p:spPr>
+          <a:xfrm>
+            <a:off x="2560320" y="4169664"/>
+            <a:ext cx="3840480" cy="347472"/>
           </a:xfrm>
           <a:prstGeom prst="rect">
             <a:avLst/>
@@ -28163,14 +28938,14 @@
       </p:sp>
       <p:sp>
         <p:nvSpPr>
-          <p:cNvPr id="20" name="Text 18"/>
-          <p:cNvSpPr/>
-          <p:nvPr/>
-        </p:nvSpPr>
-        <p:spPr>
-          <a:xfrm>
-            <a:off x="2560320" y="4480560"/>
-            <a:ext cx="3840480" cy="320040"/>
+          <p:cNvPr id="21" name="Text 19"/>
+          <p:cNvSpPr/>
+          <p:nvPr/>
+        </p:nvSpPr>
+        <p:spPr>
+          <a:xfrm>
+            <a:off x="2560320" y="4535424"/>
+            <a:ext cx="3840480" cy="292608"/>
           </a:xfrm>
           <a:prstGeom prst="rect">
             <a:avLst/>
@@ -28202,14 +28977,14 @@
       </p:sp>
       <p:sp>
         <p:nvSpPr>
-          <p:cNvPr id="21" name="Text 19"/>
-          <p:cNvSpPr/>
-          <p:nvPr/>
-        </p:nvSpPr>
-        <p:spPr>
-          <a:xfrm>
-            <a:off x="6583680" y="4069080"/>
-            <a:ext cx="4785055" cy="777240"/>
+          <p:cNvPr id="22" name="Text 20"/>
+          <p:cNvSpPr/>
+          <p:nvPr/>
+        </p:nvSpPr>
+        <p:spPr>
+          <a:xfrm>
+            <a:off x="6583680" y="4151376"/>
+            <a:ext cx="4785055" cy="713232"/>
           </a:xfrm>
           <a:prstGeom prst="rect">
             <a:avLst/>
@@ -28223,12 +28998,12 @@
           <a:p>
             <a:pPr indent="0" marL="0">
               <a:lnSpc>
-                <a:spcPct val="112000"/>
+                <a:spcPct val="110000"/>
               </a:lnSpc>
               <a:buNone/>
             </a:pPr>
             <a:r>
-              <a:rPr lang="en-US" sz="1150" dirty="0">
+              <a:rPr lang="en-US" sz="1100" dirty="0">
                 <a:solidFill>
                   <a:srgbClr val="1A1F26"/>
                 </a:solidFill>
@@ -28238,24 +29013,24 @@
               </a:rPr>
               <a:t>Forbes / Business Insider / a national broadcast segment. Needs the Julie hook to land — realistic but not promised.</a:t>
             </a:r>
-            <a:endParaRPr lang="en-US" sz="1150" dirty="0"/>
-          </a:p>
-        </p:txBody>
-      </p:sp>
-      <p:sp>
-        <p:nvSpPr>
-          <p:cNvPr id="22" name="Shape 20"/>
-          <p:cNvSpPr/>
-          <p:nvPr/>
-        </p:nvSpPr>
-        <p:spPr>
-          <a:xfrm>
-            <a:off x="640080" y="5029200"/>
-            <a:ext cx="10911535" cy="914400"/>
+            <a:endParaRPr lang="en-US" sz="1100" dirty="0"/>
+          </a:p>
+        </p:txBody>
+      </p:sp>
+      <p:sp>
+        <p:nvSpPr>
+          <p:cNvPr id="23" name="Shape 21"/>
+          <p:cNvSpPr/>
+          <p:nvPr/>
+        </p:nvSpPr>
+        <p:spPr>
+          <a:xfrm>
+            <a:off x="640080" y="5010912"/>
+            <a:ext cx="10911535" cy="822960"/>
           </a:xfrm>
           <a:prstGeom prst="roundRect">
             <a:avLst>
-              <a:gd name="adj" fmla="val 5000"/>
+              <a:gd name="adj" fmla="val 5556"/>
             </a:avLst>
           </a:prstGeom>
           <a:solidFill>
@@ -28271,18 +29046,18 @@
       </p:sp>
       <p:sp>
         <p:nvSpPr>
-          <p:cNvPr id="23" name="Shape 21"/>
-          <p:cNvSpPr/>
-          <p:nvPr/>
-        </p:nvSpPr>
-        <p:spPr>
-          <a:xfrm>
-            <a:off x="640080" y="5029200"/>
-            <a:ext cx="1691640" cy="914400"/>
+          <p:cNvPr id="24" name="Shape 22"/>
+          <p:cNvSpPr/>
+          <p:nvPr/>
+        </p:nvSpPr>
+        <p:spPr>
+          <a:xfrm>
+            <a:off x="640080" y="5010912"/>
+            <a:ext cx="1691640" cy="822960"/>
           </a:xfrm>
           <a:prstGeom prst="roundRect">
             <a:avLst>
-              <a:gd name="adj" fmla="val 5000"/>
+              <a:gd name="adj" fmla="val 5556"/>
             </a:avLst>
           </a:prstGeom>
           <a:solidFill>
@@ -28293,14 +29068,14 @@
       </p:sp>
       <p:sp>
         <p:nvSpPr>
-          <p:cNvPr id="24" name="Text 22"/>
-          <p:cNvSpPr/>
-          <p:nvPr/>
-        </p:nvSpPr>
-        <p:spPr>
-          <a:xfrm>
-            <a:off x="640080" y="5029200"/>
-            <a:ext cx="1691640" cy="914400"/>
+          <p:cNvPr id="25" name="Text 23"/>
+          <p:cNvSpPr/>
+          <p:nvPr/>
+        </p:nvSpPr>
+        <p:spPr>
+          <a:xfrm>
+            <a:off x="640080" y="5010912"/>
+            <a:ext cx="1691640" cy="822960"/>
           </a:xfrm>
           <a:prstGeom prst="rect">
             <a:avLst/>
@@ -28332,14 +29107,14 @@
       </p:sp>
       <p:sp>
         <p:nvSpPr>
-          <p:cNvPr id="25" name="Text 23"/>
-          <p:cNvSpPr/>
-          <p:nvPr/>
-        </p:nvSpPr>
-        <p:spPr>
-          <a:xfrm>
-            <a:off x="2560320" y="5138928"/>
-            <a:ext cx="3840480" cy="365760"/>
+          <p:cNvPr id="26" name="Text 24"/>
+          <p:cNvSpPr/>
+          <p:nvPr/>
+        </p:nvSpPr>
+        <p:spPr>
+          <a:xfrm>
+            <a:off x="2560320" y="5102352"/>
+            <a:ext cx="3840480" cy="347472"/>
           </a:xfrm>
           <a:prstGeom prst="rect">
             <a:avLst/>
@@ -28371,14 +29146,14 @@
       </p:sp>
       <p:sp>
         <p:nvSpPr>
-          <p:cNvPr id="26" name="Text 24"/>
-          <p:cNvSpPr/>
-          <p:nvPr/>
-        </p:nvSpPr>
-        <p:spPr>
-          <a:xfrm>
-            <a:off x="2560320" y="5532120"/>
-            <a:ext cx="3840480" cy="320040"/>
+          <p:cNvPr id="27" name="Text 25"/>
+          <p:cNvSpPr/>
+          <p:nvPr/>
+        </p:nvSpPr>
+        <p:spPr>
+          <a:xfrm>
+            <a:off x="2560320" y="5468112"/>
+            <a:ext cx="3840480" cy="292608"/>
           </a:xfrm>
           <a:prstGeom prst="rect">
             <a:avLst/>
@@ -28410,14 +29185,14 @@
       </p:sp>
       <p:sp>
         <p:nvSpPr>
-          <p:cNvPr id="27" name="Text 25"/>
-          <p:cNvSpPr/>
-          <p:nvPr/>
-        </p:nvSpPr>
-        <p:spPr>
-          <a:xfrm>
-            <a:off x="6583680" y="5120640"/>
-            <a:ext cx="4785055" cy="777240"/>
+          <p:cNvPr id="28" name="Text 26"/>
+          <p:cNvSpPr/>
+          <p:nvPr/>
+        </p:nvSpPr>
+        <p:spPr>
+          <a:xfrm>
+            <a:off x="6583680" y="5084064"/>
+            <a:ext cx="4785055" cy="713232"/>
           </a:xfrm>
           <a:prstGeom prst="rect">
             <a:avLst/>
@@ -28431,12 +29206,12 @@
           <a:p>
             <a:pPr indent="0" marL="0">
               <a:lnSpc>
-                <a:spcPct val="112000"/>
+                <a:spcPct val="110000"/>
               </a:lnSpc>
               <a:buNone/>
             </a:pPr>
             <a:r>
-              <a:rPr lang="en-US" sz="1150" dirty="0">
+              <a:rPr lang="en-US" sz="1100" dirty="0">
                 <a:solidFill>
                   <a:srgbClr val="1A1F26"/>
                 </a:solidFill>
@@ -28446,19 +29221,19 @@
               </a:rPr>
               <a:t>GMA / Today national booking. Great if it happens; never the plan we bank on.</a:t>
             </a:r>
-            <a:endParaRPr lang="en-US" sz="1150" dirty="0"/>
-          </a:p>
-        </p:txBody>
-      </p:sp>
-      <p:sp>
-        <p:nvSpPr>
-          <p:cNvPr id="28" name="Text 26"/>
-          <p:cNvSpPr/>
-          <p:nvPr/>
-        </p:nvSpPr>
-        <p:spPr>
-          <a:xfrm>
-            <a:off x="640080" y="6035040"/>
+            <a:endParaRPr lang="en-US" sz="1100" dirty="0"/>
+          </a:p>
+        </p:txBody>
+      </p:sp>
+      <p:sp>
+        <p:nvSpPr>
+          <p:cNvPr id="29" name="Text 27"/>
+          <p:cNvSpPr/>
+          <p:nvPr/>
+        </p:nvSpPr>
+        <p:spPr>
+          <a:xfrm>
+            <a:off x="640080" y="6053328"/>
             <a:ext cx="10911535" cy="502920"/>
           </a:xfrm>
           <a:prstGeom prst="rect">
@@ -28511,7 +29286,7 @@
       </p:sp>
       <p:sp>
         <p:nvSpPr>
-          <p:cNvPr id="29" name="Text 27"/>
+          <p:cNvPr id="30" name="Text 28"/>
           <p:cNvSpPr/>
           <p:nvPr/>
         </p:nvSpPr>
@@ -28606,7 +29381,7 @@
       </p:sp>
       <p:sp>
         <p:nvSpPr>
-          <p:cNvPr id="30" name="Text 28"/>
+          <p:cNvPr id="31" name="Text 29"/>
           <p:cNvSpPr/>
           <p:nvPr/>
         </p:nvSpPr>

</xml_diff>

<commit_message>
Cost slide: remove leftover jargon (SoS/#journorequest/owned channels)
</commit_message>
<xml_diff>
--- a/eTeacher_Longevity_PR_Campaign.pptx
+++ b/eTeacher_Longevity_PR_Campaign.pptx
@@ -27293,7 +27293,7 @@
                 <a:ea typeface="Calibri" pitchFamily="34" charset="-122"/>
                 <a:cs typeface="Calibri" pitchFamily="34" charset="-120"/>
               </a:rPr>
-              <a:t>EIN Presswire 5-pack</a:t>
+              <a:t>EIN Presswire 5-pack (all 4 waves)</a:t>
             </a:r>
             <a:endParaRPr lang="en-US" sz="1250" dirty="0"/>
           </a:p>
@@ -27371,7 +27371,7 @@
                 <a:ea typeface="Calibri" pitchFamily="34" charset="-122"/>
                 <a:cs typeface="Calibri" pitchFamily="34" charset="-120"/>
               </a:rPr>
-              <a:t>Free tactics (SoS, #journorequest, pitching)</a:t>
+              <a:t>Free press tactics (reporter pitching)</a:t>
             </a:r>
             <a:endParaRPr lang="en-US" sz="1250" dirty="0"/>
           </a:p>
@@ -27449,7 +27449,7 @@
                 <a:ea typeface="Calibri" pitchFamily="34" charset="-122"/>
                 <a:cs typeface="Calibri" pitchFamily="34" charset="-120"/>
               </a:rPr>
-              <a:t>Optional: 1 stock headshot/logo cleanup</a:t>
+              <a:t>Optional: headshot / logo cleanup</a:t>
             </a:r>
             <a:endParaRPr lang="en-US" sz="1250" dirty="0"/>
           </a:p>
@@ -27527,7 +27527,7 @@
                 <a:ea typeface="Calibri" pitchFamily="34" charset="-122"/>
                 <a:cs typeface="Calibri" pitchFamily="34" charset="-120"/>
               </a:rPr>
-              <a:t>Owned channels (LinkedIn, site)</a:t>
+              <a:t>Our own channels (LinkedIn, website)</a:t>
             </a:r>
             <a:endParaRPr lang="en-US" sz="1250" dirty="0"/>
           </a:p>
@@ -28042,7 +28042,7 @@
                 <a:ea typeface="Calibri" pitchFamily="34" charset="-122"/>
                 <a:cs typeface="Calibri" pitchFamily="34" charset="-120"/>
               </a:rPr>
-              <a:t>Freelance media-list / pitch help</a:t>
+              <a:t>Freelance reporter-list / pitch help</a:t>
             </a:r>
             <a:endParaRPr lang="en-US" sz="1250" dirty="0"/>
           </a:p>

</xml_diff>

<commit_message>
Rewrite all CEO quotes fresh/on-voice + rebuild deck & doc
</commit_message>
<xml_diff>
--- a/eTeacher_Longevity_PR_Campaign.pptx
+++ b/eTeacher_Longevity_PR_Campaign.pptx
@@ -4207,7 +4207,7 @@
                 <a:ea typeface="Cambria" pitchFamily="34" charset="-122"/>
                 <a:cs typeface="Cambria" pitchFamily="34" charset="-120"/>
               </a:rPr>
-              <a:t>eTeacher Group Enters the $8 Trillion Longevity Market with Longevity Life Academy, Its Fifth Online School</a:t>
+              <a:t>eTeacher Group Launches Longevity Life Academy — an 18-Week Live Course That Ships a Glucose Monitor to Every Student</a:t>
             </a:r>
             <a:endParaRPr lang="en-US" sz="2600" dirty="0"/>
           </a:p>
@@ -4249,7 +4249,7 @@
                 <a:ea typeface="Calibri" pitchFamily="34" charset="-122"/>
                 <a:cs typeface="Calibri" pitchFamily="34" charset="-120"/>
               </a:rPr>
-              <a:t>After 25 years and 400,000+ courses delivered to students across nearly 200 countries, the Israeli EdTech veteran launches an 18-week live longevity program — with a glucose monitor shipped to every student.</a:t>
+              <a:t>After 25 years and 400,000+ courses across nearly 200 countries, the Israeli education company opens its fifth online school — an 18-week live longevity program, with a continuous glucose monitor shipped to every student.</a:t>
             </a:r>
             <a:endParaRPr lang="en-US" sz="1350" dirty="0"/>
           </a:p>
@@ -4425,7 +4425,7 @@
                 <a:ea typeface="Calibri" pitchFamily="34" charset="-122"/>
                 <a:cs typeface="Calibri" pitchFamily="34" charset="-120"/>
               </a:rPr>
-              <a:t>“The world of education was stuck for hundreds of years, but in the age of artificial intelligence it is undergoing a dramatic transformation,” said Harel Tayeb, CEO of eTeacher Group. “We believe we can bring the world of longevity into every household in the United States and raise healthspan globally.”
+              <a:t>“For twenty-five years we have taught one thing well: real people learn from real teachers, live, in small groups,” said Harel Tayeb, CEO of eTeacher Group. “We are now pointing that method at the question that matters most — how to add healthy years to a life. Longevity has been sold as a luxury. We intend to make it a habit anyone can keep.”
 </a:t>
             </a:r>
             <a:pPr indent="0" marL="0">
@@ -4574,7 +4574,7 @@
                 <a:ea typeface="Calibri" pitchFamily="34" charset="-122"/>
                 <a:cs typeface="Calibri" pitchFamily="34" charset="-120"/>
               </a:rPr>
-              <a:t>“The world of education was stuck for hundreds of years, but in the age of artificial intelligence it is undergoing a dramatic transformation. We believe we can bring the world of longevity into every household in the United States and raise healthspan globally.”</a:t>
+              <a:t>“For twenty-five years we have taught one thing well: real people learn from real teachers, live, in small groups. We are now pointing that method at the question that matters most — how to add healthy years to a life. Longevity has been sold as a luxury. We intend to make it a habit anyone can keep.”</a:t>
             </a:r>
             <a:endParaRPr lang="en-US" sz="1150" dirty="0"/>
           </a:p>
@@ -4616,7 +4616,7 @@
                 <a:ea typeface="Calibri" pitchFamily="34" charset="-122"/>
                 <a:cs typeface="Calibri" pitchFamily="34" charset="-120"/>
               </a:rPr>
-              <a:t>Sentence 1 is verbatim from TheMarker Labels (1 Feb 2026), Q3. Sentence 2 is the one voice-matched new line, drawn from the user's theme line — flagged for CEO approval.</a:t>
+              <a:t>NET-NEW CEO statement — flagged for Harel's approval. Written fresh in his voice; deliberately does NOT reuse any of his published TheMarker lines.</a:t>
             </a:r>
             <a:endParaRPr lang="en-US" sz="680" dirty="0"/>
           </a:p>
@@ -4877,7 +4877,7 @@
                 <a:ea typeface="Calibri" pitchFamily="34" charset="-122"/>
                 <a:cs typeface="Calibri" pitchFamily="34" charset="-120"/>
               </a:rPr>
-              <a:t>The company that taught languages to 400,000+ learners is betting its small-class, “gym for the brain” model can crack the hardest problem in wellness — sticking with it.</a:t>
+              <a:t>The company that taught languages to 400,000+ learners is betting its small-class, live-teaching model can crack the hardest problem in wellness — actually sticking with it.</a:t>
             </a:r>
             <a:endParaRPr lang="en-US" sz="1350" dirty="0"/>
           </a:p>
@@ -4966,7 +4966,7 @@
                 <a:ea typeface="Calibri" pitchFamily="34" charset="-122"/>
                 <a:cs typeface="Calibri" pitchFamily="34" charset="-120"/>
               </a:rPr>
-              <a:t>It is a pointed answer to an industry problem. Self-guided wellness content is abundant, but completion is not; eTeacher argues that longevity, like language, is a practice that fails without persistence. Its model pairs a weekly live “anchor” session with an expert and short daily AI micro-learning — what CEO Harel Tayeb calls a “gym for the brain.”
+              <a:t>It is a pointed answer to an industry problem. Self-guided wellness content is abundant, but completion is not; eTeacher argues that longevity, like language, is a practice that fails without persistence. Its model pairs a weekly live “anchor” session with an expert and short daily practice between classes.
 </a:t>
             </a:r>
             <a:pPr indent="0" marL="0">
@@ -5053,7 +5053,7 @@
                 <a:ea typeface="Calibri" pitchFamily="34" charset="-122"/>
                 <a:cs typeface="Calibri" pitchFamily="34" charset="-120"/>
               </a:rPr>
-              <a:t>“In a world where excessive asynchronous learning leads to dropout and lack of commitment, eTeacher offers a ‘gym for the brain,’ keeping motivation and learning levels high, so that at the next session you can take a meaningful step forward,” Tayeb said. “Longevity is a practice, not a lecture — and that is exactly where our model wins.”
+              <a:t>“Information about living longer is everywhere and almost no one follows through,” Tayeb said. “The hard part was never the science — it was staying with it. Our whole model exists to solve that: a live teacher, a small class, and a small step you actually take before the next session.”
 </a:t>
             </a:r>
             <a:pPr indent="0" marL="0">
@@ -5202,7 +5202,7 @@
                 <a:ea typeface="Calibri" pitchFamily="34" charset="-122"/>
                 <a:cs typeface="Calibri" pitchFamily="34" charset="-120"/>
               </a:rPr>
-              <a:t>“In a world where excessive asynchronous learning leads to dropout and lack of commitment, eTeacher offers a ‘gym for the brain,’ keeping motivation and learning levels high, so that at the next session you can take a meaningful step forward. Longevity is a practice, not a lecture — and that is exactly where our model wins.”</a:t>
+              <a:t>“Information about living longer is everywhere and almost no one follows through. The hard part was never the science — it was staying with it. Our whole model exists to solve that: a live teacher, a small class, and a small step you actually take before the next session.”</a:t>
             </a:r>
             <a:endParaRPr lang="en-US" sz="1150" dirty="0"/>
           </a:p>
@@ -5244,7 +5244,7 @@
                 <a:ea typeface="Calibri" pitchFamily="34" charset="-122"/>
                 <a:cs typeface="Calibri" pitchFamily="34" charset="-120"/>
               </a:rPr>
-              <a:t>Sentence 1 is verbatim from TheMarker Labels (1 Feb 2026), Q4. Sentence 2 is the one voice-matched new line applying the method to longevity — flagged for CEO approval.</a:t>
+              <a:t>NET-NEW CEO statement — flagged for Harel's approval. Fresh in his voice; does NOT reuse the published ‘gym for the brain’ line.</a:t>
             </a:r>
             <a:endParaRPr lang="en-US" sz="680" dirty="0"/>
           </a:p>
@@ -5463,7 +5463,7 @@
                 <a:ea typeface="Cambria" pitchFamily="34" charset="-122"/>
                 <a:cs typeface="Cambria" pitchFamily="34" charset="-120"/>
               </a:rPr>
-              <a:t>eTeacher Launches Longevity Life Academy to Serve the Middle of the $8 Trillion Longevity Market</a:t>
+              <a:t>Longevity Life Academy Targets the Middle of the $8 Trillion Longevity Market — From $289 a Month</a:t>
             </a:r>
             <a:endParaRPr lang="en-US" sz="2600" dirty="0"/>
           </a:p>
@@ -5505,7 +5505,7 @@
                 <a:ea typeface="Calibri" pitchFamily="34" charset="-122"/>
                 <a:cs typeface="Calibri" pitchFamily="34" charset="-120"/>
               </a:rPr>
-              <a:t>With 70% of its customers already in the US, eTeacher is positioning Longevity Life Academy in the underserved middle of an $8 trillion market, starting at $289 a month.</a:t>
+              <a:t>With 70% of its customers already in the US, eTeacher positions Longevity Life Academy between costly clinics and free advice — the underserved middle of an $8 trillion market, starting at $289 a month.</a:t>
             </a:r>
             <a:endParaRPr lang="en-US" sz="1350" dirty="0"/>
           </a:p>
@@ -5681,7 +5681,7 @@
                 <a:ea typeface="Calibri" pitchFamily="34" charset="-122"/>
                 <a:cs typeface="Calibri" pitchFamily="34" charset="-120"/>
               </a:rPr>
-              <a:t>“Israel is well known in cyber and technology, but in edtech — which combines technology with education — it is still not at center stage. My vision is to turn eTeacher into the ‘Wiz’ of the education world,” said CEO Harel Tayeb. “Longevity is where that vision meets the largest consumer opportunity of our time.”
+              <a:t>“The longevity market today has two doors: a clinic that costs a fortune, or a feed full of advice no one checked,” said CEO Harel Tayeb. “Most families are locked out of both. We built the door in the middle — the same rigor, taught live, at a price a household can plan around.”
 </a:t>
             </a:r>
             <a:pPr indent="0" marL="0">
@@ -5830,7 +5830,7 @@
                 <a:ea typeface="Calibri" pitchFamily="34" charset="-122"/>
                 <a:cs typeface="Calibri" pitchFamily="34" charset="-120"/>
               </a:rPr>
-              <a:t>“Israel is well known in cyber and technology, but in edtech — which combines technology with education — it is still not at center stage. My vision is to turn eTeacher into the ‘Wiz’ of the education world. Longevity is where that vision meets the largest consumer opportunity of our time.”</a:t>
+              <a:t>“The longevity market today has two doors: a clinic that costs a fortune, or a feed full of advice no one checked. Most families are locked out of both. We built the door in the middle — the same rigor, taught live, at a price a household can plan around.”</a:t>
             </a:r>
             <a:endParaRPr lang="en-US" sz="1150" dirty="0"/>
           </a:p>
@@ -5872,7 +5872,7 @@
                 <a:ea typeface="Calibri" pitchFamily="34" charset="-122"/>
                 <a:cs typeface="Calibri" pitchFamily="34" charset="-120"/>
               </a:rPr>
-              <a:t>Sentences 1–2 are verbatim from TheMarker Labels (1 Feb 2026), Q8. Sentence 3 is the one voice-matched new line tying the vision to longevity — flagged for CEO approval.</a:t>
+              <a:t>NET-NEW CEO statement — flagged for Harel's approval. Fresh in his voice; does NOT reuse the published ‘Wiz of edtech’ line.</a:t>
             </a:r>
             <a:endParaRPr lang="en-US" sz="680" dirty="0"/>
           </a:p>
@@ -6309,7 +6309,7 @@
                 <a:ea typeface="Calibri" pitchFamily="34" charset="-122"/>
                 <a:cs typeface="Calibri" pitchFamily="34" charset="-120"/>
               </a:rPr>
-              <a:t>“We want to keep the mind and body active and vital in a world where technology may cause cognitive atrophy,” said CEO Harel Tayeb. “Generic health advice ends where personal data begins — so we put a glucose monitor in every student's hands and teach them to build a protocol from their own biology.”
+              <a:t>“Generic advice tells everyone the same thing. Your body doesn't work that way,” said CEO Harel Tayeb. “That is why every student learns from their own data — we ship a glucose monitor to their door and teach them to read what their own biology is telling them, then build one protocol that fits their life.”
 </a:t>
             </a:r>
             <a:pPr indent="0" marL="0">
@@ -6458,7 +6458,7 @@
                 <a:ea typeface="Calibri" pitchFamily="34" charset="-122"/>
                 <a:cs typeface="Calibri" pitchFamily="34" charset="-120"/>
               </a:rPr>
-              <a:t>“We want to keep the mind and body active and vital in a world where technology may cause cognitive atrophy. Generic health advice ends where personal data begins — so we put a glucose monitor in every student's hands and teach them to build a protocol from their own biology.”</a:t>
+              <a:t>“Generic advice tells everyone the same thing. Your body doesn't work that way. That is why every student learns from their own data — we ship a glucose monitor to their door and teach them to read what their own biology is telling them, then build one protocol that fits their life.”</a:t>
             </a:r>
             <a:endParaRPr lang="en-US" sz="1150" dirty="0"/>
           </a:p>
@@ -6500,7 +6500,7 @@
                 <a:ea typeface="Calibri" pitchFamily="34" charset="-122"/>
                 <a:cs typeface="Calibri" pitchFamily="34" charset="-120"/>
               </a:rPr>
-              <a:t>Sentence 1 adapts his verbatim “active and vital / cognitive atrophy” language from TheMarker Labels (1 Feb 2026), Q9. Sentence 2 is the one voice-matched new line — flagged for CEO approval.</a:t>
+              <a:t>NET-NEW CEO statement — flagged for Harel's approval. Fresh in his voice; does NOT reuse the published ‘cognitive atrophy’ line.</a:t>
             </a:r>
             <a:endParaRPr lang="en-US" sz="680" dirty="0"/>
           </a:p>
@@ -6937,7 +6937,7 @@
                 <a:ea typeface="Calibri" pitchFamily="34" charset="-122"/>
                 <a:cs typeface="Calibri" pitchFamily="34" charset="-120"/>
               </a:rPr>
-              <a:t>“Our aspiration is to be the leading platform for meaningful and personalized learning for the adult audience — to keep the mind active and vital in a world where technology may cause cognitive atrophy,” Tayeb said. “Longevity is the most human expression of that mission.”
+              <a:t>“This is an Israeli method, taught to learners in nearly two hundred countries. We are proud of that — quietly,” Tayeb said. “What we care about is whether a person in Ohio or Osaka finishes the course healthier and more capable than they started. Longevity is the most human subject we have ever taught, and it deserves our best work.”
 </a:t>
             </a:r>
             <a:pPr indent="0" marL="0">
@@ -7086,7 +7086,7 @@
                 <a:ea typeface="Calibri" pitchFamily="34" charset="-122"/>
                 <a:cs typeface="Calibri" pitchFamily="34" charset="-120"/>
               </a:rPr>
-              <a:t>“Our aspiration is to be the leading platform for meaningful and personalized learning for the adult audience — to keep the mind active and vital in a world where technology may cause cognitive atrophy. Longevity is the most human expression of that mission.”</a:t>
+              <a:t>“This is an Israeli method, taught to learners in nearly two hundred countries. We are proud of that — quietly. What we care about is whether a person in Ohio or Osaka finishes the course healthier and more capable than they started. Longevity is the most human subject we have ever taught, and it deserves our best work.”</a:t>
             </a:r>
             <a:endParaRPr lang="en-US" sz="1150" dirty="0"/>
           </a:p>
@@ -7128,7 +7128,7 @@
                 <a:ea typeface="Calibri" pitchFamily="34" charset="-122"/>
                 <a:cs typeface="Calibri" pitchFamily="34" charset="-120"/>
               </a:rPr>
-              <a:t>Sentence 1 is verbatim from TheMarker Labels (1 Feb 2026), Q9. Sentence 2 is the one voice-matched new line — flagged for CEO approval. The mid-body “image reinforcement for Israel” phrase is verbatim from Q7.</a:t>
+              <a:t>NET-NEW CEO statement — flagged for Harel's approval. Fresh in his voice; the mid-body ‘image reinforcement for Israel’ phrase remains verbatim from TheMarker Q7.</a:t>
             </a:r>
             <a:endParaRPr lang="en-US" sz="680" dirty="0"/>
           </a:p>
@@ -7565,7 +7565,7 @@
                 <a:ea typeface="Calibri" pitchFamily="34" charset="-122"/>
                 <a:cs typeface="Calibri" pitchFamily="34" charset="-120"/>
               </a:rPr>
-              <a:t>“When the content is compelling and the teacher creates a personal connection, there are no real barriers and learning occurs naturally, without pressure or coercion,” said CEO Harel Tayeb. “Our goal is to simplify and democratize longevity so anyone, whatever their background, can start their own routine.”
+              <a:t>“A longer, stronger life should not depend on your bank balance,” said CEO Harel Tayeb. “Our promise is simple: show up for a live class each week, take one honest step, and let it compound. That is how ordinary people build extraordinary health — not with a fortune, but with a routine that finally sticks.”
 </a:t>
             </a:r>
             <a:pPr indent="0" marL="0">
@@ -7714,7 +7714,7 @@
                 <a:ea typeface="Calibri" pitchFamily="34" charset="-122"/>
                 <a:cs typeface="Calibri" pitchFamily="34" charset="-120"/>
               </a:rPr>
-              <a:t>“When the content is compelling and the teacher creates a personal connection, there are no real barriers and learning occurs naturally, without pressure or coercion. Our goal is to simplify and democratize longevity so anyone, whatever their background, can start their own routine.”</a:t>
+              <a:t>“A longer, stronger life should not depend on your bank balance. Our promise is simple: show up for a live class each week, take one honest step, and let it compound. That is how ordinary people build extraordinary health — not with a fortune, but with a routine that finally sticks.”</a:t>
             </a:r>
             <a:endParaRPr lang="en-US" sz="1150" dirty="0"/>
           </a:p>
@@ -7756,7 +7756,7 @@
                 <a:ea typeface="Calibri" pitchFamily="34" charset="-122"/>
                 <a:cs typeface="Calibri" pitchFamily="34" charset="-120"/>
               </a:rPr>
-              <a:t>Sentence 1 is verbatim from TheMarker Labels (1 Feb 2026), Q5. Sentence 2 is the one voice-matched new line incorporating the user's “every household” brief — flagged for CEO approval.</a:t>
+              <a:t>NET-NEW CEO statement — flagged for Harel's approval. Fresh in his voice; does NOT reuse published lines.</a:t>
             </a:r>
             <a:endParaRPr lang="en-US" sz="680" dirty="0"/>
           </a:p>
@@ -8467,7 +8467,7 @@
                 <a:ea typeface="Calibri" pitchFamily="34" charset="-122"/>
                 <a:cs typeface="Calibri" pitchFamily="34" charset="-120"/>
               </a:rPr>
-              <a:t>“We are focused on impact and results, and Julie's results speak for themselves,” said eTeacher CEO Harel Tayeb. “She is living proof that world-class longevity is about consistent, teachable habits — not spending millions — and that is exactly the school we are building.” Gibson Clark begins teaching with the current enrollment cohort.</a:t>
+              <a:t>“We measure ourselves by results, and Julie's results are impossible to argue with,” said eTeacher CEO Harel Tayeb. “She proved what we teach every day — that world-class health is built from consistent, learnable habits, not from a millionaire's budget. Having her teach it live is exactly the school we set out to build.” Gibson Clark begins teaching with the current enrollment cohort.</a:t>
             </a:r>
             <a:endParaRPr lang="en-US" sz="1050" dirty="0"/>
           </a:p>
@@ -8595,7 +8595,7 @@
                 <a:ea typeface="Calibri" pitchFamily="34" charset="-122"/>
                 <a:cs typeface="Calibri" pitchFamily="34" charset="-120"/>
               </a:rPr>
-              <a:t>“We are focused on impact and results, and Julie's results speak for themselves. She is living proof that world-class longevity is about consistent, teachable habits — not spending millions — and that is exactly the school we are building.”</a:t>
+              <a:t>“We measure ourselves by results, and Julie's results are impossible to argue with. She proved what we teach every day — that world-class health is built from consistent, learnable habits, not from a millionaire's budget. Having her teach it live is exactly the school we set out to build.”</a:t>
             </a:r>
             <a:endParaRPr lang="en-US" sz="1000" dirty="0"/>
           </a:p>
@@ -8637,7 +8637,7 @@
                 <a:ea typeface="Calibri" pitchFamily="34" charset="-122"/>
                 <a:cs typeface="Calibri" pitchFamily="34" charset="-120"/>
               </a:rPr>
-              <a:t>Sentence 1 is verbatim from TheMarker Labels (1 Feb 2026), Q2. Sentence 2 is the one voice-matched new line — flagged for CEO approval.</a:t>
+              <a:t>NET-NEW CEO statement — flagged for Harel's approval. Fresh in his voice; does NOT reuse published lines.</a:t>
             </a:r>
             <a:endParaRPr lang="en-US" sz="680" dirty="0"/>
           </a:p>
@@ -9265,7 +9265,7 @@
                 <a:ea typeface="Calibri" pitchFamily="34" charset="-122"/>
                 <a:cs typeface="Calibri" pitchFamily="34" charset="-120"/>
               </a:rPr>
-              <a:t>“We are focused on impact and results, and Julie's results speak for themselves,” said CEO Harel Tayeb. “Our whole mission is to democratize what used to be a luxury — and a $12-a-day protocol that beats a $2-million-a-year one is the clearest case we could ask for.”</a:t>
+              <a:t>“A twelve-dollar-a-day routine that outperforms a two-million-dollar one is the whole thesis of our school in a single fact,” said CEO Harel Tayeb. “We don't sell shortcuts. We teach the fundamentals, in a room with a real instructor, until they become who you are.”</a:t>
             </a:r>
             <a:endParaRPr lang="en-US" sz="1050" dirty="0"/>
           </a:p>
@@ -9393,7 +9393,7 @@
                 <a:ea typeface="Calibri" pitchFamily="34" charset="-122"/>
                 <a:cs typeface="Calibri" pitchFamily="34" charset="-120"/>
               </a:rPr>
-              <a:t>“We are focused on impact and results, and Julie's results speak for themselves. Our whole mission is to democratize what used to be a luxury — and a $12-a-day protocol that beats a $2-million-a-year one is the clearest case we could ask for.”</a:t>
+              <a:t>“A twelve-dollar-a-day routine that outperforms a two-million-dollar one is the whole thesis of our school in a single fact. We don't sell shortcuts. We teach the fundamentals, in a room with a real instructor, until they become who you are.”</a:t>
             </a:r>
             <a:endParaRPr lang="en-US" sz="1000" dirty="0"/>
           </a:p>
@@ -9435,7 +9435,7 @@
                 <a:ea typeface="Calibri" pitchFamily="34" charset="-122"/>
                 <a:cs typeface="Calibri" pitchFamily="34" charset="-120"/>
               </a:rPr>
-              <a:t>Sentence 1 is verbatim from TheMarker Labels (1 Feb 2026), Q2. Sentence 2 is the one voice-matched new line — flagged for CEO approval.</a:t>
+              <a:t>NET-NEW CEO statement — flagged for Harel's approval. Fresh in his voice; does NOT reuse published lines.</a:t>
             </a:r>
             <a:endParaRPr lang="en-US" sz="680" dirty="0"/>
           </a:p>
@@ -11228,7 +11228,7 @@
                 <a:ea typeface="Calibri" pitchFamily="34" charset="-122"/>
                 <a:cs typeface="Calibri" pitchFamily="34" charset="-120"/>
               </a:rPr>
-              <a:t>“When the teacher creates a personal connection, there are no real barriers and learning happens naturally,” added CEO Harel Tayeb. “Julie starts from why, not from numbers — and that is why she will reach people a leaderboard never could.”</a:t>
+              <a:t>“The best learning always starts with a personal reason, not a number on a chart,” added CEO Harel Tayeb. “Julie begins with why someone wants more years — then teaches the how. That is precisely why she will reach people a leaderboard never could.”</a:t>
             </a:r>
             <a:endParaRPr lang="en-US" sz="1050" dirty="0"/>
           </a:p>
@@ -11356,7 +11356,7 @@
                 <a:ea typeface="Calibri" pitchFamily="34" charset="-122"/>
                 <a:cs typeface="Calibri" pitchFamily="34" charset="-120"/>
               </a:rPr>
-              <a:t>“When the teacher creates a personal connection, there are no real barriers and learning happens naturally. Julie starts from why, not from numbers — and that is why she will reach people a leaderboard never could.”</a:t>
+              <a:t>“The best learning always starts with a personal reason, not a number on a chart. Julie begins with why someone wants more years — then teaches the how. That is precisely why she will reach people a leaderboard never could.”</a:t>
             </a:r>
             <a:endParaRPr lang="en-US" sz="1000" dirty="0"/>
           </a:p>
@@ -11398,7 +11398,7 @@
                 <a:ea typeface="Calibri" pitchFamily="34" charset="-122"/>
                 <a:cs typeface="Calibri" pitchFamily="34" charset="-120"/>
               </a:rPr>
-              <a:t>Sentence 1 is verbatim from TheMarker Labels (1 Feb 2026), Q5. Sentence 2 is the one voice-matched new line — flagged for CEO approval.</a:t>
+              <a:t>NET-NEW CEO statement — flagged for Harel's approval. Fresh in his voice; does NOT reuse published lines.</a:t>
             </a:r>
             <a:endParaRPr lang="en-US" sz="680" dirty="0"/>
           </a:p>
@@ -12654,7 +12654,7 @@
                 <a:ea typeface="Calibri" pitchFamily="34" charset="-122"/>
                 <a:cs typeface="Calibri" pitchFamily="34" charset="-120"/>
               </a:rPr>
-              <a:t>“We want to make accessible content with meaning that will touch the heart and the human core of each person,” added CEO Harel Tayeb.</a:t>
+              <a:t>“We want to teach with meaning — content that reaches the human core of a person, not just their calendar,” added CEO Harel Tayeb. “Julie gives that mission a face: real, humble, and living proof that a longer, healthier life is within reach for anyone willing to practice it.”</a:t>
             </a:r>
             <a:endParaRPr lang="en-US" sz="1050" dirty="0"/>
           </a:p>
@@ -12782,7 +12782,7 @@
                 <a:ea typeface="Calibri" pitchFamily="34" charset="-122"/>
                 <a:cs typeface="Calibri" pitchFamily="34" charset="-120"/>
               </a:rPr>
-              <a:t>“We want to make accessible content with meaning that will touch the heart and the human core of each person. Julie gives that mission a face — real, relatable, and living proof that a longer, healthier life is within reach for anyone.”</a:t>
+              <a:t>“We want to teach with meaning — content that reaches the human core of a person, not just their calendar. Julie gives that mission a face: real, humble, and living proof that a longer, healthier life is within reach for anyone willing to practice it.”</a:t>
             </a:r>
             <a:endParaRPr lang="en-US" sz="1000" dirty="0"/>
           </a:p>
@@ -12824,7 +12824,7 @@
                 <a:ea typeface="Calibri" pitchFamily="34" charset="-122"/>
                 <a:cs typeface="Calibri" pitchFamily="34" charset="-120"/>
               </a:rPr>
-              <a:t>Sentence 1 is verbatim from TheMarker Labels (1 Feb 2026), Q9. Sentence 2 is the one voice-matched new line — flagged for CEO approval.</a:t>
+              <a:t>NET-NEW CEO statement — flagged for Harel's approval. Fresh in his voice; does NOT reuse published lines.</a:t>
             </a:r>
             <a:endParaRPr lang="en-US" sz="680" dirty="0"/>
           </a:p>
@@ -14940,7 +14940,7 @@
                 <a:ea typeface="Calibri" pitchFamily="34" charset="-122"/>
                 <a:cs typeface="Calibri" pitchFamily="34" charset="-120"/>
               </a:rPr>
-              <a:t>“The ‘professor’ is available 24/7 with reliable information and tools that connect learning to your everyday life,” said CEO Harel Tayeb, describing the app's intent. “The Longevity Hub will be that professor for healthspan — a quarter-hour of light practice with your morning coffee.”
+              <a:t>“A weekly class changes what you know. A daily habit changes who you are,” said CEO Harel Tayeb, describing the app's intent. “The Hub we are building will live in that daily space — a few quiet minutes each morning that keep your protocol alive between classes. It is on our roadmap, and we will only ship it when it earns a place in someone's real routine.”
 </a:t>
             </a:r>
             <a:pPr indent="0" marL="0">
@@ -15089,7 +15089,7 @@
                 <a:ea typeface="Calibri" pitchFamily="34" charset="-122"/>
                 <a:cs typeface="Calibri" pitchFamily="34" charset="-120"/>
               </a:rPr>
-              <a:t>“The ‘professor’ is available 24/7 with reliable information and tools that connect learning to your everyday life. The Longevity Hub will be that professor for healthspan — a quarter-hour of light practice with your morning coffee.”</a:t>
+              <a:t>“A weekly class changes what you know. A daily habit changes who you are. The Hub we are building will live in that daily space — a few quiet minutes each morning that keep your protocol alive between classes. It is on our roadmap, and we will only ship it when it earns a place in someone's real routine.”</a:t>
             </a:r>
             <a:endParaRPr lang="en-US" sz="1150" dirty="0"/>
           </a:p>
@@ -15131,7 +15131,7 @@
                 <a:ea typeface="Calibri" pitchFamily="34" charset="-122"/>
                 <a:cs typeface="Calibri" pitchFamily="34" charset="-120"/>
               </a:rPr>
-              <a:t>Sentence 1 is verbatim from TheMarker Labels (1 Feb 2026), Q6; the “quarter-hour with your coffee” phrasing echoes Q4. Sentence 2 is the one voice-matched new line — flagged for approval.</a:t>
+              <a:t>NET-NEW CEO statement — flagged for Harel's approval. Fresh in his voice; does NOT reuse the published ‘professor available 24/7’ line.</a:t>
             </a:r>
             <a:endParaRPr lang="en-US" sz="680" dirty="0"/>
           </a:p>
@@ -15568,7 +15568,7 @@
                 <a:ea typeface="Calibri" pitchFamily="34" charset="-122"/>
                 <a:cs typeface="Calibri" pitchFamily="34" charset="-120"/>
               </a:rPr>
-              <a:t>“In a world where excessive asynchronous learning leads to dropout and lack of commitment, eTeacher offers a ‘gym for the brain,’” said CEO Harel Tayeb. “That same engine — applied to healthspan — is how we plan to make persistence stop being the hard part.”
+              <a:t>“In adult learning, the enemy is not ignorance — it is the day you skip, and then the week,” said CEO Harel Tayeb. “We are designing the Hub's AI to notice that moment and gently pull you back, using your own glucose and sleep data so the nudge means something. That is how we plan to make persistence stop being the hard part.”
 </a:t>
             </a:r>
             <a:pPr indent="0" marL="0">
@@ -15717,7 +15717,7 @@
                 <a:ea typeface="Calibri" pitchFamily="34" charset="-122"/>
                 <a:cs typeface="Calibri" pitchFamily="34" charset="-120"/>
               </a:rPr>
-              <a:t>“In a world where excessive asynchronous learning leads to dropout and lack of commitment, eTeacher offers a ‘gym for the brain.’ That same engine — applied to healthspan — is how we plan to make persistence stop being the hard part.”</a:t>
+              <a:t>“In adult learning, the enemy is not ignorance — it is the day you skip, and then the week. We are designing the Hub's AI to notice that moment and gently pull you back, using your own glucose and sleep data so the nudge means something. That is how we plan to make persistence stop being the hard part.”</a:t>
             </a:r>
             <a:endParaRPr lang="en-US" sz="1150" dirty="0"/>
           </a:p>
@@ -15759,7 +15759,7 @@
                 <a:ea typeface="Calibri" pitchFamily="34" charset="-122"/>
                 <a:cs typeface="Calibri" pitchFamily="34" charset="-120"/>
               </a:rPr>
-              <a:t>Sentence 1 is verbatim from TheMarker Labels (1 Feb 2026), Q4. Sentence 2 is the one voice-matched new line — flagged for approval.</a:t>
+              <a:t>NET-NEW CEO statement — flagged for Harel's approval. Fresh in his voice; does NOT reuse the published ‘gym for the brain’ line.</a:t>
             </a:r>
             <a:endParaRPr lang="en-US" sz="680" dirty="0"/>
           </a:p>
@@ -16449,7 +16449,7 @@
                 <a:ea typeface="Calibri" pitchFamily="34" charset="-122"/>
                 <a:cs typeface="Calibri" pitchFamily="34" charset="-120"/>
               </a:rPr>
-              <a:t>“Our aspiration is to be the leading platform for meaningful and personalized learning for the adult audience,” said CEO Harel Tayeb. “Longevity is not one course — it is a lifelong practice, and we are building the school for it.”
+              <a:t>“One course can change a season. A school can change a life,” said CEO Harel Tayeb. “We are not adding classes to a catalog — we are building a place a person can keep coming back to as their body and their goals change over the decades. Longevity is a lifelong practice, and it deserves a lifelong school.”
 </a:t>
             </a:r>
             <a:pPr indent="0" marL="0">
@@ -16598,7 +16598,7 @@
                 <a:ea typeface="Calibri" pitchFamily="34" charset="-122"/>
                 <a:cs typeface="Calibri" pitchFamily="34" charset="-120"/>
               </a:rPr>
-              <a:t>“Our aspiration is to be the leading platform for meaningful and personalized learning for the adult audience. Longevity is not one course — it is a lifelong practice, and we are building the school for it.”</a:t>
+              <a:t>“One course can change a season. A school can change a life. We are not adding classes to a catalog — we are building a place a person can keep coming back to as their body and their goals change over the decades. Longevity is a lifelong practice, and it deserves a lifelong school.”</a:t>
             </a:r>
             <a:endParaRPr lang="en-US" sz="1150" dirty="0"/>
           </a:p>
@@ -16640,7 +16640,7 @@
                 <a:ea typeface="Calibri" pitchFamily="34" charset="-122"/>
                 <a:cs typeface="Calibri" pitchFamily="34" charset="-120"/>
               </a:rPr>
-              <a:t>Sentence 1 is verbatim from TheMarker Labels (1 Feb 2026), Q9. Sentence 2 is the one voice-matched new line — flagged for approval.</a:t>
+              <a:t>NET-NEW CEO statement — flagged for Harel's approval. Fresh in his voice; does NOT reuse published lines.</a:t>
             </a:r>
             <a:endParaRPr lang="en-US" sz="680" dirty="0"/>
           </a:p>
@@ -17800,7 +17800,7 @@
                 <a:ea typeface="Calibri" pitchFamily="34" charset="-122"/>
                 <a:cs typeface="Calibri" pitchFamily="34" charset="-120"/>
               </a:rPr>
-              <a:t>“We want communities in small groups that keep the mind active and vital in a world where technology may cause cognitive atrophy,” said CEO Harel Tayeb. “Longevity Brain will make that explicit — you can train your brain like you train your body, and social connection is one of the strongest longevity levers we have.”
+              <a:t>“We spend billions keeping the body young and almost nothing keeping the mind and our relationships strong,” said CEO Harel Tayeb. “Longevity Brain will treat memory, focus, and human connection as things you can train — because a long life you can't fully feel or share is only half the goal.”
 </a:t>
             </a:r>
             <a:pPr indent="0" marL="0">
@@ -17949,7 +17949,7 @@
                 <a:ea typeface="Calibri" pitchFamily="34" charset="-122"/>
                 <a:cs typeface="Calibri" pitchFamily="34" charset="-120"/>
               </a:rPr>
-              <a:t>“We want communities in small groups that keep the mind active and vital in a world where technology may cause cognitive atrophy. Longevity Brain will make that explicit — you can train your brain like you train your body, and social connection is one of the strongest longevity levers we have.”</a:t>
+              <a:t>“We spend billions keeping the body young and almost nothing keeping the mind and our relationships strong. Longevity Brain will treat memory, focus, and human connection as things you can train — because a long life you can't fully feel or share is only half the goal.”</a:t>
             </a:r>
             <a:endParaRPr lang="en-US" sz="1150" dirty="0"/>
           </a:p>
@@ -17991,7 +17991,7 @@
                 <a:ea typeface="Calibri" pitchFamily="34" charset="-122"/>
                 <a:cs typeface="Calibri" pitchFamily="34" charset="-120"/>
               </a:rPr>
-              <a:t>Sentence 1 adapts his verbatim “active and vital / cognitive atrophy / communities in small groups” language from TheMarker Labels (1 Feb 2026), Q9. Sentence 2 is the one voice-matched new line — flagged for approval.</a:t>
+              <a:t>NET-NEW CEO statement — flagged for Harel's approval. Fresh in his voice; does NOT reuse the published ‘cognitive atrophy’ line.</a:t>
             </a:r>
             <a:endParaRPr lang="en-US" sz="680" dirty="0"/>
           </a:p>

</xml_diff>

<commit_message>
Add Wave 5: 5 Bryan Johnson newsjacking articles (respectful, LLA message in headers)
</commit_message>
<xml_diff>
--- a/eTeacher_Longevity_PR_Campaign.pptx
+++ b/eTeacher_Longevity_PR_Campaign.pptx
@@ -36,9 +36,15 @@
     <p:sldId id="284" r:id="rId30"/>
     <p:sldId id="285" r:id="rId31"/>
     <p:sldId id="286" r:id="rId32"/>
+    <p:sldId id="287" r:id="rId33"/>
+    <p:sldId id="288" r:id="rId34"/>
+    <p:sldId id="289" r:id="rId35"/>
+    <p:sldId id="290" r:id="rId36"/>
+    <p:sldId id="291" r:id="rId37"/>
+    <p:sldId id="292" r:id="rId38"/>
   </p:sldIdLst>
   <p:notesMasterIdLst>
-    <p:notesMasterId r:id="rId33"/>
+    <p:notesMasterId r:id="rId39"/>
   </p:notesMasterIdLst>
   <p:sldSz cx="12191695" cy="6858000"/>
   <p:notesSz cx="6858000" cy="12191695"/>
@@ -2668,6 +2674,534 @@
             <a:fld id="{F7021451-1387-4CA6-816F-3879F97B5CBC}" type="slidenum">
               <a:rPr lang="en-US"/>
               <a:t>31</a:t>
+            </a:fld>
+            <a:endParaRPr lang="en-US"/>
+          </a:p>
+        </p:txBody>
+      </p:sp>
+    </p:spTree>
+    <p:extLst>
+      <p:ext uri="{BB962C8B-B14F-4D97-AF65-F5344CB8AC3E}">
+        <p14:creationId xmlns:p14="http://schemas.microsoft.com/office/powerpoint/2010/main" val="1024086991"/>
+      </p:ext>
+    </p:extLst>
+  </p:cSld>
+  <p:clrMapOvr>
+    <a:masterClrMapping/>
+  </p:clrMapOvr>
+</p:notes>
+</file>
+
+<file path=ppt/notesSlides/notesSlide32.xml><?xml version="1.0" encoding="utf-8"?>
+<p:notes xmlns:a="http://schemas.openxmlformats.org/drawingml/2006/main" xmlns:r="http://schemas.openxmlformats.org/officeDocument/2006/relationships" xmlns:p="http://schemas.openxmlformats.org/presentationml/2006/main">
+  <p:cSld>
+    <p:spTree>
+      <p:nvGrpSpPr>
+        <p:cNvPr id="1" name=""/>
+        <p:cNvGrpSpPr/>
+        <p:nvPr/>
+      </p:nvGrpSpPr>
+      <p:grpSpPr>
+        <a:xfrm>
+          <a:off x="0" y="0"/>
+          <a:ext cx="0" cy="0"/>
+          <a:chOff x="0" y="0"/>
+          <a:chExt cx="0" cy="0"/>
+        </a:xfrm>
+      </p:grpSpPr>
+      <p:sp>
+        <p:nvSpPr>
+          <p:cNvPr id="2" name="Slide Image Placeholder 1"/>
+          <p:cNvSpPr>
+            <a:spLocks noGrp="1" noRot="1" noChangeAspect="1"/>
+          </p:cNvSpPr>
+          <p:nvPr>
+            <p:ph type="sldImg"/>
+          </p:nvPr>
+        </p:nvSpPr>
+        <p:spPr/>
+      </p:sp>
+      <p:sp>
+        <p:nvSpPr>
+          <p:cNvPr id="3" name="Notes Placeholder 2"/>
+          <p:cNvSpPr>
+            <a:spLocks noGrp="1"/>
+          </p:cNvSpPr>
+          <p:nvPr>
+            <p:ph type="body" idx="1"/>
+          </p:nvPr>
+        </p:nvSpPr>
+        <p:spPr/>
+        <p:txBody>
+          <a:bodyPr/>
+          <a:lstStyle/>
+          <a:p>
+            <a:r>
+              <a:rPr lang="en-US" dirty="0"/>
+              <a:t/>
+            </a:r>
+            <a:endParaRPr lang="en-US" dirty="0"/>
+          </a:p>
+        </p:txBody>
+      </p:sp>
+      <p:sp>
+        <p:nvSpPr>
+          <p:cNvPr id="4" name="Slide Number Placeholder 3"/>
+          <p:cNvSpPr>
+            <a:spLocks noGrp="1"/>
+          </p:cNvSpPr>
+          <p:nvPr>
+            <p:ph type="sldNum" sz="quarter" idx="10"/>
+          </p:nvPr>
+        </p:nvSpPr>
+        <p:spPr/>
+        <p:txBody>
+          <a:bodyPr/>
+          <a:lstStyle/>
+          <a:p>
+            <a:fld id="{F7021451-1387-4CA6-816F-3879F97B5CBC}" type="slidenum">
+              <a:rPr lang="en-US"/>
+              <a:t>32</a:t>
+            </a:fld>
+            <a:endParaRPr lang="en-US"/>
+          </a:p>
+        </p:txBody>
+      </p:sp>
+    </p:spTree>
+    <p:extLst>
+      <p:ext uri="{BB962C8B-B14F-4D97-AF65-F5344CB8AC3E}">
+        <p14:creationId xmlns:p14="http://schemas.microsoft.com/office/powerpoint/2010/main" val="1024086991"/>
+      </p:ext>
+    </p:extLst>
+  </p:cSld>
+  <p:clrMapOvr>
+    <a:masterClrMapping/>
+  </p:clrMapOvr>
+</p:notes>
+</file>
+
+<file path=ppt/notesSlides/notesSlide33.xml><?xml version="1.0" encoding="utf-8"?>
+<p:notes xmlns:a="http://schemas.openxmlformats.org/drawingml/2006/main" xmlns:r="http://schemas.openxmlformats.org/officeDocument/2006/relationships" xmlns:p="http://schemas.openxmlformats.org/presentationml/2006/main">
+  <p:cSld>
+    <p:spTree>
+      <p:nvGrpSpPr>
+        <p:cNvPr id="1" name=""/>
+        <p:cNvGrpSpPr/>
+        <p:nvPr/>
+      </p:nvGrpSpPr>
+      <p:grpSpPr>
+        <a:xfrm>
+          <a:off x="0" y="0"/>
+          <a:ext cx="0" cy="0"/>
+          <a:chOff x="0" y="0"/>
+          <a:chExt cx="0" cy="0"/>
+        </a:xfrm>
+      </p:grpSpPr>
+      <p:sp>
+        <p:nvSpPr>
+          <p:cNvPr id="2" name="Slide Image Placeholder 1"/>
+          <p:cNvSpPr>
+            <a:spLocks noGrp="1" noRot="1" noChangeAspect="1"/>
+          </p:cNvSpPr>
+          <p:nvPr>
+            <p:ph type="sldImg"/>
+          </p:nvPr>
+        </p:nvSpPr>
+        <p:spPr/>
+      </p:sp>
+      <p:sp>
+        <p:nvSpPr>
+          <p:cNvPr id="3" name="Notes Placeholder 2"/>
+          <p:cNvSpPr>
+            <a:spLocks noGrp="1"/>
+          </p:cNvSpPr>
+          <p:nvPr>
+            <p:ph type="body" idx="1"/>
+          </p:nvPr>
+        </p:nvSpPr>
+        <p:spPr/>
+        <p:txBody>
+          <a:bodyPr/>
+          <a:lstStyle/>
+          <a:p>
+            <a:r>
+              <a:rPr lang="en-US" dirty="0"/>
+              <a:t/>
+            </a:r>
+            <a:endParaRPr lang="en-US" dirty="0"/>
+          </a:p>
+        </p:txBody>
+      </p:sp>
+      <p:sp>
+        <p:nvSpPr>
+          <p:cNvPr id="4" name="Slide Number Placeholder 3"/>
+          <p:cNvSpPr>
+            <a:spLocks noGrp="1"/>
+          </p:cNvSpPr>
+          <p:nvPr>
+            <p:ph type="sldNum" sz="quarter" idx="10"/>
+          </p:nvPr>
+        </p:nvSpPr>
+        <p:spPr/>
+        <p:txBody>
+          <a:bodyPr/>
+          <a:lstStyle/>
+          <a:p>
+            <a:fld id="{F7021451-1387-4CA6-816F-3879F97B5CBC}" type="slidenum">
+              <a:rPr lang="en-US"/>
+              <a:t>33</a:t>
+            </a:fld>
+            <a:endParaRPr lang="en-US"/>
+          </a:p>
+        </p:txBody>
+      </p:sp>
+    </p:spTree>
+    <p:extLst>
+      <p:ext uri="{BB962C8B-B14F-4D97-AF65-F5344CB8AC3E}">
+        <p14:creationId xmlns:p14="http://schemas.microsoft.com/office/powerpoint/2010/main" val="1024086991"/>
+      </p:ext>
+    </p:extLst>
+  </p:cSld>
+  <p:clrMapOvr>
+    <a:masterClrMapping/>
+  </p:clrMapOvr>
+</p:notes>
+</file>
+
+<file path=ppt/notesSlides/notesSlide34.xml><?xml version="1.0" encoding="utf-8"?>
+<p:notes xmlns:a="http://schemas.openxmlformats.org/drawingml/2006/main" xmlns:r="http://schemas.openxmlformats.org/officeDocument/2006/relationships" xmlns:p="http://schemas.openxmlformats.org/presentationml/2006/main">
+  <p:cSld>
+    <p:spTree>
+      <p:nvGrpSpPr>
+        <p:cNvPr id="1" name=""/>
+        <p:cNvGrpSpPr/>
+        <p:nvPr/>
+      </p:nvGrpSpPr>
+      <p:grpSpPr>
+        <a:xfrm>
+          <a:off x="0" y="0"/>
+          <a:ext cx="0" cy="0"/>
+          <a:chOff x="0" y="0"/>
+          <a:chExt cx="0" cy="0"/>
+        </a:xfrm>
+      </p:grpSpPr>
+      <p:sp>
+        <p:nvSpPr>
+          <p:cNvPr id="2" name="Slide Image Placeholder 1"/>
+          <p:cNvSpPr>
+            <a:spLocks noGrp="1" noRot="1" noChangeAspect="1"/>
+          </p:cNvSpPr>
+          <p:nvPr>
+            <p:ph type="sldImg"/>
+          </p:nvPr>
+        </p:nvSpPr>
+        <p:spPr/>
+      </p:sp>
+      <p:sp>
+        <p:nvSpPr>
+          <p:cNvPr id="3" name="Notes Placeholder 2"/>
+          <p:cNvSpPr>
+            <a:spLocks noGrp="1"/>
+          </p:cNvSpPr>
+          <p:nvPr>
+            <p:ph type="body" idx="1"/>
+          </p:nvPr>
+        </p:nvSpPr>
+        <p:spPr/>
+        <p:txBody>
+          <a:bodyPr/>
+          <a:lstStyle/>
+          <a:p>
+            <a:r>
+              <a:rPr lang="en-US" dirty="0"/>
+              <a:t/>
+            </a:r>
+            <a:endParaRPr lang="en-US" dirty="0"/>
+          </a:p>
+        </p:txBody>
+      </p:sp>
+      <p:sp>
+        <p:nvSpPr>
+          <p:cNvPr id="4" name="Slide Number Placeholder 3"/>
+          <p:cNvSpPr>
+            <a:spLocks noGrp="1"/>
+          </p:cNvSpPr>
+          <p:nvPr>
+            <p:ph type="sldNum" sz="quarter" idx="10"/>
+          </p:nvPr>
+        </p:nvSpPr>
+        <p:spPr/>
+        <p:txBody>
+          <a:bodyPr/>
+          <a:lstStyle/>
+          <a:p>
+            <a:fld id="{F7021451-1387-4CA6-816F-3879F97B5CBC}" type="slidenum">
+              <a:rPr lang="en-US"/>
+              <a:t>34</a:t>
+            </a:fld>
+            <a:endParaRPr lang="en-US"/>
+          </a:p>
+        </p:txBody>
+      </p:sp>
+    </p:spTree>
+    <p:extLst>
+      <p:ext uri="{BB962C8B-B14F-4D97-AF65-F5344CB8AC3E}">
+        <p14:creationId xmlns:p14="http://schemas.microsoft.com/office/powerpoint/2010/main" val="1024086991"/>
+      </p:ext>
+    </p:extLst>
+  </p:cSld>
+  <p:clrMapOvr>
+    <a:masterClrMapping/>
+  </p:clrMapOvr>
+</p:notes>
+</file>
+
+<file path=ppt/notesSlides/notesSlide35.xml><?xml version="1.0" encoding="utf-8"?>
+<p:notes xmlns:a="http://schemas.openxmlformats.org/drawingml/2006/main" xmlns:r="http://schemas.openxmlformats.org/officeDocument/2006/relationships" xmlns:p="http://schemas.openxmlformats.org/presentationml/2006/main">
+  <p:cSld>
+    <p:spTree>
+      <p:nvGrpSpPr>
+        <p:cNvPr id="1" name=""/>
+        <p:cNvGrpSpPr/>
+        <p:nvPr/>
+      </p:nvGrpSpPr>
+      <p:grpSpPr>
+        <a:xfrm>
+          <a:off x="0" y="0"/>
+          <a:ext cx="0" cy="0"/>
+          <a:chOff x="0" y="0"/>
+          <a:chExt cx="0" cy="0"/>
+        </a:xfrm>
+      </p:grpSpPr>
+      <p:sp>
+        <p:nvSpPr>
+          <p:cNvPr id="2" name="Slide Image Placeholder 1"/>
+          <p:cNvSpPr>
+            <a:spLocks noGrp="1" noRot="1" noChangeAspect="1"/>
+          </p:cNvSpPr>
+          <p:nvPr>
+            <p:ph type="sldImg"/>
+          </p:nvPr>
+        </p:nvSpPr>
+        <p:spPr/>
+      </p:sp>
+      <p:sp>
+        <p:nvSpPr>
+          <p:cNvPr id="3" name="Notes Placeholder 2"/>
+          <p:cNvSpPr>
+            <a:spLocks noGrp="1"/>
+          </p:cNvSpPr>
+          <p:nvPr>
+            <p:ph type="body" idx="1"/>
+          </p:nvPr>
+        </p:nvSpPr>
+        <p:spPr/>
+        <p:txBody>
+          <a:bodyPr/>
+          <a:lstStyle/>
+          <a:p>
+            <a:r>
+              <a:rPr lang="en-US" dirty="0"/>
+              <a:t/>
+            </a:r>
+            <a:endParaRPr lang="en-US" dirty="0"/>
+          </a:p>
+        </p:txBody>
+      </p:sp>
+      <p:sp>
+        <p:nvSpPr>
+          <p:cNvPr id="4" name="Slide Number Placeholder 3"/>
+          <p:cNvSpPr>
+            <a:spLocks noGrp="1"/>
+          </p:cNvSpPr>
+          <p:nvPr>
+            <p:ph type="sldNum" sz="quarter" idx="10"/>
+          </p:nvPr>
+        </p:nvSpPr>
+        <p:spPr/>
+        <p:txBody>
+          <a:bodyPr/>
+          <a:lstStyle/>
+          <a:p>
+            <a:fld id="{F7021451-1387-4CA6-816F-3879F97B5CBC}" type="slidenum">
+              <a:rPr lang="en-US"/>
+              <a:t>35</a:t>
+            </a:fld>
+            <a:endParaRPr lang="en-US"/>
+          </a:p>
+        </p:txBody>
+      </p:sp>
+    </p:spTree>
+    <p:extLst>
+      <p:ext uri="{BB962C8B-B14F-4D97-AF65-F5344CB8AC3E}">
+        <p14:creationId xmlns:p14="http://schemas.microsoft.com/office/powerpoint/2010/main" val="1024086991"/>
+      </p:ext>
+    </p:extLst>
+  </p:cSld>
+  <p:clrMapOvr>
+    <a:masterClrMapping/>
+  </p:clrMapOvr>
+</p:notes>
+</file>
+
+<file path=ppt/notesSlides/notesSlide36.xml><?xml version="1.0" encoding="utf-8"?>
+<p:notes xmlns:a="http://schemas.openxmlformats.org/drawingml/2006/main" xmlns:r="http://schemas.openxmlformats.org/officeDocument/2006/relationships" xmlns:p="http://schemas.openxmlformats.org/presentationml/2006/main">
+  <p:cSld>
+    <p:spTree>
+      <p:nvGrpSpPr>
+        <p:cNvPr id="1" name=""/>
+        <p:cNvGrpSpPr/>
+        <p:nvPr/>
+      </p:nvGrpSpPr>
+      <p:grpSpPr>
+        <a:xfrm>
+          <a:off x="0" y="0"/>
+          <a:ext cx="0" cy="0"/>
+          <a:chOff x="0" y="0"/>
+          <a:chExt cx="0" cy="0"/>
+        </a:xfrm>
+      </p:grpSpPr>
+      <p:sp>
+        <p:nvSpPr>
+          <p:cNvPr id="2" name="Slide Image Placeholder 1"/>
+          <p:cNvSpPr>
+            <a:spLocks noGrp="1" noRot="1" noChangeAspect="1"/>
+          </p:cNvSpPr>
+          <p:nvPr>
+            <p:ph type="sldImg"/>
+          </p:nvPr>
+        </p:nvSpPr>
+        <p:spPr/>
+      </p:sp>
+      <p:sp>
+        <p:nvSpPr>
+          <p:cNvPr id="3" name="Notes Placeholder 2"/>
+          <p:cNvSpPr>
+            <a:spLocks noGrp="1"/>
+          </p:cNvSpPr>
+          <p:nvPr>
+            <p:ph type="body" idx="1"/>
+          </p:nvPr>
+        </p:nvSpPr>
+        <p:spPr/>
+        <p:txBody>
+          <a:bodyPr/>
+          <a:lstStyle/>
+          <a:p>
+            <a:r>
+              <a:rPr lang="en-US" dirty="0"/>
+              <a:t/>
+            </a:r>
+            <a:endParaRPr lang="en-US" dirty="0"/>
+          </a:p>
+        </p:txBody>
+      </p:sp>
+      <p:sp>
+        <p:nvSpPr>
+          <p:cNvPr id="4" name="Slide Number Placeholder 3"/>
+          <p:cNvSpPr>
+            <a:spLocks noGrp="1"/>
+          </p:cNvSpPr>
+          <p:nvPr>
+            <p:ph type="sldNum" sz="quarter" idx="10"/>
+          </p:nvPr>
+        </p:nvSpPr>
+        <p:spPr/>
+        <p:txBody>
+          <a:bodyPr/>
+          <a:lstStyle/>
+          <a:p>
+            <a:fld id="{F7021451-1387-4CA6-816F-3879F97B5CBC}" type="slidenum">
+              <a:rPr lang="en-US"/>
+              <a:t>36</a:t>
+            </a:fld>
+            <a:endParaRPr lang="en-US"/>
+          </a:p>
+        </p:txBody>
+      </p:sp>
+    </p:spTree>
+    <p:extLst>
+      <p:ext uri="{BB962C8B-B14F-4D97-AF65-F5344CB8AC3E}">
+        <p14:creationId xmlns:p14="http://schemas.microsoft.com/office/powerpoint/2010/main" val="1024086991"/>
+      </p:ext>
+    </p:extLst>
+  </p:cSld>
+  <p:clrMapOvr>
+    <a:masterClrMapping/>
+  </p:clrMapOvr>
+</p:notes>
+</file>
+
+<file path=ppt/notesSlides/notesSlide37.xml><?xml version="1.0" encoding="utf-8"?>
+<p:notes xmlns:a="http://schemas.openxmlformats.org/drawingml/2006/main" xmlns:r="http://schemas.openxmlformats.org/officeDocument/2006/relationships" xmlns:p="http://schemas.openxmlformats.org/presentationml/2006/main">
+  <p:cSld>
+    <p:spTree>
+      <p:nvGrpSpPr>
+        <p:cNvPr id="1" name=""/>
+        <p:cNvGrpSpPr/>
+        <p:nvPr/>
+      </p:nvGrpSpPr>
+      <p:grpSpPr>
+        <a:xfrm>
+          <a:off x="0" y="0"/>
+          <a:ext cx="0" cy="0"/>
+          <a:chOff x="0" y="0"/>
+          <a:chExt cx="0" cy="0"/>
+        </a:xfrm>
+      </p:grpSpPr>
+      <p:sp>
+        <p:nvSpPr>
+          <p:cNvPr id="2" name="Slide Image Placeholder 1"/>
+          <p:cNvSpPr>
+            <a:spLocks noGrp="1" noRot="1" noChangeAspect="1"/>
+          </p:cNvSpPr>
+          <p:nvPr>
+            <p:ph type="sldImg"/>
+          </p:nvPr>
+        </p:nvSpPr>
+        <p:spPr/>
+      </p:sp>
+      <p:sp>
+        <p:nvSpPr>
+          <p:cNvPr id="3" name="Notes Placeholder 2"/>
+          <p:cNvSpPr>
+            <a:spLocks noGrp="1"/>
+          </p:cNvSpPr>
+          <p:nvPr>
+            <p:ph type="body" idx="1"/>
+          </p:nvPr>
+        </p:nvSpPr>
+        <p:spPr/>
+        <p:txBody>
+          <a:bodyPr/>
+          <a:lstStyle/>
+          <a:p>
+            <a:r>
+              <a:rPr lang="en-US" dirty="0"/>
+              <a:t/>
+            </a:r>
+            <a:endParaRPr lang="en-US" dirty="0"/>
+          </a:p>
+        </p:txBody>
+      </p:sp>
+      <p:sp>
+        <p:nvSpPr>
+          <p:cNvPr id="4" name="Slide Number Placeholder 3"/>
+          <p:cNvSpPr>
+            <a:spLocks noGrp="1"/>
+          </p:cNvSpPr>
+          <p:nvPr>
+            <p:ph type="sldNum" sz="quarter" idx="10"/>
+          </p:nvPr>
+        </p:nvSpPr>
+        <p:spPr/>
+        <p:txBody>
+          <a:bodyPr/>
+          <a:lstStyle/>
+          <a:p>
+            <a:fld id="{F7021451-1387-4CA6-816F-3879F97B5CBC}" type="slidenum">
+              <a:rPr lang="en-US"/>
+              <a:t>37</a:t>
             </a:fld>
             <a:endParaRPr lang="en-US"/>
           </a:p>
@@ -9814,11 +10348,11 @@
         <p:spPr>
           <a:xfrm>
             <a:off x="640080" y="2514600"/>
-            <a:ext cx="2590724" cy="2468880"/>
+            <a:ext cx="2036003" cy="2468880"/>
           </a:xfrm>
           <a:prstGeom prst="roundRect">
             <a:avLst>
-              <a:gd name="adj" fmla="val 2963"/>
+              <a:gd name="adj" fmla="val 3593"/>
             </a:avLst>
           </a:prstGeom>
           <a:solidFill>
@@ -9841,7 +10375,7 @@
         <p:spPr>
           <a:xfrm>
             <a:off x="640080" y="2514600"/>
-            <a:ext cx="2590724" cy="457200"/>
+            <a:ext cx="2036003" cy="457200"/>
           </a:xfrm>
           <a:prstGeom prst="roundRect">
             <a:avLst>
@@ -9863,7 +10397,7 @@
         <p:spPr>
           <a:xfrm>
             <a:off x="640080" y="2514600"/>
-            <a:ext cx="2590724" cy="457200"/>
+            <a:ext cx="2036003" cy="457200"/>
           </a:xfrm>
           <a:prstGeom prst="rect">
             <a:avLst/>
@@ -9902,7 +10436,7 @@
         <p:spPr>
           <a:xfrm>
             <a:off x="777240" y="3108960"/>
-            <a:ext cx="2316404" cy="365760"/>
+            <a:ext cx="1761683" cy="365760"/>
           </a:xfrm>
           <a:prstGeom prst="rect">
             <a:avLst/>
@@ -9941,7 +10475,7 @@
         <p:spPr>
           <a:xfrm>
             <a:off x="777240" y="3520440"/>
-            <a:ext cx="2316404" cy="914400"/>
+            <a:ext cx="1761683" cy="914400"/>
           </a:xfrm>
           <a:prstGeom prst="rect">
             <a:avLst/>
@@ -9983,7 +10517,7 @@
         <p:spPr>
           <a:xfrm>
             <a:off x="777240" y="4526280"/>
-            <a:ext cx="2316404" cy="320040"/>
+            <a:ext cx="1761683" cy="320040"/>
           </a:xfrm>
           <a:prstGeom prst="rect">
             <a:avLst/>
@@ -10021,12 +10555,12 @@
         </p:nvSpPr>
         <p:spPr>
           <a:xfrm>
-            <a:off x="3413684" y="2514600"/>
-            <a:ext cx="2590724" cy="2468880"/>
+            <a:off x="2858963" y="2514600"/>
+            <a:ext cx="2036003" cy="2468880"/>
           </a:xfrm>
           <a:prstGeom prst="roundRect">
             <a:avLst>
-              <a:gd name="adj" fmla="val 2963"/>
+              <a:gd name="adj" fmla="val 3593"/>
             </a:avLst>
           </a:prstGeom>
           <a:solidFill>
@@ -10048,8 +10582,8 @@
         </p:nvSpPr>
         <p:spPr>
           <a:xfrm>
-            <a:off x="3413684" y="2514600"/>
-            <a:ext cx="2590724" cy="457200"/>
+            <a:off x="2858963" y="2514600"/>
+            <a:ext cx="2036003" cy="457200"/>
           </a:xfrm>
           <a:prstGeom prst="roundRect">
             <a:avLst>
@@ -10070,8 +10604,8 @@
         </p:nvSpPr>
         <p:spPr>
           <a:xfrm>
-            <a:off x="3413684" y="2514600"/>
-            <a:ext cx="2590724" cy="457200"/>
+            <a:off x="2858963" y="2514600"/>
+            <a:ext cx="2036003" cy="457200"/>
           </a:xfrm>
           <a:prstGeom prst="rect">
             <a:avLst/>
@@ -10109,8 +10643,8 @@
         </p:nvSpPr>
         <p:spPr>
           <a:xfrm>
-            <a:off x="3550844" y="3108960"/>
-            <a:ext cx="2316404" cy="365760"/>
+            <a:off x="2996123" y="3108960"/>
+            <a:ext cx="1761683" cy="365760"/>
           </a:xfrm>
           <a:prstGeom prst="rect">
             <a:avLst/>
@@ -10148,8 +10682,8 @@
         </p:nvSpPr>
         <p:spPr>
           <a:xfrm>
-            <a:off x="3550844" y="3520440"/>
-            <a:ext cx="2316404" cy="914400"/>
+            <a:off x="2996123" y="3520440"/>
+            <a:ext cx="1761683" cy="914400"/>
           </a:xfrm>
           <a:prstGeom prst="rect">
             <a:avLst/>
@@ -10190,8 +10724,8 @@
         </p:nvSpPr>
         <p:spPr>
           <a:xfrm>
-            <a:off x="3550844" y="4526280"/>
-            <a:ext cx="2316404" cy="320040"/>
+            <a:off x="2996123" y="4526280"/>
+            <a:ext cx="1761683" cy="320040"/>
           </a:xfrm>
           <a:prstGeom prst="rect">
             <a:avLst/>
@@ -10229,12 +10763,12 @@
         </p:nvSpPr>
         <p:spPr>
           <a:xfrm>
-            <a:off x="6187288" y="2514600"/>
-            <a:ext cx="2590724" cy="2468880"/>
+            <a:off x="5077846" y="2514600"/>
+            <a:ext cx="2036003" cy="2468880"/>
           </a:xfrm>
           <a:prstGeom prst="roundRect">
             <a:avLst>
-              <a:gd name="adj" fmla="val 2963"/>
+              <a:gd name="adj" fmla="val 3593"/>
             </a:avLst>
           </a:prstGeom>
           <a:solidFill>
@@ -10256,8 +10790,8 @@
         </p:nvSpPr>
         <p:spPr>
           <a:xfrm>
-            <a:off x="6187288" y="2514600"/>
-            <a:ext cx="2590724" cy="457200"/>
+            <a:off x="5077846" y="2514600"/>
+            <a:ext cx="2036003" cy="457200"/>
           </a:xfrm>
           <a:prstGeom prst="roundRect">
             <a:avLst>
@@ -10278,8 +10812,8 @@
         </p:nvSpPr>
         <p:spPr>
           <a:xfrm>
-            <a:off x="6187288" y="2514600"/>
-            <a:ext cx="2590724" cy="457200"/>
+            <a:off x="5077846" y="2514600"/>
+            <a:ext cx="2036003" cy="457200"/>
           </a:xfrm>
           <a:prstGeom prst="rect">
             <a:avLst/>
@@ -10317,8 +10851,8 @@
         </p:nvSpPr>
         <p:spPr>
           <a:xfrm>
-            <a:off x="6324448" y="3108960"/>
-            <a:ext cx="2316404" cy="365760"/>
+            <a:off x="5215006" y="3108960"/>
+            <a:ext cx="1761683" cy="365760"/>
           </a:xfrm>
           <a:prstGeom prst="rect">
             <a:avLst/>
@@ -10356,8 +10890,8 @@
         </p:nvSpPr>
         <p:spPr>
           <a:xfrm>
-            <a:off x="6324448" y="3520440"/>
-            <a:ext cx="2316404" cy="914400"/>
+            <a:off x="5215006" y="3520440"/>
+            <a:ext cx="1761683" cy="914400"/>
           </a:xfrm>
           <a:prstGeom prst="rect">
             <a:avLst/>
@@ -10398,8 +10932,8 @@
         </p:nvSpPr>
         <p:spPr>
           <a:xfrm>
-            <a:off x="6324448" y="4526280"/>
-            <a:ext cx="2316404" cy="320040"/>
+            <a:off x="5215006" y="4526280"/>
+            <a:ext cx="1761683" cy="320040"/>
           </a:xfrm>
           <a:prstGeom prst="rect">
             <a:avLst/>
@@ -10437,12 +10971,12 @@
         </p:nvSpPr>
         <p:spPr>
           <a:xfrm>
-            <a:off x="8960891" y="2514600"/>
-            <a:ext cx="2590724" cy="2468880"/>
+            <a:off x="7296729" y="2514600"/>
+            <a:ext cx="2036003" cy="2468880"/>
           </a:xfrm>
           <a:prstGeom prst="roundRect">
             <a:avLst>
-              <a:gd name="adj" fmla="val 2963"/>
+              <a:gd name="adj" fmla="val 3593"/>
             </a:avLst>
           </a:prstGeom>
           <a:solidFill>
@@ -10464,8 +10998,8 @@
         </p:nvSpPr>
         <p:spPr>
           <a:xfrm>
-            <a:off x="8960891" y="2514600"/>
-            <a:ext cx="2590724" cy="457200"/>
+            <a:off x="7296729" y="2514600"/>
+            <a:ext cx="2036003" cy="457200"/>
           </a:xfrm>
           <a:prstGeom prst="roundRect">
             <a:avLst>
@@ -10486,8 +11020,8 @@
         </p:nvSpPr>
         <p:spPr>
           <a:xfrm>
-            <a:off x="8960891" y="2514600"/>
-            <a:ext cx="2590724" cy="457200"/>
+            <a:off x="7296729" y="2514600"/>
+            <a:ext cx="2036003" cy="457200"/>
           </a:xfrm>
           <a:prstGeom prst="rect">
             <a:avLst/>
@@ -10525,8 +11059,8 @@
         </p:nvSpPr>
         <p:spPr>
           <a:xfrm>
-            <a:off x="9098051" y="3108960"/>
-            <a:ext cx="2316404" cy="365760"/>
+            <a:off x="7433889" y="3108960"/>
+            <a:ext cx="1761683" cy="365760"/>
           </a:xfrm>
           <a:prstGeom prst="rect">
             <a:avLst/>
@@ -10564,8 +11098,8 @@
         </p:nvSpPr>
         <p:spPr>
           <a:xfrm>
-            <a:off x="9098051" y="3520440"/>
-            <a:ext cx="2316404" cy="914400"/>
+            <a:off x="7433889" y="3520440"/>
+            <a:ext cx="1761683" cy="914400"/>
           </a:xfrm>
           <a:prstGeom prst="rect">
             <a:avLst/>
@@ -10606,8 +11140,8 @@
         </p:nvSpPr>
         <p:spPr>
           <a:xfrm>
-            <a:off x="9098051" y="4526280"/>
-            <a:ext cx="2316404" cy="320040"/>
+            <a:off x="7433889" y="4526280"/>
+            <a:ext cx="1761683" cy="320040"/>
           </a:xfrm>
           <a:prstGeom prst="rect">
             <a:avLst/>
@@ -10640,6 +11174,214 @@
       <p:sp>
         <p:nvSpPr>
           <p:cNvPr id="29" name="Shape 27"/>
+          <p:cNvSpPr/>
+          <p:nvPr/>
+        </p:nvSpPr>
+        <p:spPr>
+          <a:xfrm>
+            <a:off x="9515612" y="2514600"/>
+            <a:ext cx="2036003" cy="2468880"/>
+          </a:xfrm>
+          <a:prstGeom prst="roundRect">
+            <a:avLst>
+              <a:gd name="adj" fmla="val 3593"/>
+            </a:avLst>
+          </a:prstGeom>
+          <a:solidFill>
+            <a:srgbClr val="FFFFFF"/>
+          </a:solidFill>
+          <a:ln w="12700">
+            <a:solidFill>
+              <a:srgbClr val="D9DDE2"/>
+            </a:solidFill>
+            <a:prstDash val="solid"/>
+          </a:ln>
+        </p:spPr>
+      </p:sp>
+      <p:sp>
+        <p:nvSpPr>
+          <p:cNvPr id="30" name="Shape 28"/>
+          <p:cNvSpPr/>
+          <p:nvPr/>
+        </p:nvSpPr>
+        <p:spPr>
+          <a:xfrm>
+            <a:off x="9515612" y="2514600"/>
+            <a:ext cx="2036003" cy="457200"/>
+          </a:xfrm>
+          <a:prstGeom prst="roundRect">
+            <a:avLst>
+              <a:gd name="adj" fmla="val 16000"/>
+            </a:avLst>
+          </a:prstGeom>
+          <a:solidFill>
+            <a:srgbClr val="7A2E1A"/>
+          </a:solidFill>
+          <a:ln/>
+        </p:spPr>
+      </p:sp>
+      <p:sp>
+        <p:nvSpPr>
+          <p:cNvPr id="31" name="Text 29"/>
+          <p:cNvSpPr/>
+          <p:nvPr/>
+        </p:nvSpPr>
+        <p:spPr>
+          <a:xfrm>
+            <a:off x="9515612" y="2514600"/>
+            <a:ext cx="2036003" cy="457200"/>
+          </a:xfrm>
+          <a:prstGeom prst="rect">
+            <a:avLst/>
+          </a:prstGeom>
+          <a:noFill/>
+          <a:ln/>
+        </p:spPr>
+        <p:txBody>
+          <a:bodyPr wrap="square" rtlCol="0" anchor="ctr"/>
+          <a:lstStyle/>
+          <a:p>
+            <a:pPr algn="ctr" indent="0" marL="0">
+              <a:buNone/>
+            </a:pPr>
+            <a:r>
+              <a:rPr lang="en-US" sz="1300" b="1" spc="200" kern="0" dirty="0">
+                <a:solidFill>
+                  <a:srgbClr val="FFFFFF"/>
+                </a:solidFill>
+                <a:latin typeface="Calibri" pitchFamily="34" charset="0"/>
+                <a:ea typeface="Calibri" pitchFamily="34" charset="-122"/>
+                <a:cs typeface="Calibri" pitchFamily="34" charset="-120"/>
+              </a:rPr>
+              <a:t>WAVE 5</a:t>
+            </a:r>
+            <a:endParaRPr lang="en-US" sz="1300" dirty="0"/>
+          </a:p>
+        </p:txBody>
+      </p:sp>
+      <p:sp>
+        <p:nvSpPr>
+          <p:cNvPr id="32" name="Text 30"/>
+          <p:cNvSpPr/>
+          <p:nvPr/>
+        </p:nvSpPr>
+        <p:spPr>
+          <a:xfrm>
+            <a:off x="9652772" y="3108960"/>
+            <a:ext cx="1761683" cy="365760"/>
+          </a:xfrm>
+          <a:prstGeom prst="rect">
+            <a:avLst/>
+          </a:prstGeom>
+          <a:noFill/>
+          <a:ln/>
+        </p:spPr>
+        <p:txBody>
+          <a:bodyPr wrap="square" rtlCol="0" anchor="ctr"/>
+          <a:lstStyle/>
+          <a:p>
+            <a:pPr algn="ctr" indent="0" marL="0">
+              <a:buNone/>
+            </a:pPr>
+            <a:r>
+              <a:rPr lang="en-US" sz="1500" b="1" dirty="0">
+                <a:solidFill>
+                  <a:srgbClr val="7A2E1A"/>
+                </a:solidFill>
+                <a:latin typeface="Cambria" pitchFamily="34" charset="0"/>
+                <a:ea typeface="Cambria" pitchFamily="34" charset="-122"/>
+                <a:cs typeface="Cambria" pitchFamily="34" charset="-120"/>
+              </a:rPr>
+              <a:t>The Reset</a:t>
+            </a:r>
+            <a:endParaRPr lang="en-US" sz="1500" dirty="0"/>
+          </a:p>
+        </p:txBody>
+      </p:sp>
+      <p:sp>
+        <p:nvSpPr>
+          <p:cNvPr id="33" name="Text 31"/>
+          <p:cNvSpPr/>
+          <p:nvPr/>
+        </p:nvSpPr>
+        <p:spPr>
+          <a:xfrm>
+            <a:off x="9652772" y="3520440"/>
+            <a:ext cx="1761683" cy="914400"/>
+          </a:xfrm>
+          <a:prstGeom prst="rect">
+            <a:avLst/>
+          </a:prstGeom>
+          <a:noFill/>
+          <a:ln/>
+        </p:spPr>
+        <p:txBody>
+          <a:bodyPr wrap="square" rtlCol="0" anchor="ctr"/>
+          <a:lstStyle/>
+          <a:p>
+            <a:pPr algn="ctr" indent="0" marL="0">
+              <a:lnSpc>
+                <a:spcPct val="110000"/>
+              </a:lnSpc>
+              <a:buNone/>
+            </a:pPr>
+            <a:r>
+              <a:rPr lang="en-US" sz="1200" dirty="0">
+                <a:solidFill>
+                  <a:srgbClr val="1A1F26"/>
+                </a:solidFill>
+                <a:latin typeface="Calibri" pitchFamily="34" charset="0"/>
+                <a:ea typeface="Calibri" pitchFamily="34" charset="-122"/>
+                <a:cs typeface="Calibri" pitchFamily="34" charset="-120"/>
+              </a:rPr>
+              <a:t>Consistency over cost — the affordability message</a:t>
+            </a:r>
+            <a:endParaRPr lang="en-US" sz="1200" dirty="0"/>
+          </a:p>
+        </p:txBody>
+      </p:sp>
+      <p:sp>
+        <p:nvSpPr>
+          <p:cNvPr id="34" name="Text 32"/>
+          <p:cNvSpPr/>
+          <p:nvPr/>
+        </p:nvSpPr>
+        <p:spPr>
+          <a:xfrm>
+            <a:off x="9652772" y="4526280"/>
+            <a:ext cx="1761683" cy="320040"/>
+          </a:xfrm>
+          <a:prstGeom prst="rect">
+            <a:avLst/>
+          </a:prstGeom>
+          <a:noFill/>
+          <a:ln/>
+        </p:spPr>
+        <p:txBody>
+          <a:bodyPr wrap="square" rtlCol="0" anchor="ctr"/>
+          <a:lstStyle/>
+          <a:p>
+            <a:pPr algn="ctr" indent="0" marL="0">
+              <a:buNone/>
+            </a:pPr>
+            <a:r>
+              <a:rPr lang="en-US" sz="1200" b="1" dirty="0">
+                <a:solidFill>
+                  <a:srgbClr val="5C6672"/>
+                </a:solidFill>
+                <a:latin typeface="Calibri" pitchFamily="34" charset="0"/>
+                <a:ea typeface="Calibri" pitchFamily="34" charset="-122"/>
+                <a:cs typeface="Calibri" pitchFamily="34" charset="-120"/>
+              </a:rPr>
+              <a:t>5 articles</a:t>
+            </a:r>
+            <a:endParaRPr lang="en-US" sz="1200" dirty="0"/>
+          </a:p>
+        </p:txBody>
+      </p:sp>
+      <p:sp>
+        <p:nvSpPr>
+          <p:cNvPr id="35" name="Shape 33"/>
           <p:cNvSpPr/>
           <p:nvPr/>
         </p:nvSpPr>
@@ -10659,7 +11401,7 @@
       </p:sp>
       <p:sp>
         <p:nvSpPr>
-          <p:cNvPr id="30" name="Text 28"/>
+          <p:cNvPr id="36" name="Text 34"/>
           <p:cNvSpPr/>
           <p:nvPr/>
         </p:nvSpPr>
@@ -10710,7 +11452,7 @@
                 <a:ea typeface="Calibri" pitchFamily="34" charset="-122"/>
                 <a:cs typeface="Calibri" pitchFamily="34" charset="-120"/>
               </a:rPr>
-              <a:t>By Wave 4, a journalist searching “eTeacher longevity” finds a market-entry story, a celebrity signing, a product launch, and a curriculum expansion — a company with momentum, not a one-off announcement.</a:t>
+              <a:t>By Wave 5, a journalist searching “eTeacher longevity” finds a market-entry story, a celebrity signing, a product launch, a curriculum expansion, and a timely, respectful take on longevity's biggest story — a company with momentum, not a one-off announcement.</a:t>
             </a:r>
             <a:endParaRPr lang="en-US" sz="1300" dirty="0"/>
           </a:p>
@@ -10718,7 +11460,7 @@
       </p:sp>
       <p:sp>
         <p:nvSpPr>
-          <p:cNvPr id="31" name="Text 29"/>
+          <p:cNvPr id="37" name="Text 35"/>
           <p:cNvSpPr/>
           <p:nvPr/>
         </p:nvSpPr>
@@ -10778,7 +11520,7 @@
       </p:sp>
       <p:sp>
         <p:nvSpPr>
-          <p:cNvPr id="32" name="Text 30"/>
+          <p:cNvPr id="38" name="Text 36"/>
           <p:cNvSpPr/>
           <p:nvPr/>
         </p:nvSpPr>
@@ -18077,7 +18819,674 @@
         <p:spPr>
           <a:xfrm>
             <a:off x="0" y="0"/>
-            <a:ext cx="12191695" cy="164592"/>
+            <a:ext cx="228600" cy="6858000"/>
+          </a:xfrm>
+          <a:prstGeom prst="rect">
+            <a:avLst/>
+          </a:prstGeom>
+          <a:solidFill>
+            <a:srgbClr val="7A2E1A"/>
+          </a:solidFill>
+          <a:ln/>
+        </p:spPr>
+      </p:sp>
+      <p:sp>
+        <p:nvSpPr>
+          <p:cNvPr id="3" name="Text 1"/>
+          <p:cNvSpPr/>
+          <p:nvPr/>
+        </p:nvSpPr>
+        <p:spPr>
+          <a:xfrm>
+            <a:off x="640080" y="1965960"/>
+            <a:ext cx="10911535" cy="365760"/>
+          </a:xfrm>
+          <a:prstGeom prst="rect">
+            <a:avLst/>
+          </a:prstGeom>
+          <a:noFill/>
+          <a:ln/>
+        </p:spPr>
+        <p:txBody>
+          <a:bodyPr wrap="square" rtlCol="0" anchor="ctr"/>
+          <a:lstStyle/>
+          <a:p>
+            <a:pPr indent="0" marL="0">
+              <a:buNone/>
+            </a:pPr>
+            <a:r>
+              <a:rPr lang="en-US" sz="1500" b="1" spc="400" kern="0" dirty="0">
+                <a:solidFill>
+                  <a:srgbClr val="C08A2E"/>
+                </a:solidFill>
+                <a:latin typeface="Calibri" pitchFamily="34" charset="0"/>
+                <a:ea typeface="Calibri" pitchFamily="34" charset="-122"/>
+                <a:cs typeface="Calibri" pitchFamily="34" charset="-120"/>
+              </a:rPr>
+              <a:t>CHAPTER 5 OF 4</a:t>
+            </a:r>
+            <a:endParaRPr lang="en-US" sz="1500" dirty="0"/>
+          </a:p>
+        </p:txBody>
+      </p:sp>
+      <p:sp>
+        <p:nvSpPr>
+          <p:cNvPr id="4" name="Text 2"/>
+          <p:cNvSpPr/>
+          <p:nvPr/>
+        </p:nvSpPr>
+        <p:spPr>
+          <a:xfrm>
+            <a:off x="640080" y="2514600"/>
+            <a:ext cx="10911535" cy="1463040"/>
+          </a:xfrm>
+          <a:prstGeom prst="rect">
+            <a:avLst/>
+          </a:prstGeom>
+          <a:noFill/>
+          <a:ln/>
+        </p:spPr>
+        <p:txBody>
+          <a:bodyPr wrap="square" rtlCol="0" anchor="ctr"/>
+          <a:lstStyle/>
+          <a:p>
+            <a:pPr indent="0" marL="0">
+              <a:lnSpc>
+                <a:spcPct val="100000"/>
+              </a:lnSpc>
+              <a:buNone/>
+            </a:pPr>
+            <a:r>
+              <a:rPr lang="en-US" sz="4200" b="1" dirty="0">
+                <a:solidFill>
+                  <a:srgbClr val="FFFFFF"/>
+                </a:solidFill>
+                <a:latin typeface="Cambria" pitchFamily="34" charset="0"/>
+                <a:ea typeface="Cambria" pitchFamily="34" charset="-122"/>
+                <a:cs typeface="Cambria" pitchFamily="34" charset="-120"/>
+              </a:rPr>
+              <a:t>The Longevity Reset: Consistency Over Cost</a:t>
+            </a:r>
+            <a:endParaRPr lang="en-US" sz="4200" dirty="0"/>
+          </a:p>
+        </p:txBody>
+      </p:sp>
+      <p:sp>
+        <p:nvSpPr>
+          <p:cNvPr id="5" name="Text 3"/>
+          <p:cNvSpPr/>
+          <p:nvPr/>
+        </p:nvSpPr>
+        <p:spPr>
+          <a:xfrm>
+            <a:off x="640080" y="4297680"/>
+            <a:ext cx="10241280" cy="914400"/>
+          </a:xfrm>
+          <a:prstGeom prst="rect">
+            <a:avLst/>
+          </a:prstGeom>
+          <a:noFill/>
+          <a:ln/>
+        </p:spPr>
+        <p:txBody>
+          <a:bodyPr wrap="square" rtlCol="0" anchor="ctr"/>
+          <a:lstStyle/>
+          <a:p>
+            <a:pPr indent="0" marL="0">
+              <a:lnSpc>
+                <a:spcPct val="120000"/>
+              </a:lnSpc>
+              <a:buNone/>
+            </a:pPr>
+            <a:r>
+              <a:rPr lang="en-US" sz="1700" dirty="0">
+                <a:solidFill>
+                  <a:srgbClr val="C9D3DD"/>
+                </a:solidFill>
+                <a:latin typeface="Calibri" pitchFamily="34" charset="0"/>
+                <a:ea typeface="Calibri" pitchFamily="34" charset="-122"/>
+                <a:cs typeface="Calibri" pitchFamily="34" charset="-120"/>
+              </a:rPr>
+              <a:t>One message: You don't need $2 million a year to live longer — you need a live teacher, a small class, and habits that stick.</a:t>
+            </a:r>
+            <a:endParaRPr lang="en-US" sz="1700" dirty="0"/>
+          </a:p>
+        </p:txBody>
+      </p:sp>
+      <p:sp>
+        <p:nvSpPr>
+          <p:cNvPr id="6" name="Text 4"/>
+          <p:cNvSpPr/>
+          <p:nvPr/>
+        </p:nvSpPr>
+        <p:spPr>
+          <a:xfrm>
+            <a:off x="640080" y="5394960"/>
+            <a:ext cx="3657600" cy="365760"/>
+          </a:xfrm>
+          <a:prstGeom prst="rect">
+            <a:avLst/>
+          </a:prstGeom>
+          <a:noFill/>
+          <a:ln/>
+        </p:spPr>
+        <p:txBody>
+          <a:bodyPr wrap="square" rtlCol="0" anchor="ctr"/>
+          <a:lstStyle/>
+          <a:p>
+            <a:pPr indent="0" marL="0">
+              <a:buNone/>
+            </a:pPr>
+            <a:r>
+              <a:rPr lang="en-US" sz="1300" b="1" spc="200" kern="0" dirty="0">
+                <a:solidFill>
+                  <a:srgbClr val="C08A2E"/>
+                </a:solidFill>
+                <a:latin typeface="Calibri" pitchFamily="34" charset="0"/>
+                <a:ea typeface="Calibri" pitchFamily="34" charset="-122"/>
+                <a:cs typeface="Calibri" pitchFamily="34" charset="-120"/>
+              </a:rPr>
+              <a:t>5 ARTICLES</a:t>
+            </a:r>
+            <a:endParaRPr lang="en-US" sz="1300" dirty="0"/>
+          </a:p>
+        </p:txBody>
+      </p:sp>
+      <p:sp>
+        <p:nvSpPr>
+          <p:cNvPr id="7" name="Text 5"/>
+          <p:cNvSpPr/>
+          <p:nvPr/>
+        </p:nvSpPr>
+        <p:spPr>
+          <a:xfrm>
+            <a:off x="11368735" y="6446520"/>
+            <a:ext cx="548640" cy="274320"/>
+          </a:xfrm>
+          <a:prstGeom prst="rect">
+            <a:avLst/>
+          </a:prstGeom>
+          <a:noFill/>
+          <a:ln/>
+        </p:spPr>
+        <p:txBody>
+          <a:bodyPr wrap="square" rtlCol="0" anchor="ctr"/>
+          <a:lstStyle/>
+          <a:p>
+            <a:pPr algn="r" indent="0" marL="0">
+              <a:buNone/>
+            </a:pPr>
+            <a:r>
+              <a:rPr lang="en-US" sz="900" dirty="0">
+                <a:solidFill>
+                  <a:srgbClr val="9AA4AF"/>
+                </a:solidFill>
+                <a:latin typeface="Calibri" pitchFamily="34" charset="0"/>
+                <a:ea typeface="Calibri" pitchFamily="34" charset="-122"/>
+                <a:cs typeface="Calibri" pitchFamily="34" charset="-120"/>
+              </a:rPr>
+              <a:t>31</a:t>
+            </a:r>
+            <a:endParaRPr lang="en-US" sz="900" dirty="0"/>
+          </a:p>
+        </p:txBody>
+      </p:sp>
+    </p:spTree>
+  </p:cSld>
+  <p:clrMapOvr>
+    <a:masterClrMapping/>
+  </p:clrMapOvr>
+</p:sld>
+</file>
+
+<file path=ppt/slides/slide32.xml><?xml version="1.0" encoding="utf-8"?>
+<p:sld xmlns:a="http://schemas.openxmlformats.org/drawingml/2006/main" xmlns:r="http://schemas.openxmlformats.org/officeDocument/2006/relationships" xmlns:p="http://schemas.openxmlformats.org/presentationml/2006/main">
+  <p:cSld name="Slide 32">
+    <p:bg>
+      <p:bgPr>
+        <a:solidFill>
+          <a:srgbClr val="F7F6F2"/>
+        </a:solidFill>
+      </p:bgPr>
+    </p:bg>
+    <p:spTree>
+      <p:nvGrpSpPr>
+        <p:cNvPr id="1" name=""/>
+        <p:cNvGrpSpPr/>
+        <p:nvPr/>
+      </p:nvGrpSpPr>
+      <p:grpSpPr>
+        <a:xfrm>
+          <a:off x="0" y="0"/>
+          <a:ext cx="0" cy="0"/>
+          <a:chOff x="0" y="0"/>
+          <a:chExt cx="0" cy="0"/>
+        </a:xfrm>
+      </p:grpSpPr>
+      <p:sp>
+        <p:nvSpPr>
+          <p:cNvPr id="2" name="Text 0"/>
+          <p:cNvSpPr/>
+          <p:nvPr/>
+        </p:nvSpPr>
+        <p:spPr>
+          <a:xfrm>
+            <a:off x="640080" y="310896"/>
+            <a:ext cx="7955280" cy="274320"/>
+          </a:xfrm>
+          <a:prstGeom prst="rect">
+            <a:avLst/>
+          </a:prstGeom>
+          <a:noFill/>
+          <a:ln/>
+        </p:spPr>
+        <p:txBody>
+          <a:bodyPr wrap="square" rtlCol="0" anchor="ctr"/>
+          <a:lstStyle/>
+          <a:p>
+            <a:pPr indent="0" marL="0">
+              <a:buNone/>
+            </a:pPr>
+            <a:r>
+              <a:rPr lang="en-US" sz="1050" b="1" spc="150" kern="0" dirty="0">
+                <a:solidFill>
+                  <a:srgbClr val="7A2E1A"/>
+                </a:solidFill>
+                <a:latin typeface="Calibri" pitchFamily="34" charset="0"/>
+                <a:ea typeface="Calibri" pitchFamily="34" charset="-122"/>
+                <a:cs typeface="Calibri" pitchFamily="34" charset="-120"/>
+              </a:rPr>
+              <a:t>ARTICLE 5.1   ·   </a:t>
+            </a:r>
+            <a:pPr indent="0" marL="0">
+              <a:buNone/>
+            </a:pPr>
+            <a:r>
+              <a:rPr lang="en-US" sz="1050" b="1" spc="150" kern="0" dirty="0">
+                <a:solidFill>
+                  <a:srgbClr val="5C6672"/>
+                </a:solidFill>
+                <a:latin typeface="Calibri" pitchFamily="34" charset="0"/>
+                <a:ea typeface="Calibri" pitchFamily="34" charset="-122"/>
+                <a:cs typeface="Calibri" pitchFamily="34" charset="-120"/>
+              </a:rPr>
+              <a:t>REACTIVE NEWS PEG — THE AFFORDABILITY CONTRAST (RESPECTFUL)</a:t>
+            </a:r>
+            <a:endParaRPr lang="en-US" sz="1050" dirty="0"/>
+          </a:p>
+        </p:txBody>
+      </p:sp>
+      <p:sp>
+        <p:nvSpPr>
+          <p:cNvPr id="3" name="Text 1"/>
+          <p:cNvSpPr/>
+          <p:nvPr/>
+        </p:nvSpPr>
+        <p:spPr>
+          <a:xfrm>
+            <a:off x="6705295" y="310896"/>
+            <a:ext cx="4846320" cy="274320"/>
+          </a:xfrm>
+          <a:prstGeom prst="rect">
+            <a:avLst/>
+          </a:prstGeom>
+          <a:noFill/>
+          <a:ln/>
+        </p:spPr>
+        <p:txBody>
+          <a:bodyPr wrap="square" rtlCol="0" anchor="ctr"/>
+          <a:lstStyle/>
+          <a:p>
+            <a:pPr algn="r" indent="0" marL="0">
+              <a:buNone/>
+            </a:pPr>
+            <a:r>
+              <a:rPr lang="en-US" sz="950" dirty="0">
+                <a:solidFill>
+                  <a:srgbClr val="9AA4AF"/>
+                </a:solidFill>
+                <a:latin typeface="Calibri" pitchFamily="34" charset="0"/>
+                <a:ea typeface="Calibri" pitchFamily="34" charset="-122"/>
+                <a:cs typeface="Calibri" pitchFamily="34" charset="-120"/>
+              </a:rPr>
+              <a:t>TARGET  </a:t>
+            </a:r>
+            <a:pPr algn="r" indent="0" marL="0">
+              <a:buNone/>
+            </a:pPr>
+            <a:r>
+              <a:rPr lang="en-US" sz="950" b="1" dirty="0">
+                <a:solidFill>
+                  <a:srgbClr val="7A2E1A"/>
+                </a:solidFill>
+                <a:latin typeface="Calibri" pitchFamily="34" charset="0"/>
+                <a:ea typeface="Calibri" pitchFamily="34" charset="-122"/>
+                <a:cs typeface="Calibri" pitchFamily="34" charset="-120"/>
+              </a:rPr>
+              <a:t>Business Insider / Fortune Well / CNBC Make It</a:t>
+            </a:r>
+            <a:endParaRPr lang="en-US" sz="950" dirty="0"/>
+          </a:p>
+        </p:txBody>
+      </p:sp>
+      <p:sp>
+        <p:nvSpPr>
+          <p:cNvPr id="4" name="Text 2"/>
+          <p:cNvSpPr/>
+          <p:nvPr/>
+        </p:nvSpPr>
+        <p:spPr>
+          <a:xfrm>
+            <a:off x="640080" y="603504"/>
+            <a:ext cx="10911535" cy="896112"/>
+          </a:xfrm>
+          <a:prstGeom prst="rect">
+            <a:avLst/>
+          </a:prstGeom>
+          <a:noFill/>
+          <a:ln/>
+        </p:spPr>
+        <p:txBody>
+          <a:bodyPr wrap="square" rtlCol="0" anchor="t"/>
+          <a:lstStyle/>
+          <a:p>
+            <a:pPr indent="0" marL="0">
+              <a:lnSpc>
+                <a:spcPct val="96000"/>
+              </a:lnSpc>
+              <a:buNone/>
+            </a:pPr>
+            <a:r>
+              <a:rPr lang="en-US" sz="2600" b="1" dirty="0">
+                <a:solidFill>
+                  <a:srgbClr val="0C2A43"/>
+                </a:solidFill>
+                <a:latin typeface="Cambria" pitchFamily="34" charset="0"/>
+                <a:ea typeface="Cambria" pitchFamily="34" charset="-122"/>
+                <a:cs typeface="Cambria" pitchFamily="34" charset="-120"/>
+              </a:rPr>
+              <a:t>You Don't Need $2 Million a Year to Live Longer — Longevity Life Academy Teaches the Habits That Actually Stick, From $289 a Month</a:t>
+            </a:r>
+            <a:endParaRPr lang="en-US" sz="2600" dirty="0"/>
+          </a:p>
+        </p:txBody>
+      </p:sp>
+      <p:sp>
+        <p:nvSpPr>
+          <p:cNvPr id="5" name="Text 3"/>
+          <p:cNvSpPr/>
+          <p:nvPr/>
+        </p:nvSpPr>
+        <p:spPr>
+          <a:xfrm>
+            <a:off x="640080" y="1572768"/>
+            <a:ext cx="10911535" cy="512064"/>
+          </a:xfrm>
+          <a:prstGeom prst="rect">
+            <a:avLst/>
+          </a:prstGeom>
+          <a:noFill/>
+          <a:ln/>
+        </p:spPr>
+        <p:txBody>
+          <a:bodyPr wrap="square" rtlCol="0" anchor="t"/>
+          <a:lstStyle/>
+          <a:p>
+            <a:pPr indent="0" marL="0">
+              <a:lnSpc>
+                <a:spcPct val="110000"/>
+              </a:lnSpc>
+              <a:buNone/>
+            </a:pPr>
+            <a:r>
+              <a:rPr lang="en-US" sz="1350" b="1" i="1" dirty="0">
+                <a:solidFill>
+                  <a:srgbClr val="1A1F26"/>
+                </a:solidFill>
+                <a:latin typeface="Calibri" pitchFamily="34" charset="0"/>
+                <a:ea typeface="Calibri" pitchFamily="34" charset="-122"/>
+                <a:cs typeface="Calibri" pitchFamily="34" charset="-120"/>
+              </a:rPr>
+              <a:t>As the world's most-watched biohacker faces an incurable diagnosis, eTeacher's Longevity Life Academy makes its case: healthspan is built through consistent, learnable habits — taught live — not through spending most people could never match.</a:t>
+            </a:r>
+            <a:endParaRPr lang="en-US" sz="1350" dirty="0"/>
+          </a:p>
+        </p:txBody>
+      </p:sp>
+      <p:sp>
+        <p:nvSpPr>
+          <p:cNvPr id="6" name="Shape 4"/>
+          <p:cNvSpPr/>
+          <p:nvPr/>
+        </p:nvSpPr>
+        <p:spPr>
+          <a:xfrm>
+            <a:off x="640080" y="2194560"/>
+            <a:ext cx="10911535" cy="0"/>
+          </a:xfrm>
+          <a:prstGeom prst="line">
+            <a:avLst/>
+          </a:prstGeom>
+          <a:noFill/>
+          <a:ln w="12700">
+            <a:solidFill>
+              <a:srgbClr val="D9DDE2"/>
+            </a:solidFill>
+            <a:prstDash val="solid"/>
+          </a:ln>
+        </p:spPr>
+      </p:sp>
+      <p:sp>
+        <p:nvSpPr>
+          <p:cNvPr id="7" name="Text 5"/>
+          <p:cNvSpPr/>
+          <p:nvPr/>
+        </p:nvSpPr>
+        <p:spPr>
+          <a:xfrm>
+            <a:off x="640080" y="2286000"/>
+            <a:ext cx="5486400" cy="2468880"/>
+          </a:xfrm>
+          <a:prstGeom prst="rect">
+            <a:avLst/>
+          </a:prstGeom>
+          <a:noFill/>
+          <a:ln/>
+        </p:spPr>
+        <p:txBody>
+          <a:bodyPr wrap="square" rtlCol="0" anchor="t"/>
+          <a:lstStyle/>
+          <a:p>
+            <a:pPr indent="0" marL="0">
+              <a:lnSpc>
+                <a:spcPct val="114000"/>
+              </a:lnSpc>
+              <a:spcAft>
+                <a:spcPts val="400"/>
+              </a:spcAft>
+              <a:buNone/>
+            </a:pPr>
+            <a:r>
+              <a:rPr lang="en-US" sz="1050" dirty="0">
+                <a:solidFill>
+                  <a:srgbClr val="1A1F26"/>
+                </a:solidFill>
+                <a:latin typeface="Calibri" pitchFamily="34" charset="0"/>
+                <a:ea typeface="Calibri" pitchFamily="34" charset="-122"/>
+                <a:cs typeface="Calibri" pitchFamily="34" charset="-120"/>
+              </a:rPr>
+              <a:t>RAMAT GAN, Israel — This month, biohacker Bryan Johnson disclosed that he has been diagnosed with autoimmune gastritis, an incurable condition he says medicine can only manage. His candor deserves respect; illness spares no one, however carefully they live. But the moment also sharpens a question millions are now asking: if the most expensive longevity routine on earth can't guarantee an outcome, what should the rest of us actually do?
+</a:t>
+            </a:r>
+            <a:pPr indent="0" marL="0">
+              <a:lnSpc>
+                <a:spcPct val="114000"/>
+              </a:lnSpc>
+              <a:spcAft>
+                <a:spcPts val="400"/>
+              </a:spcAft>
+              <a:buNone/>
+            </a:pPr>
+            <a:r>
+              <a:rPr lang="en-US" sz="1050" dirty="0">
+                <a:solidFill>
+                  <a:srgbClr val="1A1F26"/>
+                </a:solidFill>
+                <a:latin typeface="Calibri" pitchFamily="34" charset="0"/>
+                <a:ea typeface="Calibri" pitchFamily="34" charset="-122"/>
+                <a:cs typeface="Calibri" pitchFamily="34" charset="-120"/>
+              </a:rPr>
+              <a:t>Longevity Life Academy, the fifth online school of 25-year education company eTeacher Group, was built for exactly that question. Its answer is not a bigger budget — it is a better teacher. The academy's 18-week live course turns healthy-aging science into one personalized protocol a student can keep for life, taught in small groups of 8–15 by named instructors, and grounded in each student's own body data.
+</a:t>
+            </a:r>
+            <a:pPr indent="0" marL="0">
+              <a:lnSpc>
+                <a:spcPct val="114000"/>
+              </a:lnSpc>
+              <a:spcAft>
+                <a:spcPts val="400"/>
+              </a:spcAft>
+              <a:buNone/>
+            </a:pPr>
+            <a:r>
+              <a:rPr lang="en-US" sz="1050" dirty="0">
+                <a:solidFill>
+                  <a:srgbClr val="1A1F26"/>
+                </a:solidFill>
+                <a:latin typeface="Calibri" pitchFamily="34" charset="0"/>
+                <a:ea typeface="Calibri" pitchFamily="34" charset="-122"/>
+                <a:cs typeface="Calibri" pitchFamily="34" charset="-120"/>
+              </a:rPr>
+              <a:t>The contrast the company points to is not a person — it is a philosophy. Johnson reportedly spends roughly $2 million a year. Longevity Life Academy starts at $289 a month and ships every US student an Abbott Lingo continuous glucose monitor before Lesson 5, so the science is personal from the start.</a:t>
+            </a:r>
+            <a:endParaRPr lang="en-US" sz="1050" dirty="0"/>
+          </a:p>
+        </p:txBody>
+      </p:sp>
+      <p:sp>
+        <p:nvSpPr>
+          <p:cNvPr id="8" name="Text 6"/>
+          <p:cNvSpPr/>
+          <p:nvPr/>
+        </p:nvSpPr>
+        <p:spPr>
+          <a:xfrm>
+            <a:off x="6492240" y="2286000"/>
+            <a:ext cx="5486400" cy="2468880"/>
+          </a:xfrm>
+          <a:prstGeom prst="rect">
+            <a:avLst/>
+          </a:prstGeom>
+          <a:noFill/>
+          <a:ln/>
+        </p:spPr>
+        <p:txBody>
+          <a:bodyPr wrap="square" rtlCol="0" anchor="t"/>
+          <a:lstStyle/>
+          <a:p>
+            <a:pPr indent="0" marL="0">
+              <a:lnSpc>
+                <a:spcPct val="114000"/>
+              </a:lnSpc>
+              <a:spcAft>
+                <a:spcPts val="400"/>
+              </a:spcAft>
+              <a:buNone/>
+            </a:pPr>
+            <a:r>
+              <a:rPr lang="en-US" sz="1050" dirty="0">
+                <a:solidFill>
+                  <a:srgbClr val="1A1F26"/>
+                </a:solidFill>
+                <a:latin typeface="Calibri" pitchFamily="34" charset="0"/>
+                <a:ea typeface="Calibri" pitchFamily="34" charset="-122"/>
+                <a:cs typeface="Calibri" pitchFamily="34" charset="-120"/>
+              </a:rPr>
+              <a:t>eTeacher argues the evidence for its approach is already public. Julie Gibson Clark, a 56-year-old single mother from Phoenix, held the number-two spot in the Rejuvenation Olympics for more than a year — ahead of Johnson — on a routine costing roughly $12 a day. Consistency, taught well, beat spending.
+</a:t>
+            </a:r>
+            <a:pPr indent="0" marL="0">
+              <a:lnSpc>
+                <a:spcPct val="114000"/>
+              </a:lnSpc>
+              <a:spcAft>
+                <a:spcPts val="400"/>
+              </a:spcAft>
+              <a:buNone/>
+            </a:pPr>
+            <a:r>
+              <a:rPr lang="en-US" sz="1050" dirty="0">
+                <a:solidFill>
+                  <a:srgbClr val="1A1F26"/>
+                </a:solidFill>
+                <a:latin typeface="Calibri" pitchFamily="34" charset="0"/>
+                <a:ea typeface="Calibri" pitchFamily="34" charset="-122"/>
+                <a:cs typeface="Calibri" pitchFamily="34" charset="-120"/>
+              </a:rPr>
+              <a:t>“We wish Bryan Johnson a full recovery, and we respect how openly he shares what he learns,” said Harel Tayeb, CEO of eTeacher Group. “But his news carries a lesson for everyone: a healthy life was never something you could buy in bulk. It is built one taught, repeated habit at a time — and that is something we can put within reach of an ordinary household.”
+</a:t>
+            </a:r>
+            <a:pPr indent="0" marL="0">
+              <a:lnSpc>
+                <a:spcPct val="114000"/>
+              </a:lnSpc>
+              <a:spcAft>
+                <a:spcPts val="400"/>
+              </a:spcAft>
+              <a:buNone/>
+            </a:pPr>
+            <a:r>
+              <a:rPr lang="en-US" sz="1050" dirty="0">
+                <a:solidFill>
+                  <a:srgbClr val="1A1F26"/>
+                </a:solidFill>
+                <a:latin typeface="Calibri" pitchFamily="34" charset="0"/>
+                <a:ea typeface="Calibri" pitchFamily="34" charset="-122"/>
+                <a:cs typeface="Calibri" pitchFamily="34" charset="-120"/>
+              </a:rPr>
+              <a:t>Longevity Life Academy is enrolling now from $289 per month, with additional courses planned for the year ahead.</a:t>
+            </a:r>
+            <a:endParaRPr lang="en-US" sz="1050" dirty="0"/>
+          </a:p>
+        </p:txBody>
+      </p:sp>
+      <p:sp>
+        <p:nvSpPr>
+          <p:cNvPr id="9" name="Shape 7"/>
+          <p:cNvSpPr/>
+          <p:nvPr/>
+        </p:nvSpPr>
+        <p:spPr>
+          <a:xfrm>
+            <a:off x="640080" y="4892040"/>
+            <a:ext cx="10911535" cy="1399032"/>
+          </a:xfrm>
+          <a:prstGeom prst="roundRect">
+            <a:avLst>
+              <a:gd name="adj" fmla="val 3268"/>
+            </a:avLst>
+          </a:prstGeom>
+          <a:solidFill>
+            <a:srgbClr val="0C2A43"/>
+          </a:solidFill>
+          <a:ln w="25400">
+            <a:solidFill>
+              <a:srgbClr val="C08A2E"/>
+            </a:solidFill>
+            <a:prstDash val="solid"/>
+          </a:ln>
+        </p:spPr>
+      </p:sp>
+      <p:sp>
+        <p:nvSpPr>
+          <p:cNvPr id="10" name="Shape 8"/>
+          <p:cNvSpPr/>
+          <p:nvPr/>
+        </p:nvSpPr>
+        <p:spPr>
+          <a:xfrm>
+            <a:off x="658368" y="4910328"/>
+            <a:ext cx="10874959" cy="310896"/>
           </a:xfrm>
           <a:prstGeom prst="rect">
             <a:avLst/>
@@ -18090,14 +19499,261 @@
       </p:sp>
       <p:sp>
         <p:nvSpPr>
+          <p:cNvPr id="11" name="Text 9"/>
+          <p:cNvSpPr/>
+          <p:nvPr/>
+        </p:nvSpPr>
+        <p:spPr>
+          <a:xfrm>
+            <a:off x="841248" y="4910328"/>
+            <a:ext cx="10509199" cy="310896"/>
+          </a:xfrm>
+          <a:prstGeom prst="rect">
+            <a:avLst/>
+          </a:prstGeom>
+          <a:noFill/>
+          <a:ln/>
+        </p:spPr>
+        <p:txBody>
+          <a:bodyPr wrap="square" rtlCol="0" anchor="ctr"/>
+          <a:lstStyle/>
+          <a:p>
+            <a:pPr indent="0" marL="0">
+              <a:buNone/>
+            </a:pPr>
+            <a:r>
+              <a:rPr lang="en-US" sz="900" b="1" spc="80" kern="0" dirty="0">
+                <a:solidFill>
+                  <a:srgbClr val="0C2A43"/>
+                </a:solidFill>
+                <a:latin typeface="Calibri" pitchFamily="34" charset="0"/>
+                <a:ea typeface="Calibri" pitchFamily="34" charset="-122"/>
+                <a:cs typeface="Calibri" pitchFamily="34" charset="-120"/>
+              </a:rPr>
+              <a:t>HIGHLIGHTED QUOTE  ·  HAREL TAYEB, CEO, eTeacher Group</a:t>
+            </a:r>
+            <a:endParaRPr lang="en-US" sz="900" dirty="0"/>
+          </a:p>
+        </p:txBody>
+      </p:sp>
+      <p:sp>
+        <p:nvSpPr>
+          <p:cNvPr id="12" name="Text 10"/>
+          <p:cNvSpPr/>
+          <p:nvPr/>
+        </p:nvSpPr>
+        <p:spPr>
+          <a:xfrm>
+            <a:off x="859536" y="5294376"/>
+            <a:ext cx="10472623" cy="466344"/>
+          </a:xfrm>
+          <a:prstGeom prst="rect">
+            <a:avLst/>
+          </a:prstGeom>
+          <a:noFill/>
+          <a:ln/>
+        </p:spPr>
+        <p:txBody>
+          <a:bodyPr wrap="square" rtlCol="0" anchor="t"/>
+          <a:lstStyle/>
+          <a:p>
+            <a:pPr indent="0" marL="0">
+              <a:lnSpc>
+                <a:spcPct val="108000"/>
+              </a:lnSpc>
+              <a:buNone/>
+            </a:pPr>
+            <a:r>
+              <a:rPr lang="en-US" sz="1150" b="1" i="1" dirty="0">
+                <a:solidFill>
+                  <a:srgbClr val="FFF3DA"/>
+                </a:solidFill>
+                <a:latin typeface="Calibri" pitchFamily="34" charset="0"/>
+                <a:ea typeface="Calibri" pitchFamily="34" charset="-122"/>
+                <a:cs typeface="Calibri" pitchFamily="34" charset="-120"/>
+              </a:rPr>
+              <a:t>“We wish Bryan Johnson a full recovery, and we respect how openly he shares what he learns. But his news carries a lesson for everyone: a healthy life was never something you could buy in bulk. It is built one taught, repeated habit at a time — and that is something we can put within reach of an ordinary household.”</a:t>
+            </a:r>
+            <a:endParaRPr lang="en-US" sz="1150" dirty="0"/>
+          </a:p>
+        </p:txBody>
+      </p:sp>
+      <p:sp>
+        <p:nvSpPr>
+          <p:cNvPr id="13" name="Text 11"/>
+          <p:cNvSpPr/>
+          <p:nvPr/>
+        </p:nvSpPr>
+        <p:spPr>
+          <a:xfrm>
+            <a:off x="859536" y="5833872"/>
+            <a:ext cx="10472623" cy="329184"/>
+          </a:xfrm>
+          <a:prstGeom prst="rect">
+            <a:avLst/>
+          </a:prstGeom>
+          <a:noFill/>
+          <a:ln/>
+        </p:spPr>
+        <p:txBody>
+          <a:bodyPr wrap="square" rtlCol="0" anchor="b"/>
+          <a:lstStyle/>
+          <a:p>
+            <a:pPr indent="0" marL="0">
+              <a:lnSpc>
+                <a:spcPct val="102000"/>
+              </a:lnSpc>
+              <a:buNone/>
+            </a:pPr>
+            <a:r>
+              <a:rPr lang="en-US" sz="680" i="1" dirty="0">
+                <a:solidFill>
+                  <a:srgbClr val="C9B892"/>
+                </a:solidFill>
+                <a:latin typeface="Calibri" pitchFamily="34" charset="0"/>
+                <a:ea typeface="Calibri" pitchFamily="34" charset="-122"/>
+                <a:cs typeface="Calibri" pitchFamily="34" charset="-120"/>
+              </a:rPr>
+              <a:t>NET-NEW CEO statement — flagged for Harel's approval. Leads with genuine respect/goodwill toward Johnson (no mockery), then pivots to LLA's affordability + consistency message. Verify comfort with naming him directly.</a:t>
+            </a:r>
+            <a:endParaRPr lang="en-US" sz="680" dirty="0"/>
+          </a:p>
+        </p:txBody>
+      </p:sp>
+      <p:sp>
+        <p:nvSpPr>
+          <p:cNvPr id="14" name="Text 12"/>
+          <p:cNvSpPr/>
+          <p:nvPr/>
+        </p:nvSpPr>
+        <p:spPr>
+          <a:xfrm>
+            <a:off x="11368735" y="6446520"/>
+            <a:ext cx="548640" cy="274320"/>
+          </a:xfrm>
+          <a:prstGeom prst="rect">
+            <a:avLst/>
+          </a:prstGeom>
+          <a:noFill/>
+          <a:ln/>
+        </p:spPr>
+        <p:txBody>
+          <a:bodyPr wrap="square" rtlCol="0" anchor="ctr"/>
+          <a:lstStyle/>
+          <a:p>
+            <a:pPr algn="r" indent="0" marL="0">
+              <a:buNone/>
+            </a:pPr>
+            <a:r>
+              <a:rPr lang="en-US" sz="900" dirty="0">
+                <a:solidFill>
+                  <a:srgbClr val="9AA4AF"/>
+                </a:solidFill>
+                <a:latin typeface="Calibri" pitchFamily="34" charset="0"/>
+                <a:ea typeface="Calibri" pitchFamily="34" charset="-122"/>
+                <a:cs typeface="Calibri" pitchFamily="34" charset="-120"/>
+              </a:rPr>
+              <a:t>32</a:t>
+            </a:r>
+            <a:endParaRPr lang="en-US" sz="900" dirty="0"/>
+          </a:p>
+        </p:txBody>
+      </p:sp>
+    </p:spTree>
+  </p:cSld>
+  <p:clrMapOvr>
+    <a:masterClrMapping/>
+  </p:clrMapOvr>
+</p:sld>
+</file>
+
+<file path=ppt/slides/slide33.xml><?xml version="1.0" encoding="utf-8"?>
+<p:sld xmlns:a="http://schemas.openxmlformats.org/drawingml/2006/main" xmlns:r="http://schemas.openxmlformats.org/officeDocument/2006/relationships" xmlns:p="http://schemas.openxmlformats.org/presentationml/2006/main">
+  <p:cSld name="Slide 33">
+    <p:bg>
+      <p:bgPr>
+        <a:solidFill>
+          <a:srgbClr val="F7F6F2"/>
+        </a:solidFill>
+      </p:bgPr>
+    </p:bg>
+    <p:spTree>
+      <p:nvGrpSpPr>
+        <p:cNvPr id="1" name=""/>
+        <p:cNvGrpSpPr/>
+        <p:nvPr/>
+      </p:nvGrpSpPr>
+      <p:grpSpPr>
+        <a:xfrm>
+          <a:off x="0" y="0"/>
+          <a:ext cx="0" cy="0"/>
+          <a:chOff x="0" y="0"/>
+          <a:chExt cx="0" cy="0"/>
+        </a:xfrm>
+      </p:grpSpPr>
+      <p:sp>
+        <p:nvSpPr>
+          <p:cNvPr id="2" name="Text 0"/>
+          <p:cNvSpPr/>
+          <p:nvPr/>
+        </p:nvSpPr>
+        <p:spPr>
+          <a:xfrm>
+            <a:off x="640080" y="310896"/>
+            <a:ext cx="7955280" cy="274320"/>
+          </a:xfrm>
+          <a:prstGeom prst="rect">
+            <a:avLst/>
+          </a:prstGeom>
+          <a:noFill/>
+          <a:ln/>
+        </p:spPr>
+        <p:txBody>
+          <a:bodyPr wrap="square" rtlCol="0" anchor="ctr"/>
+          <a:lstStyle/>
+          <a:p>
+            <a:pPr indent="0" marL="0">
+              <a:buNone/>
+            </a:pPr>
+            <a:r>
+              <a:rPr lang="en-US" sz="1050" b="1" spc="150" kern="0" dirty="0">
+                <a:solidFill>
+                  <a:srgbClr val="7A2E1A"/>
+                </a:solidFill>
+                <a:latin typeface="Calibri" pitchFamily="34" charset="0"/>
+                <a:ea typeface="Calibri" pitchFamily="34" charset="-122"/>
+                <a:cs typeface="Calibri" pitchFamily="34" charset="-120"/>
+              </a:rPr>
+              <a:t>ARTICLE 5.2   ·   </a:t>
+            </a:r>
+            <a:pPr indent="0" marL="0">
+              <a:buNone/>
+            </a:pPr>
+            <a:r>
+              <a:rPr lang="en-US" sz="1050" b="1" spc="150" kern="0" dirty="0">
+                <a:solidFill>
+                  <a:srgbClr val="5C6672"/>
+                </a:solidFill>
+                <a:latin typeface="Calibri" pitchFamily="34" charset="0"/>
+                <a:ea typeface="Calibri" pitchFamily="34" charset="-122"/>
+                <a:cs typeface="Calibri" pitchFamily="34" charset="-120"/>
+              </a:rPr>
+              <a:t>EARLY DETECTION / KNOW-YOUR-OWN-DATA (HEALTH-DESK, RESPECTFUL)</a:t>
+            </a:r>
+            <a:endParaRPr lang="en-US" sz="1050" dirty="0"/>
+          </a:p>
+        </p:txBody>
+      </p:sp>
+      <p:sp>
+        <p:nvSpPr>
           <p:cNvPr id="3" name="Text 1"/>
           <p:cNvSpPr/>
           <p:nvPr/>
         </p:nvSpPr>
         <p:spPr>
           <a:xfrm>
-            <a:off x="640080" y="1280160"/>
-            <a:ext cx="10911535" cy="365760"/>
+            <a:off x="6705295" y="310896"/>
+            <a:ext cx="4846320" cy="274320"/>
           </a:xfrm>
           <a:prstGeom prst="rect">
             <a:avLst/>
@@ -18109,21 +19765,35 @@
           <a:bodyPr wrap="square" rtlCol="0" anchor="ctr"/>
           <a:lstStyle/>
           <a:p>
-            <a:pPr indent="0" marL="0">
-              <a:buNone/>
-            </a:pPr>
-            <a:r>
-              <a:rPr lang="en-US" sz="1400" b="1" spc="300" kern="0" dirty="0">
-                <a:solidFill>
-                  <a:srgbClr val="C08A2E"/>
-                </a:solidFill>
-                <a:latin typeface="Calibri" pitchFamily="34" charset="0"/>
-                <a:ea typeface="Calibri" pitchFamily="34" charset="-122"/>
-                <a:cs typeface="Calibri" pitchFamily="34" charset="-120"/>
-              </a:rPr>
-              <a:t>NEXT STEPS</a:t>
-            </a:r>
-            <a:endParaRPr lang="en-US" sz="1400" dirty="0"/>
+            <a:pPr algn="r" indent="0" marL="0">
+              <a:buNone/>
+            </a:pPr>
+            <a:r>
+              <a:rPr lang="en-US" sz="950" dirty="0">
+                <a:solidFill>
+                  <a:srgbClr val="9AA4AF"/>
+                </a:solidFill>
+                <a:latin typeface="Calibri" pitchFamily="34" charset="0"/>
+                <a:ea typeface="Calibri" pitchFamily="34" charset="-122"/>
+                <a:cs typeface="Calibri" pitchFamily="34" charset="-120"/>
+              </a:rPr>
+              <a:t>TARGET  </a:t>
+            </a:r>
+            <a:pPr algn="r" indent="0" marL="0">
+              <a:buNone/>
+            </a:pPr>
+            <a:r>
+              <a:rPr lang="en-US" sz="950" b="1" dirty="0">
+                <a:solidFill>
+                  <a:srgbClr val="7A2E1A"/>
+                </a:solidFill>
+                <a:latin typeface="Calibri" pitchFamily="34" charset="0"/>
+                <a:ea typeface="Calibri" pitchFamily="34" charset="-122"/>
+                <a:cs typeface="Calibri" pitchFamily="34" charset="-120"/>
+              </a:rPr>
+              <a:t>Fortune Well / Healthline / MedCity News</a:t>
+            </a:r>
+            <a:endParaRPr lang="en-US" sz="950" dirty="0"/>
           </a:p>
         </p:txBody>
       </p:sp>
@@ -18135,31 +19805,2496 @@
         </p:nvSpPr>
         <p:spPr>
           <a:xfrm>
-            <a:off x="640080" y="1783080"/>
-            <a:ext cx="10911535" cy="822960"/>
-          </a:xfrm>
-          <a:prstGeom prst="rect">
-            <a:avLst/>
-          </a:prstGeom>
-          <a:noFill/>
-          <a:ln/>
-        </p:spPr>
-        <p:txBody>
-          <a:bodyPr wrap="square" rtlCol="0" anchor="ctr"/>
-          <a:lstStyle/>
-          <a:p>
-            <a:pPr indent="0" marL="0">
-              <a:buNone/>
-            </a:pPr>
-            <a:r>
-              <a:rPr lang="en-US" sz="3200" b="1" dirty="0">
-                <a:solidFill>
-                  <a:srgbClr val="FFFFFF"/>
+            <a:off x="640080" y="603504"/>
+            <a:ext cx="10911535" cy="896112"/>
+          </a:xfrm>
+          <a:prstGeom prst="rect">
+            <a:avLst/>
+          </a:prstGeom>
+          <a:noFill/>
+          <a:ln/>
+        </p:spPr>
+        <p:txBody>
+          <a:bodyPr wrap="square" rtlCol="0" anchor="t"/>
+          <a:lstStyle/>
+          <a:p>
+            <a:pPr indent="0" marL="0">
+              <a:lnSpc>
+                <a:spcPct val="96000"/>
+              </a:lnSpc>
+              <a:buNone/>
+            </a:pPr>
+            <a:r>
+              <a:rPr lang="en-US" sz="2600" b="1" dirty="0">
+                <a:solidFill>
+                  <a:srgbClr val="0C2A43"/>
                 </a:solidFill>
                 <a:latin typeface="Cambria" pitchFamily="34" charset="0"/>
                 <a:ea typeface="Cambria" pitchFamily="34" charset="-122"/>
                 <a:cs typeface="Cambria" pitchFamily="34" charset="-120"/>
               </a:rPr>
+              <a:t>Longevity Life Academy Teaches Students to Read Their Own Biomarkers Early — So They Catch What Silent Conditions Hide</a:t>
+            </a:r>
+            <a:endParaRPr lang="en-US" sz="2600" dirty="0"/>
+          </a:p>
+        </p:txBody>
+      </p:sp>
+      <p:sp>
+        <p:nvSpPr>
+          <p:cNvPr id="5" name="Text 3"/>
+          <p:cNvSpPr/>
+          <p:nvPr/>
+        </p:nvSpPr>
+        <p:spPr>
+          <a:xfrm>
+            <a:off x="640080" y="1572768"/>
+            <a:ext cx="10911535" cy="512064"/>
+          </a:xfrm>
+          <a:prstGeom prst="rect">
+            <a:avLst/>
+          </a:prstGeom>
+          <a:noFill/>
+          <a:ln/>
+        </p:spPr>
+        <p:txBody>
+          <a:bodyPr wrap="square" rtlCol="0" anchor="t"/>
+          <a:lstStyle/>
+          <a:p>
+            <a:pPr indent="0" marL="0">
+              <a:lnSpc>
+                <a:spcPct val="110000"/>
+              </a:lnSpc>
+              <a:buNone/>
+            </a:pPr>
+            <a:r>
+              <a:rPr lang="en-US" sz="1350" b="1" i="1" dirty="0">
+                <a:solidFill>
+                  <a:srgbClr val="1A1F26"/>
+                </a:solidFill>
+                <a:latin typeface="Calibri" pitchFamily="34" charset="0"/>
+                <a:ea typeface="Calibri" pitchFamily="34" charset="-122"/>
+                <a:cs typeface="Calibri" pitchFamily="34" charset="-120"/>
+              </a:rPr>
+              <a:t>Bryan Johnson's autoimmune gastritis went undetected for years despite intensive monitoring. Longevity Life Academy is built on a simpler premise: teach ordinary people to read their own body data, consistently, before problems compound.</a:t>
+            </a:r>
+            <a:endParaRPr lang="en-US" sz="1350" dirty="0"/>
+          </a:p>
+        </p:txBody>
+      </p:sp>
+      <p:sp>
+        <p:nvSpPr>
+          <p:cNvPr id="6" name="Shape 4"/>
+          <p:cNvSpPr/>
+          <p:nvPr/>
+        </p:nvSpPr>
+        <p:spPr>
+          <a:xfrm>
+            <a:off x="640080" y="2194560"/>
+            <a:ext cx="10911535" cy="0"/>
+          </a:xfrm>
+          <a:prstGeom prst="line">
+            <a:avLst/>
+          </a:prstGeom>
+          <a:noFill/>
+          <a:ln w="12700">
+            <a:solidFill>
+              <a:srgbClr val="D9DDE2"/>
+            </a:solidFill>
+            <a:prstDash val="solid"/>
+          </a:ln>
+        </p:spPr>
+      </p:sp>
+      <p:sp>
+        <p:nvSpPr>
+          <p:cNvPr id="7" name="Text 5"/>
+          <p:cNvSpPr/>
+          <p:nvPr/>
+        </p:nvSpPr>
+        <p:spPr>
+          <a:xfrm>
+            <a:off x="640080" y="2286000"/>
+            <a:ext cx="5486400" cy="2468880"/>
+          </a:xfrm>
+          <a:prstGeom prst="rect">
+            <a:avLst/>
+          </a:prstGeom>
+          <a:noFill/>
+          <a:ln/>
+        </p:spPr>
+        <p:txBody>
+          <a:bodyPr wrap="square" rtlCol="0" anchor="t"/>
+          <a:lstStyle/>
+          <a:p>
+            <a:pPr indent="0" marL="0">
+              <a:lnSpc>
+                <a:spcPct val="114000"/>
+              </a:lnSpc>
+              <a:spcAft>
+                <a:spcPts val="400"/>
+              </a:spcAft>
+              <a:buNone/>
+            </a:pPr>
+            <a:r>
+              <a:rPr lang="en-US" sz="1050" dirty="0">
+                <a:solidFill>
+                  <a:srgbClr val="1A1F26"/>
+                </a:solidFill>
+                <a:latin typeface="Calibri" pitchFamily="34" charset="0"/>
+                <a:ea typeface="Calibri" pitchFamily="34" charset="-122"/>
+                <a:cs typeface="Calibri" pitchFamily="34" charset="-120"/>
+              </a:rPr>
+              <a:t>RAMAT GAN, Israel — One detail in Bryan Johnson's recent disclosure resonated with clinicians: even with elite monitoring, his autoimmune gastritis stayed hidden for years, surfacing only after persistent low iron was finally investigated. If a condition can hide from the world's most-tracked body, the case for teaching everyone to read their own data grows stronger, not weaker.
+</a:t>
+            </a:r>
+            <a:pPr indent="0" marL="0">
+              <a:lnSpc>
+                <a:spcPct val="114000"/>
+              </a:lnSpc>
+              <a:spcAft>
+                <a:spcPts val="400"/>
+              </a:spcAft>
+              <a:buNone/>
+            </a:pPr>
+            <a:r>
+              <a:rPr lang="en-US" sz="1050" dirty="0">
+                <a:solidFill>
+                  <a:srgbClr val="1A1F26"/>
+                </a:solidFill>
+                <a:latin typeface="Calibri" pitchFamily="34" charset="0"/>
+                <a:ea typeface="Calibri" pitchFamily="34" charset="-122"/>
+                <a:cs typeface="Calibri" pitchFamily="34" charset="-120"/>
+              </a:rPr>
+              <a:t>That is the founding premise of Longevity Life Academy, the fifth online school of 25-year education company eTeacher Group. The academy does not promise to out-spend disease. It teaches students to understand their own biomarkers — glucose, sleep, movement, and the numbers on their own lab reports — so they become active participants in their health rather than passive patients.
+</a:t>
+            </a:r>
+            <a:pPr indent="0" marL="0">
+              <a:lnSpc>
+                <a:spcPct val="114000"/>
+              </a:lnSpc>
+              <a:spcAft>
+                <a:spcPts val="400"/>
+              </a:spcAft>
+              <a:buNone/>
+            </a:pPr>
+            <a:r>
+              <a:rPr lang="en-US" sz="1050" dirty="0">
+                <a:solidFill>
+                  <a:srgbClr val="1A1F26"/>
+                </a:solidFill>
+                <a:latin typeface="Calibri" pitchFamily="34" charset="0"/>
+                <a:ea typeface="Calibri" pitchFamily="34" charset="-122"/>
+                <a:cs typeface="Calibri" pitchFamily="34" charset="-120"/>
+              </a:rPr>
+              <a:t>Every US student receives an Abbott Lingo continuous glucose monitor before Lesson 5, and the 18-week live curriculum builds the habit of asking what one's own body is signaling. Instruction happens in small groups of 8–15, led by named faculty, so questions get real answers in real time.</a:t>
+            </a:r>
+            <a:endParaRPr lang="en-US" sz="1050" dirty="0"/>
+          </a:p>
+        </p:txBody>
+      </p:sp>
+      <p:sp>
+        <p:nvSpPr>
+          <p:cNvPr id="8" name="Text 6"/>
+          <p:cNvSpPr/>
+          <p:nvPr/>
+        </p:nvSpPr>
+        <p:spPr>
+          <a:xfrm>
+            <a:off x="6492240" y="2286000"/>
+            <a:ext cx="5486400" cy="2468880"/>
+          </a:xfrm>
+          <a:prstGeom prst="rect">
+            <a:avLst/>
+          </a:prstGeom>
+          <a:noFill/>
+          <a:ln/>
+        </p:spPr>
+        <p:txBody>
+          <a:bodyPr wrap="square" rtlCol="0" anchor="t"/>
+          <a:lstStyle/>
+          <a:p>
+            <a:pPr indent="0" marL="0">
+              <a:lnSpc>
+                <a:spcPct val="114000"/>
+              </a:lnSpc>
+              <a:spcAft>
+                <a:spcPts val="400"/>
+              </a:spcAft>
+              <a:buNone/>
+            </a:pPr>
+            <a:r>
+              <a:rPr lang="en-US" sz="1050" dirty="0">
+                <a:solidFill>
+                  <a:srgbClr val="1A1F26"/>
+                </a:solidFill>
+                <a:latin typeface="Calibri" pitchFamily="34" charset="0"/>
+                <a:ea typeface="Calibri" pitchFamily="34" charset="-122"/>
+                <a:cs typeface="Calibri" pitchFamily="34" charset="-120"/>
+              </a:rPr>
+              <a:t>The academy is careful about its lane: it is education, not diagnosis, and it encourages students to work with their physicians. Its contribution is literacy — the daily, teachable skill of noticing change early, which even the most expensive protocols can't outsource.
+</a:t>
+            </a:r>
+            <a:pPr indent="0" marL="0">
+              <a:lnSpc>
+                <a:spcPct val="114000"/>
+              </a:lnSpc>
+              <a:spcAft>
+                <a:spcPts val="400"/>
+              </a:spcAft>
+              <a:buNone/>
+            </a:pPr>
+            <a:r>
+              <a:rPr lang="en-US" sz="1050" dirty="0">
+                <a:solidFill>
+                  <a:srgbClr val="1A1F26"/>
+                </a:solidFill>
+                <a:latin typeface="Calibri" pitchFamily="34" charset="0"/>
+                <a:ea typeface="Calibri" pitchFamily="34" charset="-122"/>
+                <a:cs typeface="Calibri" pitchFamily="34" charset="-120"/>
+              </a:rPr>
+              <a:t>“Bryan Johnson's experience is a reminder that no one is exempt, and that early awareness matters more than any single gadget,” said CEO Harel Tayeb. “We don't teach people to fear their bodies. We teach them to read them — calmly, consistently, and early enough to act.”
+</a:t>
+            </a:r>
+            <a:pPr indent="0" marL="0">
+              <a:lnSpc>
+                <a:spcPct val="114000"/>
+              </a:lnSpc>
+              <a:spcAft>
+                <a:spcPts val="400"/>
+              </a:spcAft>
+              <a:buNone/>
+            </a:pPr>
+            <a:r>
+              <a:rPr lang="en-US" sz="1050" dirty="0">
+                <a:solidFill>
+                  <a:srgbClr val="1A1F26"/>
+                </a:solidFill>
+                <a:latin typeface="Calibri" pitchFamily="34" charset="0"/>
+                <a:ea typeface="Calibri" pitchFamily="34" charset="-122"/>
+                <a:cs typeface="Calibri" pitchFamily="34" charset="-120"/>
+              </a:rPr>
+              <a:t>Longevity Life Academy is enrolling now from $289 per month.</a:t>
+            </a:r>
+            <a:endParaRPr lang="en-US" sz="1050" dirty="0"/>
+          </a:p>
+        </p:txBody>
+      </p:sp>
+      <p:sp>
+        <p:nvSpPr>
+          <p:cNvPr id="9" name="Shape 7"/>
+          <p:cNvSpPr/>
+          <p:nvPr/>
+        </p:nvSpPr>
+        <p:spPr>
+          <a:xfrm>
+            <a:off x="640080" y="4892040"/>
+            <a:ext cx="10911535" cy="1399032"/>
+          </a:xfrm>
+          <a:prstGeom prst="roundRect">
+            <a:avLst>
+              <a:gd name="adj" fmla="val 3268"/>
+            </a:avLst>
+          </a:prstGeom>
+          <a:solidFill>
+            <a:srgbClr val="0C2A43"/>
+          </a:solidFill>
+          <a:ln w="25400">
+            <a:solidFill>
+              <a:srgbClr val="C08A2E"/>
+            </a:solidFill>
+            <a:prstDash val="solid"/>
+          </a:ln>
+        </p:spPr>
+      </p:sp>
+      <p:sp>
+        <p:nvSpPr>
+          <p:cNvPr id="10" name="Shape 8"/>
+          <p:cNvSpPr/>
+          <p:nvPr/>
+        </p:nvSpPr>
+        <p:spPr>
+          <a:xfrm>
+            <a:off x="658368" y="4910328"/>
+            <a:ext cx="10874959" cy="310896"/>
+          </a:xfrm>
+          <a:prstGeom prst="rect">
+            <a:avLst/>
+          </a:prstGeom>
+          <a:solidFill>
+            <a:srgbClr val="C08A2E"/>
+          </a:solidFill>
+          <a:ln/>
+        </p:spPr>
+      </p:sp>
+      <p:sp>
+        <p:nvSpPr>
+          <p:cNvPr id="11" name="Text 9"/>
+          <p:cNvSpPr/>
+          <p:nvPr/>
+        </p:nvSpPr>
+        <p:spPr>
+          <a:xfrm>
+            <a:off x="841248" y="4910328"/>
+            <a:ext cx="10509199" cy="310896"/>
+          </a:xfrm>
+          <a:prstGeom prst="rect">
+            <a:avLst/>
+          </a:prstGeom>
+          <a:noFill/>
+          <a:ln/>
+        </p:spPr>
+        <p:txBody>
+          <a:bodyPr wrap="square" rtlCol="0" anchor="ctr"/>
+          <a:lstStyle/>
+          <a:p>
+            <a:pPr indent="0" marL="0">
+              <a:buNone/>
+            </a:pPr>
+            <a:r>
+              <a:rPr lang="en-US" sz="900" b="1" spc="80" kern="0" dirty="0">
+                <a:solidFill>
+                  <a:srgbClr val="0C2A43"/>
+                </a:solidFill>
+                <a:latin typeface="Calibri" pitchFamily="34" charset="0"/>
+                <a:ea typeface="Calibri" pitchFamily="34" charset="-122"/>
+                <a:cs typeface="Calibri" pitchFamily="34" charset="-120"/>
+              </a:rPr>
+              <a:t>HIGHLIGHTED QUOTE  ·  HAREL TAYEB, CEO, eTeacher Group</a:t>
+            </a:r>
+            <a:endParaRPr lang="en-US" sz="900" dirty="0"/>
+          </a:p>
+        </p:txBody>
+      </p:sp>
+      <p:sp>
+        <p:nvSpPr>
+          <p:cNvPr id="12" name="Text 10"/>
+          <p:cNvSpPr/>
+          <p:nvPr/>
+        </p:nvSpPr>
+        <p:spPr>
+          <a:xfrm>
+            <a:off x="859536" y="5294376"/>
+            <a:ext cx="10472623" cy="466344"/>
+          </a:xfrm>
+          <a:prstGeom prst="rect">
+            <a:avLst/>
+          </a:prstGeom>
+          <a:noFill/>
+          <a:ln/>
+        </p:spPr>
+        <p:txBody>
+          <a:bodyPr wrap="square" rtlCol="0" anchor="t"/>
+          <a:lstStyle/>
+          <a:p>
+            <a:pPr indent="0" marL="0">
+              <a:lnSpc>
+                <a:spcPct val="108000"/>
+              </a:lnSpc>
+              <a:buNone/>
+            </a:pPr>
+            <a:r>
+              <a:rPr lang="en-US" sz="1150" b="1" i="1" dirty="0">
+                <a:solidFill>
+                  <a:srgbClr val="FFF3DA"/>
+                </a:solidFill>
+                <a:latin typeface="Calibri" pitchFamily="34" charset="0"/>
+                <a:ea typeface="Calibri" pitchFamily="34" charset="-122"/>
+                <a:cs typeface="Calibri" pitchFamily="34" charset="-120"/>
+              </a:rPr>
+              <a:t>“Bryan Johnson's experience is a reminder that no one is exempt, and that early awareness matters more than any single gadget. We don't teach people to fear their bodies. We teach them to read them — calmly, consistently, and early enough to act.”</a:t>
+            </a:r>
+            <a:endParaRPr lang="en-US" sz="1150" dirty="0"/>
+          </a:p>
+        </p:txBody>
+      </p:sp>
+      <p:sp>
+        <p:nvSpPr>
+          <p:cNvPr id="13" name="Text 11"/>
+          <p:cNvSpPr/>
+          <p:nvPr/>
+        </p:nvSpPr>
+        <p:spPr>
+          <a:xfrm>
+            <a:off x="859536" y="5833872"/>
+            <a:ext cx="10472623" cy="329184"/>
+          </a:xfrm>
+          <a:prstGeom prst="rect">
+            <a:avLst/>
+          </a:prstGeom>
+          <a:noFill/>
+          <a:ln/>
+        </p:spPr>
+        <p:txBody>
+          <a:bodyPr wrap="square" rtlCol="0" anchor="b"/>
+          <a:lstStyle/>
+          <a:p>
+            <a:pPr indent="0" marL="0">
+              <a:lnSpc>
+                <a:spcPct val="102000"/>
+              </a:lnSpc>
+              <a:buNone/>
+            </a:pPr>
+            <a:r>
+              <a:rPr lang="en-US" sz="680" i="1" dirty="0">
+                <a:solidFill>
+                  <a:srgbClr val="C9B892"/>
+                </a:solidFill>
+                <a:latin typeface="Calibri" pitchFamily="34" charset="0"/>
+                <a:ea typeface="Calibri" pitchFamily="34" charset="-122"/>
+                <a:cs typeface="Calibri" pitchFamily="34" charset="-120"/>
+              </a:rPr>
+              <a:t>NET-NEW CEO statement — flagged for Harel's approval. Respectful framing; positions LLA as education/literacy, not diagnosis (important liability guardrail).</a:t>
+            </a:r>
+            <a:endParaRPr lang="en-US" sz="680" dirty="0"/>
+          </a:p>
+        </p:txBody>
+      </p:sp>
+      <p:sp>
+        <p:nvSpPr>
+          <p:cNvPr id="14" name="Text 12"/>
+          <p:cNvSpPr/>
+          <p:nvPr/>
+        </p:nvSpPr>
+        <p:spPr>
+          <a:xfrm>
+            <a:off x="11368735" y="6446520"/>
+            <a:ext cx="548640" cy="274320"/>
+          </a:xfrm>
+          <a:prstGeom prst="rect">
+            <a:avLst/>
+          </a:prstGeom>
+          <a:noFill/>
+          <a:ln/>
+        </p:spPr>
+        <p:txBody>
+          <a:bodyPr wrap="square" rtlCol="0" anchor="ctr"/>
+          <a:lstStyle/>
+          <a:p>
+            <a:pPr algn="r" indent="0" marL="0">
+              <a:buNone/>
+            </a:pPr>
+            <a:r>
+              <a:rPr lang="en-US" sz="900" dirty="0">
+                <a:solidFill>
+                  <a:srgbClr val="9AA4AF"/>
+                </a:solidFill>
+                <a:latin typeface="Calibri" pitchFamily="34" charset="0"/>
+                <a:ea typeface="Calibri" pitchFamily="34" charset="-122"/>
+                <a:cs typeface="Calibri" pitchFamily="34" charset="-120"/>
+              </a:rPr>
+              <a:t>33</a:t>
+            </a:r>
+            <a:endParaRPr lang="en-US" sz="900" dirty="0"/>
+          </a:p>
+        </p:txBody>
+      </p:sp>
+    </p:spTree>
+  </p:cSld>
+  <p:clrMapOvr>
+    <a:masterClrMapping/>
+  </p:clrMapOvr>
+</p:sld>
+</file>
+
+<file path=ppt/slides/slide34.xml><?xml version="1.0" encoding="utf-8"?>
+<p:sld xmlns:a="http://schemas.openxmlformats.org/drawingml/2006/main" xmlns:r="http://schemas.openxmlformats.org/officeDocument/2006/relationships" xmlns:p="http://schemas.openxmlformats.org/presentationml/2006/main">
+  <p:cSld name="Slide 34">
+    <p:bg>
+      <p:bgPr>
+        <a:solidFill>
+          <a:srgbClr val="F7F6F2"/>
+        </a:solidFill>
+      </p:bgPr>
+    </p:bg>
+    <p:spTree>
+      <p:nvGrpSpPr>
+        <p:cNvPr id="1" name=""/>
+        <p:cNvGrpSpPr/>
+        <p:nvPr/>
+      </p:nvGrpSpPr>
+      <p:grpSpPr>
+        <a:xfrm>
+          <a:off x="0" y="0"/>
+          <a:ext cx="0" cy="0"/>
+          <a:chOff x="0" y="0"/>
+          <a:chExt cx="0" cy="0"/>
+        </a:xfrm>
+      </p:grpSpPr>
+      <p:sp>
+        <p:nvSpPr>
+          <p:cNvPr id="2" name="Text 0"/>
+          <p:cNvSpPr/>
+          <p:nvPr/>
+        </p:nvSpPr>
+        <p:spPr>
+          <a:xfrm>
+            <a:off x="640080" y="310896"/>
+            <a:ext cx="7955280" cy="274320"/>
+          </a:xfrm>
+          <a:prstGeom prst="rect">
+            <a:avLst/>
+          </a:prstGeom>
+          <a:noFill/>
+          <a:ln/>
+        </p:spPr>
+        <p:txBody>
+          <a:bodyPr wrap="square" rtlCol="0" anchor="ctr"/>
+          <a:lstStyle/>
+          <a:p>
+            <a:pPr indent="0" marL="0">
+              <a:buNone/>
+            </a:pPr>
+            <a:r>
+              <a:rPr lang="en-US" sz="1050" b="1" spc="150" kern="0" dirty="0">
+                <a:solidFill>
+                  <a:srgbClr val="7A2E1A"/>
+                </a:solidFill>
+                <a:latin typeface="Calibri" pitchFamily="34" charset="0"/>
+                <a:ea typeface="Calibri" pitchFamily="34" charset="-122"/>
+                <a:cs typeface="Calibri" pitchFamily="34" charset="-120"/>
+              </a:rPr>
+              <a:t>ARTICLE 5.3   ·   </a:t>
+            </a:r>
+            <a:pPr indent="0" marL="0">
+              <a:buNone/>
+            </a:pPr>
+            <a:r>
+              <a:rPr lang="en-US" sz="1050" b="1" spc="150" kern="0" dirty="0">
+                <a:solidFill>
+                  <a:srgbClr val="5C6672"/>
+                </a:solidFill>
+                <a:latin typeface="Calibri" pitchFamily="34" charset="0"/>
+                <a:ea typeface="Calibri" pitchFamily="34" charset="-122"/>
+                <a:cs typeface="Calibri" pitchFamily="34" charset="-120"/>
+              </a:rPr>
+              <a:t>THE JULIE CONTRAST — $12 A DAY VS $2M A YEAR (PROOF, RESPECTFUL)</a:t>
+            </a:r>
+            <a:endParaRPr lang="en-US" sz="1050" dirty="0"/>
+          </a:p>
+        </p:txBody>
+      </p:sp>
+      <p:sp>
+        <p:nvSpPr>
+          <p:cNvPr id="3" name="Text 1"/>
+          <p:cNvSpPr/>
+          <p:nvPr/>
+        </p:nvSpPr>
+        <p:spPr>
+          <a:xfrm>
+            <a:off x="6705295" y="310896"/>
+            <a:ext cx="4846320" cy="274320"/>
+          </a:xfrm>
+          <a:prstGeom prst="rect">
+            <a:avLst/>
+          </a:prstGeom>
+          <a:noFill/>
+          <a:ln/>
+        </p:spPr>
+        <p:txBody>
+          <a:bodyPr wrap="square" rtlCol="0" anchor="ctr"/>
+          <a:lstStyle/>
+          <a:p>
+            <a:pPr algn="r" indent="0" marL="0">
+              <a:buNone/>
+            </a:pPr>
+            <a:r>
+              <a:rPr lang="en-US" sz="950" dirty="0">
+                <a:solidFill>
+                  <a:srgbClr val="9AA4AF"/>
+                </a:solidFill>
+                <a:latin typeface="Calibri" pitchFamily="34" charset="0"/>
+                <a:ea typeface="Calibri" pitchFamily="34" charset="-122"/>
+                <a:cs typeface="Calibri" pitchFamily="34" charset="-120"/>
+              </a:rPr>
+              <a:t>TARGET  </a:t>
+            </a:r>
+            <a:pPr algn="r" indent="0" marL="0">
+              <a:buNone/>
+            </a:pPr>
+            <a:r>
+              <a:rPr lang="en-US" sz="950" b="1" dirty="0">
+                <a:solidFill>
+                  <a:srgbClr val="7A2E1A"/>
+                </a:solidFill>
+                <a:latin typeface="Calibri" pitchFamily="34" charset="0"/>
+                <a:ea typeface="Calibri" pitchFamily="34" charset="-122"/>
+                <a:cs typeface="Calibri" pitchFamily="34" charset="-120"/>
+              </a:rPr>
+              <a:t>People / Yahoo Life / Today</a:t>
+            </a:r>
+            <a:endParaRPr lang="en-US" sz="950" dirty="0"/>
+          </a:p>
+        </p:txBody>
+      </p:sp>
+      <p:sp>
+        <p:nvSpPr>
+          <p:cNvPr id="4" name="Text 2"/>
+          <p:cNvSpPr/>
+          <p:nvPr/>
+        </p:nvSpPr>
+        <p:spPr>
+          <a:xfrm>
+            <a:off x="640080" y="603504"/>
+            <a:ext cx="10911535" cy="896112"/>
+          </a:xfrm>
+          <a:prstGeom prst="rect">
+            <a:avLst/>
+          </a:prstGeom>
+          <a:noFill/>
+          <a:ln/>
+        </p:spPr>
+        <p:txBody>
+          <a:bodyPr wrap="square" rtlCol="0" anchor="t"/>
+          <a:lstStyle/>
+          <a:p>
+            <a:pPr indent="0" marL="0">
+              <a:lnSpc>
+                <a:spcPct val="96000"/>
+              </a:lnSpc>
+              <a:buNone/>
+            </a:pPr>
+            <a:r>
+              <a:rPr lang="en-US" sz="2600" b="1" dirty="0">
+                <a:solidFill>
+                  <a:srgbClr val="0C2A43"/>
+                </a:solidFill>
+                <a:latin typeface="Cambria" pitchFamily="34" charset="0"/>
+                <a:ea typeface="Cambria" pitchFamily="34" charset="-122"/>
+                <a:cs typeface="Cambria" pitchFamily="34" charset="-120"/>
+              </a:rPr>
+              <a:t>A $12-a-Day Routine Ranked Ahead of a $2-Million-a-Year One — Longevity Life Academy Teaches the Habits Behind It</a:t>
+            </a:r>
+            <a:endParaRPr lang="en-US" sz="2600" dirty="0"/>
+          </a:p>
+        </p:txBody>
+      </p:sp>
+      <p:sp>
+        <p:nvSpPr>
+          <p:cNvPr id="5" name="Text 3"/>
+          <p:cNvSpPr/>
+          <p:nvPr/>
+        </p:nvSpPr>
+        <p:spPr>
+          <a:xfrm>
+            <a:off x="640080" y="1572768"/>
+            <a:ext cx="10911535" cy="512064"/>
+          </a:xfrm>
+          <a:prstGeom prst="rect">
+            <a:avLst/>
+          </a:prstGeom>
+          <a:noFill/>
+          <a:ln/>
+        </p:spPr>
+        <p:txBody>
+          <a:bodyPr wrap="square" rtlCol="0" anchor="t"/>
+          <a:lstStyle/>
+          <a:p>
+            <a:pPr indent="0" marL="0">
+              <a:lnSpc>
+                <a:spcPct val="110000"/>
+              </a:lnSpc>
+              <a:buNone/>
+            </a:pPr>
+            <a:r>
+              <a:rPr lang="en-US" sz="1350" b="1" i="1" dirty="0">
+                <a:solidFill>
+                  <a:srgbClr val="1A1F26"/>
+                </a:solidFill>
+                <a:latin typeface="Calibri" pitchFamily="34" charset="0"/>
+                <a:ea typeface="Calibri" pitchFamily="34" charset="-122"/>
+                <a:cs typeface="Calibri" pitchFamily="34" charset="-120"/>
+              </a:rPr>
+              <a:t>Longevity Life Academy student-turned-instructor Julie Gibson Clark once ranked second in the Rejuvenation Olympics — ahead of Bryan Johnson — on a fraction of the budget. As Johnson faces a hard diagnosis, her story shows what consistency can do.</a:t>
+            </a:r>
+            <a:endParaRPr lang="en-US" sz="1350" dirty="0"/>
+          </a:p>
+        </p:txBody>
+      </p:sp>
+      <p:sp>
+        <p:nvSpPr>
+          <p:cNvPr id="6" name="Shape 4"/>
+          <p:cNvSpPr/>
+          <p:nvPr/>
+        </p:nvSpPr>
+        <p:spPr>
+          <a:xfrm>
+            <a:off x="640080" y="2194560"/>
+            <a:ext cx="10911535" cy="0"/>
+          </a:xfrm>
+          <a:prstGeom prst="line">
+            <a:avLst/>
+          </a:prstGeom>
+          <a:noFill/>
+          <a:ln w="12700">
+            <a:solidFill>
+              <a:srgbClr val="D9DDE2"/>
+            </a:solidFill>
+            <a:prstDash val="solid"/>
+          </a:ln>
+        </p:spPr>
+      </p:sp>
+      <p:sp>
+        <p:nvSpPr>
+          <p:cNvPr id="7" name="Text 5"/>
+          <p:cNvSpPr/>
+          <p:nvPr/>
+        </p:nvSpPr>
+        <p:spPr>
+          <a:xfrm>
+            <a:off x="640080" y="2286000"/>
+            <a:ext cx="5486400" cy="2468880"/>
+          </a:xfrm>
+          <a:prstGeom prst="rect">
+            <a:avLst/>
+          </a:prstGeom>
+          <a:noFill/>
+          <a:ln/>
+        </p:spPr>
+        <p:txBody>
+          <a:bodyPr wrap="square" rtlCol="0" anchor="t"/>
+          <a:lstStyle/>
+          <a:p>
+            <a:pPr indent="0" marL="0">
+              <a:lnSpc>
+                <a:spcPct val="114000"/>
+              </a:lnSpc>
+              <a:spcAft>
+                <a:spcPts val="400"/>
+              </a:spcAft>
+              <a:buNone/>
+            </a:pPr>
+            <a:r>
+              <a:rPr lang="en-US" sz="1050" dirty="0">
+                <a:solidFill>
+                  <a:srgbClr val="1A1F26"/>
+                </a:solidFill>
+                <a:latin typeface="Calibri" pitchFamily="34" charset="0"/>
+                <a:ea typeface="Calibri" pitchFamily="34" charset="-122"/>
+                <a:cs typeface="Calibri" pitchFamily="34" charset="-120"/>
+              </a:rPr>
+              <a:t>RAMAT GAN, Israel — The longevity conversation is at an inflection point. Bryan Johnson, its most famous figure, recently shared that he has an incurable autoimmune condition — a sobering reminder that spending is not the same as certainty. Longevity Life Academy, eTeacher Group's fifth online school, offers a quieter counter-story that predates the news.
+</a:t>
+            </a:r>
+            <a:pPr indent="0" marL="0">
+              <a:lnSpc>
+                <a:spcPct val="114000"/>
+              </a:lnSpc>
+              <a:spcAft>
+                <a:spcPts val="400"/>
+              </a:spcAft>
+              <a:buNone/>
+            </a:pPr>
+            <a:r>
+              <a:rPr lang="en-US" sz="1050" dirty="0">
+                <a:solidFill>
+                  <a:srgbClr val="1A1F26"/>
+                </a:solidFill>
+                <a:latin typeface="Calibri" pitchFamily="34" charset="0"/>
+                <a:ea typeface="Calibri" pitchFamily="34" charset="-122"/>
+                <a:cs typeface="Calibri" pitchFamily="34" charset="-120"/>
+              </a:rPr>
+              <a:t>Julie Gibson Clark, a 56-year-old single mother and former structural engineer from Phoenix, held the number-two position in the Rejuvenation Olympics for more than a year — ranking ahead of Johnson — while spending roughly $12 a day. Her DunedinPACE score of 0.665 indicated a pace of aging roughly a third slower than expected. She did it with sleep, nutrition, movement, and stress habits, kept consistently.
+</a:t>
+            </a:r>
+            <a:pPr indent="0" marL="0">
+              <a:lnSpc>
+                <a:spcPct val="114000"/>
+              </a:lnSpc>
+              <a:spcAft>
+                <a:spcPts val="400"/>
+              </a:spcAft>
+              <a:buNone/>
+            </a:pPr>
+            <a:r>
+              <a:rPr lang="en-US" sz="1050" dirty="0">
+                <a:solidFill>
+                  <a:srgbClr val="1A1F26"/>
+                </a:solidFill>
+                <a:latin typeface="Calibri" pitchFamily="34" charset="0"/>
+                <a:ea typeface="Calibri" pitchFamily="34" charset="-122"/>
+                <a:cs typeface="Calibri" pitchFamily="34" charset="-120"/>
+              </a:rPr>
+              <a:t>That is precisely what Longevity Life Academy teaches, and why the company brought Julie in as an instructor. The academy's 18-week live course, taught in groups of 8–15 with an Abbott Lingo glucose monitor shipped to every US student, turns the fundamentals she lives by into a protocol any motivated adult can learn and keep.</a:t>
+            </a:r>
+            <a:endParaRPr lang="en-US" sz="1050" dirty="0"/>
+          </a:p>
+        </p:txBody>
+      </p:sp>
+      <p:sp>
+        <p:nvSpPr>
+          <p:cNvPr id="8" name="Text 6"/>
+          <p:cNvSpPr/>
+          <p:nvPr/>
+        </p:nvSpPr>
+        <p:spPr>
+          <a:xfrm>
+            <a:off x="6492240" y="2286000"/>
+            <a:ext cx="5486400" cy="2468880"/>
+          </a:xfrm>
+          <a:prstGeom prst="rect">
+            <a:avLst/>
+          </a:prstGeom>
+          <a:noFill/>
+          <a:ln/>
+        </p:spPr>
+        <p:txBody>
+          <a:bodyPr wrap="square" rtlCol="0" anchor="t"/>
+          <a:lstStyle/>
+          <a:p>
+            <a:pPr indent="0" marL="0">
+              <a:lnSpc>
+                <a:spcPct val="114000"/>
+              </a:lnSpc>
+              <a:spcAft>
+                <a:spcPts val="400"/>
+              </a:spcAft>
+              <a:buNone/>
+            </a:pPr>
+            <a:r>
+              <a:rPr lang="en-US" sz="1050" dirty="0">
+                <a:solidFill>
+                  <a:srgbClr val="1A1F26"/>
+                </a:solidFill>
+                <a:latin typeface="Calibri" pitchFamily="34" charset="0"/>
+                <a:ea typeface="Calibri" pitchFamily="34" charset="-122"/>
+                <a:cs typeface="Calibri" pitchFamily="34" charset="-120"/>
+              </a:rPr>
+              <a:t>The point is not to diminish anyone's journey — Johnson's data-sharing has advanced the whole field. It is to show that the levers that matter most are affordable and learnable, and that a good teacher may matter more than a big budget.
+</a:t>
+            </a:r>
+            <a:pPr indent="0" marL="0">
+              <a:lnSpc>
+                <a:spcPct val="114000"/>
+              </a:lnSpc>
+              <a:spcAft>
+                <a:spcPts val="400"/>
+              </a:spcAft>
+              <a:buNone/>
+            </a:pPr>
+            <a:r>
+              <a:rPr lang="en-US" sz="1050" dirty="0">
+                <a:solidFill>
+                  <a:srgbClr val="1A1F26"/>
+                </a:solidFill>
+                <a:latin typeface="Calibri" pitchFamily="34" charset="0"/>
+                <a:ea typeface="Calibri" pitchFamily="34" charset="-122"/>
+                <a:cs typeface="Calibri" pitchFamily="34" charset="-120"/>
+              </a:rPr>
+              <a:t>“Julie proved something we build our whole school around: the fundamentals, done consistently, are extraordinarily powerful — and they don't require a fortune,” said CEO Harel Tayeb. “That is not a knock on anyone spending more. It is an invitation to everyone who assumed this was out of reach.”
+</a:t>
+            </a:r>
+            <a:pPr indent="0" marL="0">
+              <a:lnSpc>
+                <a:spcPct val="114000"/>
+              </a:lnSpc>
+              <a:spcAft>
+                <a:spcPts val="400"/>
+              </a:spcAft>
+              <a:buNone/>
+            </a:pPr>
+            <a:r>
+              <a:rPr lang="en-US" sz="1050" dirty="0">
+                <a:solidFill>
+                  <a:srgbClr val="1A1F26"/>
+                </a:solidFill>
+                <a:latin typeface="Calibri" pitchFamily="34" charset="0"/>
+                <a:ea typeface="Calibri" pitchFamily="34" charset="-122"/>
+                <a:cs typeface="Calibri" pitchFamily="34" charset="-120"/>
+              </a:rPr>
+              <a:t>Longevity Life Academy is enrolling now from $289 per month.</a:t>
+            </a:r>
+            <a:endParaRPr lang="en-US" sz="1050" dirty="0"/>
+          </a:p>
+        </p:txBody>
+      </p:sp>
+      <p:sp>
+        <p:nvSpPr>
+          <p:cNvPr id="9" name="Shape 7"/>
+          <p:cNvSpPr/>
+          <p:nvPr/>
+        </p:nvSpPr>
+        <p:spPr>
+          <a:xfrm>
+            <a:off x="640080" y="4892040"/>
+            <a:ext cx="10911535" cy="1399032"/>
+          </a:xfrm>
+          <a:prstGeom prst="roundRect">
+            <a:avLst>
+              <a:gd name="adj" fmla="val 3268"/>
+            </a:avLst>
+          </a:prstGeom>
+          <a:solidFill>
+            <a:srgbClr val="0C2A43"/>
+          </a:solidFill>
+          <a:ln w="25400">
+            <a:solidFill>
+              <a:srgbClr val="C08A2E"/>
+            </a:solidFill>
+            <a:prstDash val="solid"/>
+          </a:ln>
+        </p:spPr>
+      </p:sp>
+      <p:sp>
+        <p:nvSpPr>
+          <p:cNvPr id="10" name="Shape 8"/>
+          <p:cNvSpPr/>
+          <p:nvPr/>
+        </p:nvSpPr>
+        <p:spPr>
+          <a:xfrm>
+            <a:off x="658368" y="4910328"/>
+            <a:ext cx="10874959" cy="310896"/>
+          </a:xfrm>
+          <a:prstGeom prst="rect">
+            <a:avLst/>
+          </a:prstGeom>
+          <a:solidFill>
+            <a:srgbClr val="C08A2E"/>
+          </a:solidFill>
+          <a:ln/>
+        </p:spPr>
+      </p:sp>
+      <p:sp>
+        <p:nvSpPr>
+          <p:cNvPr id="11" name="Text 9"/>
+          <p:cNvSpPr/>
+          <p:nvPr/>
+        </p:nvSpPr>
+        <p:spPr>
+          <a:xfrm>
+            <a:off x="841248" y="4910328"/>
+            <a:ext cx="10509199" cy="310896"/>
+          </a:xfrm>
+          <a:prstGeom prst="rect">
+            <a:avLst/>
+          </a:prstGeom>
+          <a:noFill/>
+          <a:ln/>
+        </p:spPr>
+        <p:txBody>
+          <a:bodyPr wrap="square" rtlCol="0" anchor="ctr"/>
+          <a:lstStyle/>
+          <a:p>
+            <a:pPr indent="0" marL="0">
+              <a:buNone/>
+            </a:pPr>
+            <a:r>
+              <a:rPr lang="en-US" sz="900" b="1" spc="80" kern="0" dirty="0">
+                <a:solidFill>
+                  <a:srgbClr val="0C2A43"/>
+                </a:solidFill>
+                <a:latin typeface="Calibri" pitchFamily="34" charset="0"/>
+                <a:ea typeface="Calibri" pitchFamily="34" charset="-122"/>
+                <a:cs typeface="Calibri" pitchFamily="34" charset="-120"/>
+              </a:rPr>
+              <a:t>HIGHLIGHTED QUOTE  ·  HAREL TAYEB, CEO, eTeacher Group</a:t>
+            </a:r>
+            <a:endParaRPr lang="en-US" sz="900" dirty="0"/>
+          </a:p>
+        </p:txBody>
+      </p:sp>
+      <p:sp>
+        <p:nvSpPr>
+          <p:cNvPr id="12" name="Text 10"/>
+          <p:cNvSpPr/>
+          <p:nvPr/>
+        </p:nvSpPr>
+        <p:spPr>
+          <a:xfrm>
+            <a:off x="859536" y="5294376"/>
+            <a:ext cx="10472623" cy="466344"/>
+          </a:xfrm>
+          <a:prstGeom prst="rect">
+            <a:avLst/>
+          </a:prstGeom>
+          <a:noFill/>
+          <a:ln/>
+        </p:spPr>
+        <p:txBody>
+          <a:bodyPr wrap="square" rtlCol="0" anchor="t"/>
+          <a:lstStyle/>
+          <a:p>
+            <a:pPr indent="0" marL="0">
+              <a:lnSpc>
+                <a:spcPct val="108000"/>
+              </a:lnSpc>
+              <a:buNone/>
+            </a:pPr>
+            <a:r>
+              <a:rPr lang="en-US" sz="1150" b="1" i="1" dirty="0">
+                <a:solidFill>
+                  <a:srgbClr val="FFF3DA"/>
+                </a:solidFill>
+                <a:latin typeface="Calibri" pitchFamily="34" charset="0"/>
+                <a:ea typeface="Calibri" pitchFamily="34" charset="-122"/>
+                <a:cs typeface="Calibri" pitchFamily="34" charset="-120"/>
+              </a:rPr>
+              <a:t>“Julie proved something we build our whole school around: the fundamentals, done consistently, are extraordinarily powerful — and they don't require a fortune. That is not a knock on anyone spending more. It is an invitation to everyone who assumed this was out of reach.”</a:t>
+            </a:r>
+            <a:endParaRPr lang="en-US" sz="1150" dirty="0"/>
+          </a:p>
+        </p:txBody>
+      </p:sp>
+      <p:sp>
+        <p:nvSpPr>
+          <p:cNvPr id="13" name="Text 11"/>
+          <p:cNvSpPr/>
+          <p:nvPr/>
+        </p:nvSpPr>
+        <p:spPr>
+          <a:xfrm>
+            <a:off x="859536" y="5833872"/>
+            <a:ext cx="10472623" cy="329184"/>
+          </a:xfrm>
+          <a:prstGeom prst="rect">
+            <a:avLst/>
+          </a:prstGeom>
+          <a:noFill/>
+          <a:ln/>
+        </p:spPr>
+        <p:txBody>
+          <a:bodyPr wrap="square" rtlCol="0" anchor="b"/>
+          <a:lstStyle/>
+          <a:p>
+            <a:pPr indent="0" marL="0">
+              <a:lnSpc>
+                <a:spcPct val="102000"/>
+              </a:lnSpc>
+              <a:buNone/>
+            </a:pPr>
+            <a:r>
+              <a:rPr lang="en-US" sz="680" i="1" dirty="0">
+                <a:solidFill>
+                  <a:srgbClr val="C9B892"/>
+                </a:solidFill>
+                <a:latin typeface="Calibri" pitchFamily="34" charset="0"/>
+                <a:ea typeface="Calibri" pitchFamily="34" charset="-122"/>
+                <a:cs typeface="Calibri" pitchFamily="34" charset="-120"/>
+              </a:rPr>
+              <a:t>NET-NEW CEO statement — flagged for Harel's approval. Julie's #2 ranking kept PAST-tense ('held'). Respectful toward Johnson.</a:t>
+            </a:r>
+            <a:endParaRPr lang="en-US" sz="680" dirty="0"/>
+          </a:p>
+        </p:txBody>
+      </p:sp>
+      <p:sp>
+        <p:nvSpPr>
+          <p:cNvPr id="14" name="Text 12"/>
+          <p:cNvSpPr/>
+          <p:nvPr/>
+        </p:nvSpPr>
+        <p:spPr>
+          <a:xfrm>
+            <a:off x="11368735" y="6446520"/>
+            <a:ext cx="548640" cy="274320"/>
+          </a:xfrm>
+          <a:prstGeom prst="rect">
+            <a:avLst/>
+          </a:prstGeom>
+          <a:noFill/>
+          <a:ln/>
+        </p:spPr>
+        <p:txBody>
+          <a:bodyPr wrap="square" rtlCol="0" anchor="ctr"/>
+          <a:lstStyle/>
+          <a:p>
+            <a:pPr algn="r" indent="0" marL="0">
+              <a:buNone/>
+            </a:pPr>
+            <a:r>
+              <a:rPr lang="en-US" sz="900" dirty="0">
+                <a:solidFill>
+                  <a:srgbClr val="9AA4AF"/>
+                </a:solidFill>
+                <a:latin typeface="Calibri" pitchFamily="34" charset="0"/>
+                <a:ea typeface="Calibri" pitchFamily="34" charset="-122"/>
+                <a:cs typeface="Calibri" pitchFamily="34" charset="-120"/>
+              </a:rPr>
+              <a:t>34</a:t>
+            </a:r>
+            <a:endParaRPr lang="en-US" sz="900" dirty="0"/>
+          </a:p>
+        </p:txBody>
+      </p:sp>
+    </p:spTree>
+  </p:cSld>
+  <p:clrMapOvr>
+    <a:masterClrMapping/>
+  </p:clrMapOvr>
+</p:sld>
+</file>
+
+<file path=ppt/slides/slide35.xml><?xml version="1.0" encoding="utf-8"?>
+<p:sld xmlns:a="http://schemas.openxmlformats.org/drawingml/2006/main" xmlns:r="http://schemas.openxmlformats.org/officeDocument/2006/relationships" xmlns:p="http://schemas.openxmlformats.org/presentationml/2006/main">
+  <p:cSld name="Slide 35">
+    <p:bg>
+      <p:bgPr>
+        <a:solidFill>
+          <a:srgbClr val="F7F6F2"/>
+        </a:solidFill>
+      </p:bgPr>
+    </p:bg>
+    <p:spTree>
+      <p:nvGrpSpPr>
+        <p:cNvPr id="1" name=""/>
+        <p:cNvGrpSpPr/>
+        <p:nvPr/>
+      </p:nvGrpSpPr>
+      <p:grpSpPr>
+        <a:xfrm>
+          <a:off x="0" y="0"/>
+          <a:ext cx="0" cy="0"/>
+          <a:chOff x="0" y="0"/>
+          <a:chExt cx="0" cy="0"/>
+        </a:xfrm>
+      </p:grpSpPr>
+      <p:sp>
+        <p:nvSpPr>
+          <p:cNvPr id="2" name="Text 0"/>
+          <p:cNvSpPr/>
+          <p:nvPr/>
+        </p:nvSpPr>
+        <p:spPr>
+          <a:xfrm>
+            <a:off x="640080" y="310896"/>
+            <a:ext cx="7955280" cy="274320"/>
+          </a:xfrm>
+          <a:prstGeom prst="rect">
+            <a:avLst/>
+          </a:prstGeom>
+          <a:noFill/>
+          <a:ln/>
+        </p:spPr>
+        <p:txBody>
+          <a:bodyPr wrap="square" rtlCol="0" anchor="ctr"/>
+          <a:lstStyle/>
+          <a:p>
+            <a:pPr indent="0" marL="0">
+              <a:buNone/>
+            </a:pPr>
+            <a:r>
+              <a:rPr lang="en-US" sz="1050" b="1" spc="150" kern="0" dirty="0">
+                <a:solidFill>
+                  <a:srgbClr val="7A2E1A"/>
+                </a:solidFill>
+                <a:latin typeface="Calibri" pitchFamily="34" charset="0"/>
+                <a:ea typeface="Calibri" pitchFamily="34" charset="-122"/>
+                <a:cs typeface="Calibri" pitchFamily="34" charset="-120"/>
+              </a:rPr>
+              <a:t>ARTICLE 5.4   ·   </a:t>
+            </a:r>
+            <a:pPr indent="0" marL="0">
+              <a:buNone/>
+            </a:pPr>
+            <a:r>
+              <a:rPr lang="en-US" sz="1050" b="1" spc="150" kern="0" dirty="0">
+                <a:solidFill>
+                  <a:srgbClr val="5C6672"/>
+                </a:solidFill>
+                <a:latin typeface="Calibri" pitchFamily="34" charset="0"/>
+                <a:ea typeface="Calibri" pitchFamily="34" charset="-122"/>
+                <a:cs typeface="Calibri" pitchFamily="34" charset="-120"/>
+              </a:rPr>
+              <a:t>LONGEVITY FOR EVERYONE / ACCESSIBILITY (OP-ED STYLE, RESPECTFUL)</a:t>
+            </a:r>
+            <a:endParaRPr lang="en-US" sz="1050" dirty="0"/>
+          </a:p>
+        </p:txBody>
+      </p:sp>
+      <p:sp>
+        <p:nvSpPr>
+          <p:cNvPr id="3" name="Text 1"/>
+          <p:cNvSpPr/>
+          <p:nvPr/>
+        </p:nvSpPr>
+        <p:spPr>
+          <a:xfrm>
+            <a:off x="6705295" y="310896"/>
+            <a:ext cx="4846320" cy="274320"/>
+          </a:xfrm>
+          <a:prstGeom prst="rect">
+            <a:avLst/>
+          </a:prstGeom>
+          <a:noFill/>
+          <a:ln/>
+        </p:spPr>
+        <p:txBody>
+          <a:bodyPr wrap="square" rtlCol="0" anchor="ctr"/>
+          <a:lstStyle/>
+          <a:p>
+            <a:pPr algn="r" indent="0" marL="0">
+              <a:buNone/>
+            </a:pPr>
+            <a:r>
+              <a:rPr lang="en-US" sz="950" dirty="0">
+                <a:solidFill>
+                  <a:srgbClr val="9AA4AF"/>
+                </a:solidFill>
+                <a:latin typeface="Calibri" pitchFamily="34" charset="0"/>
+                <a:ea typeface="Calibri" pitchFamily="34" charset="-122"/>
+                <a:cs typeface="Calibri" pitchFamily="34" charset="-120"/>
+              </a:rPr>
+              <a:t>TARGET  </a:t>
+            </a:r>
+            <a:pPr algn="r" indent="0" marL="0">
+              <a:buNone/>
+            </a:pPr>
+            <a:r>
+              <a:rPr lang="en-US" sz="950" b="1" dirty="0">
+                <a:solidFill>
+                  <a:srgbClr val="7A2E1A"/>
+                </a:solidFill>
+                <a:latin typeface="Calibri" pitchFamily="34" charset="0"/>
+                <a:ea typeface="Calibri" pitchFamily="34" charset="-122"/>
+                <a:cs typeface="Calibri" pitchFamily="34" charset="-120"/>
+              </a:rPr>
+              <a:t>Newsweek / USA Today opinion / Fast Company</a:t>
+            </a:r>
+            <a:endParaRPr lang="en-US" sz="950" dirty="0"/>
+          </a:p>
+        </p:txBody>
+      </p:sp>
+      <p:sp>
+        <p:nvSpPr>
+          <p:cNvPr id="4" name="Text 2"/>
+          <p:cNvSpPr/>
+          <p:nvPr/>
+        </p:nvSpPr>
+        <p:spPr>
+          <a:xfrm>
+            <a:off x="640080" y="603504"/>
+            <a:ext cx="10911535" cy="896112"/>
+          </a:xfrm>
+          <a:prstGeom prst="rect">
+            <a:avLst/>
+          </a:prstGeom>
+          <a:noFill/>
+          <a:ln/>
+        </p:spPr>
+        <p:txBody>
+          <a:bodyPr wrap="square" rtlCol="0" anchor="t"/>
+          <a:lstStyle/>
+          <a:p>
+            <a:pPr indent="0" marL="0">
+              <a:lnSpc>
+                <a:spcPct val="96000"/>
+              </a:lnSpc>
+              <a:buNone/>
+            </a:pPr>
+            <a:r>
+              <a:rPr lang="en-US" sz="2600" b="1" dirty="0">
+                <a:solidFill>
+                  <a:srgbClr val="0C2A43"/>
+                </a:solidFill>
+                <a:latin typeface="Cambria" pitchFamily="34" charset="0"/>
+                <a:ea typeface="Cambria" pitchFamily="34" charset="-122"/>
+                <a:cs typeface="Cambria" pitchFamily="34" charset="-120"/>
+              </a:rPr>
+              <a:t>Longevity Shouldn't Depend on Your Bank Balance — Longevity Life Academy Puts Science-Backed Healthy Aging Within Reach for $289 a Month</a:t>
+            </a:r>
+            <a:endParaRPr lang="en-US" sz="2600" dirty="0"/>
+          </a:p>
+        </p:txBody>
+      </p:sp>
+      <p:sp>
+        <p:nvSpPr>
+          <p:cNvPr id="5" name="Text 3"/>
+          <p:cNvSpPr/>
+          <p:nvPr/>
+        </p:nvSpPr>
+        <p:spPr>
+          <a:xfrm>
+            <a:off x="640080" y="1572768"/>
+            <a:ext cx="10911535" cy="512064"/>
+          </a:xfrm>
+          <a:prstGeom prst="rect">
+            <a:avLst/>
+          </a:prstGeom>
+          <a:noFill/>
+          <a:ln/>
+        </p:spPr>
+        <p:txBody>
+          <a:bodyPr wrap="square" rtlCol="0" anchor="t"/>
+          <a:lstStyle/>
+          <a:p>
+            <a:pPr indent="0" marL="0">
+              <a:lnSpc>
+                <a:spcPct val="110000"/>
+              </a:lnSpc>
+              <a:buNone/>
+            </a:pPr>
+            <a:r>
+              <a:rPr lang="en-US" sz="1350" b="1" i="1" dirty="0">
+                <a:solidFill>
+                  <a:srgbClr val="1A1F26"/>
+                </a:solidFill>
+                <a:latin typeface="Calibri" pitchFamily="34" charset="0"/>
+                <a:ea typeface="Calibri" pitchFamily="34" charset="-122"/>
+                <a:cs typeface="Calibri" pitchFamily="34" charset="-120"/>
+              </a:rPr>
+              <a:t>The biohacking headlines make longevity look like a billionaire's hobby. eTeacher's Longevity Life Academy exists to prove the opposite — that the science is teachable, and the habits are affordable.</a:t>
+            </a:r>
+            <a:endParaRPr lang="en-US" sz="1350" dirty="0"/>
+          </a:p>
+        </p:txBody>
+      </p:sp>
+      <p:sp>
+        <p:nvSpPr>
+          <p:cNvPr id="6" name="Shape 4"/>
+          <p:cNvSpPr/>
+          <p:nvPr/>
+        </p:nvSpPr>
+        <p:spPr>
+          <a:xfrm>
+            <a:off x="640080" y="2194560"/>
+            <a:ext cx="10911535" cy="0"/>
+          </a:xfrm>
+          <a:prstGeom prst="line">
+            <a:avLst/>
+          </a:prstGeom>
+          <a:noFill/>
+          <a:ln w="12700">
+            <a:solidFill>
+              <a:srgbClr val="D9DDE2"/>
+            </a:solidFill>
+            <a:prstDash val="solid"/>
+          </a:ln>
+        </p:spPr>
+      </p:sp>
+      <p:sp>
+        <p:nvSpPr>
+          <p:cNvPr id="7" name="Text 5"/>
+          <p:cNvSpPr/>
+          <p:nvPr/>
+        </p:nvSpPr>
+        <p:spPr>
+          <a:xfrm>
+            <a:off x="640080" y="2286000"/>
+            <a:ext cx="5486400" cy="2468880"/>
+          </a:xfrm>
+          <a:prstGeom prst="rect">
+            <a:avLst/>
+          </a:prstGeom>
+          <a:noFill/>
+          <a:ln/>
+        </p:spPr>
+        <p:txBody>
+          <a:bodyPr wrap="square" rtlCol="0" anchor="t"/>
+          <a:lstStyle/>
+          <a:p>
+            <a:pPr indent="0" marL="0">
+              <a:lnSpc>
+                <a:spcPct val="114000"/>
+              </a:lnSpc>
+              <a:spcAft>
+                <a:spcPts val="400"/>
+              </a:spcAft>
+              <a:buNone/>
+            </a:pPr>
+            <a:r>
+              <a:rPr lang="en-US" sz="1050" dirty="0">
+                <a:solidFill>
+                  <a:srgbClr val="1A1F26"/>
+                </a:solidFill>
+                <a:latin typeface="Calibri" pitchFamily="34" charset="0"/>
+                <a:ea typeface="Calibri" pitchFamily="34" charset="-122"/>
+                <a:cs typeface="Calibri" pitchFamily="34" charset="-120"/>
+              </a:rPr>
+              <a:t>RAMAT GAN, Israel — Every few months, longevity returns to the headlines through a single extraordinary figure and an extraordinary budget. The latest news — Bryan Johnson's disclosure of an incurable autoimmune condition — is a human moment first, and we wish him well. It is also a chance to correct a widespread misconception: that living longer is a game only the wealthy can play.
+</a:t>
+            </a:r>
+            <a:pPr indent="0" marL="0">
+              <a:lnSpc>
+                <a:spcPct val="114000"/>
+              </a:lnSpc>
+              <a:spcAft>
+                <a:spcPts val="400"/>
+              </a:spcAft>
+              <a:buNone/>
+            </a:pPr>
+            <a:r>
+              <a:rPr lang="en-US" sz="1050" dirty="0">
+                <a:solidFill>
+                  <a:srgbClr val="1A1F26"/>
+                </a:solidFill>
+                <a:latin typeface="Calibri" pitchFamily="34" charset="0"/>
+                <a:ea typeface="Calibri" pitchFamily="34" charset="-122"/>
+                <a:cs typeface="Calibri" pitchFamily="34" charset="-120"/>
+              </a:rPr>
+              <a:t>Longevity Life Academy, the fifth online school of 25-year education company eTeacher Group, is built on the opposite conviction. The science of healthy aging — sleep, nutrition, movement, stress, and personal biomarkers — is not proprietary to the rich. What most people lack is not money; it is a teacher, a structure, and the support to stay consistent.
+</a:t>
+            </a:r>
+            <a:pPr indent="0" marL="0">
+              <a:lnSpc>
+                <a:spcPct val="114000"/>
+              </a:lnSpc>
+              <a:spcAft>
+                <a:spcPts val="400"/>
+              </a:spcAft>
+              <a:buNone/>
+            </a:pPr>
+            <a:r>
+              <a:rPr lang="en-US" sz="1050" dirty="0">
+                <a:solidFill>
+                  <a:srgbClr val="1A1F26"/>
+                </a:solidFill>
+                <a:latin typeface="Calibri" pitchFamily="34" charset="0"/>
+                <a:ea typeface="Calibri" pitchFamily="34" charset="-122"/>
+                <a:cs typeface="Calibri" pitchFamily="34" charset="-120"/>
+              </a:rPr>
+              <a:t>The academy's flagship 18-week course delivers all three: live sessions with named instructors, small cohorts of 8–15, and an Abbott Lingo continuous glucose monitor shipped to every US student before Lesson 5 — all starting at $289 a month. It is the same live-teaching method eTeacher has used to deliver 400,000+ courses across nearly 200 countries, now aimed at healthspan.</a:t>
+            </a:r>
+            <a:endParaRPr lang="en-US" sz="1050" dirty="0"/>
+          </a:p>
+        </p:txBody>
+      </p:sp>
+      <p:sp>
+        <p:nvSpPr>
+          <p:cNvPr id="8" name="Text 6"/>
+          <p:cNvSpPr/>
+          <p:nvPr/>
+        </p:nvSpPr>
+        <p:spPr>
+          <a:xfrm>
+            <a:off x="6492240" y="2286000"/>
+            <a:ext cx="5486400" cy="2468880"/>
+          </a:xfrm>
+          <a:prstGeom prst="rect">
+            <a:avLst/>
+          </a:prstGeom>
+          <a:noFill/>
+          <a:ln/>
+        </p:spPr>
+        <p:txBody>
+          <a:bodyPr wrap="square" rtlCol="0" anchor="t"/>
+          <a:lstStyle/>
+          <a:p>
+            <a:pPr indent="0" marL="0">
+              <a:lnSpc>
+                <a:spcPct val="114000"/>
+              </a:lnSpc>
+              <a:spcAft>
+                <a:spcPts val="400"/>
+              </a:spcAft>
+              <a:buNone/>
+            </a:pPr>
+            <a:r>
+              <a:rPr lang="en-US" sz="1050" dirty="0">
+                <a:solidFill>
+                  <a:srgbClr val="1A1F26"/>
+                </a:solidFill>
+                <a:latin typeface="Calibri" pitchFamily="34" charset="0"/>
+                <a:ea typeface="Calibri" pitchFamily="34" charset="-122"/>
+                <a:cs typeface="Calibri" pitchFamily="34" charset="-120"/>
+              </a:rPr>
+              <a:t>This is not about competing with anyone's regimen. It is about widening the door — taking the parts of longevity science that genuinely work for ordinary people and teaching them in a way that sticks.
+</a:t>
+            </a:r>
+            <a:pPr indent="0" marL="0">
+              <a:lnSpc>
+                <a:spcPct val="114000"/>
+              </a:lnSpc>
+              <a:spcAft>
+                <a:spcPts val="400"/>
+              </a:spcAft>
+              <a:buNone/>
+            </a:pPr>
+            <a:r>
+              <a:rPr lang="en-US" sz="1050" dirty="0">
+                <a:solidFill>
+                  <a:srgbClr val="1A1F26"/>
+                </a:solidFill>
+                <a:latin typeface="Calibri" pitchFamily="34" charset="0"/>
+                <a:ea typeface="Calibri" pitchFamily="34" charset="-122"/>
+                <a:cs typeface="Calibri" pitchFamily="34" charset="-120"/>
+              </a:rPr>
+              <a:t>“A longer, stronger life should not depend on your bank balance,” said CEO Harel Tayeb. “The billionaires can afford to experiment. Our job is to take what is proven, teach it live, and make it something a working family can actually follow.”
+</a:t>
+            </a:r>
+            <a:pPr indent="0" marL="0">
+              <a:lnSpc>
+                <a:spcPct val="114000"/>
+              </a:lnSpc>
+              <a:spcAft>
+                <a:spcPts val="400"/>
+              </a:spcAft>
+              <a:buNone/>
+            </a:pPr>
+            <a:r>
+              <a:rPr lang="en-US" sz="1050" dirty="0">
+                <a:solidFill>
+                  <a:srgbClr val="1A1F26"/>
+                </a:solidFill>
+                <a:latin typeface="Calibri" pitchFamily="34" charset="0"/>
+                <a:ea typeface="Calibri" pitchFamily="34" charset="-122"/>
+                <a:cs typeface="Calibri" pitchFamily="34" charset="-120"/>
+              </a:rPr>
+              <a:t>Longevity Life Academy is enrolling now from $289 per month.</a:t>
+            </a:r>
+            <a:endParaRPr lang="en-US" sz="1050" dirty="0"/>
+          </a:p>
+        </p:txBody>
+      </p:sp>
+      <p:sp>
+        <p:nvSpPr>
+          <p:cNvPr id="9" name="Shape 7"/>
+          <p:cNvSpPr/>
+          <p:nvPr/>
+        </p:nvSpPr>
+        <p:spPr>
+          <a:xfrm>
+            <a:off x="640080" y="4892040"/>
+            <a:ext cx="10911535" cy="1399032"/>
+          </a:xfrm>
+          <a:prstGeom prst="roundRect">
+            <a:avLst>
+              <a:gd name="adj" fmla="val 3268"/>
+            </a:avLst>
+          </a:prstGeom>
+          <a:solidFill>
+            <a:srgbClr val="0C2A43"/>
+          </a:solidFill>
+          <a:ln w="25400">
+            <a:solidFill>
+              <a:srgbClr val="C08A2E"/>
+            </a:solidFill>
+            <a:prstDash val="solid"/>
+          </a:ln>
+        </p:spPr>
+      </p:sp>
+      <p:sp>
+        <p:nvSpPr>
+          <p:cNvPr id="10" name="Shape 8"/>
+          <p:cNvSpPr/>
+          <p:nvPr/>
+        </p:nvSpPr>
+        <p:spPr>
+          <a:xfrm>
+            <a:off x="658368" y="4910328"/>
+            <a:ext cx="10874959" cy="310896"/>
+          </a:xfrm>
+          <a:prstGeom prst="rect">
+            <a:avLst/>
+          </a:prstGeom>
+          <a:solidFill>
+            <a:srgbClr val="C08A2E"/>
+          </a:solidFill>
+          <a:ln/>
+        </p:spPr>
+      </p:sp>
+      <p:sp>
+        <p:nvSpPr>
+          <p:cNvPr id="11" name="Text 9"/>
+          <p:cNvSpPr/>
+          <p:nvPr/>
+        </p:nvSpPr>
+        <p:spPr>
+          <a:xfrm>
+            <a:off x="841248" y="4910328"/>
+            <a:ext cx="10509199" cy="310896"/>
+          </a:xfrm>
+          <a:prstGeom prst="rect">
+            <a:avLst/>
+          </a:prstGeom>
+          <a:noFill/>
+          <a:ln/>
+        </p:spPr>
+        <p:txBody>
+          <a:bodyPr wrap="square" rtlCol="0" anchor="ctr"/>
+          <a:lstStyle/>
+          <a:p>
+            <a:pPr indent="0" marL="0">
+              <a:buNone/>
+            </a:pPr>
+            <a:r>
+              <a:rPr lang="en-US" sz="900" b="1" spc="80" kern="0" dirty="0">
+                <a:solidFill>
+                  <a:srgbClr val="0C2A43"/>
+                </a:solidFill>
+                <a:latin typeface="Calibri" pitchFamily="34" charset="0"/>
+                <a:ea typeface="Calibri" pitchFamily="34" charset="-122"/>
+                <a:cs typeface="Calibri" pitchFamily="34" charset="-120"/>
+              </a:rPr>
+              <a:t>HIGHLIGHTED QUOTE  ·  HAREL TAYEB, CEO, eTeacher Group</a:t>
+            </a:r>
+            <a:endParaRPr lang="en-US" sz="900" dirty="0"/>
+          </a:p>
+        </p:txBody>
+      </p:sp>
+      <p:sp>
+        <p:nvSpPr>
+          <p:cNvPr id="12" name="Text 10"/>
+          <p:cNvSpPr/>
+          <p:nvPr/>
+        </p:nvSpPr>
+        <p:spPr>
+          <a:xfrm>
+            <a:off x="859536" y="5294376"/>
+            <a:ext cx="10472623" cy="466344"/>
+          </a:xfrm>
+          <a:prstGeom prst="rect">
+            <a:avLst/>
+          </a:prstGeom>
+          <a:noFill/>
+          <a:ln/>
+        </p:spPr>
+        <p:txBody>
+          <a:bodyPr wrap="square" rtlCol="0" anchor="t"/>
+          <a:lstStyle/>
+          <a:p>
+            <a:pPr indent="0" marL="0">
+              <a:lnSpc>
+                <a:spcPct val="108000"/>
+              </a:lnSpc>
+              <a:buNone/>
+            </a:pPr>
+            <a:r>
+              <a:rPr lang="en-US" sz="1150" b="1" i="1" dirty="0">
+                <a:solidFill>
+                  <a:srgbClr val="FFF3DA"/>
+                </a:solidFill>
+                <a:latin typeface="Calibri" pitchFamily="34" charset="0"/>
+                <a:ea typeface="Calibri" pitchFamily="34" charset="-122"/>
+                <a:cs typeface="Calibri" pitchFamily="34" charset="-120"/>
+              </a:rPr>
+              <a:t>“A longer, stronger life should not depend on your bank balance. The billionaires can afford to experiment. Our job is to take what is proven, teach it live, and make it something a working family can actually follow.”</a:t>
+            </a:r>
+            <a:endParaRPr lang="en-US" sz="1150" dirty="0"/>
+          </a:p>
+        </p:txBody>
+      </p:sp>
+      <p:sp>
+        <p:nvSpPr>
+          <p:cNvPr id="13" name="Text 11"/>
+          <p:cNvSpPr/>
+          <p:nvPr/>
+        </p:nvSpPr>
+        <p:spPr>
+          <a:xfrm>
+            <a:off x="859536" y="5833872"/>
+            <a:ext cx="10472623" cy="329184"/>
+          </a:xfrm>
+          <a:prstGeom prst="rect">
+            <a:avLst/>
+          </a:prstGeom>
+          <a:noFill/>
+          <a:ln/>
+        </p:spPr>
+        <p:txBody>
+          <a:bodyPr wrap="square" rtlCol="0" anchor="b"/>
+          <a:lstStyle/>
+          <a:p>
+            <a:pPr indent="0" marL="0">
+              <a:lnSpc>
+                <a:spcPct val="102000"/>
+              </a:lnSpc>
+              <a:buNone/>
+            </a:pPr>
+            <a:r>
+              <a:rPr lang="en-US" sz="680" i="1" dirty="0">
+                <a:solidFill>
+                  <a:srgbClr val="C9B892"/>
+                </a:solidFill>
+                <a:latin typeface="Calibri" pitchFamily="34" charset="0"/>
+                <a:ea typeface="Calibri" pitchFamily="34" charset="-122"/>
+                <a:cs typeface="Calibri" pitchFamily="34" charset="-120"/>
+              </a:rPr>
+              <a:t>NET-NEW CEO statement — flagged for Harel's approval. 'Billionaires can afford to experiment' is pointed but not disrespectful to Johnson personally — confirm tone comfort.</a:t>
+            </a:r>
+            <a:endParaRPr lang="en-US" sz="680" dirty="0"/>
+          </a:p>
+        </p:txBody>
+      </p:sp>
+      <p:sp>
+        <p:nvSpPr>
+          <p:cNvPr id="14" name="Text 12"/>
+          <p:cNvSpPr/>
+          <p:nvPr/>
+        </p:nvSpPr>
+        <p:spPr>
+          <a:xfrm>
+            <a:off x="11368735" y="6446520"/>
+            <a:ext cx="548640" cy="274320"/>
+          </a:xfrm>
+          <a:prstGeom prst="rect">
+            <a:avLst/>
+          </a:prstGeom>
+          <a:noFill/>
+          <a:ln/>
+        </p:spPr>
+        <p:txBody>
+          <a:bodyPr wrap="square" rtlCol="0" anchor="ctr"/>
+          <a:lstStyle/>
+          <a:p>
+            <a:pPr algn="r" indent="0" marL="0">
+              <a:buNone/>
+            </a:pPr>
+            <a:r>
+              <a:rPr lang="en-US" sz="900" dirty="0">
+                <a:solidFill>
+                  <a:srgbClr val="9AA4AF"/>
+                </a:solidFill>
+                <a:latin typeface="Calibri" pitchFamily="34" charset="0"/>
+                <a:ea typeface="Calibri" pitchFamily="34" charset="-122"/>
+                <a:cs typeface="Calibri" pitchFamily="34" charset="-120"/>
+              </a:rPr>
+              <a:t>35</a:t>
+            </a:r>
+            <a:endParaRPr lang="en-US" sz="900" dirty="0"/>
+          </a:p>
+        </p:txBody>
+      </p:sp>
+    </p:spTree>
+  </p:cSld>
+  <p:clrMapOvr>
+    <a:masterClrMapping/>
+  </p:clrMapOvr>
+</p:sld>
+</file>
+
+<file path=ppt/slides/slide36.xml><?xml version="1.0" encoding="utf-8"?>
+<p:sld xmlns:a="http://schemas.openxmlformats.org/drawingml/2006/main" xmlns:r="http://schemas.openxmlformats.org/officeDocument/2006/relationships" xmlns:p="http://schemas.openxmlformats.org/presentationml/2006/main">
+  <p:cSld name="Slide 36">
+    <p:bg>
+      <p:bgPr>
+        <a:solidFill>
+          <a:srgbClr val="F7F6F2"/>
+        </a:solidFill>
+      </p:bgPr>
+    </p:bg>
+    <p:spTree>
+      <p:nvGrpSpPr>
+        <p:cNvPr id="1" name=""/>
+        <p:cNvGrpSpPr/>
+        <p:nvPr/>
+      </p:nvGrpSpPr>
+      <p:grpSpPr>
+        <a:xfrm>
+          <a:off x="0" y="0"/>
+          <a:ext cx="0" cy="0"/>
+          <a:chOff x="0" y="0"/>
+          <a:chExt cx="0" cy="0"/>
+        </a:xfrm>
+      </p:grpSpPr>
+      <p:sp>
+        <p:nvSpPr>
+          <p:cNvPr id="2" name="Text 0"/>
+          <p:cNvSpPr/>
+          <p:nvPr/>
+        </p:nvSpPr>
+        <p:spPr>
+          <a:xfrm>
+            <a:off x="640080" y="310896"/>
+            <a:ext cx="7955280" cy="274320"/>
+          </a:xfrm>
+          <a:prstGeom prst="rect">
+            <a:avLst/>
+          </a:prstGeom>
+          <a:noFill/>
+          <a:ln/>
+        </p:spPr>
+        <p:txBody>
+          <a:bodyPr wrap="square" rtlCol="0" anchor="ctr"/>
+          <a:lstStyle/>
+          <a:p>
+            <a:pPr indent="0" marL="0">
+              <a:buNone/>
+            </a:pPr>
+            <a:r>
+              <a:rPr lang="en-US" sz="1050" b="1" spc="150" kern="0" dirty="0">
+                <a:solidFill>
+                  <a:srgbClr val="7A2E1A"/>
+                </a:solidFill>
+                <a:latin typeface="Calibri" pitchFamily="34" charset="0"/>
+                <a:ea typeface="Calibri" pitchFamily="34" charset="-122"/>
+                <a:cs typeface="Calibri" pitchFamily="34" charset="-120"/>
+              </a:rPr>
+              <a:t>ARTICLE 5.5   ·   </a:t>
+            </a:r>
+            <a:pPr indent="0" marL="0">
+              <a:buNone/>
+            </a:pPr>
+            <a:r>
+              <a:rPr lang="en-US" sz="1050" b="1" spc="150" kern="0" dirty="0">
+                <a:solidFill>
+                  <a:srgbClr val="5C6672"/>
+                </a:solidFill>
+                <a:latin typeface="Calibri" pitchFamily="34" charset="0"/>
+                <a:ea typeface="Calibri" pitchFamily="34" charset="-122"/>
+                <a:cs typeface="Calibri" pitchFamily="34" charset="-120"/>
+              </a:rPr>
+              <a:t>LIVE TEACHING VS SOLO BIOHACKING (METHOD STORY, RESPECTFUL)</a:t>
+            </a:r>
+            <a:endParaRPr lang="en-US" sz="1050" dirty="0"/>
+          </a:p>
+        </p:txBody>
+      </p:sp>
+      <p:sp>
+        <p:nvSpPr>
+          <p:cNvPr id="3" name="Text 1"/>
+          <p:cNvSpPr/>
+          <p:nvPr/>
+        </p:nvSpPr>
+        <p:spPr>
+          <a:xfrm>
+            <a:off x="6705295" y="310896"/>
+            <a:ext cx="4846320" cy="274320"/>
+          </a:xfrm>
+          <a:prstGeom prst="rect">
+            <a:avLst/>
+          </a:prstGeom>
+          <a:noFill/>
+          <a:ln/>
+        </p:spPr>
+        <p:txBody>
+          <a:bodyPr wrap="square" rtlCol="0" anchor="ctr"/>
+          <a:lstStyle/>
+          <a:p>
+            <a:pPr algn="r" indent="0" marL="0">
+              <a:buNone/>
+            </a:pPr>
+            <a:r>
+              <a:rPr lang="en-US" sz="950" dirty="0">
+                <a:solidFill>
+                  <a:srgbClr val="9AA4AF"/>
+                </a:solidFill>
+                <a:latin typeface="Calibri" pitchFamily="34" charset="0"/>
+                <a:ea typeface="Calibri" pitchFamily="34" charset="-122"/>
+                <a:cs typeface="Calibri" pitchFamily="34" charset="-120"/>
+              </a:rPr>
+              <a:t>TARGET  </a:t>
+            </a:r>
+            <a:pPr algn="r" indent="0" marL="0">
+              <a:buNone/>
+            </a:pPr>
+            <a:r>
+              <a:rPr lang="en-US" sz="950" b="1" dirty="0">
+                <a:solidFill>
+                  <a:srgbClr val="7A2E1A"/>
+                </a:solidFill>
+                <a:latin typeface="Calibri" pitchFamily="34" charset="0"/>
+                <a:ea typeface="Calibri" pitchFamily="34" charset="-122"/>
+                <a:cs typeface="Calibri" pitchFamily="34" charset="-120"/>
+              </a:rPr>
+              <a:t>EdSurge / Fast Company / Longevity.Technology</a:t>
+            </a:r>
+            <a:endParaRPr lang="en-US" sz="950" dirty="0"/>
+          </a:p>
+        </p:txBody>
+      </p:sp>
+      <p:sp>
+        <p:nvSpPr>
+          <p:cNvPr id="4" name="Text 2"/>
+          <p:cNvSpPr/>
+          <p:nvPr/>
+        </p:nvSpPr>
+        <p:spPr>
+          <a:xfrm>
+            <a:off x="640080" y="603504"/>
+            <a:ext cx="10911535" cy="896112"/>
+          </a:xfrm>
+          <a:prstGeom prst="rect">
+            <a:avLst/>
+          </a:prstGeom>
+          <a:noFill/>
+          <a:ln/>
+        </p:spPr>
+        <p:txBody>
+          <a:bodyPr wrap="square" rtlCol="0" anchor="t"/>
+          <a:lstStyle/>
+          <a:p>
+            <a:pPr indent="0" marL="0">
+              <a:lnSpc>
+                <a:spcPct val="96000"/>
+              </a:lnSpc>
+              <a:buNone/>
+            </a:pPr>
+            <a:r>
+              <a:rPr lang="en-US" sz="2600" b="1" dirty="0">
+                <a:solidFill>
+                  <a:srgbClr val="0C2A43"/>
+                </a:solidFill>
+                <a:latin typeface="Cambria" pitchFamily="34" charset="0"/>
+                <a:ea typeface="Cambria" pitchFamily="34" charset="-122"/>
+                <a:cs typeface="Cambria" pitchFamily="34" charset="-120"/>
+              </a:rPr>
+              <a:t>Longevity Life Academy Bets on Live Teachers, Not Solo Experiments — Because Habits Stick When Someone Teaches You</a:t>
+            </a:r>
+            <a:endParaRPr lang="en-US" sz="2600" dirty="0"/>
+          </a:p>
+        </p:txBody>
+      </p:sp>
+      <p:sp>
+        <p:nvSpPr>
+          <p:cNvPr id="5" name="Text 3"/>
+          <p:cNvSpPr/>
+          <p:nvPr/>
+        </p:nvSpPr>
+        <p:spPr>
+          <a:xfrm>
+            <a:off x="640080" y="1572768"/>
+            <a:ext cx="10911535" cy="512064"/>
+          </a:xfrm>
+          <a:prstGeom prst="rect">
+            <a:avLst/>
+          </a:prstGeom>
+          <a:noFill/>
+          <a:ln/>
+        </p:spPr>
+        <p:txBody>
+          <a:bodyPr wrap="square" rtlCol="0" anchor="t"/>
+          <a:lstStyle/>
+          <a:p>
+            <a:pPr indent="0" marL="0">
+              <a:lnSpc>
+                <a:spcPct val="110000"/>
+              </a:lnSpc>
+              <a:buNone/>
+            </a:pPr>
+            <a:r>
+              <a:rPr lang="en-US" sz="1350" b="1" i="1" dirty="0">
+                <a:solidFill>
+                  <a:srgbClr val="1A1F26"/>
+                </a:solidFill>
+                <a:latin typeface="Calibri" pitchFamily="34" charset="0"/>
+                <a:ea typeface="Calibri" pitchFamily="34" charset="-122"/>
+                <a:cs typeface="Calibri" pitchFamily="34" charset="-120"/>
+              </a:rPr>
+              <a:t>The most famous longevity story is a solo experiment run at enormous cost. eTeacher's Longevity Life Academy is the opposite model: live teachers, small classes, and a structure built so ordinary people actually stay the course.</a:t>
+            </a:r>
+            <a:endParaRPr lang="en-US" sz="1350" dirty="0"/>
+          </a:p>
+        </p:txBody>
+      </p:sp>
+      <p:sp>
+        <p:nvSpPr>
+          <p:cNvPr id="6" name="Shape 4"/>
+          <p:cNvSpPr/>
+          <p:nvPr/>
+        </p:nvSpPr>
+        <p:spPr>
+          <a:xfrm>
+            <a:off x="640080" y="2194560"/>
+            <a:ext cx="10911535" cy="0"/>
+          </a:xfrm>
+          <a:prstGeom prst="line">
+            <a:avLst/>
+          </a:prstGeom>
+          <a:noFill/>
+          <a:ln w="12700">
+            <a:solidFill>
+              <a:srgbClr val="D9DDE2"/>
+            </a:solidFill>
+            <a:prstDash val="solid"/>
+          </a:ln>
+        </p:spPr>
+      </p:sp>
+      <p:sp>
+        <p:nvSpPr>
+          <p:cNvPr id="7" name="Text 5"/>
+          <p:cNvSpPr/>
+          <p:nvPr/>
+        </p:nvSpPr>
+        <p:spPr>
+          <a:xfrm>
+            <a:off x="640080" y="2286000"/>
+            <a:ext cx="5486400" cy="2468880"/>
+          </a:xfrm>
+          <a:prstGeom prst="rect">
+            <a:avLst/>
+          </a:prstGeom>
+          <a:noFill/>
+          <a:ln/>
+        </p:spPr>
+        <p:txBody>
+          <a:bodyPr wrap="square" rtlCol="0" anchor="t"/>
+          <a:lstStyle/>
+          <a:p>
+            <a:pPr indent="0" marL="0">
+              <a:lnSpc>
+                <a:spcPct val="114000"/>
+              </a:lnSpc>
+              <a:spcAft>
+                <a:spcPts val="400"/>
+              </a:spcAft>
+              <a:buNone/>
+            </a:pPr>
+            <a:r>
+              <a:rPr lang="en-US" sz="1050" dirty="0">
+                <a:solidFill>
+                  <a:srgbClr val="1A1F26"/>
+                </a:solidFill>
+                <a:latin typeface="Calibri" pitchFamily="34" charset="0"/>
+                <a:ea typeface="Calibri" pitchFamily="34" charset="-122"/>
+                <a:cs typeface="Calibri" pitchFamily="34" charset="-120"/>
+              </a:rPr>
+              <a:t>RAMAT GAN, Israel — Bryan Johnson's Blueprint is the defining image of modern longevity: one person, a large team, and a vast budget, self-experimenting in public. His openness has taught the field a great deal, and his recent autoimmune-gastritis diagnosis is a reminder of how hard the work is even at that scale. But it also raises a practical question for everyone else: what model works when you don't have a lab and millions to spend?
+</a:t>
+            </a:r>
+            <a:pPr indent="0" marL="0">
+              <a:lnSpc>
+                <a:spcPct val="114000"/>
+              </a:lnSpc>
+              <a:spcAft>
+                <a:spcPts val="400"/>
+              </a:spcAft>
+              <a:buNone/>
+            </a:pPr>
+            <a:r>
+              <a:rPr lang="en-US" sz="1050" dirty="0">
+                <a:solidFill>
+                  <a:srgbClr val="1A1F26"/>
+                </a:solidFill>
+                <a:latin typeface="Calibri" pitchFamily="34" charset="0"/>
+                <a:ea typeface="Calibri" pitchFamily="34" charset="-122"/>
+                <a:cs typeface="Calibri" pitchFamily="34" charset="-120"/>
+              </a:rPr>
+              <a:t>eTeacher Group's answer, delivered through its fifth online school, Longevity Life Academy, is decades old and deceptively simple: people learn best from teachers, live, in small groups. Where solo biohacking asks individuals to self-direct, LLA provides a weekly live anchor session, an expert instructor, a cohort of 8–15 peers, and short daily practice — the structure that turns intentions into habits.
+</a:t>
+            </a:r>
+            <a:pPr indent="0" marL="0">
+              <a:lnSpc>
+                <a:spcPct val="114000"/>
+              </a:lnSpc>
+              <a:spcAft>
+                <a:spcPts val="400"/>
+              </a:spcAft>
+              <a:buNone/>
+            </a:pPr>
+            <a:r>
+              <a:rPr lang="en-US" sz="1050" dirty="0">
+                <a:solidFill>
+                  <a:srgbClr val="1A1F26"/>
+                </a:solidFill>
+                <a:latin typeface="Calibri" pitchFamily="34" charset="0"/>
+                <a:ea typeface="Calibri" pitchFamily="34" charset="-122"/>
+                <a:cs typeface="Calibri" pitchFamily="34" charset="-120"/>
+              </a:rPr>
+              <a:t>The academy applies the same method behind eTeacher's 400,000+ courses to healthspan. Each 18-week program pairs live instruction with personal data — an Abbott Lingo continuous glucose monitor ships to every US student before Lesson 5 — so lessons are grounded in the student's own body, guided by a real teacher rather than a lonely feed of tips.</a:t>
+            </a:r>
+            <a:endParaRPr lang="en-US" sz="1050" dirty="0"/>
+          </a:p>
+        </p:txBody>
+      </p:sp>
+      <p:sp>
+        <p:nvSpPr>
+          <p:cNvPr id="8" name="Text 6"/>
+          <p:cNvSpPr/>
+          <p:nvPr/>
+        </p:nvSpPr>
+        <p:spPr>
+          <a:xfrm>
+            <a:off x="6492240" y="2286000"/>
+            <a:ext cx="5486400" cy="2468880"/>
+          </a:xfrm>
+          <a:prstGeom prst="rect">
+            <a:avLst/>
+          </a:prstGeom>
+          <a:noFill/>
+          <a:ln/>
+        </p:spPr>
+        <p:txBody>
+          <a:bodyPr wrap="square" rtlCol="0" anchor="t"/>
+          <a:lstStyle/>
+          <a:p>
+            <a:pPr indent="0" marL="0">
+              <a:lnSpc>
+                <a:spcPct val="114000"/>
+              </a:lnSpc>
+              <a:spcAft>
+                <a:spcPts val="400"/>
+              </a:spcAft>
+              <a:buNone/>
+            </a:pPr>
+            <a:r>
+              <a:rPr lang="en-US" sz="1050" dirty="0">
+                <a:solidFill>
+                  <a:srgbClr val="1A1F26"/>
+                </a:solidFill>
+                <a:latin typeface="Calibri" pitchFamily="34" charset="0"/>
+                <a:ea typeface="Calibri" pitchFamily="34" charset="-122"/>
+                <a:cs typeface="Calibri" pitchFamily="34" charset="-120"/>
+              </a:rPr>
+              <a:t>The company's thesis is that persistence, not information, is the scarce resource in wellness — and that persistence is a social act. A teacher who knows your name and a small class that expects you back do what a dashboard alone cannot.
+</a:t>
+            </a:r>
+            <a:pPr indent="0" marL="0">
+              <a:lnSpc>
+                <a:spcPct val="114000"/>
+              </a:lnSpc>
+              <a:spcAft>
+                <a:spcPts val="400"/>
+              </a:spcAft>
+              <a:buNone/>
+            </a:pPr>
+            <a:r>
+              <a:rPr lang="en-US" sz="1050" dirty="0">
+                <a:solidFill>
+                  <a:srgbClr val="1A1F26"/>
+                </a:solidFill>
+                <a:latin typeface="Calibri" pitchFamily="34" charset="0"/>
+                <a:ea typeface="Calibri" pitchFamily="34" charset="-122"/>
+                <a:cs typeface="Calibri" pitchFamily="34" charset="-120"/>
+              </a:rPr>
+              <a:t>“The hardest part of living longer isn't knowing what to do — it's doing it next week, and the week after,” said CEO Harel Tayeb. “That is why we put a real teacher in the room. You can experiment alone, or you can be taught, supported, and expected back. We built our whole school on the second one.”
+</a:t>
+            </a:r>
+            <a:pPr indent="0" marL="0">
+              <a:lnSpc>
+                <a:spcPct val="114000"/>
+              </a:lnSpc>
+              <a:spcAft>
+                <a:spcPts val="400"/>
+              </a:spcAft>
+              <a:buNone/>
+            </a:pPr>
+            <a:r>
+              <a:rPr lang="en-US" sz="1050" dirty="0">
+                <a:solidFill>
+                  <a:srgbClr val="1A1F26"/>
+                </a:solidFill>
+                <a:latin typeface="Calibri" pitchFamily="34" charset="0"/>
+                <a:ea typeface="Calibri" pitchFamily="34" charset="-122"/>
+                <a:cs typeface="Calibri" pitchFamily="34" charset="-120"/>
+              </a:rPr>
+              <a:t>Longevity Life Academy is enrolling now from $289 per month.</a:t>
+            </a:r>
+            <a:endParaRPr lang="en-US" sz="1050" dirty="0"/>
+          </a:p>
+        </p:txBody>
+      </p:sp>
+      <p:sp>
+        <p:nvSpPr>
+          <p:cNvPr id="9" name="Shape 7"/>
+          <p:cNvSpPr/>
+          <p:nvPr/>
+        </p:nvSpPr>
+        <p:spPr>
+          <a:xfrm>
+            <a:off x="640080" y="4892040"/>
+            <a:ext cx="10911535" cy="1399032"/>
+          </a:xfrm>
+          <a:prstGeom prst="roundRect">
+            <a:avLst>
+              <a:gd name="adj" fmla="val 3268"/>
+            </a:avLst>
+          </a:prstGeom>
+          <a:solidFill>
+            <a:srgbClr val="0C2A43"/>
+          </a:solidFill>
+          <a:ln w="25400">
+            <a:solidFill>
+              <a:srgbClr val="C08A2E"/>
+            </a:solidFill>
+            <a:prstDash val="solid"/>
+          </a:ln>
+        </p:spPr>
+      </p:sp>
+      <p:sp>
+        <p:nvSpPr>
+          <p:cNvPr id="10" name="Shape 8"/>
+          <p:cNvSpPr/>
+          <p:nvPr/>
+        </p:nvSpPr>
+        <p:spPr>
+          <a:xfrm>
+            <a:off x="658368" y="4910328"/>
+            <a:ext cx="10874959" cy="310896"/>
+          </a:xfrm>
+          <a:prstGeom prst="rect">
+            <a:avLst/>
+          </a:prstGeom>
+          <a:solidFill>
+            <a:srgbClr val="C08A2E"/>
+          </a:solidFill>
+          <a:ln/>
+        </p:spPr>
+      </p:sp>
+      <p:sp>
+        <p:nvSpPr>
+          <p:cNvPr id="11" name="Text 9"/>
+          <p:cNvSpPr/>
+          <p:nvPr/>
+        </p:nvSpPr>
+        <p:spPr>
+          <a:xfrm>
+            <a:off x="841248" y="4910328"/>
+            <a:ext cx="10509199" cy="310896"/>
+          </a:xfrm>
+          <a:prstGeom prst="rect">
+            <a:avLst/>
+          </a:prstGeom>
+          <a:noFill/>
+          <a:ln/>
+        </p:spPr>
+        <p:txBody>
+          <a:bodyPr wrap="square" rtlCol="0" anchor="ctr"/>
+          <a:lstStyle/>
+          <a:p>
+            <a:pPr indent="0" marL="0">
+              <a:buNone/>
+            </a:pPr>
+            <a:r>
+              <a:rPr lang="en-US" sz="900" b="1" spc="80" kern="0" dirty="0">
+                <a:solidFill>
+                  <a:srgbClr val="0C2A43"/>
+                </a:solidFill>
+                <a:latin typeface="Calibri" pitchFamily="34" charset="0"/>
+                <a:ea typeface="Calibri" pitchFamily="34" charset="-122"/>
+                <a:cs typeface="Calibri" pitchFamily="34" charset="-120"/>
+              </a:rPr>
+              <a:t>HIGHLIGHTED QUOTE  ·  HAREL TAYEB, CEO, eTeacher Group</a:t>
+            </a:r>
+            <a:endParaRPr lang="en-US" sz="900" dirty="0"/>
+          </a:p>
+        </p:txBody>
+      </p:sp>
+      <p:sp>
+        <p:nvSpPr>
+          <p:cNvPr id="12" name="Text 10"/>
+          <p:cNvSpPr/>
+          <p:nvPr/>
+        </p:nvSpPr>
+        <p:spPr>
+          <a:xfrm>
+            <a:off x="859536" y="5294376"/>
+            <a:ext cx="10472623" cy="466344"/>
+          </a:xfrm>
+          <a:prstGeom prst="rect">
+            <a:avLst/>
+          </a:prstGeom>
+          <a:noFill/>
+          <a:ln/>
+        </p:spPr>
+        <p:txBody>
+          <a:bodyPr wrap="square" rtlCol="0" anchor="t"/>
+          <a:lstStyle/>
+          <a:p>
+            <a:pPr indent="0" marL="0">
+              <a:lnSpc>
+                <a:spcPct val="108000"/>
+              </a:lnSpc>
+              <a:buNone/>
+            </a:pPr>
+            <a:r>
+              <a:rPr lang="en-US" sz="1150" b="1" i="1" dirty="0">
+                <a:solidFill>
+                  <a:srgbClr val="FFF3DA"/>
+                </a:solidFill>
+                <a:latin typeface="Calibri" pitchFamily="34" charset="0"/>
+                <a:ea typeface="Calibri" pitchFamily="34" charset="-122"/>
+                <a:cs typeface="Calibri" pitchFamily="34" charset="-120"/>
+              </a:rPr>
+              <a:t>“The hardest part of living longer isn't knowing what to do — it's doing it next week, and the week after. That is why we put a real teacher in the room. You can experiment alone, or you can be taught, supported, and expected back. We built our whole school on the second one.”</a:t>
+            </a:r>
+            <a:endParaRPr lang="en-US" sz="1150" dirty="0"/>
+          </a:p>
+        </p:txBody>
+      </p:sp>
+      <p:sp>
+        <p:nvSpPr>
+          <p:cNvPr id="13" name="Text 11"/>
+          <p:cNvSpPr/>
+          <p:nvPr/>
+        </p:nvSpPr>
+        <p:spPr>
+          <a:xfrm>
+            <a:off x="859536" y="5833872"/>
+            <a:ext cx="10472623" cy="329184"/>
+          </a:xfrm>
+          <a:prstGeom prst="rect">
+            <a:avLst/>
+          </a:prstGeom>
+          <a:noFill/>
+          <a:ln/>
+        </p:spPr>
+        <p:txBody>
+          <a:bodyPr wrap="square" rtlCol="0" anchor="b"/>
+          <a:lstStyle/>
+          <a:p>
+            <a:pPr indent="0" marL="0">
+              <a:lnSpc>
+                <a:spcPct val="102000"/>
+              </a:lnSpc>
+              <a:buNone/>
+            </a:pPr>
+            <a:r>
+              <a:rPr lang="en-US" sz="680" i="1" dirty="0">
+                <a:solidFill>
+                  <a:srgbClr val="C9B892"/>
+                </a:solidFill>
+                <a:latin typeface="Calibri" pitchFamily="34" charset="0"/>
+                <a:ea typeface="Calibri" pitchFamily="34" charset="-122"/>
+                <a:cs typeface="Calibri" pitchFamily="34" charset="-120"/>
+              </a:rPr>
+              <a:t>NET-NEW CEO statement — flagged for Harel's approval. Contrasts LLA's live-teaching method with solo biohacking without disparaging Johnson personally.</a:t>
+            </a:r>
+            <a:endParaRPr lang="en-US" sz="680" dirty="0"/>
+          </a:p>
+        </p:txBody>
+      </p:sp>
+      <p:sp>
+        <p:nvSpPr>
+          <p:cNvPr id="14" name="Text 12"/>
+          <p:cNvSpPr/>
+          <p:nvPr/>
+        </p:nvSpPr>
+        <p:spPr>
+          <a:xfrm>
+            <a:off x="11368735" y="6446520"/>
+            <a:ext cx="548640" cy="274320"/>
+          </a:xfrm>
+          <a:prstGeom prst="rect">
+            <a:avLst/>
+          </a:prstGeom>
+          <a:noFill/>
+          <a:ln/>
+        </p:spPr>
+        <p:txBody>
+          <a:bodyPr wrap="square" rtlCol="0" anchor="ctr"/>
+          <a:lstStyle/>
+          <a:p>
+            <a:pPr algn="r" indent="0" marL="0">
+              <a:buNone/>
+            </a:pPr>
+            <a:r>
+              <a:rPr lang="en-US" sz="900" dirty="0">
+                <a:solidFill>
+                  <a:srgbClr val="9AA4AF"/>
+                </a:solidFill>
+                <a:latin typeface="Calibri" pitchFamily="34" charset="0"/>
+                <a:ea typeface="Calibri" pitchFamily="34" charset="-122"/>
+                <a:cs typeface="Calibri" pitchFamily="34" charset="-120"/>
+              </a:rPr>
+              <a:t>36</a:t>
+            </a:r>
+            <a:endParaRPr lang="en-US" sz="900" dirty="0"/>
+          </a:p>
+        </p:txBody>
+      </p:sp>
+    </p:spTree>
+  </p:cSld>
+  <p:clrMapOvr>
+    <a:masterClrMapping/>
+  </p:clrMapOvr>
+</p:sld>
+</file>
+
+<file path=ppt/slides/slide37.xml><?xml version="1.0" encoding="utf-8"?>
+<p:sld xmlns:a="http://schemas.openxmlformats.org/drawingml/2006/main" xmlns:r="http://schemas.openxmlformats.org/officeDocument/2006/relationships" xmlns:p="http://schemas.openxmlformats.org/presentationml/2006/main">
+  <p:cSld name="Slide 37">
+    <p:bg>
+      <p:bgPr>
+        <a:solidFill>
+          <a:srgbClr val="0C2A43"/>
+        </a:solidFill>
+      </p:bgPr>
+    </p:bg>
+    <p:spTree>
+      <p:nvGrpSpPr>
+        <p:cNvPr id="1" name=""/>
+        <p:cNvGrpSpPr/>
+        <p:nvPr/>
+      </p:nvGrpSpPr>
+      <p:grpSpPr>
+        <a:xfrm>
+          <a:off x="0" y="0"/>
+          <a:ext cx="0" cy="0"/>
+          <a:chOff x="0" y="0"/>
+          <a:chExt cx="0" cy="0"/>
+        </a:xfrm>
+      </p:grpSpPr>
+      <p:sp>
+        <p:nvSpPr>
+          <p:cNvPr id="2" name="Shape 0"/>
+          <p:cNvSpPr/>
+          <p:nvPr/>
+        </p:nvSpPr>
+        <p:spPr>
+          <a:xfrm>
+            <a:off x="0" y="0"/>
+            <a:ext cx="12191695" cy="164592"/>
+          </a:xfrm>
+          <a:prstGeom prst="rect">
+            <a:avLst/>
+          </a:prstGeom>
+          <a:solidFill>
+            <a:srgbClr val="C08A2E"/>
+          </a:solidFill>
+          <a:ln/>
+        </p:spPr>
+      </p:sp>
+      <p:sp>
+        <p:nvSpPr>
+          <p:cNvPr id="3" name="Text 1"/>
+          <p:cNvSpPr/>
+          <p:nvPr/>
+        </p:nvSpPr>
+        <p:spPr>
+          <a:xfrm>
+            <a:off x="640080" y="1280160"/>
+            <a:ext cx="10911535" cy="365760"/>
+          </a:xfrm>
+          <a:prstGeom prst="rect">
+            <a:avLst/>
+          </a:prstGeom>
+          <a:noFill/>
+          <a:ln/>
+        </p:spPr>
+        <p:txBody>
+          <a:bodyPr wrap="square" rtlCol="0" anchor="ctr"/>
+          <a:lstStyle/>
+          <a:p>
+            <a:pPr indent="0" marL="0">
+              <a:buNone/>
+            </a:pPr>
+            <a:r>
+              <a:rPr lang="en-US" sz="1400" b="1" spc="300" kern="0" dirty="0">
+                <a:solidFill>
+                  <a:srgbClr val="C08A2E"/>
+                </a:solidFill>
+                <a:latin typeface="Calibri" pitchFamily="34" charset="0"/>
+                <a:ea typeface="Calibri" pitchFamily="34" charset="-122"/>
+                <a:cs typeface="Calibri" pitchFamily="34" charset="-120"/>
+              </a:rPr>
+              <a:t>NEXT STEPS</a:t>
+            </a:r>
+            <a:endParaRPr lang="en-US" sz="1400" dirty="0"/>
+          </a:p>
+        </p:txBody>
+      </p:sp>
+      <p:sp>
+        <p:nvSpPr>
+          <p:cNvPr id="4" name="Text 2"/>
+          <p:cNvSpPr/>
+          <p:nvPr/>
+        </p:nvSpPr>
+        <p:spPr>
+          <a:xfrm>
+            <a:off x="640080" y="1783080"/>
+            <a:ext cx="10911535" cy="822960"/>
+          </a:xfrm>
+          <a:prstGeom prst="rect">
+            <a:avLst/>
+          </a:prstGeom>
+          <a:noFill/>
+          <a:ln/>
+        </p:spPr>
+        <p:txBody>
+          <a:bodyPr wrap="square" rtlCol="0" anchor="ctr"/>
+          <a:lstStyle/>
+          <a:p>
+            <a:pPr indent="0" marL="0">
+              <a:buNone/>
+            </a:pPr>
+            <a:r>
+              <a:rPr lang="en-US" sz="3200" b="1" dirty="0">
+                <a:solidFill>
+                  <a:srgbClr val="FFFFFF"/>
+                </a:solidFill>
+                <a:latin typeface="Cambria" pitchFamily="34" charset="0"/>
+                <a:ea typeface="Cambria" pitchFamily="34" charset="-122"/>
+                <a:cs typeface="Cambria" pitchFamily="34" charset="-120"/>
+              </a:rPr>
               <a:t>Your approval turns this into coverage</a:t>
             </a:r>
             <a:endParaRPr lang="en-US" sz="3200" dirty="0"/>
@@ -18274,7 +22409,7 @@
                 <a:ea typeface="Calibri" pitchFamily="34" charset="-122"/>
                 <a:cs typeface="Calibri" pitchFamily="34" charset="-120"/>
               </a:rPr>
-              <a:t>5.  Lock the calendar: approve quotes this week so Wave 1 wires Monday, July 13 — the full four-wave program then runs about eight weeks, wrapping by early September.</a:t>
+              <a:t>5.  Lock the calendar: approve quotes this week so Wave 1 wires Monday, July 13 — the full five-wave program then runs about nine weeks, wrapping by mid-September.</a:t>
             </a:r>
             <a:endParaRPr lang="en-US" sz="1400" dirty="0"/>
           </a:p>

</xml_diff>

<commit_message>
Wave 5: Bryan Johnson in every headline; fix body/quote overflow on 5.1 & 5.5
</commit_message>
<xml_diff>
--- a/eTeacher_Longevity_PR_Campaign.pptx
+++ b/eTeacher_Longevity_PR_Campaign.pptx
@@ -4821,7 +4821,7 @@
         <p:spPr>
           <a:xfrm>
             <a:off x="640080" y="2286000"/>
-            <a:ext cx="5486400" cy="2468880"/>
+            <a:ext cx="5486400" cy="2697480"/>
           </a:xfrm>
           <a:prstGeom prst="rect">
             <a:avLst/>
@@ -4835,15 +4835,15 @@
           <a:p>
             <a:pPr indent="0" marL="0">
               <a:lnSpc>
-                <a:spcPct val="114000"/>
+                <a:spcPct val="110000"/>
               </a:lnSpc>
               <a:spcAft>
-                <a:spcPts val="400"/>
+                <a:spcPts val="300"/>
               </a:spcAft>
               <a:buNone/>
             </a:pPr>
             <a:r>
-              <a:rPr lang="en-US" sz="1050" dirty="0">
+              <a:rPr lang="en-US" sz="980" dirty="0">
                 <a:solidFill>
                   <a:srgbClr val="1A1F26"/>
                 </a:solidFill>
@@ -4856,15 +4856,15 @@
             </a:r>
             <a:pPr indent="0" marL="0">
               <a:lnSpc>
-                <a:spcPct val="114000"/>
+                <a:spcPct val="110000"/>
               </a:lnSpc>
               <a:spcAft>
-                <a:spcPts val="400"/>
+                <a:spcPts val="300"/>
               </a:spcAft>
               <a:buNone/>
             </a:pPr>
             <a:r>
-              <a:rPr lang="en-US" sz="1050" dirty="0">
+              <a:rPr lang="en-US" sz="980" dirty="0">
                 <a:solidFill>
                   <a:srgbClr val="1A1F26"/>
                 </a:solidFill>
@@ -4877,15 +4877,15 @@
             </a:r>
             <a:pPr indent="0" marL="0">
               <a:lnSpc>
-                <a:spcPct val="114000"/>
+                <a:spcPct val="110000"/>
               </a:lnSpc>
               <a:spcAft>
-                <a:spcPts val="400"/>
+                <a:spcPts val="300"/>
               </a:spcAft>
               <a:buNone/>
             </a:pPr>
             <a:r>
-              <a:rPr lang="en-US" sz="1050" dirty="0">
+              <a:rPr lang="en-US" sz="980" dirty="0">
                 <a:solidFill>
                   <a:srgbClr val="1A1F26"/>
                 </a:solidFill>
@@ -4895,7 +4895,7 @@
               </a:rPr>
               <a:t>LLA's flagship program, “The Longevity Blueprint,” is an 18-week live course — 18 sessions across four phases, 50 minutes weekly, in groups of 8–15 — that turns healthy-aging science into one personalized protocol each student can live by. Every student receives an Abbott Lingo continuous glucose monitor, shipped to their US home before Lesson 5, so learning is grounded in their own body data.</a:t>
             </a:r>
-            <a:endParaRPr lang="en-US" sz="1050" dirty="0"/>
+            <a:endParaRPr lang="en-US" sz="980" dirty="0"/>
           </a:p>
         </p:txBody>
       </p:sp>
@@ -4908,7 +4908,7 @@
         <p:spPr>
           <a:xfrm>
             <a:off x="6492240" y="2286000"/>
-            <a:ext cx="5486400" cy="2468880"/>
+            <a:ext cx="5486400" cy="2697480"/>
           </a:xfrm>
           <a:prstGeom prst="rect">
             <a:avLst/>
@@ -4922,15 +4922,15 @@
           <a:p>
             <a:pPr indent="0" marL="0">
               <a:lnSpc>
-                <a:spcPct val="114000"/>
+                <a:spcPct val="110000"/>
               </a:lnSpc>
               <a:spcAft>
-                <a:spcPts val="400"/>
+                <a:spcPts val="300"/>
               </a:spcAft>
               <a:buNone/>
             </a:pPr>
             <a:r>
-              <a:rPr lang="en-US" sz="1050" dirty="0">
+              <a:rPr lang="en-US" sz="980" dirty="0">
                 <a:solidFill>
                   <a:srgbClr val="1A1F26"/>
                 </a:solidFill>
@@ -4943,15 +4943,15 @@
             </a:r>
             <a:pPr indent="0" marL="0">
               <a:lnSpc>
-                <a:spcPct val="114000"/>
+                <a:spcPct val="110000"/>
               </a:lnSpc>
               <a:spcAft>
-                <a:spcPts val="400"/>
+                <a:spcPts val="300"/>
               </a:spcAft>
               <a:buNone/>
             </a:pPr>
             <a:r>
-              <a:rPr lang="en-US" sz="1050" dirty="0">
+              <a:rPr lang="en-US" sz="980" dirty="0">
                 <a:solidFill>
                   <a:srgbClr val="1A1F26"/>
                 </a:solidFill>
@@ -4964,15 +4964,15 @@
             </a:r>
             <a:pPr indent="0" marL="0">
               <a:lnSpc>
-                <a:spcPct val="114000"/>
+                <a:spcPct val="110000"/>
               </a:lnSpc>
               <a:spcAft>
-                <a:spcPts val="400"/>
+                <a:spcPts val="300"/>
               </a:spcAft>
               <a:buNone/>
             </a:pPr>
             <a:r>
-              <a:rPr lang="en-US" sz="1050" dirty="0">
+              <a:rPr lang="en-US" sz="980" dirty="0">
                 <a:solidFill>
                   <a:srgbClr val="1A1F26"/>
                 </a:solidFill>
@@ -4982,7 +4982,7 @@
               </a:rPr>
               <a:t>The Longevity Blueprint is enrolling now from $289 per month, and eTeacher says additional longevity courses and a companion practice app are on its roadmap for the year ahead.</a:t>
             </a:r>
-            <a:endParaRPr lang="en-US" sz="1050" dirty="0"/>
+            <a:endParaRPr lang="en-US" sz="980" dirty="0"/>
           </a:p>
         </p:txBody>
       </p:sp>
@@ -4994,12 +4994,12 @@
         </p:nvSpPr>
         <p:spPr>
           <a:xfrm>
-            <a:off x="640080" y="4892040"/>
-            <a:ext cx="10911535" cy="1399032"/>
+            <a:off x="640080" y="5138928"/>
+            <a:ext cx="10911535" cy="1152144"/>
           </a:xfrm>
           <a:prstGeom prst="roundRect">
             <a:avLst>
-              <a:gd name="adj" fmla="val 3268"/>
+              <a:gd name="adj" fmla="val 3968"/>
             </a:avLst>
           </a:prstGeom>
           <a:solidFill>
@@ -5021,7 +5021,7 @@
         </p:nvSpPr>
         <p:spPr>
           <a:xfrm>
-            <a:off x="658368" y="4910328"/>
+            <a:off x="658368" y="5157216"/>
             <a:ext cx="10874959" cy="310896"/>
           </a:xfrm>
           <a:prstGeom prst="rect">
@@ -5041,7 +5041,7 @@
         </p:nvSpPr>
         <p:spPr>
           <a:xfrm>
-            <a:off x="841248" y="4910328"/>
+            <a:off x="841248" y="5157216"/>
             <a:ext cx="10509199" cy="310896"/>
           </a:xfrm>
           <a:prstGeom prst="rect">
@@ -5080,8 +5080,8 @@
         </p:nvSpPr>
         <p:spPr>
           <a:xfrm>
-            <a:off x="859536" y="5294376"/>
-            <a:ext cx="10472623" cy="466344"/>
+            <a:off x="859536" y="5541264"/>
+            <a:ext cx="10472623" cy="219456"/>
           </a:xfrm>
           <a:prstGeom prst="rect">
             <a:avLst/>
@@ -5449,7 +5449,7 @@
         <p:spPr>
           <a:xfrm>
             <a:off x="640080" y="2286000"/>
-            <a:ext cx="5486400" cy="2468880"/>
+            <a:ext cx="5486400" cy="2697480"/>
           </a:xfrm>
           <a:prstGeom prst="rect">
             <a:avLst/>
@@ -5463,15 +5463,15 @@
           <a:p>
             <a:pPr indent="0" marL="0">
               <a:lnSpc>
-                <a:spcPct val="114000"/>
+                <a:spcPct val="110000"/>
               </a:lnSpc>
               <a:spcAft>
-                <a:spcPts val="400"/>
+                <a:spcPts val="300"/>
               </a:spcAft>
               <a:buNone/>
             </a:pPr>
             <a:r>
-              <a:rPr lang="en-US" sz="1050" dirty="0">
+              <a:rPr lang="en-US" sz="980" dirty="0">
                 <a:solidFill>
                   <a:srgbClr val="1A1F26"/>
                 </a:solidFill>
@@ -5484,15 +5484,15 @@
             </a:r>
             <a:pPr indent="0" marL="0">
               <a:lnSpc>
-                <a:spcPct val="114000"/>
+                <a:spcPct val="110000"/>
               </a:lnSpc>
               <a:spcAft>
-                <a:spcPts val="400"/>
+                <a:spcPts val="300"/>
               </a:spcAft>
               <a:buNone/>
             </a:pPr>
             <a:r>
-              <a:rPr lang="en-US" sz="1050" dirty="0">
+              <a:rPr lang="en-US" sz="980" dirty="0">
                 <a:solidFill>
                   <a:srgbClr val="1A1F26"/>
                 </a:solidFill>
@@ -5505,15 +5505,15 @@
             </a:r>
             <a:pPr indent="0" marL="0">
               <a:lnSpc>
-                <a:spcPct val="114000"/>
+                <a:spcPct val="110000"/>
               </a:lnSpc>
               <a:spcAft>
-                <a:spcPts val="400"/>
+                <a:spcPts val="300"/>
               </a:spcAft>
               <a:buNone/>
             </a:pPr>
             <a:r>
-              <a:rPr lang="en-US" sz="1050" dirty="0">
+              <a:rPr lang="en-US" sz="980" dirty="0">
                 <a:solidFill>
                   <a:srgbClr val="1A1F26"/>
                 </a:solidFill>
@@ -5523,7 +5523,7 @@
               </a:rPr>
               <a:t>In Longevity Life Academy, that means an 18-week live cohort of 8–15 students, 50 minutes weekly across four phases, plus guided daily experiments tied to each student's own glucose, sleep, and movement data. An Abbott Lingo continuous glucose monitor ships to every US student before Lesson 5, turning abstract lessons into personal feedback loops.</a:t>
             </a:r>
-            <a:endParaRPr lang="en-US" sz="1050" dirty="0"/>
+            <a:endParaRPr lang="en-US" sz="980" dirty="0"/>
           </a:p>
         </p:txBody>
       </p:sp>
@@ -5536,7 +5536,7 @@
         <p:spPr>
           <a:xfrm>
             <a:off x="6492240" y="2286000"/>
-            <a:ext cx="5486400" cy="2468880"/>
+            <a:ext cx="5486400" cy="2697480"/>
           </a:xfrm>
           <a:prstGeom prst="rect">
             <a:avLst/>
@@ -5550,15 +5550,15 @@
           <a:p>
             <a:pPr indent="0" marL="0">
               <a:lnSpc>
-                <a:spcPct val="114000"/>
+                <a:spcPct val="110000"/>
               </a:lnSpc>
               <a:spcAft>
-                <a:spcPts val="400"/>
+                <a:spcPts val="300"/>
               </a:spcAft>
               <a:buNone/>
             </a:pPr>
             <a:r>
-              <a:rPr lang="en-US" sz="1050" dirty="0">
+              <a:rPr lang="en-US" sz="980" dirty="0">
                 <a:solidFill>
                   <a:srgbClr val="1A1F26"/>
                 </a:solidFill>
@@ -5571,15 +5571,15 @@
             </a:r>
             <a:pPr indent="0" marL="0">
               <a:lnSpc>
-                <a:spcPct val="114000"/>
+                <a:spcPct val="110000"/>
               </a:lnSpc>
               <a:spcAft>
-                <a:spcPts val="400"/>
+                <a:spcPts val="300"/>
               </a:spcAft>
               <a:buNone/>
             </a:pPr>
             <a:r>
-              <a:rPr lang="en-US" sz="1050" dirty="0">
+              <a:rPr lang="en-US" sz="980" dirty="0">
                 <a:solidFill>
                   <a:srgbClr val="1A1F26"/>
                 </a:solidFill>
@@ -5592,15 +5592,15 @@
             </a:r>
             <a:pPr indent="0" marL="0">
               <a:lnSpc>
-                <a:spcPct val="114000"/>
+                <a:spcPct val="110000"/>
               </a:lnSpc>
               <a:spcAft>
-                <a:spcPts val="400"/>
+                <a:spcPts val="300"/>
               </a:spcAft>
               <a:buNone/>
             </a:pPr>
             <a:r>
-              <a:rPr lang="en-US" sz="1050" dirty="0">
+              <a:rPr lang="en-US" sz="980" dirty="0">
                 <a:solidFill>
                   <a:srgbClr val="1A1F26"/>
                 </a:solidFill>
@@ -5610,7 +5610,7 @@
               </a:rPr>
               <a:t>eTeacher says an AI longevity tutor and a companion practice app are on the roadmap, extending the daily-engagement layer across its five schools.</a:t>
             </a:r>
-            <a:endParaRPr lang="en-US" sz="1050" dirty="0"/>
+            <a:endParaRPr lang="en-US" sz="980" dirty="0"/>
           </a:p>
         </p:txBody>
       </p:sp>
@@ -5622,12 +5622,12 @@
         </p:nvSpPr>
         <p:spPr>
           <a:xfrm>
-            <a:off x="640080" y="4892040"/>
-            <a:ext cx="10911535" cy="1399032"/>
+            <a:off x="640080" y="5138928"/>
+            <a:ext cx="10911535" cy="1152144"/>
           </a:xfrm>
           <a:prstGeom prst="roundRect">
             <a:avLst>
-              <a:gd name="adj" fmla="val 3268"/>
+              <a:gd name="adj" fmla="val 3968"/>
             </a:avLst>
           </a:prstGeom>
           <a:solidFill>
@@ -5649,7 +5649,7 @@
         </p:nvSpPr>
         <p:spPr>
           <a:xfrm>
-            <a:off x="658368" y="4910328"/>
+            <a:off x="658368" y="5157216"/>
             <a:ext cx="10874959" cy="310896"/>
           </a:xfrm>
           <a:prstGeom prst="rect">
@@ -5669,7 +5669,7 @@
         </p:nvSpPr>
         <p:spPr>
           <a:xfrm>
-            <a:off x="841248" y="4910328"/>
+            <a:off x="841248" y="5157216"/>
             <a:ext cx="10509199" cy="310896"/>
           </a:xfrm>
           <a:prstGeom prst="rect">
@@ -5708,8 +5708,8 @@
         </p:nvSpPr>
         <p:spPr>
           <a:xfrm>
-            <a:off x="859536" y="5294376"/>
-            <a:ext cx="10472623" cy="466344"/>
+            <a:off x="859536" y="5541264"/>
+            <a:ext cx="10472623" cy="219456"/>
           </a:xfrm>
           <a:prstGeom prst="rect">
             <a:avLst/>
@@ -6077,7 +6077,7 @@
         <p:spPr>
           <a:xfrm>
             <a:off x="640080" y="2286000"/>
-            <a:ext cx="5486400" cy="2468880"/>
+            <a:ext cx="5486400" cy="2697480"/>
           </a:xfrm>
           <a:prstGeom prst="rect">
             <a:avLst/>
@@ -6091,15 +6091,15 @@
           <a:p>
             <a:pPr indent="0" marL="0">
               <a:lnSpc>
-                <a:spcPct val="114000"/>
+                <a:spcPct val="110000"/>
               </a:lnSpc>
               <a:spcAft>
-                <a:spcPts val="400"/>
+                <a:spcPts val="300"/>
               </a:spcAft>
               <a:buNone/>
             </a:pPr>
             <a:r>
-              <a:rPr lang="en-US" sz="1050" dirty="0">
+              <a:rPr lang="en-US" sz="980" dirty="0">
                 <a:solidFill>
                   <a:srgbClr val="1A1F26"/>
                 </a:solidFill>
@@ -6112,15 +6112,15 @@
             </a:r>
             <a:pPr indent="0" marL="0">
               <a:lnSpc>
-                <a:spcPct val="114000"/>
+                <a:spcPct val="110000"/>
               </a:lnSpc>
               <a:spcAft>
-                <a:spcPts val="400"/>
+                <a:spcPts val="300"/>
               </a:spcAft>
               <a:buNone/>
             </a:pPr>
             <a:r>
-              <a:rPr lang="en-US" sz="1050" dirty="0">
+              <a:rPr lang="en-US" sz="980" dirty="0">
                 <a:solidFill>
                   <a:srgbClr val="1A1F26"/>
                 </a:solidFill>
@@ -6133,15 +6133,15 @@
             </a:r>
             <a:pPr indent="0" marL="0">
               <a:lnSpc>
-                <a:spcPct val="114000"/>
+                <a:spcPct val="110000"/>
               </a:lnSpc>
               <a:spcAft>
-                <a:spcPts val="400"/>
+                <a:spcPts val="300"/>
               </a:spcAft>
               <a:buNone/>
             </a:pPr>
             <a:r>
-              <a:rPr lang="en-US" sz="1050" dirty="0">
+              <a:rPr lang="en-US" sz="980" dirty="0">
                 <a:solidFill>
                   <a:srgbClr val="1A1F26"/>
                 </a:solidFill>
@@ -6151,7 +6151,7 @@
               </a:rPr>
               <a:t>eTeacher enters with advantages rivals would take years to build: roughly 70% of its customers are already in the US, it runs a proven billing and retention engine (payments partner Nuvei), and it has 25 years operating small live cohorts at global scale — 400,000+ courses across nearly 200 countries.</a:t>
             </a:r>
-            <a:endParaRPr lang="en-US" sz="1050" dirty="0"/>
+            <a:endParaRPr lang="en-US" sz="980" dirty="0"/>
           </a:p>
         </p:txBody>
       </p:sp>
@@ -6164,7 +6164,7 @@
         <p:spPr>
           <a:xfrm>
             <a:off x="6492240" y="2286000"/>
-            <a:ext cx="5486400" cy="2468880"/>
+            <a:ext cx="5486400" cy="2697480"/>
           </a:xfrm>
           <a:prstGeom prst="rect">
             <a:avLst/>
@@ -6178,15 +6178,15 @@
           <a:p>
             <a:pPr indent="0" marL="0">
               <a:lnSpc>
-                <a:spcPct val="114000"/>
+                <a:spcPct val="110000"/>
               </a:lnSpc>
               <a:spcAft>
-                <a:spcPts val="400"/>
+                <a:spcPts val="300"/>
               </a:spcAft>
               <a:buNone/>
             </a:pPr>
             <a:r>
-              <a:rPr lang="en-US" sz="1050" dirty="0">
+              <a:rPr lang="en-US" sz="980" dirty="0">
                 <a:solidFill>
                   <a:srgbClr val="1A1F26"/>
                 </a:solidFill>
@@ -6199,15 +6199,15 @@
             </a:r>
             <a:pPr indent="0" marL="0">
               <a:lnSpc>
-                <a:spcPct val="114000"/>
+                <a:spcPct val="110000"/>
               </a:lnSpc>
               <a:spcAft>
-                <a:spcPts val="400"/>
+                <a:spcPts val="300"/>
               </a:spcAft>
               <a:buNone/>
             </a:pPr>
             <a:r>
-              <a:rPr lang="en-US" sz="1050" dirty="0">
+              <a:rPr lang="en-US" sz="980" dirty="0">
                 <a:solidFill>
                   <a:srgbClr val="1A1F26"/>
                 </a:solidFill>
@@ -6220,15 +6220,15 @@
             </a:r>
             <a:pPr indent="0" marL="0">
               <a:lnSpc>
-                <a:spcPct val="114000"/>
+                <a:spcPct val="110000"/>
               </a:lnSpc>
               <a:spcAft>
-                <a:spcPts val="400"/>
+                <a:spcPts val="300"/>
               </a:spcAft>
               <a:buNone/>
             </a:pPr>
             <a:r>
-              <a:rPr lang="en-US" sz="1050" dirty="0">
+              <a:rPr lang="en-US" sz="980" dirty="0">
                 <a:solidFill>
                   <a:srgbClr val="1A1F26"/>
                 </a:solidFill>
@@ -6238,7 +6238,7 @@
               </a:rPr>
               <a:t>eTeacher plans to broaden the catalog with additional longevity courses over the coming year, deepening its position in the mainstream tier of the market.</a:t>
             </a:r>
-            <a:endParaRPr lang="en-US" sz="1050" dirty="0"/>
+            <a:endParaRPr lang="en-US" sz="980" dirty="0"/>
           </a:p>
         </p:txBody>
       </p:sp>
@@ -6250,12 +6250,12 @@
         </p:nvSpPr>
         <p:spPr>
           <a:xfrm>
-            <a:off x="640080" y="4892040"/>
-            <a:ext cx="10911535" cy="1399032"/>
+            <a:off x="640080" y="5138928"/>
+            <a:ext cx="10911535" cy="1152144"/>
           </a:xfrm>
           <a:prstGeom prst="roundRect">
             <a:avLst>
-              <a:gd name="adj" fmla="val 3268"/>
+              <a:gd name="adj" fmla="val 3968"/>
             </a:avLst>
           </a:prstGeom>
           <a:solidFill>
@@ -6277,7 +6277,7 @@
         </p:nvSpPr>
         <p:spPr>
           <a:xfrm>
-            <a:off x="658368" y="4910328"/>
+            <a:off x="658368" y="5157216"/>
             <a:ext cx="10874959" cy="310896"/>
           </a:xfrm>
           <a:prstGeom prst="rect">
@@ -6297,7 +6297,7 @@
         </p:nvSpPr>
         <p:spPr>
           <a:xfrm>
-            <a:off x="841248" y="4910328"/>
+            <a:off x="841248" y="5157216"/>
             <a:ext cx="10509199" cy="310896"/>
           </a:xfrm>
           <a:prstGeom prst="rect">
@@ -6336,8 +6336,8 @@
         </p:nvSpPr>
         <p:spPr>
           <a:xfrm>
-            <a:off x="859536" y="5294376"/>
-            <a:ext cx="10472623" cy="466344"/>
+            <a:off x="859536" y="5541264"/>
+            <a:ext cx="10472623" cy="219456"/>
           </a:xfrm>
           <a:prstGeom prst="rect">
             <a:avLst/>
@@ -6705,7 +6705,7 @@
         <p:spPr>
           <a:xfrm>
             <a:off x="640080" y="2286000"/>
-            <a:ext cx="5486400" cy="2468880"/>
+            <a:ext cx="5486400" cy="2697480"/>
           </a:xfrm>
           <a:prstGeom prst="rect">
             <a:avLst/>
@@ -6719,15 +6719,15 @@
           <a:p>
             <a:pPr indent="0" marL="0">
               <a:lnSpc>
-                <a:spcPct val="114000"/>
+                <a:spcPct val="110000"/>
               </a:lnSpc>
               <a:spcAft>
-                <a:spcPts val="400"/>
+                <a:spcPts val="300"/>
               </a:spcAft>
               <a:buNone/>
             </a:pPr>
             <a:r>
-              <a:rPr lang="en-US" sz="1050" dirty="0">
+              <a:rPr lang="en-US" sz="980" dirty="0">
                 <a:solidFill>
                   <a:srgbClr val="1A1F26"/>
                 </a:solidFill>
@@ -6740,15 +6740,15 @@
             </a:r>
             <a:pPr indent="0" marL="0">
               <a:lnSpc>
-                <a:spcPct val="114000"/>
+                <a:spcPct val="110000"/>
               </a:lnSpc>
               <a:spcAft>
-                <a:spcPts val="400"/>
+                <a:spcPts val="300"/>
               </a:spcAft>
               <a:buNone/>
             </a:pPr>
             <a:r>
-              <a:rPr lang="en-US" sz="1050" dirty="0">
+              <a:rPr lang="en-US" sz="980" dirty="0">
                 <a:solidFill>
                   <a:srgbClr val="1A1F26"/>
                 </a:solidFill>
@@ -6761,15 +6761,15 @@
             </a:r>
             <a:pPr indent="0" marL="0">
               <a:lnSpc>
-                <a:spcPct val="114000"/>
+                <a:spcPct val="110000"/>
               </a:lnSpc>
               <a:spcAft>
-                <a:spcPts val="400"/>
+                <a:spcPts val="300"/>
               </a:spcAft>
               <a:buNone/>
             </a:pPr>
             <a:r>
-              <a:rPr lang="en-US" sz="1050" dirty="0">
+              <a:rPr lang="en-US" sz="980" dirty="0">
                 <a:solidFill>
                   <a:srgbClr val="1A1F26"/>
                 </a:solidFill>
@@ -6779,7 +6779,7 @@
               </a:rPr>
               <a:t>The 18-week structure moves through four phases, from Foundation to a written Blueprint tested against each student's body, in live cohorts of 8–15. Instruction comes from named practitioners including researcher Natalie Blackbourne and UC Santa Barbara senior lecturer and NASM-certified trainer Amy Jamieson.</a:t>
             </a:r>
-            <a:endParaRPr lang="en-US" sz="1050" dirty="0"/>
+            <a:endParaRPr lang="en-US" sz="980" dirty="0"/>
           </a:p>
         </p:txBody>
       </p:sp>
@@ -6792,7 +6792,7 @@
         <p:spPr>
           <a:xfrm>
             <a:off x="6492240" y="2286000"/>
-            <a:ext cx="5486400" cy="2468880"/>
+            <a:ext cx="5486400" cy="2697480"/>
           </a:xfrm>
           <a:prstGeom prst="rect">
             <a:avLst/>
@@ -6806,15 +6806,15 @@
           <a:p>
             <a:pPr indent="0" marL="0">
               <a:lnSpc>
-                <a:spcPct val="114000"/>
+                <a:spcPct val="110000"/>
               </a:lnSpc>
               <a:spcAft>
-                <a:spcPts val="400"/>
+                <a:spcPts val="300"/>
               </a:spcAft>
               <a:buNone/>
             </a:pPr>
             <a:r>
-              <a:rPr lang="en-US" sz="1050" dirty="0">
+              <a:rPr lang="en-US" sz="980" dirty="0">
                 <a:solidFill>
                   <a:srgbClr val="1A1F26"/>
                 </a:solidFill>
@@ -6827,15 +6827,15 @@
             </a:r>
             <a:pPr indent="0" marL="0">
               <a:lnSpc>
-                <a:spcPct val="114000"/>
+                <a:spcPct val="110000"/>
               </a:lnSpc>
               <a:spcAft>
-                <a:spcPts val="400"/>
+                <a:spcPts val="300"/>
               </a:spcAft>
               <a:buNone/>
             </a:pPr>
             <a:r>
-              <a:rPr lang="en-US" sz="1050" dirty="0">
+              <a:rPr lang="en-US" sz="980" dirty="0">
                 <a:solidFill>
                   <a:srgbClr val="1A1F26"/>
                 </a:solidFill>
@@ -6848,15 +6848,15 @@
             </a:r>
             <a:pPr indent="0" marL="0">
               <a:lnSpc>
-                <a:spcPct val="114000"/>
+                <a:spcPct val="110000"/>
               </a:lnSpc>
               <a:spcAft>
-                <a:spcPts val="400"/>
+                <a:spcPts val="300"/>
               </a:spcAft>
               <a:buNone/>
             </a:pPr>
             <a:r>
-              <a:rPr lang="en-US" sz="1050" dirty="0">
+              <a:rPr lang="en-US" sz="980" dirty="0">
                 <a:solidFill>
                   <a:srgbClr val="1A1F26"/>
                 </a:solidFill>
@@ -6866,7 +6866,7 @@
               </a:rPr>
               <a:t>eTeacher says wearable integration will deepen as its longevity courses expand over the coming year, with advanced biomarker content on the roadmap.</a:t>
             </a:r>
-            <a:endParaRPr lang="en-US" sz="1050" dirty="0"/>
+            <a:endParaRPr lang="en-US" sz="980" dirty="0"/>
           </a:p>
         </p:txBody>
       </p:sp>
@@ -6878,12 +6878,12 @@
         </p:nvSpPr>
         <p:spPr>
           <a:xfrm>
-            <a:off x="640080" y="4892040"/>
-            <a:ext cx="10911535" cy="1399032"/>
+            <a:off x="640080" y="5138928"/>
+            <a:ext cx="10911535" cy="1152144"/>
           </a:xfrm>
           <a:prstGeom prst="roundRect">
             <a:avLst>
-              <a:gd name="adj" fmla="val 3268"/>
+              <a:gd name="adj" fmla="val 3968"/>
             </a:avLst>
           </a:prstGeom>
           <a:solidFill>
@@ -6905,7 +6905,7 @@
         </p:nvSpPr>
         <p:spPr>
           <a:xfrm>
-            <a:off x="658368" y="4910328"/>
+            <a:off x="658368" y="5157216"/>
             <a:ext cx="10874959" cy="310896"/>
           </a:xfrm>
           <a:prstGeom prst="rect">
@@ -6925,7 +6925,7 @@
         </p:nvSpPr>
         <p:spPr>
           <a:xfrm>
-            <a:off x="841248" y="4910328"/>
+            <a:off x="841248" y="5157216"/>
             <a:ext cx="10509199" cy="310896"/>
           </a:xfrm>
           <a:prstGeom prst="rect">
@@ -6964,8 +6964,8 @@
         </p:nvSpPr>
         <p:spPr>
           <a:xfrm>
-            <a:off x="859536" y="5294376"/>
-            <a:ext cx="10472623" cy="466344"/>
+            <a:off x="859536" y="5541264"/>
+            <a:ext cx="10472623" cy="219456"/>
           </a:xfrm>
           <a:prstGeom prst="rect">
             <a:avLst/>
@@ -7333,7 +7333,7 @@
         <p:spPr>
           <a:xfrm>
             <a:off x="640080" y="2286000"/>
-            <a:ext cx="5486400" cy="2468880"/>
+            <a:ext cx="5486400" cy="2697480"/>
           </a:xfrm>
           <a:prstGeom prst="rect">
             <a:avLst/>
@@ -7347,15 +7347,15 @@
           <a:p>
             <a:pPr indent="0" marL="0">
               <a:lnSpc>
-                <a:spcPct val="114000"/>
+                <a:spcPct val="110000"/>
               </a:lnSpc>
               <a:spcAft>
-                <a:spcPts val="400"/>
+                <a:spcPts val="300"/>
               </a:spcAft>
               <a:buNone/>
             </a:pPr>
             <a:r>
-              <a:rPr lang="en-US" sz="1050" dirty="0">
+              <a:rPr lang="en-US" sz="980" dirty="0">
                 <a:solidFill>
                   <a:srgbClr val="1A1F26"/>
                 </a:solidFill>
@@ -7368,15 +7368,15 @@
             </a:r>
             <a:pPr indent="0" marL="0">
               <a:lnSpc>
-                <a:spcPct val="114000"/>
+                <a:spcPct val="110000"/>
               </a:lnSpc>
               <a:spcAft>
-                <a:spcPts val="400"/>
+                <a:spcPts val="300"/>
               </a:spcAft>
               <a:buNone/>
             </a:pPr>
             <a:r>
-              <a:rPr lang="en-US" sz="1050" dirty="0">
+              <a:rPr lang="en-US" sz="980" dirty="0">
                 <a:solidFill>
                   <a:srgbClr val="1A1F26"/>
                 </a:solidFill>
@@ -7389,15 +7389,15 @@
             </a:r>
             <a:pPr indent="0" marL="0">
               <a:lnSpc>
-                <a:spcPct val="114000"/>
+                <a:spcPct val="110000"/>
               </a:lnSpc>
               <a:spcAft>
-                <a:spcPts val="400"/>
+                <a:spcPts val="300"/>
               </a:spcAft>
               <a:buNone/>
             </a:pPr>
             <a:r>
-              <a:rPr lang="en-US" sz="1050" dirty="0">
+              <a:rPr lang="en-US" sz="980" dirty="0">
                 <a:solidFill>
                   <a:srgbClr val="1A1F26"/>
                 </a:solidFill>
@@ -7407,7 +7407,7 @@
               </a:rPr>
               <a:t>eTeacher's differentiator is a model built in Israel and exported worldwide: live experts in small groups of 8–15, paired with AI micro-learning, and courses developed in an academic-partnership tradition that includes the Hebrew University of Jerusalem. In longevity, that method anchors an 18-week live program with an Abbott Lingo glucose monitor shipped to every US student.</a:t>
             </a:r>
-            <a:endParaRPr lang="en-US" sz="1050" dirty="0"/>
+            <a:endParaRPr lang="en-US" sz="980" dirty="0"/>
           </a:p>
         </p:txBody>
       </p:sp>
@@ -7420,7 +7420,7 @@
         <p:spPr>
           <a:xfrm>
             <a:off x="6492240" y="2286000"/>
-            <a:ext cx="5486400" cy="2468880"/>
+            <a:ext cx="5486400" cy="2697480"/>
           </a:xfrm>
           <a:prstGeom prst="rect">
             <a:avLst/>
@@ -7434,15 +7434,15 @@
           <a:p>
             <a:pPr indent="0" marL="0">
               <a:lnSpc>
-                <a:spcPct val="114000"/>
+                <a:spcPct val="110000"/>
               </a:lnSpc>
               <a:spcAft>
-                <a:spcPts val="400"/>
+                <a:spcPts val="300"/>
               </a:spcAft>
               <a:buNone/>
             </a:pPr>
             <a:r>
-              <a:rPr lang="en-US" sz="1050" dirty="0">
+              <a:rPr lang="en-US" sz="980" dirty="0">
                 <a:solidFill>
                   <a:srgbClr val="1A1F26"/>
                 </a:solidFill>
@@ -7455,15 +7455,15 @@
             </a:r>
             <a:pPr indent="0" marL="0">
               <a:lnSpc>
-                <a:spcPct val="114000"/>
+                <a:spcPct val="110000"/>
               </a:lnSpc>
               <a:spcAft>
-                <a:spcPts val="400"/>
+                <a:spcPts val="300"/>
               </a:spcAft>
               <a:buNone/>
             </a:pPr>
             <a:r>
-              <a:rPr lang="en-US" sz="1050" dirty="0">
+              <a:rPr lang="en-US" sz="980" dirty="0">
                 <a:solidFill>
                   <a:srgbClr val="1A1F26"/>
                 </a:solidFill>
@@ -7476,15 +7476,15 @@
             </a:r>
             <a:pPr indent="0" marL="0">
               <a:lnSpc>
-                <a:spcPct val="114000"/>
+                <a:spcPct val="110000"/>
               </a:lnSpc>
               <a:spcAft>
-                <a:spcPts val="400"/>
+                <a:spcPts val="300"/>
               </a:spcAft>
               <a:buNone/>
             </a:pPr>
             <a:r>
-              <a:rPr lang="en-US" sz="1050" dirty="0">
+              <a:rPr lang="en-US" sz="980" dirty="0">
                 <a:solidFill>
                   <a:srgbClr val="1A1F26"/>
                 </a:solidFill>
@@ -7494,7 +7494,7 @@
               </a:rPr>
               <a:t>eTeacher says a companion practice app and additional longevity courses are on the roadmap for the coming year, deepening the school's Israeli-built technology stack.</a:t>
             </a:r>
-            <a:endParaRPr lang="en-US" sz="1050" dirty="0"/>
+            <a:endParaRPr lang="en-US" sz="980" dirty="0"/>
           </a:p>
         </p:txBody>
       </p:sp>
@@ -7506,12 +7506,12 @@
         </p:nvSpPr>
         <p:spPr>
           <a:xfrm>
-            <a:off x="640080" y="4892040"/>
-            <a:ext cx="10911535" cy="1399032"/>
+            <a:off x="640080" y="5138928"/>
+            <a:ext cx="10911535" cy="1152144"/>
           </a:xfrm>
           <a:prstGeom prst="roundRect">
             <a:avLst>
-              <a:gd name="adj" fmla="val 3268"/>
+              <a:gd name="adj" fmla="val 3968"/>
             </a:avLst>
           </a:prstGeom>
           <a:solidFill>
@@ -7533,7 +7533,7 @@
         </p:nvSpPr>
         <p:spPr>
           <a:xfrm>
-            <a:off x="658368" y="4910328"/>
+            <a:off x="658368" y="5157216"/>
             <a:ext cx="10874959" cy="310896"/>
           </a:xfrm>
           <a:prstGeom prst="rect">
@@ -7553,7 +7553,7 @@
         </p:nvSpPr>
         <p:spPr>
           <a:xfrm>
-            <a:off x="841248" y="4910328"/>
+            <a:off x="841248" y="5157216"/>
             <a:ext cx="10509199" cy="310896"/>
           </a:xfrm>
           <a:prstGeom prst="rect">
@@ -7592,8 +7592,8 @@
         </p:nvSpPr>
         <p:spPr>
           <a:xfrm>
-            <a:off x="859536" y="5294376"/>
-            <a:ext cx="10472623" cy="466344"/>
+            <a:off x="859536" y="5541264"/>
+            <a:ext cx="10472623" cy="219456"/>
           </a:xfrm>
           <a:prstGeom prst="rect">
             <a:avLst/>
@@ -7961,7 +7961,7 @@
         <p:spPr>
           <a:xfrm>
             <a:off x="640080" y="2286000"/>
-            <a:ext cx="5486400" cy="2468880"/>
+            <a:ext cx="5486400" cy="2697480"/>
           </a:xfrm>
           <a:prstGeom prst="rect">
             <a:avLst/>
@@ -7975,15 +7975,15 @@
           <a:p>
             <a:pPr indent="0" marL="0">
               <a:lnSpc>
-                <a:spcPct val="114000"/>
+                <a:spcPct val="110000"/>
               </a:lnSpc>
               <a:spcAft>
-                <a:spcPts val="400"/>
+                <a:spcPts val="300"/>
               </a:spcAft>
               <a:buNone/>
             </a:pPr>
             <a:r>
-              <a:rPr lang="en-US" sz="1050" dirty="0">
+              <a:rPr lang="en-US" sz="980" dirty="0">
                 <a:solidFill>
                   <a:srgbClr val="1A1F26"/>
                 </a:solidFill>
@@ -7996,15 +7996,15 @@
             </a:r>
             <a:pPr indent="0" marL="0">
               <a:lnSpc>
-                <a:spcPct val="114000"/>
+                <a:spcPct val="110000"/>
               </a:lnSpc>
               <a:spcAft>
-                <a:spcPts val="400"/>
+                <a:spcPts val="300"/>
               </a:spcAft>
               <a:buNone/>
             </a:pPr>
             <a:r>
-              <a:rPr lang="en-US" sz="1050" dirty="0">
+              <a:rPr lang="en-US" sz="980" dirty="0">
                 <a:solidFill>
                   <a:srgbClr val="1A1F26"/>
                 </a:solidFill>
@@ -8017,15 +8017,15 @@
             </a:r>
             <a:pPr indent="0" marL="0">
               <a:lnSpc>
-                <a:spcPct val="114000"/>
+                <a:spcPct val="110000"/>
               </a:lnSpc>
               <a:spcAft>
-                <a:spcPts val="400"/>
+                <a:spcPts val="300"/>
               </a:spcAft>
               <a:buNone/>
             </a:pPr>
             <a:r>
-              <a:rPr lang="en-US" sz="1050" dirty="0">
+              <a:rPr lang="en-US" sz="980" dirty="0">
                 <a:solidFill>
                   <a:srgbClr val="1A1F26"/>
                 </a:solidFill>
@@ -8035,7 +8035,7 @@
               </a:rPr>
               <a:t>Instead of memorizing facts about glucose or sleep, students watch those numbers move in their own bodies. Every US student receives an Abbott Lingo continuous glucose monitor before Lesson 5, then builds a personal protocol across nutrition, movement, sleep, stress, and supplements — a plan meant to be kept for life, not for a 10-week challenge.</a:t>
             </a:r>
-            <a:endParaRPr lang="en-US" sz="1050" dirty="0"/>
+            <a:endParaRPr lang="en-US" sz="980" dirty="0"/>
           </a:p>
         </p:txBody>
       </p:sp>
@@ -8048,7 +8048,7 @@
         <p:spPr>
           <a:xfrm>
             <a:off x="6492240" y="2286000"/>
-            <a:ext cx="5486400" cy="2468880"/>
+            <a:ext cx="5486400" cy="2697480"/>
           </a:xfrm>
           <a:prstGeom prst="rect">
             <a:avLst/>
@@ -8062,15 +8062,15 @@
           <a:p>
             <a:pPr indent="0" marL="0">
               <a:lnSpc>
-                <a:spcPct val="114000"/>
+                <a:spcPct val="110000"/>
               </a:lnSpc>
               <a:spcAft>
-                <a:spcPts val="400"/>
+                <a:spcPts val="300"/>
               </a:spcAft>
               <a:buNone/>
             </a:pPr>
             <a:r>
-              <a:rPr lang="en-US" sz="1050" dirty="0">
+              <a:rPr lang="en-US" sz="980" dirty="0">
                 <a:solidFill>
                   <a:srgbClr val="1A1F26"/>
                 </a:solidFill>
@@ -8083,15 +8083,15 @@
             </a:r>
             <a:pPr indent="0" marL="0">
               <a:lnSpc>
-                <a:spcPct val="114000"/>
+                <a:spcPct val="110000"/>
               </a:lnSpc>
               <a:spcAft>
-                <a:spcPts val="400"/>
+                <a:spcPts val="300"/>
               </a:spcAft>
               <a:buNone/>
             </a:pPr>
             <a:r>
-              <a:rPr lang="en-US" sz="1050" dirty="0">
+              <a:rPr lang="en-US" sz="980" dirty="0">
                 <a:solidFill>
                   <a:srgbClr val="1A1F26"/>
                 </a:solidFill>
@@ -8104,15 +8104,15 @@
             </a:r>
             <a:pPr indent="0" marL="0">
               <a:lnSpc>
-                <a:spcPct val="114000"/>
+                <a:spcPct val="110000"/>
               </a:lnSpc>
               <a:spcAft>
-                <a:spcPts val="400"/>
+                <a:spcPts val="300"/>
               </a:spcAft>
               <a:buNone/>
             </a:pPr>
             <a:r>
-              <a:rPr lang="en-US" sz="1050" dirty="0">
+              <a:rPr lang="en-US" sz="980" dirty="0">
                 <a:solidFill>
                   <a:srgbClr val="1A1F26"/>
                 </a:solidFill>
@@ -8122,7 +8122,7 @@
               </a:rPr>
               <a:t>A companion practice app is on eTeacher's roadmap, intended to bring the same daily, low-pressure guidance into students' pockets.</a:t>
             </a:r>
-            <a:endParaRPr lang="en-US" sz="1050" dirty="0"/>
+            <a:endParaRPr lang="en-US" sz="980" dirty="0"/>
           </a:p>
         </p:txBody>
       </p:sp>
@@ -8134,12 +8134,12 @@
         </p:nvSpPr>
         <p:spPr>
           <a:xfrm>
-            <a:off x="640080" y="4892040"/>
-            <a:ext cx="10911535" cy="1399032"/>
+            <a:off x="640080" y="5138928"/>
+            <a:ext cx="10911535" cy="1152144"/>
           </a:xfrm>
           <a:prstGeom prst="roundRect">
             <a:avLst>
-              <a:gd name="adj" fmla="val 3268"/>
+              <a:gd name="adj" fmla="val 3968"/>
             </a:avLst>
           </a:prstGeom>
           <a:solidFill>
@@ -8161,7 +8161,7 @@
         </p:nvSpPr>
         <p:spPr>
           <a:xfrm>
-            <a:off x="658368" y="4910328"/>
+            <a:off x="658368" y="5157216"/>
             <a:ext cx="10874959" cy="310896"/>
           </a:xfrm>
           <a:prstGeom prst="rect">
@@ -8181,7 +8181,7 @@
         </p:nvSpPr>
         <p:spPr>
           <a:xfrm>
-            <a:off x="841248" y="4910328"/>
+            <a:off x="841248" y="5157216"/>
             <a:ext cx="10509199" cy="310896"/>
           </a:xfrm>
           <a:prstGeom prst="rect">
@@ -8220,8 +8220,8 @@
         </p:nvSpPr>
         <p:spPr>
           <a:xfrm>
-            <a:off x="859536" y="5294376"/>
-            <a:ext cx="10472623" cy="466344"/>
+            <a:off x="859536" y="5541264"/>
+            <a:ext cx="10472623" cy="219456"/>
           </a:xfrm>
           <a:prstGeom prst="rect">
             <a:avLst/>
@@ -8842,7 +8842,7 @@
         <p:spPr>
           <a:xfrm>
             <a:off x="640080" y="2286000"/>
-            <a:ext cx="5486400" cy="2468880"/>
+            <a:ext cx="5486400" cy="2697480"/>
           </a:xfrm>
           <a:prstGeom prst="rect">
             <a:avLst/>
@@ -8856,15 +8856,15 @@
           <a:p>
             <a:pPr indent="0" marL="0">
               <a:lnSpc>
-                <a:spcPct val="114000"/>
+                <a:spcPct val="110000"/>
               </a:lnSpc>
               <a:spcAft>
-                <a:spcPts val="400"/>
+                <a:spcPts val="300"/>
               </a:spcAft>
               <a:buNone/>
             </a:pPr>
             <a:r>
-              <a:rPr lang="en-US" sz="1050" dirty="0">
+              <a:rPr lang="en-US" sz="980" dirty="0">
                 <a:solidFill>
                   <a:srgbClr val="1A1F26"/>
                 </a:solidFill>
@@ -8877,15 +8877,15 @@
             </a:r>
             <a:pPr indent="0" marL="0">
               <a:lnSpc>
-                <a:spcPct val="114000"/>
+                <a:spcPct val="110000"/>
               </a:lnSpc>
               <a:spcAft>
-                <a:spcPts val="400"/>
+                <a:spcPts val="300"/>
               </a:spcAft>
               <a:buNone/>
             </a:pPr>
             <a:r>
-              <a:rPr lang="en-US" sz="1050" dirty="0">
+              <a:rPr lang="en-US" sz="980" dirty="0">
                 <a:solidFill>
                   <a:srgbClr val="1A1F26"/>
                 </a:solidFill>
@@ -8898,15 +8898,15 @@
             </a:r>
             <a:pPr indent="0" marL="0">
               <a:lnSpc>
-                <a:spcPct val="114000"/>
+                <a:spcPct val="110000"/>
               </a:lnSpc>
               <a:spcAft>
-                <a:spcPts val="400"/>
+                <a:spcPts val="300"/>
               </a:spcAft>
               <a:buNone/>
             </a:pPr>
             <a:r>
-              <a:rPr lang="en-US" sz="1050" dirty="0">
+              <a:rPr lang="en-US" sz="980" dirty="0">
                 <a:solidFill>
                   <a:srgbClr val="1A1F26"/>
                 </a:solidFill>
@@ -8919,15 +8919,15 @@
             </a:r>
             <a:pPr indent="0" marL="0">
               <a:lnSpc>
-                <a:spcPct val="114000"/>
+                <a:spcPct val="110000"/>
               </a:lnSpc>
               <a:spcAft>
-                <a:spcPts val="400"/>
+                <a:spcPts val="300"/>
               </a:spcAft>
               <a:buNone/>
             </a:pPr>
             <a:r>
-              <a:rPr lang="en-US" sz="1050" dirty="0">
+              <a:rPr lang="en-US" sz="980" dirty="0">
                 <a:solidFill>
                   <a:srgbClr val="1A1F26"/>
                 </a:solidFill>
@@ -8937,7 +8937,7 @@
               </a:rPr>
               <a:t>Her signing is a proof point for the school's core thesis — that elite outcomes come from consistent, science-backed habits, not spending — and gives eTeacher a nationally recognizable, relatable face for a US audience where 70% of its customers already live.</a:t>
             </a:r>
-            <a:endParaRPr lang="en-US" sz="1050" dirty="0"/>
+            <a:endParaRPr lang="en-US" sz="980" dirty="0"/>
           </a:p>
         </p:txBody>
       </p:sp>
@@ -8950,7 +8950,7 @@
         <p:spPr>
           <a:xfrm>
             <a:off x="6492240" y="2286000"/>
-            <a:ext cx="5486400" cy="2468880"/>
+            <a:ext cx="5486400" cy="2697480"/>
           </a:xfrm>
           <a:prstGeom prst="rect">
             <a:avLst/>
@@ -8964,15 +8964,15 @@
           <a:p>
             <a:pPr indent="0" marL="0">
               <a:lnSpc>
-                <a:spcPct val="114000"/>
+                <a:spcPct val="110000"/>
               </a:lnSpc>
               <a:spcAft>
-                <a:spcPts val="400"/>
+                <a:spcPts val="300"/>
               </a:spcAft>
               <a:buNone/>
             </a:pPr>
             <a:r>
-              <a:rPr lang="en-US" sz="1050" dirty="0">
+              <a:rPr lang="en-US" sz="980" dirty="0">
                 <a:solidFill>
                   <a:srgbClr val="1A1F26"/>
                 </a:solidFill>
@@ -8985,15 +8985,15 @@
             </a:r>
             <a:pPr indent="0" marL="0">
               <a:lnSpc>
-                <a:spcPct val="114000"/>
+                <a:spcPct val="110000"/>
               </a:lnSpc>
               <a:spcAft>
-                <a:spcPts val="400"/>
+                <a:spcPts val="300"/>
               </a:spcAft>
               <a:buNone/>
             </a:pPr>
             <a:r>
-              <a:rPr lang="en-US" sz="1050" dirty="0">
+              <a:rPr lang="en-US" sz="980" dirty="0">
                 <a:solidFill>
                   <a:srgbClr val="1A1F26"/>
                 </a:solidFill>
@@ -9003,7 +9003,7 @@
               </a:rPr>
               <a:t>“We measure ourselves by results, and Julie's results are impossible to argue with,” said eTeacher CEO Harel Tayeb. “She proved what we teach every day — that world-class health is built from consistent, learnable habits, not from a millionaire's budget. Having her teach it live is exactly the school we set out to build.” Gibson Clark begins teaching with the current enrollment cohort.</a:t>
             </a:r>
-            <a:endParaRPr lang="en-US" sz="1050" dirty="0"/>
+            <a:endParaRPr lang="en-US" sz="980" dirty="0"/>
           </a:p>
         </p:txBody>
       </p:sp>
@@ -9015,12 +9015,12 @@
         </p:nvSpPr>
         <p:spPr>
           <a:xfrm>
-            <a:off x="640080" y="4892040"/>
-            <a:ext cx="5318608" cy="1399032"/>
+            <a:off x="640080" y="5138928"/>
+            <a:ext cx="5318608" cy="1152144"/>
           </a:xfrm>
           <a:prstGeom prst="roundRect">
             <a:avLst>
-              <a:gd name="adj" fmla="val 3268"/>
+              <a:gd name="adj" fmla="val 3968"/>
             </a:avLst>
           </a:prstGeom>
           <a:solidFill>
@@ -9042,7 +9042,7 @@
         </p:nvSpPr>
         <p:spPr>
           <a:xfrm>
-            <a:off x="658368" y="4910328"/>
+            <a:off x="658368" y="5157216"/>
             <a:ext cx="5282032" cy="310896"/>
           </a:xfrm>
           <a:prstGeom prst="rect">
@@ -9062,7 +9062,7 @@
         </p:nvSpPr>
         <p:spPr>
           <a:xfrm>
-            <a:off x="841248" y="4910328"/>
+            <a:off x="841248" y="5157216"/>
             <a:ext cx="4916272" cy="310896"/>
           </a:xfrm>
           <a:prstGeom prst="rect">
@@ -9101,8 +9101,8 @@
         </p:nvSpPr>
         <p:spPr>
           <a:xfrm>
-            <a:off x="859536" y="5294376"/>
-            <a:ext cx="4879696" cy="466344"/>
+            <a:off x="859536" y="5541264"/>
+            <a:ext cx="4879696" cy="219456"/>
           </a:xfrm>
           <a:prstGeom prst="rect">
             <a:avLst/>
@@ -9185,12 +9185,12 @@
         </p:nvSpPr>
         <p:spPr>
           <a:xfrm>
-            <a:off x="6233008" y="4892040"/>
-            <a:ext cx="5318608" cy="1399032"/>
+            <a:off x="6233008" y="5138928"/>
+            <a:ext cx="5318608" cy="1152144"/>
           </a:xfrm>
           <a:prstGeom prst="roundRect">
             <a:avLst>
-              <a:gd name="adj" fmla="val 3268"/>
+              <a:gd name="adj" fmla="val 3968"/>
             </a:avLst>
           </a:prstGeom>
           <a:solidFill>
@@ -9212,8 +9212,8 @@
         </p:nvSpPr>
         <p:spPr>
           <a:xfrm>
-            <a:off x="6233008" y="4946904"/>
-            <a:ext cx="73152" cy="1289304"/>
+            <a:off x="6233008" y="5193792"/>
+            <a:ext cx="73152" cy="1042416"/>
           </a:xfrm>
           <a:prstGeom prst="rect">
             <a:avLst/>
@@ -9232,7 +9232,7 @@
         </p:nvSpPr>
         <p:spPr>
           <a:xfrm>
-            <a:off x="6452464" y="4965192"/>
+            <a:off x="6452464" y="5212080"/>
             <a:ext cx="4916272" cy="201168"/>
           </a:xfrm>
           <a:prstGeom prst="rect">
@@ -9271,8 +9271,8 @@
         </p:nvSpPr>
         <p:spPr>
           <a:xfrm>
-            <a:off x="6452464" y="5166360"/>
-            <a:ext cx="4916272" cy="649224"/>
+            <a:off x="6452464" y="5413248"/>
+            <a:ext cx="4916272" cy="402336"/>
           </a:xfrm>
           <a:prstGeom prst="rect">
             <a:avLst/>
@@ -9640,7 +9640,7 @@
         <p:spPr>
           <a:xfrm>
             <a:off x="640080" y="2286000"/>
-            <a:ext cx="5486400" cy="2468880"/>
+            <a:ext cx="5486400" cy="2697480"/>
           </a:xfrm>
           <a:prstGeom prst="rect">
             <a:avLst/>
@@ -9654,15 +9654,15 @@
           <a:p>
             <a:pPr indent="0" marL="0">
               <a:lnSpc>
-                <a:spcPct val="114000"/>
+                <a:spcPct val="110000"/>
               </a:lnSpc>
               <a:spcAft>
-                <a:spcPts val="400"/>
+                <a:spcPts val="300"/>
               </a:spcAft>
               <a:buNone/>
             </a:pPr>
             <a:r>
-              <a:rPr lang="en-US" sz="1050" dirty="0">
+              <a:rPr lang="en-US" sz="980" dirty="0">
                 <a:solidFill>
                   <a:srgbClr val="1A1F26"/>
                 </a:solidFill>
@@ -9675,15 +9675,15 @@
             </a:r>
             <a:pPr indent="0" marL="0">
               <a:lnSpc>
-                <a:spcPct val="114000"/>
+                <a:spcPct val="110000"/>
               </a:lnSpc>
               <a:spcAft>
-                <a:spcPts val="400"/>
+                <a:spcPts val="300"/>
               </a:spcAft>
               <a:buNone/>
             </a:pPr>
             <a:r>
-              <a:rPr lang="en-US" sz="1050" dirty="0">
+              <a:rPr lang="en-US" sz="980" dirty="0">
                 <a:solidFill>
                   <a:srgbClr val="1A1F26"/>
                 </a:solidFill>
@@ -9696,15 +9696,15 @@
             </a:r>
             <a:pPr indent="0" marL="0">
               <a:lnSpc>
-                <a:spcPct val="114000"/>
+                <a:spcPct val="110000"/>
               </a:lnSpc>
               <a:spcAft>
-                <a:spcPts val="400"/>
+                <a:spcPts val="300"/>
               </a:spcAft>
               <a:buNone/>
             </a:pPr>
             <a:r>
-              <a:rPr lang="en-US" sz="1050" dirty="0">
+              <a:rPr lang="en-US" sz="980" dirty="0">
                 <a:solidFill>
                   <a:srgbClr val="1A1F26"/>
                 </a:solidFill>
@@ -9714,7 +9714,7 @@
               </a:rPr>
               <a:t>Now that philosophy has an institution behind it. As a Longevity Life Academy instructor, Gibson Clark brings her low-cost, high-consistency method into eTeacher's live cohorts of 8–15, where The Longevity Blueprint starts at $289 per month and includes an Abbott Lingo glucose monitor shipped to every US student.</a:t>
             </a:r>
-            <a:endParaRPr lang="en-US" sz="1050" dirty="0"/>
+            <a:endParaRPr lang="en-US" sz="980" dirty="0"/>
           </a:p>
         </p:txBody>
       </p:sp>
@@ -9727,7 +9727,7 @@
         <p:spPr>
           <a:xfrm>
             <a:off x="6492240" y="2286000"/>
-            <a:ext cx="5486400" cy="2468880"/>
+            <a:ext cx="5486400" cy="2697480"/>
           </a:xfrm>
           <a:prstGeom prst="rect">
             <a:avLst/>
@@ -9741,15 +9741,15 @@
           <a:p>
             <a:pPr indent="0" marL="0">
               <a:lnSpc>
-                <a:spcPct val="114000"/>
+                <a:spcPct val="110000"/>
               </a:lnSpc>
               <a:spcAft>
-                <a:spcPts val="400"/>
+                <a:spcPts val="300"/>
               </a:spcAft>
               <a:buNone/>
             </a:pPr>
             <a:r>
-              <a:rPr lang="en-US" sz="1050" dirty="0">
+              <a:rPr lang="en-US" sz="980" dirty="0">
                 <a:solidFill>
                   <a:srgbClr val="1A1F26"/>
                 </a:solidFill>
@@ -9762,15 +9762,15 @@
             </a:r>
             <a:pPr indent="0" marL="0">
               <a:lnSpc>
-                <a:spcPct val="114000"/>
+                <a:spcPct val="110000"/>
               </a:lnSpc>
               <a:spcAft>
-                <a:spcPts val="400"/>
+                <a:spcPts val="300"/>
               </a:spcAft>
               <a:buNone/>
             </a:pPr>
             <a:r>
-              <a:rPr lang="en-US" sz="1050" dirty="0">
+              <a:rPr lang="en-US" sz="980" dirty="0">
                 <a:solidFill>
                   <a:srgbClr val="1A1F26"/>
                 </a:solidFill>
@@ -9783,15 +9783,15 @@
             </a:r>
             <a:pPr indent="0" marL="0">
               <a:lnSpc>
-                <a:spcPct val="114000"/>
+                <a:spcPct val="110000"/>
               </a:lnSpc>
               <a:spcAft>
-                <a:spcPts val="400"/>
+                <a:spcPts val="300"/>
               </a:spcAft>
               <a:buNone/>
             </a:pPr>
             <a:r>
-              <a:rPr lang="en-US" sz="1050" dirty="0">
+              <a:rPr lang="en-US" sz="980" dirty="0">
                 <a:solidFill>
                   <a:srgbClr val="1A1F26"/>
                 </a:solidFill>
@@ -9801,7 +9801,7 @@
               </a:rPr>
               <a:t>“A twelve-dollar-a-day routine that outperforms a two-million-dollar one is the whole thesis of our school in a single fact,” said CEO Harel Tayeb. “We don't sell shortcuts. We teach the fundamentals, in a room with a real instructor, until they become who you are.”</a:t>
             </a:r>
-            <a:endParaRPr lang="en-US" sz="1050" dirty="0"/>
+            <a:endParaRPr lang="en-US" sz="980" dirty="0"/>
           </a:p>
         </p:txBody>
       </p:sp>
@@ -9813,12 +9813,12 @@
         </p:nvSpPr>
         <p:spPr>
           <a:xfrm>
-            <a:off x="640080" y="4892040"/>
-            <a:ext cx="5318608" cy="1399032"/>
+            <a:off x="640080" y="5138928"/>
+            <a:ext cx="5318608" cy="1152144"/>
           </a:xfrm>
           <a:prstGeom prst="roundRect">
             <a:avLst>
-              <a:gd name="adj" fmla="val 3268"/>
+              <a:gd name="adj" fmla="val 3968"/>
             </a:avLst>
           </a:prstGeom>
           <a:solidFill>
@@ -9840,7 +9840,7 @@
         </p:nvSpPr>
         <p:spPr>
           <a:xfrm>
-            <a:off x="658368" y="4910328"/>
+            <a:off x="658368" y="5157216"/>
             <a:ext cx="5282032" cy="310896"/>
           </a:xfrm>
           <a:prstGeom prst="rect">
@@ -9860,7 +9860,7 @@
         </p:nvSpPr>
         <p:spPr>
           <a:xfrm>
-            <a:off x="841248" y="4910328"/>
+            <a:off x="841248" y="5157216"/>
             <a:ext cx="4916272" cy="310896"/>
           </a:xfrm>
           <a:prstGeom prst="rect">
@@ -9899,8 +9899,8 @@
         </p:nvSpPr>
         <p:spPr>
           <a:xfrm>
-            <a:off x="859536" y="5294376"/>
-            <a:ext cx="4879696" cy="466344"/>
+            <a:off x="859536" y="5541264"/>
+            <a:ext cx="4879696" cy="219456"/>
           </a:xfrm>
           <a:prstGeom prst="rect">
             <a:avLst/>
@@ -9983,12 +9983,12 @@
         </p:nvSpPr>
         <p:spPr>
           <a:xfrm>
-            <a:off x="6233008" y="4892040"/>
-            <a:ext cx="5318608" cy="1399032"/>
+            <a:off x="6233008" y="5138928"/>
+            <a:ext cx="5318608" cy="1152144"/>
           </a:xfrm>
           <a:prstGeom prst="roundRect">
             <a:avLst>
-              <a:gd name="adj" fmla="val 3268"/>
+              <a:gd name="adj" fmla="val 3968"/>
             </a:avLst>
           </a:prstGeom>
           <a:solidFill>
@@ -10010,8 +10010,8 @@
         </p:nvSpPr>
         <p:spPr>
           <a:xfrm>
-            <a:off x="6233008" y="4946904"/>
-            <a:ext cx="73152" cy="1289304"/>
+            <a:off x="6233008" y="5193792"/>
+            <a:ext cx="73152" cy="1042416"/>
           </a:xfrm>
           <a:prstGeom prst="rect">
             <a:avLst/>
@@ -10030,7 +10030,7 @@
         </p:nvSpPr>
         <p:spPr>
           <a:xfrm>
-            <a:off x="6452464" y="4965192"/>
+            <a:off x="6452464" y="5212080"/>
             <a:ext cx="4916272" cy="201168"/>
           </a:xfrm>
           <a:prstGeom prst="rect">
@@ -10069,8 +10069,8 @@
         </p:nvSpPr>
         <p:spPr>
           <a:xfrm>
-            <a:off x="6452464" y="5166360"/>
-            <a:ext cx="4916272" cy="649224"/>
+            <a:off x="6452464" y="5413248"/>
+            <a:ext cx="4916272" cy="402336"/>
           </a:xfrm>
           <a:prstGeom prst="rect">
             <a:avLst/>
@@ -11811,7 +11811,7 @@
         <p:spPr>
           <a:xfrm>
             <a:off x="640080" y="2286000"/>
-            <a:ext cx="5486400" cy="2468880"/>
+            <a:ext cx="5486400" cy="2697480"/>
           </a:xfrm>
           <a:prstGeom prst="rect">
             <a:avLst/>
@@ -11825,15 +11825,15 @@
           <a:p>
             <a:pPr indent="0" marL="0">
               <a:lnSpc>
-                <a:spcPct val="114000"/>
+                <a:spcPct val="110000"/>
               </a:lnSpc>
               <a:spcAft>
-                <a:spcPts val="400"/>
+                <a:spcPts val="300"/>
               </a:spcAft>
               <a:buNone/>
             </a:pPr>
             <a:r>
-              <a:rPr lang="en-US" sz="1050" dirty="0">
+              <a:rPr lang="en-US" sz="980" dirty="0">
                 <a:solidFill>
                   <a:srgbClr val="1A1F26"/>
                 </a:solidFill>
@@ -11846,15 +11846,15 @@
             </a:r>
             <a:pPr indent="0" marL="0">
               <a:lnSpc>
-                <a:spcPct val="114000"/>
+                <a:spcPct val="110000"/>
               </a:lnSpc>
               <a:spcAft>
-                <a:spcPts val="400"/>
+                <a:spcPts val="300"/>
               </a:spcAft>
               <a:buNone/>
             </a:pPr>
             <a:r>
-              <a:rPr lang="en-US" sz="1050" dirty="0">
+              <a:rPr lang="en-US" sz="980" dirty="0">
                 <a:solidFill>
                   <a:srgbClr val="1A1F26"/>
                 </a:solidFill>
@@ -11867,15 +11867,15 @@
             </a:r>
             <a:pPr indent="0" marL="0">
               <a:lnSpc>
-                <a:spcPct val="114000"/>
+                <a:spcPct val="110000"/>
               </a:lnSpc>
               <a:spcAft>
-                <a:spcPts val="400"/>
+                <a:spcPts val="300"/>
               </a:spcAft>
               <a:buNone/>
             </a:pPr>
             <a:r>
-              <a:rPr lang="en-US" sz="1050" dirty="0">
+              <a:rPr lang="en-US" sz="980" dirty="0">
                 <a:solidFill>
                   <a:srgbClr val="1A1F26"/>
                 </a:solidFill>
@@ -11885,7 +11885,7 @@
               </a:rPr>
               <a:t>At Longevity Life Academy, that same philosophy anchors her live teaching: start with your why, then build one sustainable habit at a time until it sticks. She'll lead small cohorts of 8–15 through the 18-week Longevity Blueprint, each student working from their own glucose and wearable data.</a:t>
             </a:r>
-            <a:endParaRPr lang="en-US" sz="1050" dirty="0"/>
+            <a:endParaRPr lang="en-US" sz="980" dirty="0"/>
           </a:p>
         </p:txBody>
       </p:sp>
@@ -11898,7 +11898,7 @@
         <p:spPr>
           <a:xfrm>
             <a:off x="6492240" y="2286000"/>
-            <a:ext cx="5486400" cy="2468880"/>
+            <a:ext cx="5486400" cy="2697480"/>
           </a:xfrm>
           <a:prstGeom prst="rect">
             <a:avLst/>
@@ -11912,15 +11912,15 @@
           <a:p>
             <a:pPr indent="0" marL="0">
               <a:lnSpc>
-                <a:spcPct val="114000"/>
+                <a:spcPct val="110000"/>
               </a:lnSpc>
               <a:spcAft>
-                <a:spcPts val="400"/>
+                <a:spcPts val="300"/>
               </a:spcAft>
               <a:buNone/>
             </a:pPr>
             <a:r>
-              <a:rPr lang="en-US" sz="1050" dirty="0">
+              <a:rPr lang="en-US" sz="980" dirty="0">
                 <a:solidFill>
                   <a:srgbClr val="1A1F26"/>
                 </a:solidFill>
@@ -11933,15 +11933,15 @@
             </a:r>
             <a:pPr indent="0" marL="0">
               <a:lnSpc>
-                <a:spcPct val="114000"/>
+                <a:spcPct val="110000"/>
               </a:lnSpc>
               <a:spcAft>
-                <a:spcPts val="400"/>
+                <a:spcPts val="300"/>
               </a:spcAft>
               <a:buNone/>
             </a:pPr>
             <a:r>
-              <a:rPr lang="en-US" sz="1050" dirty="0">
+              <a:rPr lang="en-US" sz="980" dirty="0">
                 <a:solidFill>
                   <a:srgbClr val="1A1F26"/>
                 </a:solidFill>
@@ -11954,15 +11954,15 @@
             </a:r>
             <a:pPr indent="0" marL="0">
               <a:lnSpc>
-                <a:spcPct val="114000"/>
+                <a:spcPct val="110000"/>
               </a:lnSpc>
               <a:spcAft>
-                <a:spcPts val="400"/>
+                <a:spcPts val="300"/>
               </a:spcAft>
               <a:buNone/>
             </a:pPr>
             <a:r>
-              <a:rPr lang="en-US" sz="1050" dirty="0">
+              <a:rPr lang="en-US" sz="980" dirty="0">
                 <a:solidFill>
                   <a:srgbClr val="1A1F26"/>
                 </a:solidFill>
@@ -11972,7 +11972,7 @@
               </a:rPr>
               <a:t>“The best learning always starts with a personal reason, not a number on a chart,” added CEO Harel Tayeb. “Julie begins with why someone wants more years — then teaches the how. That is precisely why she will reach people a leaderboard never could.”</a:t>
             </a:r>
-            <a:endParaRPr lang="en-US" sz="1050" dirty="0"/>
+            <a:endParaRPr lang="en-US" sz="980" dirty="0"/>
           </a:p>
         </p:txBody>
       </p:sp>
@@ -11984,12 +11984,12 @@
         </p:nvSpPr>
         <p:spPr>
           <a:xfrm>
-            <a:off x="640080" y="4892040"/>
-            <a:ext cx="5318608" cy="1399032"/>
+            <a:off x="640080" y="5138928"/>
+            <a:ext cx="5318608" cy="1152144"/>
           </a:xfrm>
           <a:prstGeom prst="roundRect">
             <a:avLst>
-              <a:gd name="adj" fmla="val 3268"/>
+              <a:gd name="adj" fmla="val 3968"/>
             </a:avLst>
           </a:prstGeom>
           <a:solidFill>
@@ -12011,7 +12011,7 @@
         </p:nvSpPr>
         <p:spPr>
           <a:xfrm>
-            <a:off x="658368" y="4910328"/>
+            <a:off x="658368" y="5157216"/>
             <a:ext cx="5282032" cy="310896"/>
           </a:xfrm>
           <a:prstGeom prst="rect">
@@ -12031,7 +12031,7 @@
         </p:nvSpPr>
         <p:spPr>
           <a:xfrm>
-            <a:off x="841248" y="4910328"/>
+            <a:off x="841248" y="5157216"/>
             <a:ext cx="4916272" cy="310896"/>
           </a:xfrm>
           <a:prstGeom prst="rect">
@@ -12070,8 +12070,8 @@
         </p:nvSpPr>
         <p:spPr>
           <a:xfrm>
-            <a:off x="859536" y="5294376"/>
-            <a:ext cx="4879696" cy="466344"/>
+            <a:off x="859536" y="5541264"/>
+            <a:ext cx="4879696" cy="219456"/>
           </a:xfrm>
           <a:prstGeom prst="rect">
             <a:avLst/>
@@ -12154,12 +12154,12 @@
         </p:nvSpPr>
         <p:spPr>
           <a:xfrm>
-            <a:off x="6233008" y="4892040"/>
-            <a:ext cx="5318608" cy="1399032"/>
+            <a:off x="6233008" y="5138928"/>
+            <a:ext cx="5318608" cy="1152144"/>
           </a:xfrm>
           <a:prstGeom prst="roundRect">
             <a:avLst>
-              <a:gd name="adj" fmla="val 3268"/>
+              <a:gd name="adj" fmla="val 3968"/>
             </a:avLst>
           </a:prstGeom>
           <a:solidFill>
@@ -12181,8 +12181,8 @@
         </p:nvSpPr>
         <p:spPr>
           <a:xfrm>
-            <a:off x="6233008" y="4946904"/>
-            <a:ext cx="73152" cy="1289304"/>
+            <a:off x="6233008" y="5193792"/>
+            <a:ext cx="73152" cy="1042416"/>
           </a:xfrm>
           <a:prstGeom prst="rect">
             <a:avLst/>
@@ -12201,7 +12201,7 @@
         </p:nvSpPr>
         <p:spPr>
           <a:xfrm>
-            <a:off x="6452464" y="4965192"/>
+            <a:off x="6452464" y="5212080"/>
             <a:ext cx="4916272" cy="201168"/>
           </a:xfrm>
           <a:prstGeom prst="rect">
@@ -12240,8 +12240,8 @@
         </p:nvSpPr>
         <p:spPr>
           <a:xfrm>
-            <a:off x="6452464" y="5166360"/>
-            <a:ext cx="4916272" cy="649224"/>
+            <a:off x="6452464" y="5413248"/>
+            <a:ext cx="4916272" cy="402336"/>
           </a:xfrm>
           <a:prstGeom prst="rect">
             <a:avLst/>
@@ -12609,7 +12609,7 @@
         <p:spPr>
           <a:xfrm>
             <a:off x="640080" y="2286000"/>
-            <a:ext cx="5486400" cy="2468880"/>
+            <a:ext cx="5486400" cy="2697480"/>
           </a:xfrm>
           <a:prstGeom prst="rect">
             <a:avLst/>
@@ -12623,15 +12623,15 @@
           <a:p>
             <a:pPr indent="0" marL="0">
               <a:lnSpc>
-                <a:spcPct val="114000"/>
+                <a:spcPct val="110000"/>
               </a:lnSpc>
               <a:spcAft>
-                <a:spcPts val="400"/>
+                <a:spcPts val="300"/>
               </a:spcAft>
               <a:buNone/>
             </a:pPr>
             <a:r>
-              <a:rPr lang="en-US" sz="1050" dirty="0">
+              <a:rPr lang="en-US" sz="980" dirty="0">
                 <a:solidFill>
                   <a:srgbClr val="1A1F26"/>
                 </a:solidFill>
@@ -12644,15 +12644,15 @@
             </a:r>
             <a:pPr indent="0" marL="0">
               <a:lnSpc>
-                <a:spcPct val="114000"/>
+                <a:spcPct val="110000"/>
               </a:lnSpc>
               <a:spcAft>
-                <a:spcPts val="400"/>
+                <a:spcPts val="300"/>
               </a:spcAft>
               <a:buNone/>
             </a:pPr>
             <a:r>
-              <a:rPr lang="en-US" sz="1050" dirty="0">
+              <a:rPr lang="en-US" sz="980" dirty="0">
                 <a:solidFill>
                   <a:srgbClr val="1A1F26"/>
                 </a:solidFill>
@@ -12665,15 +12665,15 @@
             </a:r>
             <a:pPr indent="0" marL="0">
               <a:lnSpc>
-                <a:spcPct val="114000"/>
+                <a:spcPct val="110000"/>
               </a:lnSpc>
               <a:spcAft>
-                <a:spcPts val="400"/>
+                <a:spcPts val="300"/>
               </a:spcAft>
               <a:buNone/>
             </a:pPr>
             <a:r>
-              <a:rPr lang="en-US" sz="1050" dirty="0">
+              <a:rPr lang="en-US" sz="980" dirty="0">
                 <a:solidFill>
                   <a:srgbClr val="1A1F26"/>
                 </a:solidFill>
@@ -12683,7 +12683,7 @@
               </a:rPr>
               <a:t>That evidence-based, data-driven approach maps directly onto LLA's method, which puts an Abbott Lingo continuous glucose monitor in every student's hands before Lesson 5 and teaches them to read glucose, HRV, and sleep as a live feedback loop across the six pillars.</a:t>
             </a:r>
-            <a:endParaRPr lang="en-US" sz="1050" dirty="0"/>
+            <a:endParaRPr lang="en-US" sz="980" dirty="0"/>
           </a:p>
         </p:txBody>
       </p:sp>
@@ -12696,7 +12696,7 @@
         <p:spPr>
           <a:xfrm>
             <a:off x="6492240" y="2286000"/>
-            <a:ext cx="5486400" cy="2468880"/>
+            <a:ext cx="5486400" cy="2697480"/>
           </a:xfrm>
           <a:prstGeom prst="rect">
             <a:avLst/>
@@ -12710,15 +12710,15 @@
           <a:p>
             <a:pPr indent="0" marL="0">
               <a:lnSpc>
-                <a:spcPct val="114000"/>
+                <a:spcPct val="110000"/>
               </a:lnSpc>
               <a:spcAft>
-                <a:spcPts val="400"/>
+                <a:spcPts val="300"/>
               </a:spcAft>
               <a:buNone/>
             </a:pPr>
             <a:r>
-              <a:rPr lang="en-US" sz="1050" dirty="0">
+              <a:rPr lang="en-US" sz="980" dirty="0">
                 <a:solidFill>
                   <a:srgbClr val="1A1F26"/>
                 </a:solidFill>
@@ -12731,15 +12731,15 @@
             </a:r>
             <a:pPr indent="0" marL="0">
               <a:lnSpc>
-                <a:spcPct val="114000"/>
+                <a:spcPct val="110000"/>
               </a:lnSpc>
               <a:spcAft>
-                <a:spcPts val="400"/>
+                <a:spcPts val="300"/>
               </a:spcAft>
               <a:buNone/>
             </a:pPr>
             <a:r>
-              <a:rPr lang="en-US" sz="1050" dirty="0">
+              <a:rPr lang="en-US" sz="980" dirty="0">
                 <a:solidFill>
                   <a:srgbClr val="1A1F26"/>
                 </a:solidFill>
@@ -12752,15 +12752,15 @@
             </a:r>
             <a:pPr indent="0" marL="0">
               <a:lnSpc>
-                <a:spcPct val="114000"/>
+                <a:spcPct val="110000"/>
               </a:lnSpc>
               <a:spcAft>
-                <a:spcPts val="400"/>
+                <a:spcPts val="300"/>
               </a:spcAft>
               <a:buNone/>
             </a:pPr>
             <a:r>
-              <a:rPr lang="en-US" sz="1050" dirty="0">
+              <a:rPr lang="en-US" sz="980" dirty="0">
                 <a:solidFill>
                   <a:srgbClr val="1A1F26"/>
                 </a:solidFill>
@@ -12770,7 +12770,7 @@
               </a:rPr>
               <a:t>eTeacher says a dedicated Biomarkers &amp; Advanced Wearables course is on its roadmap, extending the data-first teaching Gibson Clark exemplifies.</a:t>
             </a:r>
-            <a:endParaRPr lang="en-US" sz="1050" dirty="0"/>
+            <a:endParaRPr lang="en-US" sz="980" dirty="0"/>
           </a:p>
         </p:txBody>
       </p:sp>
@@ -12782,12 +12782,12 @@
         </p:nvSpPr>
         <p:spPr>
           <a:xfrm>
-            <a:off x="640080" y="4892040"/>
-            <a:ext cx="10911535" cy="1399032"/>
+            <a:off x="640080" y="5138928"/>
+            <a:ext cx="10911535" cy="1152144"/>
           </a:xfrm>
           <a:prstGeom prst="roundRect">
             <a:avLst>
-              <a:gd name="adj" fmla="val 3268"/>
+              <a:gd name="adj" fmla="val 3968"/>
             </a:avLst>
           </a:prstGeom>
           <a:solidFill>
@@ -12809,8 +12809,8 @@
         </p:nvSpPr>
         <p:spPr>
           <a:xfrm>
-            <a:off x="640080" y="4946904"/>
-            <a:ext cx="73152" cy="1289304"/>
+            <a:off x="640080" y="5193792"/>
+            <a:ext cx="73152" cy="1042416"/>
           </a:xfrm>
           <a:prstGeom prst="rect">
             <a:avLst/>
@@ -12829,7 +12829,7 @@
         </p:nvSpPr>
         <p:spPr>
           <a:xfrm>
-            <a:off x="859536" y="4965192"/>
+            <a:off x="859536" y="5212080"/>
             <a:ext cx="10509199" cy="201168"/>
           </a:xfrm>
           <a:prstGeom prst="rect">
@@ -12868,8 +12868,8 @@
         </p:nvSpPr>
         <p:spPr>
           <a:xfrm>
-            <a:off x="859536" y="5166360"/>
-            <a:ext cx="10509199" cy="649224"/>
+            <a:off x="859536" y="5413248"/>
+            <a:ext cx="10509199" cy="402336"/>
           </a:xfrm>
           <a:prstGeom prst="rect">
             <a:avLst/>
@@ -13237,7 +13237,7 @@
         <p:spPr>
           <a:xfrm>
             <a:off x="640080" y="2286000"/>
-            <a:ext cx="5486400" cy="2468880"/>
+            <a:ext cx="5486400" cy="2697480"/>
           </a:xfrm>
           <a:prstGeom prst="rect">
             <a:avLst/>
@@ -13251,15 +13251,15 @@
           <a:p>
             <a:pPr indent="0" marL="0">
               <a:lnSpc>
-                <a:spcPct val="114000"/>
+                <a:spcPct val="110000"/>
               </a:lnSpc>
               <a:spcAft>
-                <a:spcPts val="400"/>
+                <a:spcPts val="300"/>
               </a:spcAft>
               <a:buNone/>
             </a:pPr>
             <a:r>
-              <a:rPr lang="en-US" sz="1050" dirty="0">
+              <a:rPr lang="en-US" sz="980" dirty="0">
                 <a:solidFill>
                   <a:srgbClr val="1A1F26"/>
                 </a:solidFill>
@@ -13272,15 +13272,15 @@
             </a:r>
             <a:pPr indent="0" marL="0">
               <a:lnSpc>
-                <a:spcPct val="114000"/>
+                <a:spcPct val="110000"/>
               </a:lnSpc>
               <a:spcAft>
-                <a:spcPts val="400"/>
+                <a:spcPts val="300"/>
               </a:spcAft>
               <a:buNone/>
             </a:pPr>
             <a:r>
-              <a:rPr lang="en-US" sz="1050" dirty="0">
+              <a:rPr lang="en-US" sz="980" dirty="0">
                 <a:solidFill>
                   <a:srgbClr val="1A1F26"/>
                 </a:solidFill>
@@ -13293,15 +13293,15 @@
             </a:r>
             <a:pPr indent="0" marL="0">
               <a:lnSpc>
-                <a:spcPct val="114000"/>
+                <a:spcPct val="110000"/>
               </a:lnSpc>
               <a:spcAft>
-                <a:spcPts val="400"/>
+                <a:spcPts val="300"/>
               </a:spcAft>
               <a:buNone/>
             </a:pPr>
             <a:r>
-              <a:rPr lang="en-US" sz="1050" dirty="0">
+              <a:rPr lang="en-US" sz="980" dirty="0">
                 <a:solidFill>
                   <a:srgbClr val="1A1F26"/>
                 </a:solidFill>
@@ -13311,7 +13311,7 @@
               </a:rPr>
               <a:t>LLA operationalizes that counterexample. By combining a relatable, low-cost instructor with a proven live-education model — small cohorts of 8–15, an included Abbott Lingo glucose monitor, tuition from $289 a month — it aims to make personalized longevity available to mainstream American families.</a:t>
             </a:r>
-            <a:endParaRPr lang="en-US" sz="1050" dirty="0"/>
+            <a:endParaRPr lang="en-US" sz="980" dirty="0"/>
           </a:p>
         </p:txBody>
       </p:sp>
@@ -13324,7 +13324,7 @@
         <p:spPr>
           <a:xfrm>
             <a:off x="6492240" y="2286000"/>
-            <a:ext cx="5486400" cy="2468880"/>
+            <a:ext cx="5486400" cy="2697480"/>
           </a:xfrm>
           <a:prstGeom prst="rect">
             <a:avLst/>
@@ -13338,15 +13338,15 @@
           <a:p>
             <a:pPr indent="0" marL="0">
               <a:lnSpc>
-                <a:spcPct val="114000"/>
+                <a:spcPct val="110000"/>
               </a:lnSpc>
               <a:spcAft>
-                <a:spcPts val="400"/>
+                <a:spcPts val="300"/>
               </a:spcAft>
               <a:buNone/>
             </a:pPr>
             <a:r>
-              <a:rPr lang="en-US" sz="1050" dirty="0">
+              <a:rPr lang="en-US" sz="980" dirty="0">
                 <a:solidFill>
                   <a:srgbClr val="1A1F26"/>
                 </a:solidFill>
@@ -13359,15 +13359,15 @@
             </a:r>
             <a:pPr indent="0" marL="0">
               <a:lnSpc>
-                <a:spcPct val="114000"/>
+                <a:spcPct val="110000"/>
               </a:lnSpc>
               <a:spcAft>
-                <a:spcPts val="400"/>
+                <a:spcPts val="300"/>
               </a:spcAft>
               <a:buNone/>
             </a:pPr>
             <a:r>
-              <a:rPr lang="en-US" sz="1050" dirty="0">
+              <a:rPr lang="en-US" sz="980" dirty="0">
                 <a:solidFill>
                   <a:srgbClr val="1A1F26"/>
                 </a:solidFill>
@@ -13380,15 +13380,15 @@
             </a:r>
             <a:pPr indent="0" marL="0">
               <a:lnSpc>
-                <a:spcPct val="114000"/>
+                <a:spcPct val="110000"/>
               </a:lnSpc>
               <a:spcAft>
-                <a:spcPts val="400"/>
+                <a:spcPts val="300"/>
               </a:spcAft>
               <a:buNone/>
             </a:pPr>
             <a:r>
-              <a:rPr lang="en-US" sz="1050" dirty="0">
+              <a:rPr lang="en-US" sz="980" dirty="0">
                 <a:solidFill>
                   <a:srgbClr val="1A1F26"/>
                 </a:solidFill>
@@ -13398,7 +13398,7 @@
               </a:rPr>
               <a:t>“We want to teach with meaning — content that reaches the human core of a person, not just their calendar,” added CEO Harel Tayeb. “Julie gives that mission a face: real, humble, and living proof that a longer, healthier life is within reach for anyone willing to practice it.”</a:t>
             </a:r>
-            <a:endParaRPr lang="en-US" sz="1050" dirty="0"/>
+            <a:endParaRPr lang="en-US" sz="980" dirty="0"/>
           </a:p>
         </p:txBody>
       </p:sp>
@@ -13410,12 +13410,12 @@
         </p:nvSpPr>
         <p:spPr>
           <a:xfrm>
-            <a:off x="640080" y="4892040"/>
-            <a:ext cx="5318608" cy="1399032"/>
+            <a:off x="640080" y="5138928"/>
+            <a:ext cx="5318608" cy="1152144"/>
           </a:xfrm>
           <a:prstGeom prst="roundRect">
             <a:avLst>
-              <a:gd name="adj" fmla="val 3268"/>
+              <a:gd name="adj" fmla="val 3968"/>
             </a:avLst>
           </a:prstGeom>
           <a:solidFill>
@@ -13437,7 +13437,7 @@
         </p:nvSpPr>
         <p:spPr>
           <a:xfrm>
-            <a:off x="658368" y="4910328"/>
+            <a:off x="658368" y="5157216"/>
             <a:ext cx="5282032" cy="310896"/>
           </a:xfrm>
           <a:prstGeom prst="rect">
@@ -13457,7 +13457,7 @@
         </p:nvSpPr>
         <p:spPr>
           <a:xfrm>
-            <a:off x="841248" y="4910328"/>
+            <a:off x="841248" y="5157216"/>
             <a:ext cx="4916272" cy="310896"/>
           </a:xfrm>
           <a:prstGeom prst="rect">
@@ -13496,8 +13496,8 @@
         </p:nvSpPr>
         <p:spPr>
           <a:xfrm>
-            <a:off x="859536" y="5294376"/>
-            <a:ext cx="4879696" cy="466344"/>
+            <a:off x="859536" y="5541264"/>
+            <a:ext cx="4879696" cy="219456"/>
           </a:xfrm>
           <a:prstGeom prst="rect">
             <a:avLst/>
@@ -13580,12 +13580,12 @@
         </p:nvSpPr>
         <p:spPr>
           <a:xfrm>
-            <a:off x="6233008" y="4892040"/>
-            <a:ext cx="5318608" cy="1399032"/>
+            <a:off x="6233008" y="5138928"/>
+            <a:ext cx="5318608" cy="1152144"/>
           </a:xfrm>
           <a:prstGeom prst="roundRect">
             <a:avLst>
-              <a:gd name="adj" fmla="val 3268"/>
+              <a:gd name="adj" fmla="val 3968"/>
             </a:avLst>
           </a:prstGeom>
           <a:solidFill>
@@ -13607,8 +13607,8 @@
         </p:nvSpPr>
         <p:spPr>
           <a:xfrm>
-            <a:off x="6233008" y="4946904"/>
-            <a:ext cx="73152" cy="1289304"/>
+            <a:off x="6233008" y="5193792"/>
+            <a:ext cx="73152" cy="1042416"/>
           </a:xfrm>
           <a:prstGeom prst="rect">
             <a:avLst/>
@@ -13627,7 +13627,7 @@
         </p:nvSpPr>
         <p:spPr>
           <a:xfrm>
-            <a:off x="6452464" y="4965192"/>
+            <a:off x="6452464" y="5212080"/>
             <a:ext cx="4916272" cy="201168"/>
           </a:xfrm>
           <a:prstGeom prst="rect">
@@ -13666,8 +13666,8 @@
         </p:nvSpPr>
         <p:spPr>
           <a:xfrm>
-            <a:off x="6452464" y="5166360"/>
-            <a:ext cx="4916272" cy="649224"/>
+            <a:off x="6452464" y="5413248"/>
+            <a:ext cx="4916272" cy="402336"/>
           </a:xfrm>
           <a:prstGeom prst="rect">
             <a:avLst/>
@@ -14035,7 +14035,7 @@
         <p:spPr>
           <a:xfrm>
             <a:off x="640080" y="2286000"/>
-            <a:ext cx="5486400" cy="2468880"/>
+            <a:ext cx="5486400" cy="2697480"/>
           </a:xfrm>
           <a:prstGeom prst="rect">
             <a:avLst/>
@@ -14049,15 +14049,15 @@
           <a:p>
             <a:pPr indent="0" marL="0">
               <a:lnSpc>
-                <a:spcPct val="114000"/>
+                <a:spcPct val="110000"/>
               </a:lnSpc>
               <a:spcAft>
-                <a:spcPts val="400"/>
+                <a:spcPts val="300"/>
               </a:spcAft>
               <a:buNone/>
             </a:pPr>
             <a:r>
-              <a:rPr lang="en-US" sz="1050" dirty="0">
+              <a:rPr lang="en-US" sz="980" dirty="0">
                 <a:solidFill>
                   <a:srgbClr val="1A1F26"/>
                 </a:solidFill>
@@ -14070,15 +14070,15 @@
             </a:r>
             <a:pPr indent="0" marL="0">
               <a:lnSpc>
-                <a:spcPct val="114000"/>
+                <a:spcPct val="110000"/>
               </a:lnSpc>
               <a:spcAft>
-                <a:spcPts val="400"/>
+                <a:spcPts val="300"/>
               </a:spcAft>
               <a:buNone/>
             </a:pPr>
             <a:r>
-              <a:rPr lang="en-US" sz="1050" dirty="0">
+              <a:rPr lang="en-US" sz="980" dirty="0">
                 <a:solidFill>
                   <a:srgbClr val="1A1F26"/>
                 </a:solidFill>
@@ -14091,15 +14091,15 @@
             </a:r>
             <a:pPr indent="0" marL="0">
               <a:lnSpc>
-                <a:spcPct val="114000"/>
+                <a:spcPct val="110000"/>
               </a:lnSpc>
               <a:spcAft>
-                <a:spcPts val="400"/>
+                <a:spcPts val="300"/>
               </a:spcAft>
               <a:buNone/>
             </a:pPr>
             <a:r>
-              <a:rPr lang="en-US" sz="1050" dirty="0">
+              <a:rPr lang="en-US" sz="980" dirty="0">
                 <a:solidFill>
                   <a:srgbClr val="1A1F26"/>
                 </a:solidFill>
@@ -14109,7 +14109,7 @@
               </a:rPr>
               <a:t>Within the four-phase Longevity Blueprint, she'll guide small cohorts of 8–15 as they move from Foundation through Data &amp; Discovery — the phase where each student's Abbott Lingo glucose monitor arrives before Lesson 5 — to a written protocol tested against their own biology.</a:t>
             </a:r>
-            <a:endParaRPr lang="en-US" sz="1050" dirty="0"/>
+            <a:endParaRPr lang="en-US" sz="980" dirty="0"/>
           </a:p>
         </p:txBody>
       </p:sp>
@@ -14122,7 +14122,7 @@
         <p:spPr>
           <a:xfrm>
             <a:off x="6492240" y="2286000"/>
-            <a:ext cx="5486400" cy="2468880"/>
+            <a:ext cx="5486400" cy="2697480"/>
           </a:xfrm>
           <a:prstGeom prst="rect">
             <a:avLst/>
@@ -14136,15 +14136,15 @@
           <a:p>
             <a:pPr indent="0" marL="0">
               <a:lnSpc>
-                <a:spcPct val="114000"/>
+                <a:spcPct val="110000"/>
               </a:lnSpc>
               <a:spcAft>
-                <a:spcPts val="400"/>
+                <a:spcPts val="300"/>
               </a:spcAft>
               <a:buNone/>
             </a:pPr>
             <a:r>
-              <a:rPr lang="en-US" sz="1050" dirty="0">
+              <a:rPr lang="en-US" sz="980" dirty="0">
                 <a:solidFill>
                   <a:srgbClr val="1A1F26"/>
                 </a:solidFill>
@@ -14157,15 +14157,15 @@
             </a:r>
             <a:pPr indent="0" marL="0">
               <a:lnSpc>
-                <a:spcPct val="114000"/>
+                <a:spcPct val="110000"/>
               </a:lnSpc>
               <a:spcAft>
-                <a:spcPts val="400"/>
+                <a:spcPts val="300"/>
               </a:spcAft>
               <a:buNone/>
             </a:pPr>
             <a:r>
-              <a:rPr lang="en-US" sz="1050" dirty="0">
+              <a:rPr lang="en-US" sz="980" dirty="0">
                 <a:solidFill>
                   <a:srgbClr val="1A1F26"/>
                 </a:solidFill>
@@ -14178,15 +14178,15 @@
             </a:r>
             <a:pPr indent="0" marL="0">
               <a:lnSpc>
-                <a:spcPct val="114000"/>
+                <a:spcPct val="110000"/>
               </a:lnSpc>
               <a:spcAft>
-                <a:spcPts val="400"/>
+                <a:spcPts val="300"/>
               </a:spcAft>
               <a:buNone/>
             </a:pPr>
             <a:r>
-              <a:rPr lang="en-US" sz="1050" dirty="0">
+              <a:rPr lang="en-US" sz="980" dirty="0">
                 <a:solidFill>
                   <a:srgbClr val="1A1F26"/>
                 </a:solidFill>
@@ -14196,7 +14196,7 @@
               </a:rPr>
               <a:t>eTeacher says a continuation course, Longevity Blueprint 2, is on the roadmap, giving graduates a next step in the same live, cohort-based format.</a:t>
             </a:r>
-            <a:endParaRPr lang="en-US" sz="1050" dirty="0"/>
+            <a:endParaRPr lang="en-US" sz="980" dirty="0"/>
           </a:p>
         </p:txBody>
       </p:sp>
@@ -14208,12 +14208,12 @@
         </p:nvSpPr>
         <p:spPr>
           <a:xfrm>
-            <a:off x="640080" y="4892040"/>
-            <a:ext cx="10911535" cy="1399032"/>
+            <a:off x="640080" y="5138928"/>
+            <a:ext cx="10911535" cy="1152144"/>
           </a:xfrm>
           <a:prstGeom prst="roundRect">
             <a:avLst>
-              <a:gd name="adj" fmla="val 3268"/>
+              <a:gd name="adj" fmla="val 3968"/>
             </a:avLst>
           </a:prstGeom>
           <a:solidFill>
@@ -14235,8 +14235,8 @@
         </p:nvSpPr>
         <p:spPr>
           <a:xfrm>
-            <a:off x="640080" y="4946904"/>
-            <a:ext cx="73152" cy="1289304"/>
+            <a:off x="640080" y="5193792"/>
+            <a:ext cx="73152" cy="1042416"/>
           </a:xfrm>
           <a:prstGeom prst="rect">
             <a:avLst/>
@@ -14255,7 +14255,7 @@
         </p:nvSpPr>
         <p:spPr>
           <a:xfrm>
-            <a:off x="859536" y="4965192"/>
+            <a:off x="859536" y="5212080"/>
             <a:ext cx="10509199" cy="201168"/>
           </a:xfrm>
           <a:prstGeom prst="rect">
@@ -14294,8 +14294,8 @@
         </p:nvSpPr>
         <p:spPr>
           <a:xfrm>
-            <a:off x="859536" y="5166360"/>
-            <a:ext cx="10509199" cy="649224"/>
+            <a:off x="859536" y="5413248"/>
+            <a:ext cx="10509199" cy="402336"/>
           </a:xfrm>
           <a:prstGeom prst="rect">
             <a:avLst/>
@@ -14663,7 +14663,7 @@
         <p:spPr>
           <a:xfrm>
             <a:off x="640080" y="2286000"/>
-            <a:ext cx="5486400" cy="2468880"/>
+            <a:ext cx="5486400" cy="2697480"/>
           </a:xfrm>
           <a:prstGeom prst="rect">
             <a:avLst/>
@@ -14677,15 +14677,15 @@
           <a:p>
             <a:pPr indent="0" marL="0">
               <a:lnSpc>
-                <a:spcPct val="114000"/>
+                <a:spcPct val="110000"/>
               </a:lnSpc>
               <a:spcAft>
-                <a:spcPts val="400"/>
+                <a:spcPts val="300"/>
               </a:spcAft>
               <a:buNone/>
             </a:pPr>
             <a:r>
-              <a:rPr lang="en-US" sz="1050" dirty="0">
+              <a:rPr lang="en-US" sz="980" dirty="0">
                 <a:solidFill>
                   <a:srgbClr val="1A1F26"/>
                 </a:solidFill>
@@ -14698,15 +14698,15 @@
             </a:r>
             <a:pPr indent="0" marL="0">
               <a:lnSpc>
-                <a:spcPct val="114000"/>
+                <a:spcPct val="110000"/>
               </a:lnSpc>
               <a:spcAft>
-                <a:spcPts val="400"/>
+                <a:spcPts val="300"/>
               </a:spcAft>
               <a:buNone/>
             </a:pPr>
             <a:r>
-              <a:rPr lang="en-US" sz="1050" dirty="0">
+              <a:rPr lang="en-US" sz="980" dirty="0">
                 <a:solidFill>
                   <a:srgbClr val="1A1F26"/>
                 </a:solidFill>
@@ -14719,15 +14719,15 @@
             </a:r>
             <a:pPr indent="0" marL="0">
               <a:lnSpc>
-                <a:spcPct val="114000"/>
+                <a:spcPct val="110000"/>
               </a:lnSpc>
               <a:spcAft>
-                <a:spcPts val="400"/>
+                <a:spcPts val="300"/>
               </a:spcAft>
               <a:buNone/>
             </a:pPr>
             <a:r>
-              <a:rPr lang="en-US" sz="1050" dirty="0">
+              <a:rPr lang="en-US" sz="980" dirty="0">
                 <a:solidFill>
                   <a:srgbClr val="1A1F26"/>
                 </a:solidFill>
@@ -14737,7 +14737,7 @@
               </a:rPr>
               <a:t>The relatability is the draw for a general audience: her DunedinPACE score of 0.665 suggests roughly 34% slower aging, but her method is ordinary — a pound of vegetables a day, protein, strength work, sleep — rituals any viewer can start that morning.</a:t>
             </a:r>
-            <a:endParaRPr lang="en-US" sz="1050" dirty="0"/>
+            <a:endParaRPr lang="en-US" sz="980" dirty="0"/>
           </a:p>
         </p:txBody>
       </p:sp>
@@ -14750,7 +14750,7 @@
         <p:spPr>
           <a:xfrm>
             <a:off x="6492240" y="2286000"/>
-            <a:ext cx="5486400" cy="2468880"/>
+            <a:ext cx="5486400" cy="2697480"/>
           </a:xfrm>
           <a:prstGeom prst="rect">
             <a:avLst/>
@@ -14764,15 +14764,15 @@
           <a:p>
             <a:pPr indent="0" marL="0">
               <a:lnSpc>
-                <a:spcPct val="114000"/>
+                <a:spcPct val="110000"/>
               </a:lnSpc>
               <a:spcAft>
-                <a:spcPts val="400"/>
+                <a:spcPts val="300"/>
               </a:spcAft>
               <a:buNone/>
             </a:pPr>
             <a:r>
-              <a:rPr lang="en-US" sz="1050" dirty="0">
+              <a:rPr lang="en-US" sz="980" dirty="0">
                 <a:solidFill>
                   <a:srgbClr val="1A1F26"/>
                 </a:solidFill>
@@ -14785,15 +14785,15 @@
             </a:r>
             <a:pPr indent="0" marL="0">
               <a:lnSpc>
-                <a:spcPct val="114000"/>
+                <a:spcPct val="110000"/>
               </a:lnSpc>
               <a:spcAft>
-                <a:spcPts val="400"/>
+                <a:spcPts val="300"/>
               </a:spcAft>
               <a:buNone/>
             </a:pPr>
             <a:r>
-              <a:rPr lang="en-US" sz="1050" dirty="0">
+              <a:rPr lang="en-US" sz="980" dirty="0">
                 <a:solidFill>
                   <a:srgbClr val="1A1F26"/>
                 </a:solidFill>
@@ -14806,15 +14806,15 @@
             </a:r>
             <a:pPr indent="0" marL="0">
               <a:lnSpc>
-                <a:spcPct val="114000"/>
+                <a:spcPct val="110000"/>
               </a:lnSpc>
               <a:spcAft>
-                <a:spcPts val="400"/>
+                <a:spcPts val="300"/>
               </a:spcAft>
               <a:buNone/>
             </a:pPr>
             <a:r>
-              <a:rPr lang="en-US" sz="1050" dirty="0">
+              <a:rPr lang="en-US" sz="980" dirty="0">
                 <a:solidFill>
                   <a:srgbClr val="1A1F26"/>
                 </a:solidFill>
@@ -14824,7 +14824,7 @@
               </a:rPr>
               <a:t>Segment availability aligns with LLA's current enrollment window, with the glucose-monitor demo available in-studio or remote.</a:t>
             </a:r>
-            <a:endParaRPr lang="en-US" sz="1050" dirty="0"/>
+            <a:endParaRPr lang="en-US" sz="980" dirty="0"/>
           </a:p>
         </p:txBody>
       </p:sp>
@@ -14836,12 +14836,12 @@
         </p:nvSpPr>
         <p:spPr>
           <a:xfrm>
-            <a:off x="640080" y="4892040"/>
-            <a:ext cx="10911535" cy="1399032"/>
+            <a:off x="640080" y="5138928"/>
+            <a:ext cx="10911535" cy="1152144"/>
           </a:xfrm>
           <a:prstGeom prst="roundRect">
             <a:avLst>
-              <a:gd name="adj" fmla="val 3268"/>
+              <a:gd name="adj" fmla="val 3968"/>
             </a:avLst>
           </a:prstGeom>
           <a:solidFill>
@@ -14863,8 +14863,8 @@
         </p:nvSpPr>
         <p:spPr>
           <a:xfrm>
-            <a:off x="640080" y="4946904"/>
-            <a:ext cx="73152" cy="1289304"/>
+            <a:off x="640080" y="5193792"/>
+            <a:ext cx="73152" cy="1042416"/>
           </a:xfrm>
           <a:prstGeom prst="rect">
             <a:avLst/>
@@ -14883,7 +14883,7 @@
         </p:nvSpPr>
         <p:spPr>
           <a:xfrm>
-            <a:off x="859536" y="4965192"/>
+            <a:off x="859536" y="5212080"/>
             <a:ext cx="10509199" cy="201168"/>
           </a:xfrm>
           <a:prstGeom prst="rect">
@@ -14922,8 +14922,8 @@
         </p:nvSpPr>
         <p:spPr>
           <a:xfrm>
-            <a:off x="859536" y="5166360"/>
-            <a:ext cx="10509199" cy="649224"/>
+            <a:off x="859536" y="5413248"/>
+            <a:ext cx="10509199" cy="402336"/>
           </a:xfrm>
           <a:prstGeom prst="rect">
             <a:avLst/>
@@ -15544,7 +15544,7 @@
         <p:spPr>
           <a:xfrm>
             <a:off x="640080" y="2286000"/>
-            <a:ext cx="5486400" cy="2468880"/>
+            <a:ext cx="5486400" cy="2697480"/>
           </a:xfrm>
           <a:prstGeom prst="rect">
             <a:avLst/>
@@ -15558,15 +15558,15 @@
           <a:p>
             <a:pPr indent="0" marL="0">
               <a:lnSpc>
-                <a:spcPct val="114000"/>
+                <a:spcPct val="110000"/>
               </a:lnSpc>
               <a:spcAft>
-                <a:spcPts val="400"/>
+                <a:spcPts val="300"/>
               </a:spcAft>
               <a:buNone/>
             </a:pPr>
             <a:r>
-              <a:rPr lang="en-US" sz="1050" dirty="0">
+              <a:rPr lang="en-US" sz="980" dirty="0">
                 <a:solidFill>
                   <a:srgbClr val="1A1F26"/>
                 </a:solidFill>
@@ -15579,15 +15579,15 @@
             </a:r>
             <a:pPr indent="0" marL="0">
               <a:lnSpc>
-                <a:spcPct val="114000"/>
+                <a:spcPct val="110000"/>
               </a:lnSpc>
               <a:spcAft>
-                <a:spcPts val="400"/>
+                <a:spcPts val="300"/>
               </a:spcAft>
               <a:buNone/>
             </a:pPr>
             <a:r>
-              <a:rPr lang="en-US" sz="1050" dirty="0">
+              <a:rPr lang="en-US" sz="980" dirty="0">
                 <a:solidFill>
                   <a:srgbClr val="1A1F26"/>
                 </a:solidFill>
@@ -15600,15 +15600,15 @@
             </a:r>
             <a:pPr indent="0" marL="0">
               <a:lnSpc>
-                <a:spcPct val="114000"/>
+                <a:spcPct val="110000"/>
               </a:lnSpc>
               <a:spcAft>
-                <a:spcPts val="400"/>
+                <a:spcPts val="300"/>
               </a:spcAft>
               <a:buNone/>
             </a:pPr>
             <a:r>
-              <a:rPr lang="en-US" sz="1050" dirty="0">
+              <a:rPr lang="en-US" sz="980" dirty="0">
                 <a:solidFill>
                   <a:srgbClr val="1A1F26"/>
                 </a:solidFill>
@@ -15618,7 +15618,7 @@
               </a:rPr>
               <a:t>At the Hub's center will be an AI longevity tutor — the same “gym for the brain” approach eTeacher pioneered across its five schools — intended to check in daily, adapt to each user's data, and keep them progressing between live sessions. The company plans for the Hub to connect with CGM, sleep, and wearable data so each user's biology becomes a personal feedback loop.</a:t>
             </a:r>
-            <a:endParaRPr lang="en-US" sz="1050" dirty="0"/>
+            <a:endParaRPr lang="en-US" sz="980" dirty="0"/>
           </a:p>
         </p:txBody>
       </p:sp>
@@ -15631,7 +15631,7 @@
         <p:spPr>
           <a:xfrm>
             <a:off x="6492240" y="2286000"/>
-            <a:ext cx="5486400" cy="2468880"/>
+            <a:ext cx="5486400" cy="2697480"/>
           </a:xfrm>
           <a:prstGeom prst="rect">
             <a:avLst/>
@@ -15645,15 +15645,15 @@
           <a:p>
             <a:pPr indent="0" marL="0">
               <a:lnSpc>
-                <a:spcPct val="114000"/>
+                <a:spcPct val="110000"/>
               </a:lnSpc>
               <a:spcAft>
-                <a:spcPts val="400"/>
+                <a:spcPts val="300"/>
               </a:spcAft>
               <a:buNone/>
             </a:pPr>
             <a:r>
-              <a:rPr lang="en-US" sz="1050" dirty="0">
+              <a:rPr lang="en-US" sz="980" dirty="0">
                 <a:solidFill>
                   <a:srgbClr val="1A1F26"/>
                 </a:solidFill>
@@ -15666,15 +15666,15 @@
             </a:r>
             <a:pPr indent="0" marL="0">
               <a:lnSpc>
-                <a:spcPct val="114000"/>
+                <a:spcPct val="110000"/>
               </a:lnSpc>
               <a:spcAft>
-                <a:spcPts val="400"/>
+                <a:spcPts val="300"/>
               </a:spcAft>
               <a:buNone/>
             </a:pPr>
             <a:r>
-              <a:rPr lang="en-US" sz="1050" dirty="0">
+              <a:rPr lang="en-US" sz="980" dirty="0">
                 <a:solidFill>
                   <a:srgbClr val="1A1F26"/>
                 </a:solidFill>
@@ -15687,15 +15687,15 @@
             </a:r>
             <a:pPr indent="0" marL="0">
               <a:lnSpc>
-                <a:spcPct val="114000"/>
+                <a:spcPct val="110000"/>
               </a:lnSpc>
               <a:spcAft>
-                <a:spcPts val="400"/>
+                <a:spcPts val="300"/>
               </a:spcAft>
               <a:buNone/>
             </a:pPr>
             <a:r>
-              <a:rPr lang="en-US" sz="1050" dirty="0">
+              <a:rPr lang="en-US" sz="980" dirty="0">
                 <a:solidFill>
                   <a:srgbClr val="1A1F26"/>
                 </a:solidFill>
@@ -15705,7 +15705,7 @@
               </a:rPr>
               <a:t>eTeacher says the Longevity Hub is planned for release in the year ahead, with timing to follow the expansion of its live course catalog.</a:t>
             </a:r>
-            <a:endParaRPr lang="en-US" sz="1050" dirty="0"/>
+            <a:endParaRPr lang="en-US" sz="980" dirty="0"/>
           </a:p>
         </p:txBody>
       </p:sp>
@@ -15717,12 +15717,12 @@
         </p:nvSpPr>
         <p:spPr>
           <a:xfrm>
-            <a:off x="640080" y="4892040"/>
-            <a:ext cx="10911535" cy="1399032"/>
+            <a:off x="640080" y="5138928"/>
+            <a:ext cx="10911535" cy="1152144"/>
           </a:xfrm>
           <a:prstGeom prst="roundRect">
             <a:avLst>
-              <a:gd name="adj" fmla="val 3268"/>
+              <a:gd name="adj" fmla="val 3968"/>
             </a:avLst>
           </a:prstGeom>
           <a:solidFill>
@@ -15744,7 +15744,7 @@
         </p:nvSpPr>
         <p:spPr>
           <a:xfrm>
-            <a:off x="658368" y="4910328"/>
+            <a:off x="658368" y="5157216"/>
             <a:ext cx="10874959" cy="310896"/>
           </a:xfrm>
           <a:prstGeom prst="rect">
@@ -15764,7 +15764,7 @@
         </p:nvSpPr>
         <p:spPr>
           <a:xfrm>
-            <a:off x="841248" y="4910328"/>
+            <a:off x="841248" y="5157216"/>
             <a:ext cx="10509199" cy="310896"/>
           </a:xfrm>
           <a:prstGeom prst="rect">
@@ -15803,8 +15803,8 @@
         </p:nvSpPr>
         <p:spPr>
           <a:xfrm>
-            <a:off x="859536" y="5294376"/>
-            <a:ext cx="10472623" cy="466344"/>
+            <a:off x="859536" y="5541264"/>
+            <a:ext cx="10472623" cy="219456"/>
           </a:xfrm>
           <a:prstGeom prst="rect">
             <a:avLst/>
@@ -16172,7 +16172,7 @@
         <p:spPr>
           <a:xfrm>
             <a:off x="640080" y="2286000"/>
-            <a:ext cx="5486400" cy="2468880"/>
+            <a:ext cx="5486400" cy="2697480"/>
           </a:xfrm>
           <a:prstGeom prst="rect">
             <a:avLst/>
@@ -16186,15 +16186,15 @@
           <a:p>
             <a:pPr indent="0" marL="0">
               <a:lnSpc>
-                <a:spcPct val="114000"/>
+                <a:spcPct val="110000"/>
               </a:lnSpc>
               <a:spcAft>
-                <a:spcPts val="400"/>
+                <a:spcPts val="300"/>
               </a:spcAft>
               <a:buNone/>
             </a:pPr>
             <a:r>
-              <a:rPr lang="en-US" sz="1050" dirty="0">
+              <a:rPr lang="en-US" sz="980" dirty="0">
                 <a:solidFill>
                   <a:srgbClr val="1A1F26"/>
                 </a:solidFill>
@@ -16207,15 +16207,15 @@
             </a:r>
             <a:pPr indent="0" marL="0">
               <a:lnSpc>
-                <a:spcPct val="114000"/>
+                <a:spcPct val="110000"/>
               </a:lnSpc>
               <a:spcAft>
-                <a:spcPts val="400"/>
+                <a:spcPts val="300"/>
               </a:spcAft>
               <a:buNone/>
             </a:pPr>
             <a:r>
-              <a:rPr lang="en-US" sz="1050" dirty="0">
+              <a:rPr lang="en-US" sz="980" dirty="0">
                 <a:solidFill>
                   <a:srgbClr val="1A1F26"/>
                 </a:solidFill>
@@ -16228,15 +16228,15 @@
             </a:r>
             <a:pPr indent="0" marL="0">
               <a:lnSpc>
-                <a:spcPct val="114000"/>
+                <a:spcPct val="110000"/>
               </a:lnSpc>
               <a:spcAft>
-                <a:spcPts val="400"/>
+                <a:spcPts val="300"/>
               </a:spcAft>
               <a:buNone/>
             </a:pPr>
             <a:r>
-              <a:rPr lang="en-US" sz="1050" dirty="0">
+              <a:rPr lang="en-US" sz="980" dirty="0">
                 <a:solidFill>
                   <a:srgbClr val="1A1F26"/>
                 </a:solidFill>
@@ -16246,7 +16246,7 @@
               </a:rPr>
               <a:t>The proposed solution is an AI tutor built on eTeacher's micro-learning model — the “gym for the brain” — that will deliver relevant, personalized prompts, recognize streaks, and re-engage users who drift. The company plans for it to draw on each user's glucose, sleep, and movement data so the nudges reflect real biology, not generic reminders.</a:t>
             </a:r>
-            <a:endParaRPr lang="en-US" sz="1050" dirty="0"/>
+            <a:endParaRPr lang="en-US" sz="980" dirty="0"/>
           </a:p>
         </p:txBody>
       </p:sp>
@@ -16259,7 +16259,7 @@
         <p:spPr>
           <a:xfrm>
             <a:off x="6492240" y="2286000"/>
-            <a:ext cx="5486400" cy="2468880"/>
+            <a:ext cx="5486400" cy="2697480"/>
           </a:xfrm>
           <a:prstGeom prst="rect">
             <a:avLst/>
@@ -16273,15 +16273,15 @@
           <a:p>
             <a:pPr indent="0" marL="0">
               <a:lnSpc>
-                <a:spcPct val="114000"/>
+                <a:spcPct val="110000"/>
               </a:lnSpc>
               <a:spcAft>
-                <a:spcPts val="400"/>
+                <a:spcPts val="300"/>
               </a:spcAft>
               <a:buNone/>
             </a:pPr>
             <a:r>
-              <a:rPr lang="en-US" sz="1050" dirty="0">
+              <a:rPr lang="en-US" sz="980" dirty="0">
                 <a:solidFill>
                   <a:srgbClr val="1A1F26"/>
                 </a:solidFill>
@@ -16294,15 +16294,15 @@
             </a:r>
             <a:pPr indent="0" marL="0">
               <a:lnSpc>
-                <a:spcPct val="114000"/>
+                <a:spcPct val="110000"/>
               </a:lnSpc>
               <a:spcAft>
-                <a:spcPts val="400"/>
+                <a:spcPts val="300"/>
               </a:spcAft>
               <a:buNone/>
             </a:pPr>
             <a:r>
-              <a:rPr lang="en-US" sz="1050" dirty="0">
+              <a:rPr lang="en-US" sz="980" dirty="0">
                 <a:solidFill>
                   <a:srgbClr val="1A1F26"/>
                 </a:solidFill>
@@ -16315,15 +16315,15 @@
             </a:r>
             <a:pPr indent="0" marL="0">
               <a:lnSpc>
-                <a:spcPct val="114000"/>
+                <a:spcPct val="110000"/>
               </a:lnSpc>
               <a:spcAft>
-                <a:spcPts val="400"/>
+                <a:spcPts val="300"/>
               </a:spcAft>
               <a:buNone/>
             </a:pPr>
             <a:r>
-              <a:rPr lang="en-US" sz="1050" dirty="0">
+              <a:rPr lang="en-US" sz="980" dirty="0">
                 <a:solidFill>
                   <a:srgbClr val="1A1F26"/>
                 </a:solidFill>
@@ -16333,7 +16333,7 @@
               </a:rPr>
               <a:t>eTeacher expects to roll out the Longevity Hub in the year ahead, alongside a broader expansion of its longevity curriculum.</a:t>
             </a:r>
-            <a:endParaRPr lang="en-US" sz="1050" dirty="0"/>
+            <a:endParaRPr lang="en-US" sz="980" dirty="0"/>
           </a:p>
         </p:txBody>
       </p:sp>
@@ -16345,12 +16345,12 @@
         </p:nvSpPr>
         <p:spPr>
           <a:xfrm>
-            <a:off x="640080" y="4892040"/>
-            <a:ext cx="10911535" cy="1399032"/>
+            <a:off x="640080" y="5138928"/>
+            <a:ext cx="10911535" cy="1152144"/>
           </a:xfrm>
           <a:prstGeom prst="roundRect">
             <a:avLst>
-              <a:gd name="adj" fmla="val 3268"/>
+              <a:gd name="adj" fmla="val 3968"/>
             </a:avLst>
           </a:prstGeom>
           <a:solidFill>
@@ -16372,7 +16372,7 @@
         </p:nvSpPr>
         <p:spPr>
           <a:xfrm>
-            <a:off x="658368" y="4910328"/>
+            <a:off x="658368" y="5157216"/>
             <a:ext cx="10874959" cy="310896"/>
           </a:xfrm>
           <a:prstGeom prst="rect">
@@ -16392,7 +16392,7 @@
         </p:nvSpPr>
         <p:spPr>
           <a:xfrm>
-            <a:off x="841248" y="4910328"/>
+            <a:off x="841248" y="5157216"/>
             <a:ext cx="10509199" cy="310896"/>
           </a:xfrm>
           <a:prstGeom prst="rect">
@@ -16431,8 +16431,8 @@
         </p:nvSpPr>
         <p:spPr>
           <a:xfrm>
-            <a:off x="859536" y="5294376"/>
-            <a:ext cx="10472623" cy="466344"/>
+            <a:off x="859536" y="5541264"/>
+            <a:ext cx="10472623" cy="219456"/>
           </a:xfrm>
           <a:prstGeom prst="rect">
             <a:avLst/>
@@ -17053,7 +17053,7 @@
         <p:spPr>
           <a:xfrm>
             <a:off x="640080" y="2286000"/>
-            <a:ext cx="5486400" cy="2468880"/>
+            <a:ext cx="5486400" cy="2697480"/>
           </a:xfrm>
           <a:prstGeom prst="rect">
             <a:avLst/>
@@ -17067,15 +17067,15 @@
           <a:p>
             <a:pPr indent="0" marL="0">
               <a:lnSpc>
-                <a:spcPct val="114000"/>
+                <a:spcPct val="110000"/>
               </a:lnSpc>
               <a:spcAft>
-                <a:spcPts val="400"/>
+                <a:spcPts val="300"/>
               </a:spcAft>
               <a:buNone/>
             </a:pPr>
             <a:r>
-              <a:rPr lang="en-US" sz="1050" dirty="0">
+              <a:rPr lang="en-US" sz="980" dirty="0">
                 <a:solidFill>
                   <a:srgbClr val="1A1F26"/>
                 </a:solidFill>
@@ -17088,15 +17088,15 @@
             </a:r>
             <a:pPr indent="0" marL="0">
               <a:lnSpc>
-                <a:spcPct val="114000"/>
+                <a:spcPct val="110000"/>
               </a:lnSpc>
               <a:spcAft>
-                <a:spcPts val="400"/>
+                <a:spcPts val="300"/>
               </a:spcAft>
               <a:buNone/>
             </a:pPr>
             <a:r>
-              <a:rPr lang="en-US" sz="1050" dirty="0">
+              <a:rPr lang="en-US" sz="980" dirty="0">
                 <a:solidFill>
                   <a:srgbClr val="1A1F26"/>
                 </a:solidFill>
@@ -17109,15 +17109,15 @@
             </a:r>
             <a:pPr indent="0" marL="0">
               <a:lnSpc>
-                <a:spcPct val="114000"/>
+                <a:spcPct val="110000"/>
               </a:lnSpc>
               <a:spcAft>
-                <a:spcPts val="400"/>
+                <a:spcPts val="300"/>
               </a:spcAft>
               <a:buNone/>
             </a:pPr>
             <a:r>
-              <a:rPr lang="en-US" sz="1050" dirty="0">
+              <a:rPr lang="en-US" sz="980" dirty="0">
                 <a:solidFill>
                   <a:srgbClr val="1A1F26"/>
                 </a:solidFill>
@@ -17127,7 +17127,7 @@
               </a:rPr>
               <a:t>Each new course is planned to keep the LLA format that defines the flagship: live, small-group sessions of 8–15, instructor-led across multiple phases, with personal-data integration and named expert faculty.</a:t>
             </a:r>
-            <a:endParaRPr lang="en-US" sz="1050" dirty="0"/>
+            <a:endParaRPr lang="en-US" sz="980" dirty="0"/>
           </a:p>
         </p:txBody>
       </p:sp>
@@ -17140,7 +17140,7 @@
         <p:spPr>
           <a:xfrm>
             <a:off x="6492240" y="2286000"/>
-            <a:ext cx="5486400" cy="2468880"/>
+            <a:ext cx="5486400" cy="2697480"/>
           </a:xfrm>
           <a:prstGeom prst="rect">
             <a:avLst/>
@@ -17154,15 +17154,15 @@
           <a:p>
             <a:pPr indent="0" marL="0">
               <a:lnSpc>
-                <a:spcPct val="114000"/>
+                <a:spcPct val="110000"/>
               </a:lnSpc>
               <a:spcAft>
-                <a:spcPts val="400"/>
+                <a:spcPts val="300"/>
               </a:spcAft>
               <a:buNone/>
             </a:pPr>
             <a:r>
-              <a:rPr lang="en-US" sz="1050" dirty="0">
+              <a:rPr lang="en-US" sz="980" dirty="0">
                 <a:solidFill>
                   <a:srgbClr val="1A1F26"/>
                 </a:solidFill>
@@ -17175,15 +17175,15 @@
             </a:r>
             <a:pPr indent="0" marL="0">
               <a:lnSpc>
-                <a:spcPct val="114000"/>
+                <a:spcPct val="110000"/>
               </a:lnSpc>
               <a:spcAft>
-                <a:spcPts val="400"/>
+                <a:spcPts val="300"/>
               </a:spcAft>
               <a:buNone/>
             </a:pPr>
             <a:r>
-              <a:rPr lang="en-US" sz="1050" dirty="0">
+              <a:rPr lang="en-US" sz="980" dirty="0">
                 <a:solidFill>
                   <a:srgbClr val="1A1F26"/>
                 </a:solidFill>
@@ -17196,15 +17196,15 @@
             </a:r>
             <a:pPr indent="0" marL="0">
               <a:lnSpc>
-                <a:spcPct val="114000"/>
+                <a:spcPct val="110000"/>
               </a:lnSpc>
               <a:spcAft>
-                <a:spcPts val="400"/>
+                <a:spcPts val="300"/>
               </a:spcAft>
               <a:buNone/>
             </a:pPr>
             <a:r>
-              <a:rPr lang="en-US" sz="1050" dirty="0">
+              <a:rPr lang="en-US" sz="980" dirty="0">
                 <a:solidFill>
                   <a:srgbClr val="1A1F26"/>
                 </a:solidFill>
@@ -17214,7 +17214,7 @@
               </a:rPr>
               <a:t>eTeacher says the six courses are on its roadmap for the year following the Q2 debut, with instructors and enrollment dates to be announced.</a:t>
             </a:r>
-            <a:endParaRPr lang="en-US" sz="1050" dirty="0"/>
+            <a:endParaRPr lang="en-US" sz="980" dirty="0"/>
           </a:p>
         </p:txBody>
       </p:sp>
@@ -17226,12 +17226,12 @@
         </p:nvSpPr>
         <p:spPr>
           <a:xfrm>
-            <a:off x="640080" y="4892040"/>
-            <a:ext cx="10911535" cy="1399032"/>
+            <a:off x="640080" y="5138928"/>
+            <a:ext cx="10911535" cy="1152144"/>
           </a:xfrm>
           <a:prstGeom prst="roundRect">
             <a:avLst>
-              <a:gd name="adj" fmla="val 3268"/>
+              <a:gd name="adj" fmla="val 3968"/>
             </a:avLst>
           </a:prstGeom>
           <a:solidFill>
@@ -17253,7 +17253,7 @@
         </p:nvSpPr>
         <p:spPr>
           <a:xfrm>
-            <a:off x="658368" y="4910328"/>
+            <a:off x="658368" y="5157216"/>
             <a:ext cx="10874959" cy="310896"/>
           </a:xfrm>
           <a:prstGeom prst="rect">
@@ -17273,7 +17273,7 @@
         </p:nvSpPr>
         <p:spPr>
           <a:xfrm>
-            <a:off x="841248" y="4910328"/>
+            <a:off x="841248" y="5157216"/>
             <a:ext cx="10509199" cy="310896"/>
           </a:xfrm>
           <a:prstGeom prst="rect">
@@ -17312,8 +17312,8 @@
         </p:nvSpPr>
         <p:spPr>
           <a:xfrm>
-            <a:off x="859536" y="5294376"/>
-            <a:ext cx="10472623" cy="466344"/>
+            <a:off x="859536" y="5541264"/>
+            <a:ext cx="10472623" cy="219456"/>
           </a:xfrm>
           <a:prstGeom prst="rect">
             <a:avLst/>
@@ -18404,7 +18404,7 @@
         <p:spPr>
           <a:xfrm>
             <a:off x="640080" y="2286000"/>
-            <a:ext cx="5486400" cy="2468880"/>
+            <a:ext cx="5486400" cy="2697480"/>
           </a:xfrm>
           <a:prstGeom prst="rect">
             <a:avLst/>
@@ -18418,15 +18418,15 @@
           <a:p>
             <a:pPr indent="0" marL="0">
               <a:lnSpc>
-                <a:spcPct val="114000"/>
+                <a:spcPct val="110000"/>
               </a:lnSpc>
               <a:spcAft>
-                <a:spcPts val="400"/>
+                <a:spcPts val="300"/>
               </a:spcAft>
               <a:buNone/>
             </a:pPr>
             <a:r>
-              <a:rPr lang="en-US" sz="1050" dirty="0">
+              <a:rPr lang="en-US" sz="980" dirty="0">
                 <a:solidFill>
                   <a:srgbClr val="1A1F26"/>
                 </a:solidFill>
@@ -18439,15 +18439,15 @@
             </a:r>
             <a:pPr indent="0" marL="0">
               <a:lnSpc>
-                <a:spcPct val="114000"/>
+                <a:spcPct val="110000"/>
               </a:lnSpc>
               <a:spcAft>
-                <a:spcPts val="400"/>
+                <a:spcPts val="300"/>
               </a:spcAft>
               <a:buNone/>
             </a:pPr>
             <a:r>
-              <a:rPr lang="en-US" sz="1050" dirty="0">
+              <a:rPr lang="en-US" sz="980" dirty="0">
                 <a:solidFill>
                   <a:srgbClr val="1A1F26"/>
                 </a:solidFill>
@@ -18460,15 +18460,15 @@
             </a:r>
             <a:pPr indent="0" marL="0">
               <a:lnSpc>
-                <a:spcPct val="114000"/>
+                <a:spcPct val="110000"/>
               </a:lnSpc>
               <a:spcAft>
-                <a:spcPts val="400"/>
+                <a:spcPts val="300"/>
               </a:spcAft>
               <a:buNone/>
             </a:pPr>
             <a:r>
-              <a:rPr lang="en-US" sz="1050" dirty="0">
+              <a:rPr lang="en-US" sz="980" dirty="0">
                 <a:solidFill>
                   <a:srgbClr val="1A1F26"/>
                 </a:solidFill>
@@ -18478,7 +18478,7 @@
               </a:rPr>
               <a:t>Longevity Brain is planned to cover memory, focus, emotional resilience, and the science of relationships and social connection — directly answering eTeacher's founding concern about keeping the adult mind engaged. Emotional Resilience &amp; Stress and Longevity Blueprint 2 round out the mental-and-continuation track.</a:t>
             </a:r>
-            <a:endParaRPr lang="en-US" sz="1050" dirty="0"/>
+            <a:endParaRPr lang="en-US" sz="980" dirty="0"/>
           </a:p>
         </p:txBody>
       </p:sp>
@@ -18491,7 +18491,7 @@
         <p:spPr>
           <a:xfrm>
             <a:off x="6492240" y="2286000"/>
-            <a:ext cx="5486400" cy="2468880"/>
+            <a:ext cx="5486400" cy="2697480"/>
           </a:xfrm>
           <a:prstGeom prst="rect">
             <a:avLst/>
@@ -18505,15 +18505,15 @@
           <a:p>
             <a:pPr indent="0" marL="0">
               <a:lnSpc>
-                <a:spcPct val="114000"/>
+                <a:spcPct val="110000"/>
               </a:lnSpc>
               <a:spcAft>
-                <a:spcPts val="400"/>
+                <a:spcPts val="300"/>
               </a:spcAft>
               <a:buNone/>
             </a:pPr>
             <a:r>
-              <a:rPr lang="en-US" sz="1050" dirty="0">
+              <a:rPr lang="en-US" sz="980" dirty="0">
                 <a:solidFill>
                   <a:srgbClr val="1A1F26"/>
                 </a:solidFill>
@@ -18526,15 +18526,15 @@
             </a:r>
             <a:pPr indent="0" marL="0">
               <a:lnSpc>
-                <a:spcPct val="114000"/>
+                <a:spcPct val="110000"/>
               </a:lnSpc>
               <a:spcAft>
-                <a:spcPts val="400"/>
+                <a:spcPts val="300"/>
               </a:spcAft>
               <a:buNone/>
             </a:pPr>
             <a:r>
-              <a:rPr lang="en-US" sz="1050" dirty="0">
+              <a:rPr lang="en-US" sz="980" dirty="0">
                 <a:solidFill>
                   <a:srgbClr val="1A1F26"/>
                 </a:solidFill>
@@ -18547,15 +18547,15 @@
             </a:r>
             <a:pPr indent="0" marL="0">
               <a:lnSpc>
-                <a:spcPct val="114000"/>
+                <a:spcPct val="110000"/>
               </a:lnSpc>
               <a:spcAft>
-                <a:spcPts val="400"/>
+                <a:spcPts val="300"/>
               </a:spcAft>
               <a:buNone/>
             </a:pPr>
             <a:r>
-              <a:rPr lang="en-US" sz="1050" dirty="0">
+              <a:rPr lang="en-US" sz="980" dirty="0">
                 <a:solidFill>
                   <a:srgbClr val="1A1F26"/>
                 </a:solidFill>
@@ -18565,7 +18565,7 @@
               </a:rPr>
               <a:t>eTeacher says the full learning journey is planned for the year following the Q2 launch, with course sequencing and faculty to be confirmed.</a:t>
             </a:r>
-            <a:endParaRPr lang="en-US" sz="1050" dirty="0"/>
+            <a:endParaRPr lang="en-US" sz="980" dirty="0"/>
           </a:p>
         </p:txBody>
       </p:sp>
@@ -18577,12 +18577,12 @@
         </p:nvSpPr>
         <p:spPr>
           <a:xfrm>
-            <a:off x="640080" y="4892040"/>
-            <a:ext cx="10911535" cy="1399032"/>
+            <a:off x="640080" y="5138928"/>
+            <a:ext cx="10911535" cy="1152144"/>
           </a:xfrm>
           <a:prstGeom prst="roundRect">
             <a:avLst>
-              <a:gd name="adj" fmla="val 3268"/>
+              <a:gd name="adj" fmla="val 3968"/>
             </a:avLst>
           </a:prstGeom>
           <a:solidFill>
@@ -18604,7 +18604,7 @@
         </p:nvSpPr>
         <p:spPr>
           <a:xfrm>
-            <a:off x="658368" y="4910328"/>
+            <a:off x="658368" y="5157216"/>
             <a:ext cx="10874959" cy="310896"/>
           </a:xfrm>
           <a:prstGeom prst="rect">
@@ -18624,7 +18624,7 @@
         </p:nvSpPr>
         <p:spPr>
           <a:xfrm>
-            <a:off x="841248" y="4910328"/>
+            <a:off x="841248" y="5157216"/>
             <a:ext cx="10509199" cy="310896"/>
           </a:xfrm>
           <a:prstGeom prst="rect">
@@ -18663,8 +18663,8 @@
         </p:nvSpPr>
         <p:spPr>
           <a:xfrm>
-            <a:off x="859536" y="5294376"/>
-            <a:ext cx="10472623" cy="466344"/>
+            <a:off x="859536" y="5541264"/>
+            <a:ext cx="10472623" cy="219456"/>
           </a:xfrm>
           <a:prstGeom prst="rect">
             <a:avLst/>
@@ -19205,7 +19205,7 @@
                 <a:ea typeface="Cambria" pitchFamily="34" charset="-122"/>
                 <a:cs typeface="Cambria" pitchFamily="34" charset="-120"/>
               </a:rPr>
-              <a:t>You Don't Need $2 Million a Year to Live Longer — Longevity Life Academy Teaches the Habits That Actually Stick, From $289 a Month</a:t>
+              <a:t>Bryan Johnson Spends $2 Million a Year — Longevity Life Academy Teaches the Same Healthy-Aging Habits, Live, From $289 a Month</a:t>
             </a:r>
             <a:endParaRPr lang="en-US" sz="2600" dirty="0"/>
           </a:p>
@@ -19285,7 +19285,7 @@
         <p:spPr>
           <a:xfrm>
             <a:off x="640080" y="2286000"/>
-            <a:ext cx="5486400" cy="2468880"/>
+            <a:ext cx="5486400" cy="2697480"/>
           </a:xfrm>
           <a:prstGeom prst="rect">
             <a:avLst/>
@@ -19299,15 +19299,15 @@
           <a:p>
             <a:pPr indent="0" marL="0">
               <a:lnSpc>
-                <a:spcPct val="114000"/>
+                <a:spcPct val="110000"/>
               </a:lnSpc>
               <a:spcAft>
-                <a:spcPts val="400"/>
+                <a:spcPts val="300"/>
               </a:spcAft>
               <a:buNone/>
             </a:pPr>
             <a:r>
-              <a:rPr lang="en-US" sz="1050" dirty="0">
+              <a:rPr lang="en-US" sz="980" dirty="0">
                 <a:solidFill>
                   <a:srgbClr val="1A1F26"/>
                 </a:solidFill>
@@ -19315,20 +19315,20 @@
                 <a:ea typeface="Calibri" pitchFamily="34" charset="-122"/>
                 <a:cs typeface="Calibri" pitchFamily="34" charset="-120"/>
               </a:rPr>
-              <a:t>RAMAT GAN, Israel — This month, biohacker Bryan Johnson disclosed that he has been diagnosed with autoimmune gastritis, an incurable condition he says medicine can only manage. His candor deserves respect; illness spares no one, however carefully they live. But the moment also sharpens a question millions are now asking: if the most expensive longevity routine on earth can't guarantee an outcome, what should the rest of us actually do?
+              <a:t>RAMAT GAN, Israel — This month, biohacker Bryan Johnson disclosed that he has been diagnosed with autoimmune gastritis, an incurable condition he says medicine can only manage. His candor deserves respect; illness spares no one. But it sharpens a question millions are now asking: if the most expensive longevity routine on earth can't guarantee an outcome, what should the rest of us actually do?
 </a:t>
             </a:r>
             <a:pPr indent="0" marL="0">
               <a:lnSpc>
-                <a:spcPct val="114000"/>
+                <a:spcPct val="110000"/>
               </a:lnSpc>
               <a:spcAft>
-                <a:spcPts val="400"/>
+                <a:spcPts val="300"/>
               </a:spcAft>
               <a:buNone/>
             </a:pPr>
             <a:r>
-              <a:rPr lang="en-US" sz="1050" dirty="0">
+              <a:rPr lang="en-US" sz="980" dirty="0">
                 <a:solidFill>
                   <a:srgbClr val="1A1F26"/>
                 </a:solidFill>
@@ -19336,20 +19336,20 @@
                 <a:ea typeface="Calibri" pitchFamily="34" charset="-122"/>
                 <a:cs typeface="Calibri" pitchFamily="34" charset="-120"/>
               </a:rPr>
-              <a:t>Longevity Life Academy, the fifth online school of 25-year education company eTeacher Group, was built for exactly that question. Its answer is not a bigger budget — it is a better teacher. The academy's 18-week live course turns healthy-aging science into one personalized protocol a student can keep for life, taught in small groups of 8–15 by named instructors, and grounded in each student's own body data.
+              <a:t>Longevity Life Academy, the fifth online school of 25-year education company eTeacher Group, was built for exactly that question. Its answer is not a bigger budget — it is a better teacher. The academy's 18-week live course turns healthy-aging science into one personalized protocol a student keeps for life, taught in small groups of 8–15 by named instructors and grounded in each student's own body data.
 </a:t>
             </a:r>
             <a:pPr indent="0" marL="0">
               <a:lnSpc>
-                <a:spcPct val="114000"/>
+                <a:spcPct val="110000"/>
               </a:lnSpc>
               <a:spcAft>
-                <a:spcPts val="400"/>
+                <a:spcPts val="300"/>
               </a:spcAft>
               <a:buNone/>
             </a:pPr>
             <a:r>
-              <a:rPr lang="en-US" sz="1050" dirty="0">
+              <a:rPr lang="en-US" sz="980" dirty="0">
                 <a:solidFill>
                   <a:srgbClr val="1A1F26"/>
                 </a:solidFill>
@@ -19359,7 +19359,7 @@
               </a:rPr>
               <a:t>The contrast the company points to is not a person — it is a philosophy. Johnson reportedly spends roughly $2 million a year. Longevity Life Academy starts at $289 a month and ships every US student an Abbott Lingo continuous glucose monitor before Lesson 5, so the science is personal from the start.</a:t>
             </a:r>
-            <a:endParaRPr lang="en-US" sz="1050" dirty="0"/>
+            <a:endParaRPr lang="en-US" sz="980" dirty="0"/>
           </a:p>
         </p:txBody>
       </p:sp>
@@ -19372,7 +19372,7 @@
         <p:spPr>
           <a:xfrm>
             <a:off x="6492240" y="2286000"/>
-            <a:ext cx="5486400" cy="2468880"/>
+            <a:ext cx="5486400" cy="2697480"/>
           </a:xfrm>
           <a:prstGeom prst="rect">
             <a:avLst/>
@@ -19386,15 +19386,15 @@
           <a:p>
             <a:pPr indent="0" marL="0">
               <a:lnSpc>
-                <a:spcPct val="114000"/>
+                <a:spcPct val="110000"/>
               </a:lnSpc>
               <a:spcAft>
-                <a:spcPts val="400"/>
+                <a:spcPts val="300"/>
               </a:spcAft>
               <a:buNone/>
             </a:pPr>
             <a:r>
-              <a:rPr lang="en-US" sz="1050" dirty="0">
+              <a:rPr lang="en-US" sz="980" dirty="0">
                 <a:solidFill>
                   <a:srgbClr val="1A1F26"/>
                 </a:solidFill>
@@ -19402,20 +19402,20 @@
                 <a:ea typeface="Calibri" pitchFamily="34" charset="-122"/>
                 <a:cs typeface="Calibri" pitchFamily="34" charset="-120"/>
               </a:rPr>
-              <a:t>eTeacher argues the evidence for its approach is already public. Julie Gibson Clark, a 56-year-old single mother from Phoenix, held the number-two spot in the Rejuvenation Olympics for more than a year — ahead of Johnson — on a routine costing roughly $12 a day. Consistency, taught well, beat spending.
+              <a:t>eTeacher argues the evidence is already public. Julie Gibson Clark, a 56-year-old single mother from Phoenix, held the number-two spot in the Rejuvenation Olympics for more than a year — ahead of Johnson — on a routine costing roughly $12 a day. Consistency, taught well, beat spending.
 </a:t>
             </a:r>
             <a:pPr indent="0" marL="0">
               <a:lnSpc>
-                <a:spcPct val="114000"/>
+                <a:spcPct val="110000"/>
               </a:lnSpc>
               <a:spcAft>
-                <a:spcPts val="400"/>
+                <a:spcPts val="300"/>
               </a:spcAft>
               <a:buNone/>
             </a:pPr>
             <a:r>
-              <a:rPr lang="en-US" sz="1050" dirty="0">
+              <a:rPr lang="en-US" sz="980" dirty="0">
                 <a:solidFill>
                   <a:srgbClr val="1A1F26"/>
                 </a:solidFill>
@@ -19428,15 +19428,15 @@
             </a:r>
             <a:pPr indent="0" marL="0">
               <a:lnSpc>
-                <a:spcPct val="114000"/>
+                <a:spcPct val="110000"/>
               </a:lnSpc>
               <a:spcAft>
-                <a:spcPts val="400"/>
+                <a:spcPts val="300"/>
               </a:spcAft>
               <a:buNone/>
             </a:pPr>
             <a:r>
-              <a:rPr lang="en-US" sz="1050" dirty="0">
+              <a:rPr lang="en-US" sz="980" dirty="0">
                 <a:solidFill>
                   <a:srgbClr val="1A1F26"/>
                 </a:solidFill>
@@ -19446,7 +19446,7 @@
               </a:rPr>
               <a:t>Longevity Life Academy is enrolling now from $289 per month, with additional courses planned for the year ahead.</a:t>
             </a:r>
-            <a:endParaRPr lang="en-US" sz="1050" dirty="0"/>
+            <a:endParaRPr lang="en-US" sz="980" dirty="0"/>
           </a:p>
         </p:txBody>
       </p:sp>
@@ -19458,12 +19458,12 @@
         </p:nvSpPr>
         <p:spPr>
           <a:xfrm>
-            <a:off x="640080" y="4892040"/>
-            <a:ext cx="10911535" cy="1399032"/>
+            <a:off x="640080" y="5138928"/>
+            <a:ext cx="10911535" cy="1152144"/>
           </a:xfrm>
           <a:prstGeom prst="roundRect">
             <a:avLst>
-              <a:gd name="adj" fmla="val 3268"/>
+              <a:gd name="adj" fmla="val 3968"/>
             </a:avLst>
           </a:prstGeom>
           <a:solidFill>
@@ -19485,7 +19485,7 @@
         </p:nvSpPr>
         <p:spPr>
           <a:xfrm>
-            <a:off x="658368" y="4910328"/>
+            <a:off x="658368" y="5157216"/>
             <a:ext cx="10874959" cy="310896"/>
           </a:xfrm>
           <a:prstGeom prst="rect">
@@ -19505,7 +19505,7 @@
         </p:nvSpPr>
         <p:spPr>
           <a:xfrm>
-            <a:off x="841248" y="4910328"/>
+            <a:off x="841248" y="5157216"/>
             <a:ext cx="10509199" cy="310896"/>
           </a:xfrm>
           <a:prstGeom prst="rect">
@@ -19544,8 +19544,8 @@
         </p:nvSpPr>
         <p:spPr>
           <a:xfrm>
-            <a:off x="859536" y="5294376"/>
-            <a:ext cx="10472623" cy="466344"/>
+            <a:off x="859536" y="5541264"/>
+            <a:ext cx="10472623" cy="219456"/>
           </a:xfrm>
           <a:prstGeom prst="rect">
             <a:avLst/>
@@ -19833,7 +19833,7 @@
                 <a:ea typeface="Cambria" pitchFamily="34" charset="-122"/>
                 <a:cs typeface="Cambria" pitchFamily="34" charset="-120"/>
               </a:rPr>
-              <a:t>Longevity Life Academy Teaches Students to Read Their Own Biomarkers Early — So They Catch What Silent Conditions Hide</a:t>
+              <a:t>Bryan Johnson's Diagnosis Hid for Years — Longevity Life Academy Teaches Students to Read Their Own Biomarkers Early</a:t>
             </a:r>
             <a:endParaRPr lang="en-US" sz="2600" dirty="0"/>
           </a:p>
@@ -19913,7 +19913,7 @@
         <p:spPr>
           <a:xfrm>
             <a:off x="640080" y="2286000"/>
-            <a:ext cx="5486400" cy="2468880"/>
+            <a:ext cx="5486400" cy="2697480"/>
           </a:xfrm>
           <a:prstGeom prst="rect">
             <a:avLst/>
@@ -19927,15 +19927,15 @@
           <a:p>
             <a:pPr indent="0" marL="0">
               <a:lnSpc>
-                <a:spcPct val="114000"/>
+                <a:spcPct val="110000"/>
               </a:lnSpc>
               <a:spcAft>
-                <a:spcPts val="400"/>
+                <a:spcPts val="300"/>
               </a:spcAft>
               <a:buNone/>
             </a:pPr>
             <a:r>
-              <a:rPr lang="en-US" sz="1050" dirty="0">
+              <a:rPr lang="en-US" sz="980" dirty="0">
                 <a:solidFill>
                   <a:srgbClr val="1A1F26"/>
                 </a:solidFill>
@@ -19948,15 +19948,15 @@
             </a:r>
             <a:pPr indent="0" marL="0">
               <a:lnSpc>
-                <a:spcPct val="114000"/>
+                <a:spcPct val="110000"/>
               </a:lnSpc>
               <a:spcAft>
-                <a:spcPts val="400"/>
+                <a:spcPts val="300"/>
               </a:spcAft>
               <a:buNone/>
             </a:pPr>
             <a:r>
-              <a:rPr lang="en-US" sz="1050" dirty="0">
+              <a:rPr lang="en-US" sz="980" dirty="0">
                 <a:solidFill>
                   <a:srgbClr val="1A1F26"/>
                 </a:solidFill>
@@ -19969,15 +19969,15 @@
             </a:r>
             <a:pPr indent="0" marL="0">
               <a:lnSpc>
-                <a:spcPct val="114000"/>
+                <a:spcPct val="110000"/>
               </a:lnSpc>
               <a:spcAft>
-                <a:spcPts val="400"/>
+                <a:spcPts val="300"/>
               </a:spcAft>
               <a:buNone/>
             </a:pPr>
             <a:r>
-              <a:rPr lang="en-US" sz="1050" dirty="0">
+              <a:rPr lang="en-US" sz="980" dirty="0">
                 <a:solidFill>
                   <a:srgbClr val="1A1F26"/>
                 </a:solidFill>
@@ -19987,7 +19987,7 @@
               </a:rPr>
               <a:t>Every US student receives an Abbott Lingo continuous glucose monitor before Lesson 5, and the 18-week live curriculum builds the habit of asking what one's own body is signaling. Instruction happens in small groups of 8–15, led by named faculty, so questions get real answers in real time.</a:t>
             </a:r>
-            <a:endParaRPr lang="en-US" sz="1050" dirty="0"/>
+            <a:endParaRPr lang="en-US" sz="980" dirty="0"/>
           </a:p>
         </p:txBody>
       </p:sp>
@@ -20000,7 +20000,7 @@
         <p:spPr>
           <a:xfrm>
             <a:off x="6492240" y="2286000"/>
-            <a:ext cx="5486400" cy="2468880"/>
+            <a:ext cx="5486400" cy="2697480"/>
           </a:xfrm>
           <a:prstGeom prst="rect">
             <a:avLst/>
@@ -20014,15 +20014,15 @@
           <a:p>
             <a:pPr indent="0" marL="0">
               <a:lnSpc>
-                <a:spcPct val="114000"/>
+                <a:spcPct val="110000"/>
               </a:lnSpc>
               <a:spcAft>
-                <a:spcPts val="400"/>
+                <a:spcPts val="300"/>
               </a:spcAft>
               <a:buNone/>
             </a:pPr>
             <a:r>
-              <a:rPr lang="en-US" sz="1050" dirty="0">
+              <a:rPr lang="en-US" sz="980" dirty="0">
                 <a:solidFill>
                   <a:srgbClr val="1A1F26"/>
                 </a:solidFill>
@@ -20035,15 +20035,15 @@
             </a:r>
             <a:pPr indent="0" marL="0">
               <a:lnSpc>
-                <a:spcPct val="114000"/>
+                <a:spcPct val="110000"/>
               </a:lnSpc>
               <a:spcAft>
-                <a:spcPts val="400"/>
+                <a:spcPts val="300"/>
               </a:spcAft>
               <a:buNone/>
             </a:pPr>
             <a:r>
-              <a:rPr lang="en-US" sz="1050" dirty="0">
+              <a:rPr lang="en-US" sz="980" dirty="0">
                 <a:solidFill>
                   <a:srgbClr val="1A1F26"/>
                 </a:solidFill>
@@ -20056,15 +20056,15 @@
             </a:r>
             <a:pPr indent="0" marL="0">
               <a:lnSpc>
-                <a:spcPct val="114000"/>
+                <a:spcPct val="110000"/>
               </a:lnSpc>
               <a:spcAft>
-                <a:spcPts val="400"/>
+                <a:spcPts val="300"/>
               </a:spcAft>
               <a:buNone/>
             </a:pPr>
             <a:r>
-              <a:rPr lang="en-US" sz="1050" dirty="0">
+              <a:rPr lang="en-US" sz="980" dirty="0">
                 <a:solidFill>
                   <a:srgbClr val="1A1F26"/>
                 </a:solidFill>
@@ -20074,7 +20074,7 @@
               </a:rPr>
               <a:t>Longevity Life Academy is enrolling now from $289 per month.</a:t>
             </a:r>
-            <a:endParaRPr lang="en-US" sz="1050" dirty="0"/>
+            <a:endParaRPr lang="en-US" sz="980" dirty="0"/>
           </a:p>
         </p:txBody>
       </p:sp>
@@ -20086,12 +20086,12 @@
         </p:nvSpPr>
         <p:spPr>
           <a:xfrm>
-            <a:off x="640080" y="4892040"/>
-            <a:ext cx="10911535" cy="1399032"/>
+            <a:off x="640080" y="5138928"/>
+            <a:ext cx="10911535" cy="1152144"/>
           </a:xfrm>
           <a:prstGeom prst="roundRect">
             <a:avLst>
-              <a:gd name="adj" fmla="val 3268"/>
+              <a:gd name="adj" fmla="val 3968"/>
             </a:avLst>
           </a:prstGeom>
           <a:solidFill>
@@ -20113,7 +20113,7 @@
         </p:nvSpPr>
         <p:spPr>
           <a:xfrm>
-            <a:off x="658368" y="4910328"/>
+            <a:off x="658368" y="5157216"/>
             <a:ext cx="10874959" cy="310896"/>
           </a:xfrm>
           <a:prstGeom prst="rect">
@@ -20133,7 +20133,7 @@
         </p:nvSpPr>
         <p:spPr>
           <a:xfrm>
-            <a:off x="841248" y="4910328"/>
+            <a:off x="841248" y="5157216"/>
             <a:ext cx="10509199" cy="310896"/>
           </a:xfrm>
           <a:prstGeom prst="rect">
@@ -20172,8 +20172,8 @@
         </p:nvSpPr>
         <p:spPr>
           <a:xfrm>
-            <a:off x="859536" y="5294376"/>
-            <a:ext cx="10472623" cy="466344"/>
+            <a:off x="859536" y="5541264"/>
+            <a:ext cx="10472623" cy="219456"/>
           </a:xfrm>
           <a:prstGeom prst="rect">
             <a:avLst/>
@@ -20461,7 +20461,7 @@
                 <a:ea typeface="Cambria" pitchFamily="34" charset="-122"/>
                 <a:cs typeface="Cambria" pitchFamily="34" charset="-120"/>
               </a:rPr>
-              <a:t>A $12-a-Day Routine Ranked Ahead of a $2-Million-a-Year One — Longevity Life Academy Teaches the Habits Behind It</a:t>
+              <a:t>Her $12-a-Day Routine Ranked Ahead of Bryan Johnson — Longevity Life Academy Teaches the Habits Behind It, From $289 a Month</a:t>
             </a:r>
             <a:endParaRPr lang="en-US" sz="2600" dirty="0"/>
           </a:p>
@@ -20541,7 +20541,7 @@
         <p:spPr>
           <a:xfrm>
             <a:off x="640080" y="2286000"/>
-            <a:ext cx="5486400" cy="2468880"/>
+            <a:ext cx="5486400" cy="2697480"/>
           </a:xfrm>
           <a:prstGeom prst="rect">
             <a:avLst/>
@@ -20555,15 +20555,15 @@
           <a:p>
             <a:pPr indent="0" marL="0">
               <a:lnSpc>
-                <a:spcPct val="114000"/>
+                <a:spcPct val="110000"/>
               </a:lnSpc>
               <a:spcAft>
-                <a:spcPts val="400"/>
+                <a:spcPts val="300"/>
               </a:spcAft>
               <a:buNone/>
             </a:pPr>
             <a:r>
-              <a:rPr lang="en-US" sz="1050" dirty="0">
+              <a:rPr lang="en-US" sz="980" dirty="0">
                 <a:solidFill>
                   <a:srgbClr val="1A1F26"/>
                 </a:solidFill>
@@ -20576,15 +20576,15 @@
             </a:r>
             <a:pPr indent="0" marL="0">
               <a:lnSpc>
-                <a:spcPct val="114000"/>
+                <a:spcPct val="110000"/>
               </a:lnSpc>
               <a:spcAft>
-                <a:spcPts val="400"/>
+                <a:spcPts val="300"/>
               </a:spcAft>
               <a:buNone/>
             </a:pPr>
             <a:r>
-              <a:rPr lang="en-US" sz="1050" dirty="0">
+              <a:rPr lang="en-US" sz="980" dirty="0">
                 <a:solidFill>
                   <a:srgbClr val="1A1F26"/>
                 </a:solidFill>
@@ -20597,15 +20597,15 @@
             </a:r>
             <a:pPr indent="0" marL="0">
               <a:lnSpc>
-                <a:spcPct val="114000"/>
+                <a:spcPct val="110000"/>
               </a:lnSpc>
               <a:spcAft>
-                <a:spcPts val="400"/>
+                <a:spcPts val="300"/>
               </a:spcAft>
               <a:buNone/>
             </a:pPr>
             <a:r>
-              <a:rPr lang="en-US" sz="1050" dirty="0">
+              <a:rPr lang="en-US" sz="980" dirty="0">
                 <a:solidFill>
                   <a:srgbClr val="1A1F26"/>
                 </a:solidFill>
@@ -20615,7 +20615,7 @@
               </a:rPr>
               <a:t>That is precisely what Longevity Life Academy teaches, and why the company brought Julie in as an instructor. The academy's 18-week live course, taught in groups of 8–15 with an Abbott Lingo glucose monitor shipped to every US student, turns the fundamentals she lives by into a protocol any motivated adult can learn and keep.</a:t>
             </a:r>
-            <a:endParaRPr lang="en-US" sz="1050" dirty="0"/>
+            <a:endParaRPr lang="en-US" sz="980" dirty="0"/>
           </a:p>
         </p:txBody>
       </p:sp>
@@ -20628,7 +20628,7 @@
         <p:spPr>
           <a:xfrm>
             <a:off x="6492240" y="2286000"/>
-            <a:ext cx="5486400" cy="2468880"/>
+            <a:ext cx="5486400" cy="2697480"/>
           </a:xfrm>
           <a:prstGeom prst="rect">
             <a:avLst/>
@@ -20642,15 +20642,15 @@
           <a:p>
             <a:pPr indent="0" marL="0">
               <a:lnSpc>
-                <a:spcPct val="114000"/>
+                <a:spcPct val="110000"/>
               </a:lnSpc>
               <a:spcAft>
-                <a:spcPts val="400"/>
+                <a:spcPts val="300"/>
               </a:spcAft>
               <a:buNone/>
             </a:pPr>
             <a:r>
-              <a:rPr lang="en-US" sz="1050" dirty="0">
+              <a:rPr lang="en-US" sz="980" dirty="0">
                 <a:solidFill>
                   <a:srgbClr val="1A1F26"/>
                 </a:solidFill>
@@ -20663,15 +20663,15 @@
             </a:r>
             <a:pPr indent="0" marL="0">
               <a:lnSpc>
-                <a:spcPct val="114000"/>
+                <a:spcPct val="110000"/>
               </a:lnSpc>
               <a:spcAft>
-                <a:spcPts val="400"/>
+                <a:spcPts val="300"/>
               </a:spcAft>
               <a:buNone/>
             </a:pPr>
             <a:r>
-              <a:rPr lang="en-US" sz="1050" dirty="0">
+              <a:rPr lang="en-US" sz="980" dirty="0">
                 <a:solidFill>
                   <a:srgbClr val="1A1F26"/>
                 </a:solidFill>
@@ -20684,15 +20684,15 @@
             </a:r>
             <a:pPr indent="0" marL="0">
               <a:lnSpc>
-                <a:spcPct val="114000"/>
+                <a:spcPct val="110000"/>
               </a:lnSpc>
               <a:spcAft>
-                <a:spcPts val="400"/>
+                <a:spcPts val="300"/>
               </a:spcAft>
               <a:buNone/>
             </a:pPr>
             <a:r>
-              <a:rPr lang="en-US" sz="1050" dirty="0">
+              <a:rPr lang="en-US" sz="980" dirty="0">
                 <a:solidFill>
                   <a:srgbClr val="1A1F26"/>
                 </a:solidFill>
@@ -20702,7 +20702,7 @@
               </a:rPr>
               <a:t>Longevity Life Academy is enrolling now from $289 per month.</a:t>
             </a:r>
-            <a:endParaRPr lang="en-US" sz="1050" dirty="0"/>
+            <a:endParaRPr lang="en-US" sz="980" dirty="0"/>
           </a:p>
         </p:txBody>
       </p:sp>
@@ -20714,12 +20714,12 @@
         </p:nvSpPr>
         <p:spPr>
           <a:xfrm>
-            <a:off x="640080" y="4892040"/>
-            <a:ext cx="10911535" cy="1399032"/>
+            <a:off x="640080" y="5138928"/>
+            <a:ext cx="10911535" cy="1152144"/>
           </a:xfrm>
           <a:prstGeom prst="roundRect">
             <a:avLst>
-              <a:gd name="adj" fmla="val 3268"/>
+              <a:gd name="adj" fmla="val 3968"/>
             </a:avLst>
           </a:prstGeom>
           <a:solidFill>
@@ -20741,7 +20741,7 @@
         </p:nvSpPr>
         <p:spPr>
           <a:xfrm>
-            <a:off x="658368" y="4910328"/>
+            <a:off x="658368" y="5157216"/>
             <a:ext cx="10874959" cy="310896"/>
           </a:xfrm>
           <a:prstGeom prst="rect">
@@ -20761,7 +20761,7 @@
         </p:nvSpPr>
         <p:spPr>
           <a:xfrm>
-            <a:off x="841248" y="4910328"/>
+            <a:off x="841248" y="5157216"/>
             <a:ext cx="10509199" cy="310896"/>
           </a:xfrm>
           <a:prstGeom prst="rect">
@@ -20800,8 +20800,8 @@
         </p:nvSpPr>
         <p:spPr>
           <a:xfrm>
-            <a:off x="859536" y="5294376"/>
-            <a:ext cx="10472623" cy="466344"/>
+            <a:off x="859536" y="5541264"/>
+            <a:ext cx="10472623" cy="219456"/>
           </a:xfrm>
           <a:prstGeom prst="rect">
             <a:avLst/>
@@ -21089,7 +21089,7 @@
                 <a:ea typeface="Cambria" pitchFamily="34" charset="-122"/>
                 <a:cs typeface="Cambria" pitchFamily="34" charset="-120"/>
               </a:rPr>
-              <a:t>Longevity Shouldn't Depend on Your Bank Balance — Longevity Life Academy Puts Science-Backed Healthy Aging Within Reach for $289 a Month</a:t>
+              <a:t>You Don't Need Bryan Johnson's Budget to Live Longer — Longevity Life Academy Puts Science-Backed Healthy Aging Within Reach for $289 a Month</a:t>
             </a:r>
             <a:endParaRPr lang="en-US" sz="2600" dirty="0"/>
           </a:p>
@@ -21169,7 +21169,7 @@
         <p:spPr>
           <a:xfrm>
             <a:off x="640080" y="2286000"/>
-            <a:ext cx="5486400" cy="2468880"/>
+            <a:ext cx="5486400" cy="2697480"/>
           </a:xfrm>
           <a:prstGeom prst="rect">
             <a:avLst/>
@@ -21183,15 +21183,15 @@
           <a:p>
             <a:pPr indent="0" marL="0">
               <a:lnSpc>
-                <a:spcPct val="114000"/>
+                <a:spcPct val="110000"/>
               </a:lnSpc>
               <a:spcAft>
-                <a:spcPts val="400"/>
+                <a:spcPts val="300"/>
               </a:spcAft>
               <a:buNone/>
             </a:pPr>
             <a:r>
-              <a:rPr lang="en-US" sz="1050" dirty="0">
+              <a:rPr lang="en-US" sz="980" dirty="0">
                 <a:solidFill>
                   <a:srgbClr val="1A1F26"/>
                 </a:solidFill>
@@ -21204,15 +21204,15 @@
             </a:r>
             <a:pPr indent="0" marL="0">
               <a:lnSpc>
-                <a:spcPct val="114000"/>
+                <a:spcPct val="110000"/>
               </a:lnSpc>
               <a:spcAft>
-                <a:spcPts val="400"/>
+                <a:spcPts val="300"/>
               </a:spcAft>
               <a:buNone/>
             </a:pPr>
             <a:r>
-              <a:rPr lang="en-US" sz="1050" dirty="0">
+              <a:rPr lang="en-US" sz="980" dirty="0">
                 <a:solidFill>
                   <a:srgbClr val="1A1F26"/>
                 </a:solidFill>
@@ -21225,15 +21225,15 @@
             </a:r>
             <a:pPr indent="0" marL="0">
               <a:lnSpc>
-                <a:spcPct val="114000"/>
+                <a:spcPct val="110000"/>
               </a:lnSpc>
               <a:spcAft>
-                <a:spcPts val="400"/>
+                <a:spcPts val="300"/>
               </a:spcAft>
               <a:buNone/>
             </a:pPr>
             <a:r>
-              <a:rPr lang="en-US" sz="1050" dirty="0">
+              <a:rPr lang="en-US" sz="980" dirty="0">
                 <a:solidFill>
                   <a:srgbClr val="1A1F26"/>
                 </a:solidFill>
@@ -21243,7 +21243,7 @@
               </a:rPr>
               <a:t>The academy's flagship 18-week course delivers all three: live sessions with named instructors, small cohorts of 8–15, and an Abbott Lingo continuous glucose monitor shipped to every US student before Lesson 5 — all starting at $289 a month. It is the same live-teaching method eTeacher has used to deliver 400,000+ courses across nearly 200 countries, now aimed at healthspan.</a:t>
             </a:r>
-            <a:endParaRPr lang="en-US" sz="1050" dirty="0"/>
+            <a:endParaRPr lang="en-US" sz="980" dirty="0"/>
           </a:p>
         </p:txBody>
       </p:sp>
@@ -21256,7 +21256,7 @@
         <p:spPr>
           <a:xfrm>
             <a:off x="6492240" y="2286000"/>
-            <a:ext cx="5486400" cy="2468880"/>
+            <a:ext cx="5486400" cy="2697480"/>
           </a:xfrm>
           <a:prstGeom prst="rect">
             <a:avLst/>
@@ -21270,15 +21270,15 @@
           <a:p>
             <a:pPr indent="0" marL="0">
               <a:lnSpc>
-                <a:spcPct val="114000"/>
+                <a:spcPct val="110000"/>
               </a:lnSpc>
               <a:spcAft>
-                <a:spcPts val="400"/>
+                <a:spcPts val="300"/>
               </a:spcAft>
               <a:buNone/>
             </a:pPr>
             <a:r>
-              <a:rPr lang="en-US" sz="1050" dirty="0">
+              <a:rPr lang="en-US" sz="980" dirty="0">
                 <a:solidFill>
                   <a:srgbClr val="1A1F26"/>
                 </a:solidFill>
@@ -21291,15 +21291,15 @@
             </a:r>
             <a:pPr indent="0" marL="0">
               <a:lnSpc>
-                <a:spcPct val="114000"/>
+                <a:spcPct val="110000"/>
               </a:lnSpc>
               <a:spcAft>
-                <a:spcPts val="400"/>
+                <a:spcPts val="300"/>
               </a:spcAft>
               <a:buNone/>
             </a:pPr>
             <a:r>
-              <a:rPr lang="en-US" sz="1050" dirty="0">
+              <a:rPr lang="en-US" sz="980" dirty="0">
                 <a:solidFill>
                   <a:srgbClr val="1A1F26"/>
                 </a:solidFill>
@@ -21312,15 +21312,15 @@
             </a:r>
             <a:pPr indent="0" marL="0">
               <a:lnSpc>
-                <a:spcPct val="114000"/>
+                <a:spcPct val="110000"/>
               </a:lnSpc>
               <a:spcAft>
-                <a:spcPts val="400"/>
+                <a:spcPts val="300"/>
               </a:spcAft>
               <a:buNone/>
             </a:pPr>
             <a:r>
-              <a:rPr lang="en-US" sz="1050" dirty="0">
+              <a:rPr lang="en-US" sz="980" dirty="0">
                 <a:solidFill>
                   <a:srgbClr val="1A1F26"/>
                 </a:solidFill>
@@ -21330,7 +21330,7 @@
               </a:rPr>
               <a:t>Longevity Life Academy is enrolling now from $289 per month.</a:t>
             </a:r>
-            <a:endParaRPr lang="en-US" sz="1050" dirty="0"/>
+            <a:endParaRPr lang="en-US" sz="980" dirty="0"/>
           </a:p>
         </p:txBody>
       </p:sp>
@@ -21342,12 +21342,12 @@
         </p:nvSpPr>
         <p:spPr>
           <a:xfrm>
-            <a:off x="640080" y="4892040"/>
-            <a:ext cx="10911535" cy="1399032"/>
+            <a:off x="640080" y="5138928"/>
+            <a:ext cx="10911535" cy="1152144"/>
           </a:xfrm>
           <a:prstGeom prst="roundRect">
             <a:avLst>
-              <a:gd name="adj" fmla="val 3268"/>
+              <a:gd name="adj" fmla="val 3968"/>
             </a:avLst>
           </a:prstGeom>
           <a:solidFill>
@@ -21369,7 +21369,7 @@
         </p:nvSpPr>
         <p:spPr>
           <a:xfrm>
-            <a:off x="658368" y="4910328"/>
+            <a:off x="658368" y="5157216"/>
             <a:ext cx="10874959" cy="310896"/>
           </a:xfrm>
           <a:prstGeom prst="rect">
@@ -21389,7 +21389,7 @@
         </p:nvSpPr>
         <p:spPr>
           <a:xfrm>
-            <a:off x="841248" y="4910328"/>
+            <a:off x="841248" y="5157216"/>
             <a:ext cx="10509199" cy="310896"/>
           </a:xfrm>
           <a:prstGeom prst="rect">
@@ -21428,8 +21428,8 @@
         </p:nvSpPr>
         <p:spPr>
           <a:xfrm>
-            <a:off x="859536" y="5294376"/>
-            <a:ext cx="10472623" cy="466344"/>
+            <a:off x="859536" y="5541264"/>
+            <a:ext cx="10472623" cy="219456"/>
           </a:xfrm>
           <a:prstGeom prst="rect">
             <a:avLst/>
@@ -21717,7 +21717,7 @@
                 <a:ea typeface="Cambria" pitchFamily="34" charset="-122"/>
                 <a:cs typeface="Cambria" pitchFamily="34" charset="-120"/>
               </a:rPr>
-              <a:t>Longevity Life Academy Bets on Live Teachers, Not Solo Experiments — Because Habits Stick When Someone Teaches You</a:t>
+              <a:t>Where Bryan Johnson Experiments Alone, Longevity Life Academy Bets on Live Teachers — Because Habits Stick When Someone Teaches You</a:t>
             </a:r>
             <a:endParaRPr lang="en-US" sz="2600" dirty="0"/>
           </a:p>
@@ -21797,7 +21797,7 @@
         <p:spPr>
           <a:xfrm>
             <a:off x="640080" y="2286000"/>
-            <a:ext cx="5486400" cy="2468880"/>
+            <a:ext cx="5486400" cy="2697480"/>
           </a:xfrm>
           <a:prstGeom prst="rect">
             <a:avLst/>
@@ -21811,15 +21811,15 @@
           <a:p>
             <a:pPr indent="0" marL="0">
               <a:lnSpc>
-                <a:spcPct val="114000"/>
+                <a:spcPct val="110000"/>
               </a:lnSpc>
               <a:spcAft>
-                <a:spcPts val="400"/>
+                <a:spcPts val="300"/>
               </a:spcAft>
               <a:buNone/>
             </a:pPr>
             <a:r>
-              <a:rPr lang="en-US" sz="1050" dirty="0">
+              <a:rPr lang="en-US" sz="980" dirty="0">
                 <a:solidFill>
                   <a:srgbClr val="1A1F26"/>
                 </a:solidFill>
@@ -21827,20 +21827,20 @@
                 <a:ea typeface="Calibri" pitchFamily="34" charset="-122"/>
                 <a:cs typeface="Calibri" pitchFamily="34" charset="-120"/>
               </a:rPr>
-              <a:t>RAMAT GAN, Israel — Bryan Johnson's Blueprint is the defining image of modern longevity: one person, a large team, and a vast budget, self-experimenting in public. His openness has taught the field a great deal, and his recent autoimmune-gastritis diagnosis is a reminder of how hard the work is even at that scale. But it also raises a practical question for everyone else: what model works when you don't have a lab and millions to spend?
+              <a:t>RAMAT GAN, Israel — Bryan Johnson's Blueprint is the defining image of modern longevity: one person, a large team, and a vast budget, self-experimenting in public. His openness has taught the field a great deal, and his recent autoimmune-gastritis diagnosis is a reminder of how hard the work is even at that scale. But it raises a practical question for everyone else: what works when you don't have a lab and millions to spend?
 </a:t>
             </a:r>
             <a:pPr indent="0" marL="0">
               <a:lnSpc>
-                <a:spcPct val="114000"/>
+                <a:spcPct val="110000"/>
               </a:lnSpc>
               <a:spcAft>
-                <a:spcPts val="400"/>
+                <a:spcPts val="300"/>
               </a:spcAft>
               <a:buNone/>
             </a:pPr>
             <a:r>
-              <a:rPr lang="en-US" sz="1050" dirty="0">
+              <a:rPr lang="en-US" sz="980" dirty="0">
                 <a:solidFill>
                   <a:srgbClr val="1A1F26"/>
                 </a:solidFill>
@@ -21848,20 +21848,20 @@
                 <a:ea typeface="Calibri" pitchFamily="34" charset="-122"/>
                 <a:cs typeface="Calibri" pitchFamily="34" charset="-120"/>
               </a:rPr>
-              <a:t>eTeacher Group's answer, delivered through its fifth online school, Longevity Life Academy, is decades old and deceptively simple: people learn best from teachers, live, in small groups. Where solo biohacking asks individuals to self-direct, LLA provides a weekly live anchor session, an expert instructor, a cohort of 8–15 peers, and short daily practice — the structure that turns intentions into habits.
+              <a:t>eTeacher Group's answer, delivered through its fifth online school, Longevity Life Academy, is decades old and simple: people learn best from teachers, live, in small groups. Where solo biohacking asks individuals to self-direct, LLA provides a weekly live anchor session, an expert instructor, a cohort of 8–15 peers, and short daily practice — the structure that turns intentions into habits.
 </a:t>
             </a:r>
             <a:pPr indent="0" marL="0">
               <a:lnSpc>
-                <a:spcPct val="114000"/>
+                <a:spcPct val="110000"/>
               </a:lnSpc>
               <a:spcAft>
-                <a:spcPts val="400"/>
+                <a:spcPts val="300"/>
               </a:spcAft>
               <a:buNone/>
             </a:pPr>
             <a:r>
-              <a:rPr lang="en-US" sz="1050" dirty="0">
+              <a:rPr lang="en-US" sz="980" dirty="0">
                 <a:solidFill>
                   <a:srgbClr val="1A1F26"/>
                 </a:solidFill>
@@ -21871,7 +21871,7 @@
               </a:rPr>
               <a:t>The academy applies the same method behind eTeacher's 400,000+ courses to healthspan. Each 18-week program pairs live instruction with personal data — an Abbott Lingo continuous glucose monitor ships to every US student before Lesson 5 — so lessons are grounded in the student's own body, guided by a real teacher rather than a lonely feed of tips.</a:t>
             </a:r>
-            <a:endParaRPr lang="en-US" sz="1050" dirty="0"/>
+            <a:endParaRPr lang="en-US" sz="980" dirty="0"/>
           </a:p>
         </p:txBody>
       </p:sp>
@@ -21884,7 +21884,7 @@
         <p:spPr>
           <a:xfrm>
             <a:off x="6492240" y="2286000"/>
-            <a:ext cx="5486400" cy="2468880"/>
+            <a:ext cx="5486400" cy="2697480"/>
           </a:xfrm>
           <a:prstGeom prst="rect">
             <a:avLst/>
@@ -21898,15 +21898,15 @@
           <a:p>
             <a:pPr indent="0" marL="0">
               <a:lnSpc>
-                <a:spcPct val="114000"/>
+                <a:spcPct val="110000"/>
               </a:lnSpc>
               <a:spcAft>
-                <a:spcPts val="400"/>
+                <a:spcPts val="300"/>
               </a:spcAft>
               <a:buNone/>
             </a:pPr>
             <a:r>
-              <a:rPr lang="en-US" sz="1050" dirty="0">
+              <a:rPr lang="en-US" sz="980" dirty="0">
                 <a:solidFill>
                   <a:srgbClr val="1A1F26"/>
                 </a:solidFill>
@@ -21919,15 +21919,15 @@
             </a:r>
             <a:pPr indent="0" marL="0">
               <a:lnSpc>
-                <a:spcPct val="114000"/>
+                <a:spcPct val="110000"/>
               </a:lnSpc>
               <a:spcAft>
-                <a:spcPts val="400"/>
+                <a:spcPts val="300"/>
               </a:spcAft>
               <a:buNone/>
             </a:pPr>
             <a:r>
-              <a:rPr lang="en-US" sz="1050" dirty="0">
+              <a:rPr lang="en-US" sz="980" dirty="0">
                 <a:solidFill>
                   <a:srgbClr val="1A1F26"/>
                 </a:solidFill>
@@ -21940,15 +21940,15 @@
             </a:r>
             <a:pPr indent="0" marL="0">
               <a:lnSpc>
-                <a:spcPct val="114000"/>
+                <a:spcPct val="110000"/>
               </a:lnSpc>
               <a:spcAft>
-                <a:spcPts val="400"/>
+                <a:spcPts val="300"/>
               </a:spcAft>
               <a:buNone/>
             </a:pPr>
             <a:r>
-              <a:rPr lang="en-US" sz="1050" dirty="0">
+              <a:rPr lang="en-US" sz="980" dirty="0">
                 <a:solidFill>
                   <a:srgbClr val="1A1F26"/>
                 </a:solidFill>
@@ -21958,7 +21958,7 @@
               </a:rPr>
               <a:t>Longevity Life Academy is enrolling now from $289 per month.</a:t>
             </a:r>
-            <a:endParaRPr lang="en-US" sz="1050" dirty="0"/>
+            <a:endParaRPr lang="en-US" sz="980" dirty="0"/>
           </a:p>
         </p:txBody>
       </p:sp>
@@ -21970,12 +21970,12 @@
         </p:nvSpPr>
         <p:spPr>
           <a:xfrm>
-            <a:off x="640080" y="4892040"/>
-            <a:ext cx="10911535" cy="1399032"/>
+            <a:off x="640080" y="5138928"/>
+            <a:ext cx="10911535" cy="1152144"/>
           </a:xfrm>
           <a:prstGeom prst="roundRect">
             <a:avLst>
-              <a:gd name="adj" fmla="val 3268"/>
+              <a:gd name="adj" fmla="val 3968"/>
             </a:avLst>
           </a:prstGeom>
           <a:solidFill>
@@ -21997,7 +21997,7 @@
         </p:nvSpPr>
         <p:spPr>
           <a:xfrm>
-            <a:off x="658368" y="4910328"/>
+            <a:off x="658368" y="5157216"/>
             <a:ext cx="10874959" cy="310896"/>
           </a:xfrm>
           <a:prstGeom prst="rect">
@@ -22017,7 +22017,7 @@
         </p:nvSpPr>
         <p:spPr>
           <a:xfrm>
-            <a:off x="841248" y="4910328"/>
+            <a:off x="841248" y="5157216"/>
             <a:ext cx="10509199" cy="310896"/>
           </a:xfrm>
           <a:prstGeom prst="rect">
@@ -22056,8 +22056,8 @@
         </p:nvSpPr>
         <p:spPr>
           <a:xfrm>
-            <a:off x="859536" y="5294376"/>
-            <a:ext cx="10472623" cy="466344"/>
+            <a:off x="859536" y="5541264"/>
+            <a:ext cx="10472623" cy="219456"/>
           </a:xfrm>
           <a:prstGeom prst="rect">
             <a:avLst/>

</xml_diff>

<commit_message>
Remove price from all headlines
</commit_message>
<xml_diff>
--- a/eTeacher_Longevity_PR_Campaign.pptx
+++ b/eTeacher_Longevity_PR_Campaign.pptx
@@ -5997,7 +5997,7 @@
                 <a:ea typeface="Cambria" pitchFamily="34" charset="-122"/>
                 <a:cs typeface="Cambria" pitchFamily="34" charset="-120"/>
               </a:rPr>
-              <a:t>Longevity Life Academy Targets the Middle of the $8 Trillion Longevity Market — From $289 a Month</a:t>
+              <a:t>Longevity Life Academy Targets the Underserved Middle of the $8 Trillion Longevity Market</a:t>
             </a:r>
             <a:endParaRPr lang="en-US" sz="2600" dirty="0"/>
           </a:p>
@@ -7881,7 +7881,7 @@
                 <a:ea typeface="Cambria" pitchFamily="34" charset="-122"/>
                 <a:cs typeface="Cambria" pitchFamily="34" charset="-120"/>
               </a:rPr>
-              <a:t>Longevity Life Academy Offers an 18-Week Live Longevity Class From $289 a Month, Glucose Monitor Included</a:t>
+              <a:t>Longevity Life Academy Offers an 18-Week Live Longevity Class With a Glucose Monitor Included</a:t>
             </a:r>
             <a:endParaRPr lang="en-US" sz="2600" dirty="0"/>
           </a:p>
@@ -20461,7 +20461,7 @@
                 <a:ea typeface="Cambria" pitchFamily="34" charset="-122"/>
                 <a:cs typeface="Cambria" pitchFamily="34" charset="-120"/>
               </a:rPr>
-              <a:t>Her $12-a-Day Routine Ranked Ahead of Bryan Johnson — Longevity Life Academy Teaches the Habits Behind It, From $289 a Month</a:t>
+              <a:t>Her $12-a-Day Routine Ranked Ahead of Bryan Johnson — Longevity Life Academy Teaches the Habits Behind It</a:t>
             </a:r>
             <a:endParaRPr lang="en-US" sz="2600" dirty="0"/>
           </a:p>
@@ -21089,7 +21089,7 @@
                 <a:ea typeface="Cambria" pitchFamily="34" charset="-122"/>
                 <a:cs typeface="Cambria" pitchFamily="34" charset="-120"/>
               </a:rPr>
-              <a:t>You Don't Need Bryan Johnson's Budget to Live Longer — Longevity Life Academy Puts Science-Backed Healthy Aging Within Reach for $289 a Month</a:t>
+              <a:t>You Don't Need Bryan Johnson's Budget to Live Longer — Longevity Life Academy Puts Science-Backed Healthy Aging Within Reach</a:t>
             </a:r>
             <a:endParaRPr lang="en-US" sz="2600" dirty="0"/>
           </a:p>

</xml_diff>

<commit_message>
Julie = founding faculty teaching masterclasses (not the Blueprint); simplify openings
</commit_message>
<xml_diff>
--- a/eTeacher_Longevity_PR_Campaign.pptx
+++ b/eTeacher_Longevity_PR_Campaign.pptx
@@ -5080,8 +5080,8 @@
         </p:nvSpPr>
         <p:spPr>
           <a:xfrm>
-            <a:off x="859536" y="5541264"/>
-            <a:ext cx="10472623" cy="219456"/>
+            <a:off x="859536" y="5559552"/>
+            <a:ext cx="10472623" cy="201168"/>
           </a:xfrm>
           <a:prstGeom prst="rect">
             <a:avLst/>
@@ -5095,7 +5095,7 @@
           <a:p>
             <a:pPr indent="0" marL="0">
               <a:lnSpc>
-                <a:spcPct val="108000"/>
+                <a:spcPct val="105000"/>
               </a:lnSpc>
               <a:buNone/>
             </a:pPr>
@@ -5708,8 +5708,8 @@
         </p:nvSpPr>
         <p:spPr>
           <a:xfrm>
-            <a:off x="859536" y="5541264"/>
-            <a:ext cx="10472623" cy="219456"/>
+            <a:off x="859536" y="5559552"/>
+            <a:ext cx="10472623" cy="201168"/>
           </a:xfrm>
           <a:prstGeom prst="rect">
             <a:avLst/>
@@ -5723,7 +5723,7 @@
           <a:p>
             <a:pPr indent="0" marL="0">
               <a:lnSpc>
-                <a:spcPct val="108000"/>
+                <a:spcPct val="105000"/>
               </a:lnSpc>
               <a:buNone/>
             </a:pPr>
@@ -6336,8 +6336,8 @@
         </p:nvSpPr>
         <p:spPr>
           <a:xfrm>
-            <a:off x="859536" y="5541264"/>
-            <a:ext cx="10472623" cy="219456"/>
+            <a:off x="859536" y="5559552"/>
+            <a:ext cx="10472623" cy="201168"/>
           </a:xfrm>
           <a:prstGeom prst="rect">
             <a:avLst/>
@@ -6351,7 +6351,7 @@
           <a:p>
             <a:pPr indent="0" marL="0">
               <a:lnSpc>
-                <a:spcPct val="108000"/>
+                <a:spcPct val="105000"/>
               </a:lnSpc>
               <a:buNone/>
             </a:pPr>
@@ -6964,8 +6964,8 @@
         </p:nvSpPr>
         <p:spPr>
           <a:xfrm>
-            <a:off x="859536" y="5541264"/>
-            <a:ext cx="10472623" cy="219456"/>
+            <a:off x="859536" y="5559552"/>
+            <a:ext cx="10472623" cy="201168"/>
           </a:xfrm>
           <a:prstGeom prst="rect">
             <a:avLst/>
@@ -6979,7 +6979,7 @@
           <a:p>
             <a:pPr indent="0" marL="0">
               <a:lnSpc>
-                <a:spcPct val="108000"/>
+                <a:spcPct val="105000"/>
               </a:lnSpc>
               <a:buNone/>
             </a:pPr>
@@ -7592,8 +7592,8 @@
         </p:nvSpPr>
         <p:spPr>
           <a:xfrm>
-            <a:off x="859536" y="5541264"/>
-            <a:ext cx="10472623" cy="219456"/>
+            <a:off x="859536" y="5559552"/>
+            <a:ext cx="10472623" cy="201168"/>
           </a:xfrm>
           <a:prstGeom prst="rect">
             <a:avLst/>
@@ -7607,7 +7607,7 @@
           <a:p>
             <a:pPr indent="0" marL="0">
               <a:lnSpc>
-                <a:spcPct val="108000"/>
+                <a:spcPct val="105000"/>
               </a:lnSpc>
               <a:buNone/>
             </a:pPr>
@@ -8220,8 +8220,8 @@
         </p:nvSpPr>
         <p:spPr>
           <a:xfrm>
-            <a:off x="859536" y="5541264"/>
-            <a:ext cx="10472623" cy="219456"/>
+            <a:off x="859536" y="5559552"/>
+            <a:ext cx="10472623" cy="201168"/>
           </a:xfrm>
           <a:prstGeom prst="rect">
             <a:avLst/>
@@ -8235,7 +8235,7 @@
           <a:p>
             <a:pPr indent="0" marL="0">
               <a:lnSpc>
-                <a:spcPct val="108000"/>
+                <a:spcPct val="105000"/>
               </a:lnSpc>
               <a:buNone/>
             </a:pPr>
@@ -8762,7 +8762,7 @@
                 <a:ea typeface="Cambria" pitchFamily="34" charset="-122"/>
                 <a:cs typeface="Cambria" pitchFamily="34" charset="-120"/>
               </a:rPr>
-              <a:t>Julie Gibson Clark — Who Out-Aged Bryan Johnson at the Rejuvenation Olympics — Joins eTeacher's Longevity Life Academy Faculty</a:t>
+              <a:t>Julie Gibson Clark — Who Out-Aged Bryan Johnson at the Rejuvenation Olympics — Joins Longevity Life Academy as Founding Faculty</a:t>
             </a:r>
             <a:endParaRPr lang="en-US" sz="2600" dirty="0"/>
           </a:p>
@@ -8804,7 +8804,7 @@
                 <a:ea typeface="Calibri" pitchFamily="34" charset="-122"/>
                 <a:cs typeface="Calibri" pitchFamily="34" charset="-120"/>
               </a:rPr>
-              <a:t>The Phoenix single mom who held second place on the Rejuvenation Olympics for over a year — ahead of Bryan Johnson — will teach live cohorts inside the 18-week Longevity Blueprint.</a:t>
+              <a:t>The Phoenix single mom who held second place on the Rejuvenation Olympics for over a year — ahead of Bryan Johnson — joins Longevity Life Academy as founding faculty to teach its live masterclasses.</a:t>
             </a:r>
             <a:endParaRPr lang="en-US" sz="1350" dirty="0"/>
           </a:p>
@@ -8872,7 +8872,7 @@
                 <a:ea typeface="Calibri" pitchFamily="34" charset="-122"/>
                 <a:cs typeface="Calibri" pitchFamily="34" charset="-120"/>
               </a:rPr>
-              <a:t>PHOENIX — eTeacher Group today announced that Julie Gibson Clark — who held the #2 spot on the Rejuvenation Olympics leaderboard for more than a year, ahead of the contest's own founder, Bryan Johnson — has joined the live faculty of Longevity Life Academy.
+              <a:t>PHOENIX — Longevity Life Academy has named Julie Gibson Clark to its founding faculty. She held the #2 spot on the Rejuvenation Olympics leaderboard for more than a year — ahead of the contest's own founder, Bryan Johnson.
 </a:t>
             </a:r>
             <a:pPr indent="0" marL="0">
@@ -8914,7 +8914,7 @@
                 <a:ea typeface="Calibri" pitchFamily="34" charset="-122"/>
                 <a:cs typeface="Calibri" pitchFamily="34" charset="-120"/>
               </a:rPr>
-              <a:t>At LLA she will teach live cohorts of 8–15 students inside The Longevity Blueprint, an 18-week program that guides students to build personalized protocols from their own Abbott Lingo glucose monitor and wearable data across six pillars.
+              <a:t>At LLA she will lead live masterclasses, teaching students the everyday habits behind her results — across nutrition, movement, sleep, and stress — alongside the school's core faculty.
 </a:t>
             </a:r>
             <a:pPr indent="0" marL="0">
@@ -9001,7 +9001,7 @@
                 <a:ea typeface="Calibri" pitchFamily="34" charset="-122"/>
                 <a:cs typeface="Calibri" pitchFamily="34" charset="-120"/>
               </a:rPr>
-              <a:t>“We measure ourselves by results, and Julie's results are impossible to argue with,” said eTeacher CEO Harel Tayeb. “She proved what we teach every day — that world-class health is built from consistent, learnable habits, not from a millionaire's budget. Having her teach it live is exactly the school we set out to build.” Gibson Clark begins teaching with the current enrollment cohort.</a:t>
+              <a:t>“We measure ourselves by results, and Julie's results are impossible to argue with,” said eTeacher CEO Harel Tayeb. “She proved what we teach every day — that world-class health is built from consistent, learnable habits, not from a millionaire's budget. Having her teach it live is exactly the school we set out to build.” Gibson Clark's masterclasses begin with the current enrollment cohort.</a:t>
             </a:r>
             <a:endParaRPr lang="en-US" sz="980" dirty="0"/>
           </a:p>
@@ -9101,27 +9101,27 @@
         </p:nvSpPr>
         <p:spPr>
           <a:xfrm>
-            <a:off x="859536" y="5541264"/>
-            <a:ext cx="4879696" cy="219456"/>
-          </a:xfrm>
-          <a:prstGeom prst="rect">
-            <a:avLst/>
-          </a:prstGeom>
-          <a:noFill/>
-          <a:ln/>
-        </p:spPr>
-        <p:txBody>
-          <a:bodyPr wrap="square" rtlCol="0" anchor="ctr"/>
-          <a:lstStyle/>
-          <a:p>
-            <a:pPr indent="0" marL="0">
-              <a:lnSpc>
-                <a:spcPct val="108000"/>
-              </a:lnSpc>
-              <a:buNone/>
-            </a:pPr>
-            <a:r>
-              <a:rPr lang="en-US" sz="1000" b="1" i="1" dirty="0">
+            <a:off x="859536" y="5559552"/>
+            <a:ext cx="4879696" cy="201168"/>
+          </a:xfrm>
+          <a:prstGeom prst="rect">
+            <a:avLst/>
+          </a:prstGeom>
+          <a:noFill/>
+          <a:ln/>
+        </p:spPr>
+        <p:txBody>
+          <a:bodyPr wrap="square" rtlCol="0" anchor="t"/>
+          <a:lstStyle/>
+          <a:p>
+            <a:pPr indent="0" marL="0">
+              <a:lnSpc>
+                <a:spcPct val="105000"/>
+              </a:lnSpc>
+              <a:buNone/>
+            </a:pPr>
+            <a:r>
+              <a:rPr lang="en-US" sz="900" b="1" i="1" dirty="0">
                 <a:solidFill>
                   <a:srgbClr val="FFF3DA"/>
                 </a:solidFill>
@@ -9131,7 +9131,7 @@
               </a:rPr>
               <a:t>“We measure ourselves by results, and Julie's results are impossible to argue with. She proved what we teach every day — that world-class health is built from consistent, learnable habits, not from a millionaire's budget. Having her teach it live is exactly the school we set out to build.”</a:t>
             </a:r>
-            <a:endParaRPr lang="en-US" sz="1000" dirty="0"/>
+            <a:endParaRPr lang="en-US" sz="900" dirty="0"/>
           </a:p>
         </p:txBody>
       </p:sp>
@@ -9257,7 +9257,7 @@
                 <a:ea typeface="Calibri" pitchFamily="34" charset="-122"/>
                 <a:cs typeface="Calibri" pitchFamily="34" charset="-120"/>
               </a:rPr>
-              <a:t>JULIE GIBSON CLARK, LLA Faculty</a:t>
+              <a:t>JULIE GIBSON CLARK, LLA Founding Faculty</a:t>
             </a:r>
             <a:endParaRPr lang="en-US" sz="800" dirty="0"/>
           </a:p>
@@ -9271,27 +9271,27 @@
         </p:nvSpPr>
         <p:spPr>
           <a:xfrm>
-            <a:off x="6452464" y="5413248"/>
-            <a:ext cx="4916272" cy="402336"/>
-          </a:xfrm>
-          <a:prstGeom prst="rect">
-            <a:avLst/>
-          </a:prstGeom>
-          <a:noFill/>
-          <a:ln/>
-        </p:spPr>
-        <p:txBody>
-          <a:bodyPr wrap="square" rtlCol="0" anchor="ctr"/>
-          <a:lstStyle/>
-          <a:p>
-            <a:pPr indent="0" marL="0">
-              <a:lnSpc>
-                <a:spcPct val="106000"/>
-              </a:lnSpc>
-              <a:buNone/>
-            </a:pPr>
-            <a:r>
-              <a:rPr lang="en-US" sz="900" i="1" dirty="0">
+            <a:off x="6452464" y="5431536"/>
+            <a:ext cx="4916272" cy="384048"/>
+          </a:xfrm>
+          <a:prstGeom prst="rect">
+            <a:avLst/>
+          </a:prstGeom>
+          <a:noFill/>
+          <a:ln/>
+        </p:spPr>
+        <p:txBody>
+          <a:bodyPr wrap="square" rtlCol="0" anchor="t"/>
+          <a:lstStyle/>
+          <a:p>
+            <a:pPr indent="0" marL="0">
+              <a:lnSpc>
+                <a:spcPct val="105000"/>
+              </a:lnSpc>
+              <a:buNone/>
+            </a:pPr>
+            <a:r>
+              <a:rPr lang="en-US" sz="850" i="1" dirty="0">
                 <a:solidFill>
                   <a:srgbClr val="1A1F26"/>
                 </a:solidFill>
@@ -9301,7 +9301,7 @@
               </a:rPr>
               <a:t>“I'm going to introduce one new habit and practice it until it becomes as routine as brushing my teeth. Getting to do that live, with real people who want to change their lives, is a dream.”</a:t>
             </a:r>
-            <a:endParaRPr lang="en-US" sz="900" dirty="0"/>
+            <a:endParaRPr lang="en-US" sz="850" dirty="0"/>
           </a:p>
         </p:txBody>
       </p:sp>
@@ -9560,7 +9560,7 @@
                 <a:ea typeface="Cambria" pitchFamily="34" charset="-122"/>
                 <a:cs typeface="Cambria" pitchFamily="34" charset="-120"/>
               </a:rPr>
-              <a:t>Longevity Life Academy Hires Julie Gibson Clark, Who Out-Aged a $2M-a-Year Biohacker on $12 a Day</a:t>
+              <a:t>Longevity Life Academy Names Julie Gibson Clark Founding Faculty — She Out-Aged a $2M-a-Year Biohacker on $12 a Day</a:t>
             </a:r>
             <a:endParaRPr lang="en-US" sz="2600" dirty="0"/>
           </a:p>
@@ -9602,7 +9602,7 @@
                 <a:ea typeface="Calibri" pitchFamily="34" charset="-122"/>
                 <a:cs typeface="Calibri" pitchFamily="34" charset="-120"/>
               </a:rPr>
-              <a:t>Julie Gibson Clark's budget longevity results ranked her #2 in the world; now she's teaching the method inside a course that starts at $289 a month.</a:t>
+              <a:t>Julie Gibson Clark's budget longevity results ranked her #2 in the world; now she teaches the method in Longevity Life Academy's live masterclasses.</a:t>
             </a:r>
             <a:endParaRPr lang="en-US" sz="1350" dirty="0"/>
           </a:p>
@@ -9670,7 +9670,7 @@
                 <a:ea typeface="Calibri" pitchFamily="34" charset="-122"/>
                 <a:cs typeface="Calibri" pitchFamily="34" charset="-120"/>
               </a:rPr>
-              <a:t>PHOENIX — Julie Gibson Clark became a global story for a simple, provocative reason: she achieved elite anti-aging results without an elite budget, ranking second worldwide on roughly $100–150 a month — about $12 a day — while Bryan Johnson reportedly spends around $2 million a year.
+              <a:t>PHOENIX — Julie Gibson Clark became a global story for a simple reason: she achieved elite anti-aging results without an elite budget, ranking second worldwide on roughly $12 a day, while Bryan Johnson reportedly spends around $2 million a year.
 </a:t>
             </a:r>
             <a:pPr indent="0" marL="0">
@@ -9712,7 +9712,7 @@
                 <a:ea typeface="Calibri" pitchFamily="34" charset="-122"/>
                 <a:cs typeface="Calibri" pitchFamily="34" charset="-120"/>
               </a:rPr>
-              <a:t>Now that philosophy has an institution behind it. As a Longevity Life Academy instructor, Gibson Clark brings her low-cost, high-consistency method into eTeacher's live cohorts of 8–15, where The Longevity Blueprint starts at $289 per month and includes an Abbott Lingo glucose monitor shipped to every US student.</a:t>
+              <a:t>Now that philosophy has an institution behind it. As founding faculty at Longevity Life Academy, Gibson Clark brings her low-cost, high-consistency method into live masterclasses, teaching students the fundamentals directly rather than leaving them to piece it together alone.</a:t>
             </a:r>
             <a:endParaRPr lang="en-US" sz="980" dirty="0"/>
           </a:p>
@@ -9899,27 +9899,27 @@
         </p:nvSpPr>
         <p:spPr>
           <a:xfrm>
-            <a:off x="859536" y="5541264"/>
-            <a:ext cx="4879696" cy="219456"/>
-          </a:xfrm>
-          <a:prstGeom prst="rect">
-            <a:avLst/>
-          </a:prstGeom>
-          <a:noFill/>
-          <a:ln/>
-        </p:spPr>
-        <p:txBody>
-          <a:bodyPr wrap="square" rtlCol="0" anchor="ctr"/>
-          <a:lstStyle/>
-          <a:p>
-            <a:pPr indent="0" marL="0">
-              <a:lnSpc>
-                <a:spcPct val="108000"/>
-              </a:lnSpc>
-              <a:buNone/>
-            </a:pPr>
-            <a:r>
-              <a:rPr lang="en-US" sz="1000" b="1" i="1" dirty="0">
+            <a:off x="859536" y="5559552"/>
+            <a:ext cx="4879696" cy="201168"/>
+          </a:xfrm>
+          <a:prstGeom prst="rect">
+            <a:avLst/>
+          </a:prstGeom>
+          <a:noFill/>
+          <a:ln/>
+        </p:spPr>
+        <p:txBody>
+          <a:bodyPr wrap="square" rtlCol="0" anchor="t"/>
+          <a:lstStyle/>
+          <a:p>
+            <a:pPr indent="0" marL="0">
+              <a:lnSpc>
+                <a:spcPct val="105000"/>
+              </a:lnSpc>
+              <a:buNone/>
+            </a:pPr>
+            <a:r>
+              <a:rPr lang="en-US" sz="900" b="1" i="1" dirty="0">
                 <a:solidFill>
                   <a:srgbClr val="FFF3DA"/>
                 </a:solidFill>
@@ -9929,7 +9929,7 @@
               </a:rPr>
               <a:t>“A twelve-dollar-a-day routine that outperforms a two-million-dollar one is the whole thesis of our school in a single fact. We don't sell shortcuts. We teach the fundamentals, in a room with a real instructor, until they become who you are.”</a:t>
             </a:r>
-            <a:endParaRPr lang="en-US" sz="1000" dirty="0"/>
+            <a:endParaRPr lang="en-US" sz="900" dirty="0"/>
           </a:p>
         </p:txBody>
       </p:sp>
@@ -10055,7 +10055,7 @@
                 <a:ea typeface="Calibri" pitchFamily="34" charset="-122"/>
                 <a:cs typeface="Calibri" pitchFamily="34" charset="-120"/>
               </a:rPr>
-              <a:t>JULIE GIBSON CLARK, LLA Faculty</a:t>
+              <a:t>JULIE GIBSON CLARK, LLA Founding Faculty</a:t>
             </a:r>
             <a:endParaRPr lang="en-US" sz="800" dirty="0"/>
           </a:p>
@@ -10069,27 +10069,27 @@
         </p:nvSpPr>
         <p:spPr>
           <a:xfrm>
-            <a:off x="6452464" y="5413248"/>
-            <a:ext cx="4916272" cy="402336"/>
-          </a:xfrm>
-          <a:prstGeom prst="rect">
-            <a:avLst/>
-          </a:prstGeom>
-          <a:noFill/>
-          <a:ln/>
-        </p:spPr>
-        <p:txBody>
-          <a:bodyPr wrap="square" rtlCol="0" anchor="ctr"/>
-          <a:lstStyle/>
-          <a:p>
-            <a:pPr indent="0" marL="0">
-              <a:lnSpc>
-                <a:spcPct val="106000"/>
-              </a:lnSpc>
-              <a:buNone/>
-            </a:pPr>
-            <a:r>
-              <a:rPr lang="en-US" sz="900" i="1" dirty="0">
+            <a:off x="6452464" y="5431536"/>
+            <a:ext cx="4916272" cy="384048"/>
+          </a:xfrm>
+          <a:prstGeom prst="rect">
+            <a:avLst/>
+          </a:prstGeom>
+          <a:noFill/>
+          <a:ln/>
+        </p:spPr>
+        <p:txBody>
+          <a:bodyPr wrap="square" rtlCol="0" anchor="t"/>
+          <a:lstStyle/>
+          <a:p>
+            <a:pPr indent="0" marL="0">
+              <a:lnSpc>
+                <a:spcPct val="105000"/>
+              </a:lnSpc>
+              <a:buNone/>
+            </a:pPr>
+            <a:r>
+              <a:rPr lang="en-US" sz="850" i="1" dirty="0">
                 <a:solidFill>
                   <a:srgbClr val="1A1F26"/>
                 </a:solidFill>
@@ -10099,7 +10099,7 @@
               </a:rPr>
               <a:t>“You have to think, ‘This is the rest of my life.’ It's not about a 10-week program for a beach body. The budget was never the barrier — the missing piece was someone teaching you what actually works.”</a:t>
             </a:r>
-            <a:endParaRPr lang="en-US" sz="900" dirty="0"/>
+            <a:endParaRPr lang="en-US" sz="850" dirty="0"/>
           </a:p>
         </p:txBody>
       </p:sp>
@@ -11883,33 +11883,9 @@
                 <a:ea typeface="Calibri" pitchFamily="34" charset="-122"/>
                 <a:cs typeface="Calibri" pitchFamily="34" charset="-120"/>
               </a:rPr>
-              <a:t>At Longevity Life Academy, that same philosophy anchors her live teaching: start with your why, then build one sustainable habit at a time until it sticks. She'll lead small cohorts of 8–15 through the 18-week Longevity Blueprint, each student working from their own glucose and wearable data.</a:t>
-            </a:r>
-            <a:endParaRPr lang="en-US" sz="980" dirty="0"/>
-          </a:p>
-        </p:txBody>
-      </p:sp>
-      <p:sp>
-        <p:nvSpPr>
-          <p:cNvPr id="8" name="Text 6"/>
-          <p:cNvSpPr/>
-          <p:nvPr/>
-        </p:nvSpPr>
-        <p:spPr>
-          <a:xfrm>
-            <a:off x="6492240" y="2286000"/>
-            <a:ext cx="5486400" cy="2697480"/>
-          </a:xfrm>
-          <a:prstGeom prst="rect">
-            <a:avLst/>
-          </a:prstGeom>
-          <a:noFill/>
-          <a:ln/>
-        </p:spPr>
-        <p:txBody>
-          <a:bodyPr wrap="square" rtlCol="0" anchor="t"/>
-          <a:lstStyle/>
-          <a:p>
+              <a:t>At Longevity Life Academy, that same philosophy anchors her live masterclasses: start with your why, then build one sustainable habit at a time until it sticks — teaching students the practices behind her own results.
+</a:t>
+            </a:r>
             <a:pPr indent="0" marL="0">
               <a:lnSpc>
                 <a:spcPct val="110000"/>
@@ -11928,9 +11904,33 @@
                 <a:ea typeface="Calibri" pitchFamily="34" charset="-122"/>
                 <a:cs typeface="Calibri" pitchFamily="34" charset="-120"/>
               </a:rPr>
-              <a:t>It's a message that fits eTeacher's belief that learning holds when it's personal and meaningful — the same conviction behind 400,000+ courses delivered across nearly 200 countries.
-</a:t>
-            </a:r>
+              <a:t>It's a message that fits eTeacher's belief that learning holds when it's personal and meaningful — the same conviction behind 400,000+ courses delivered across nearly 200 countries.</a:t>
+            </a:r>
+            <a:endParaRPr lang="en-US" sz="980" dirty="0"/>
+          </a:p>
+        </p:txBody>
+      </p:sp>
+      <p:sp>
+        <p:nvSpPr>
+          <p:cNvPr id="8" name="Text 6"/>
+          <p:cNvSpPr/>
+          <p:nvPr/>
+        </p:nvSpPr>
+        <p:spPr>
+          <a:xfrm>
+            <a:off x="6492240" y="2286000"/>
+            <a:ext cx="5486400" cy="2697480"/>
+          </a:xfrm>
+          <a:prstGeom prst="rect">
+            <a:avLst/>
+          </a:prstGeom>
+          <a:noFill/>
+          <a:ln/>
+        </p:spPr>
+        <p:txBody>
+          <a:bodyPr wrap="square" rtlCol="0" anchor="t"/>
+          <a:lstStyle/>
+          <a:p>
             <a:pPr indent="0" marL="0">
               <a:lnSpc>
                 <a:spcPct val="110000"/>
@@ -12070,27 +12070,27 @@
         </p:nvSpPr>
         <p:spPr>
           <a:xfrm>
-            <a:off x="859536" y="5541264"/>
-            <a:ext cx="4879696" cy="219456"/>
-          </a:xfrm>
-          <a:prstGeom prst="rect">
-            <a:avLst/>
-          </a:prstGeom>
-          <a:noFill/>
-          <a:ln/>
-        </p:spPr>
-        <p:txBody>
-          <a:bodyPr wrap="square" rtlCol="0" anchor="ctr"/>
-          <a:lstStyle/>
-          <a:p>
-            <a:pPr indent="0" marL="0">
-              <a:lnSpc>
-                <a:spcPct val="108000"/>
-              </a:lnSpc>
-              <a:buNone/>
-            </a:pPr>
-            <a:r>
-              <a:rPr lang="en-US" sz="1000" b="1" i="1" dirty="0">
+            <a:off x="859536" y="5559552"/>
+            <a:ext cx="4879696" cy="201168"/>
+          </a:xfrm>
+          <a:prstGeom prst="rect">
+            <a:avLst/>
+          </a:prstGeom>
+          <a:noFill/>
+          <a:ln/>
+        </p:spPr>
+        <p:txBody>
+          <a:bodyPr wrap="square" rtlCol="0" anchor="t"/>
+          <a:lstStyle/>
+          <a:p>
+            <a:pPr indent="0" marL="0">
+              <a:lnSpc>
+                <a:spcPct val="105000"/>
+              </a:lnSpc>
+              <a:buNone/>
+            </a:pPr>
+            <a:r>
+              <a:rPr lang="en-US" sz="900" b="1" i="1" dirty="0">
                 <a:solidFill>
                   <a:srgbClr val="FFF3DA"/>
                 </a:solidFill>
@@ -12100,7 +12100,7 @@
               </a:rPr>
               <a:t>“The best learning always starts with a personal reason, not a number on a chart. Julie begins with why someone wants more years — then teaches the how. That is precisely why she will reach people a leaderboard never could.”</a:t>
             </a:r>
-            <a:endParaRPr lang="en-US" sz="1000" dirty="0"/>
+            <a:endParaRPr lang="en-US" sz="900" dirty="0"/>
           </a:p>
         </p:txBody>
       </p:sp>
@@ -12226,7 +12226,7 @@
                 <a:ea typeface="Calibri" pitchFamily="34" charset="-122"/>
                 <a:cs typeface="Calibri" pitchFamily="34" charset="-120"/>
               </a:rPr>
-              <a:t>JULIE GIBSON CLARK, LLA Faculty</a:t>
+              <a:t>JULIE GIBSON CLARK, LLA Founding Faculty</a:t>
             </a:r>
             <a:endParaRPr lang="en-US" sz="800" dirty="0"/>
           </a:p>
@@ -12240,27 +12240,27 @@
         </p:nvSpPr>
         <p:spPr>
           <a:xfrm>
-            <a:off x="6452464" y="5413248"/>
-            <a:ext cx="4916272" cy="402336"/>
-          </a:xfrm>
-          <a:prstGeom prst="rect">
-            <a:avLst/>
-          </a:prstGeom>
-          <a:noFill/>
-          <a:ln/>
-        </p:spPr>
-        <p:txBody>
-          <a:bodyPr wrap="square" rtlCol="0" anchor="ctr"/>
-          <a:lstStyle/>
-          <a:p>
-            <a:pPr indent="0" marL="0">
-              <a:lnSpc>
-                <a:spcPct val="106000"/>
-              </a:lnSpc>
-              <a:buNone/>
-            </a:pPr>
-            <a:r>
-              <a:rPr lang="en-US" sz="900" i="1" dirty="0">
+            <a:off x="6452464" y="5431536"/>
+            <a:ext cx="4916272" cy="384048"/>
+          </a:xfrm>
+          <a:prstGeom prst="rect">
+            <a:avLst/>
+          </a:prstGeom>
+          <a:noFill/>
+          <a:ln/>
+        </p:spPr>
+        <p:txBody>
+          <a:bodyPr wrap="square" rtlCol="0" anchor="t"/>
+          <a:lstStyle/>
+          <a:p>
+            <a:pPr indent="0" marL="0">
+              <a:lnSpc>
+                <a:spcPct val="105000"/>
+              </a:lnSpc>
+              <a:buNone/>
+            </a:pPr>
+            <a:r>
+              <a:rPr lang="en-US" sz="850" i="1" dirty="0">
                 <a:solidFill>
                   <a:srgbClr val="1A1F26"/>
                 </a:solidFill>
@@ -12270,7 +12270,7 @@
               </a:rPr>
               <a:t>“I want to be here for my son — when he gets married and has kids, I want to be able to help in any way I can, and I just want to have that energy forever. Helping other parents find that same why is the most meaningful work I've done.”</a:t>
             </a:r>
-            <a:endParaRPr lang="en-US" sz="900" dirty="0"/>
+            <a:endParaRPr lang="en-US" sz="850" dirty="0"/>
           </a:p>
         </p:txBody>
       </p:sp>
@@ -12529,7 +12529,7 @@
                 <a:ea typeface="Cambria" pitchFamily="34" charset="-122"/>
                 <a:cs typeface="Cambria" pitchFamily="34" charset="-120"/>
               </a:rPr>
-              <a:t>Longevity Life Academy Instructor Julie Gibson Clark to Teach the Habits Behind Her 34%-Slower Aging</a:t>
+              <a:t>Longevity Life Academy Founding Faculty Member Julie Gibson Clark to Teach the Habits Behind Her 34%-Slower Aging</a:t>
             </a:r>
             <a:endParaRPr lang="en-US" sz="2600" dirty="0"/>
           </a:p>
@@ -12571,7 +12571,7 @@
                 <a:ea typeface="Calibri" pitchFamily="34" charset="-122"/>
                 <a:cs typeface="Calibri" pitchFamily="34" charset="-120"/>
               </a:rPr>
-              <a:t>Her biomarker data suggests she ages about 34% slower than average; at Longevity Life Academy she'll teach the strength, protein, and VO2-max fundamentals behind it.</a:t>
+              <a:t>Her biomarker data suggests she ages about 34% slower than average; in her Longevity Life Academy masterclasses she'll teach the strength, protein, and VO2-max fundamentals behind it.</a:t>
             </a:r>
             <a:endParaRPr lang="en-US" sz="1350" dirty="0"/>
           </a:p>
@@ -12639,7 +12639,7 @@
                 <a:ea typeface="Calibri" pitchFamily="34" charset="-122"/>
                 <a:cs typeface="Calibri" pitchFamily="34" charset="-120"/>
               </a:rPr>
-              <a:t>PHOENIX — The number that made Julie Gibson Clark famous is a DunedinPACE score of 0.665 — a measure of the pace of biological aging suggesting she ages roughly 65 days for every 100, or about 34% slower than average. She now brings the science behind that number to Longevity Life Academy.
+              <a:t>PHOENIX — The number that made Julie Gibson Clark famous is a DunedinPACE score of 0.665 — a measure of the pace of biological aging suggesting she ages roughly 65 days for every 100, or about 34% slower than average. She now brings the science behind that number to Longevity Life Academy as founding faculty.
 </a:t>
             </a:r>
             <a:pPr indent="0" marL="0">
@@ -12681,7 +12681,7 @@
                 <a:ea typeface="Calibri" pitchFamily="34" charset="-122"/>
                 <a:cs typeface="Calibri" pitchFamily="34" charset="-120"/>
               </a:rPr>
-              <a:t>That evidence-based, data-driven approach maps directly onto LLA's method, which puts an Abbott Lingo continuous glucose monitor in every student's hands before Lesson 5 and teaches them to read glucose, HRV, and sleep as a live feedback loop across the six pillars.</a:t>
+              <a:t>That evidence-based, data-driven approach maps directly onto LLA's method, which teaches students to read glucose, HRV, and sleep as a live feedback loop across the six pillars.</a:t>
             </a:r>
             <a:endParaRPr lang="en-US" sz="980" dirty="0"/>
           </a:p>
@@ -12726,7 +12726,7 @@
                 <a:ea typeface="Calibri" pitchFamily="34" charset="-122"/>
                 <a:cs typeface="Calibri" pitchFamily="34" charset="-120"/>
               </a:rPr>
-              <a:t>Her focus areas align with the curriculum's Exercise &amp; Movement, Nutrition, Sleep, and Stress Management pillars — alongside named instructors such as UC Santa Barbara senior lecturer and NASM-certified trainer Amy Jamieson — grounding the program in verifiable outcomes rather than trends.
+              <a:t>Her masterclass focus areas align with the Exercise &amp; Movement, Nutrition, Sleep, and Stress Management pillars — alongside named instructors such as UC Santa Barbara senior lecturer and NASM-certified trainer Amy Jamieson — grounding the teaching in verifiable outcomes rather than trends.
 </a:t>
             </a:r>
             <a:pPr indent="0" marL="0">
@@ -12854,7 +12854,7 @@
                 <a:ea typeface="Calibri" pitchFamily="34" charset="-122"/>
                 <a:cs typeface="Calibri" pitchFamily="34" charset="-120"/>
               </a:rPr>
-              <a:t>HIGHLIGHTED QUOTE  ·  JULIE GIBSON CLARK, LLA Faculty</a:t>
+              <a:t>HIGHLIGHTED QUOTE  ·  JULIE GIBSON CLARK, LLA Founding Faculty</a:t>
             </a:r>
             <a:endParaRPr lang="en-US" sz="800" dirty="0"/>
           </a:p>
@@ -12868,8 +12868,8 @@
         </p:nvSpPr>
         <p:spPr>
           <a:xfrm>
-            <a:off x="859536" y="5413248"/>
-            <a:ext cx="10509199" cy="402336"/>
+            <a:off x="859536" y="5431536"/>
+            <a:ext cx="10509199" cy="384048"/>
           </a:xfrm>
           <a:prstGeom prst="rect">
             <a:avLst/>
@@ -12883,7 +12883,7 @@
           <a:p>
             <a:pPr indent="0" marL="0">
               <a:lnSpc>
-                <a:spcPct val="106000"/>
+                <a:spcPct val="105000"/>
               </a:lnSpc>
               <a:buNone/>
             </a:pPr>
@@ -13309,7 +13309,7 @@
                 <a:ea typeface="Calibri" pitchFamily="34" charset="-122"/>
                 <a:cs typeface="Calibri" pitchFamily="34" charset="-120"/>
               </a:rPr>
-              <a:t>LLA operationalizes that counterexample. By combining a relatable, low-cost instructor with a proven live-education model — small cohorts of 8–15, an included Abbott Lingo glucose monitor, tuition from $289 a month — it aims to make personalized longevity available to mainstream American families.</a:t>
+              <a:t>LLA operationalizes that counterexample. By adding a relatable, low-cost founding-faculty voice to a proven live-education model — small cohorts of 8–15, an included Abbott Lingo glucose monitor, and named instructors — it aims to make personalized longevity available to mainstream American families.</a:t>
             </a:r>
             <a:endParaRPr lang="en-US" sz="980" dirty="0"/>
           </a:p>
@@ -13496,27 +13496,27 @@
         </p:nvSpPr>
         <p:spPr>
           <a:xfrm>
-            <a:off x="859536" y="5541264"/>
-            <a:ext cx="4879696" cy="219456"/>
-          </a:xfrm>
-          <a:prstGeom prst="rect">
-            <a:avLst/>
-          </a:prstGeom>
-          <a:noFill/>
-          <a:ln/>
-        </p:spPr>
-        <p:txBody>
-          <a:bodyPr wrap="square" rtlCol="0" anchor="ctr"/>
-          <a:lstStyle/>
-          <a:p>
-            <a:pPr indent="0" marL="0">
-              <a:lnSpc>
-                <a:spcPct val="108000"/>
-              </a:lnSpc>
-              <a:buNone/>
-            </a:pPr>
-            <a:r>
-              <a:rPr lang="en-US" sz="1000" b="1" i="1" dirty="0">
+            <a:off x="859536" y="5559552"/>
+            <a:ext cx="4879696" cy="201168"/>
+          </a:xfrm>
+          <a:prstGeom prst="rect">
+            <a:avLst/>
+          </a:prstGeom>
+          <a:noFill/>
+          <a:ln/>
+        </p:spPr>
+        <p:txBody>
+          <a:bodyPr wrap="square" rtlCol="0" anchor="t"/>
+          <a:lstStyle/>
+          <a:p>
+            <a:pPr indent="0" marL="0">
+              <a:lnSpc>
+                <a:spcPct val="105000"/>
+              </a:lnSpc>
+              <a:buNone/>
+            </a:pPr>
+            <a:r>
+              <a:rPr lang="en-US" sz="900" b="1" i="1" dirty="0">
                 <a:solidFill>
                   <a:srgbClr val="FFF3DA"/>
                 </a:solidFill>
@@ -13526,7 +13526,7 @@
               </a:rPr>
               <a:t>“We want to teach with meaning — content that reaches the human core of a person, not just their calendar. Julie gives that mission a face: real, humble, and living proof that a longer, healthier life is within reach for anyone willing to practice it.”</a:t>
             </a:r>
-            <a:endParaRPr lang="en-US" sz="1000" dirty="0"/>
+            <a:endParaRPr lang="en-US" sz="900" dirty="0"/>
           </a:p>
         </p:txBody>
       </p:sp>
@@ -13652,7 +13652,7 @@
                 <a:ea typeface="Calibri" pitchFamily="34" charset="-122"/>
                 <a:cs typeface="Calibri" pitchFamily="34" charset="-120"/>
               </a:rPr>
-              <a:t>JULIE GIBSON CLARK, LLA Faculty</a:t>
+              <a:t>JULIE GIBSON CLARK, LLA Founding Faculty</a:t>
             </a:r>
             <a:endParaRPr lang="en-US" sz="800" dirty="0"/>
           </a:p>
@@ -13666,27 +13666,27 @@
         </p:nvSpPr>
         <p:spPr>
           <a:xfrm>
-            <a:off x="6452464" y="5413248"/>
-            <a:ext cx="4916272" cy="402336"/>
-          </a:xfrm>
-          <a:prstGeom prst="rect">
-            <a:avLst/>
-          </a:prstGeom>
-          <a:noFill/>
-          <a:ln/>
-        </p:spPr>
-        <p:txBody>
-          <a:bodyPr wrap="square" rtlCol="0" anchor="ctr"/>
-          <a:lstStyle/>
-          <a:p>
-            <a:pPr indent="0" marL="0">
-              <a:lnSpc>
-                <a:spcPct val="106000"/>
-              </a:lnSpc>
-              <a:buNone/>
-            </a:pPr>
-            <a:r>
-              <a:rPr lang="en-US" sz="900" i="1" dirty="0">
+            <a:off x="6452464" y="5431536"/>
+            <a:ext cx="4916272" cy="384048"/>
+          </a:xfrm>
+          <a:prstGeom prst="rect">
+            <a:avLst/>
+          </a:prstGeom>
+          <a:noFill/>
+          <a:ln/>
+        </p:spPr>
+        <p:txBody>
+          <a:bodyPr wrap="square" rtlCol="0" anchor="t"/>
+          <a:lstStyle/>
+          <a:p>
+            <a:pPr indent="0" marL="0">
+              <a:lnSpc>
+                <a:spcPct val="105000"/>
+              </a:lnSpc>
+              <a:buNone/>
+            </a:pPr>
+            <a:r>
+              <a:rPr lang="en-US" sz="850" i="1" dirty="0">
                 <a:solidFill>
                   <a:srgbClr val="1A1F26"/>
                 </a:solidFill>
@@ -13696,7 +13696,7 @@
               </a:rPr>
               <a:t>“It really comes down to sleep, food, movement and connection. I don't want to add one more thing to people's lives — I want to simplify, and make this reachable for the household that never thought longevity was for them.”</a:t>
             </a:r>
-            <a:endParaRPr lang="en-US" sz="900" dirty="0"/>
+            <a:endParaRPr lang="en-US" sz="850" dirty="0"/>
           </a:p>
         </p:txBody>
       </p:sp>
@@ -13955,7 +13955,7 @@
                 <a:ea typeface="Cambria" pitchFamily="34" charset="-122"/>
                 <a:cs typeface="Cambria" pitchFamily="34" charset="-120"/>
               </a:rPr>
-              <a:t>Julie Gibson Clark Joins Longevity Life Academy to Teach Its 18-Week Live Longevity Blueprint</a:t>
+              <a:t>Julie Gibson Clark Joins Longevity Life Academy as Founding Faculty to Lead Its Live Masterclasses</a:t>
             </a:r>
             <a:endParaRPr lang="en-US" sz="2600" dirty="0"/>
           </a:p>
@@ -13997,7 +13997,7 @@
                 <a:ea typeface="Calibri" pitchFamily="34" charset="-122"/>
                 <a:cs typeface="Calibri" pitchFamily="34" charset="-120"/>
               </a:rPr>
-              <a:t>The recruiter who held the Rejuvenation Olympics #2 spot for over a year joins Longevity Life Academy to teach strength, protein, and sleep as the trainable foundations of a longer life.</a:t>
+              <a:t>The recruiter who held the Rejuvenation Olympics #2 spot for over a year joins Longevity Life Academy as founding faculty, teaching live masterclasses on strength, protein, and sleep as the trainable foundations of a longer life.</a:t>
             </a:r>
             <a:endParaRPr lang="en-US" sz="1350" dirty="0"/>
           </a:p>
@@ -14065,7 +14065,7 @@
                 <a:ea typeface="Calibri" pitchFamily="34" charset="-122"/>
                 <a:cs typeface="Calibri" pitchFamily="34" charset="-120"/>
               </a:rPr>
-              <a:t>PHOENIX — As Julie Gibson Clark joins Longevity Life Academy's live faculty, the practical question is what, exactly, she'll teach — and the answer mirrors the routine that made her a global story: build one sustainable habit at a time until it becomes automatic.
+              <a:t>PHOENIX — Julie Gibson Clark has joined Longevity Life Academy as founding faculty. The practical question is what she'll teach — and the answer mirrors the routine that made her a global story: build one sustainable habit at a time until it becomes automatic.
 </a:t>
             </a:r>
             <a:pPr indent="0" marL="0">
@@ -14086,7 +14086,7 @@
                 <a:ea typeface="Calibri" pitchFamily="34" charset="-122"/>
                 <a:cs typeface="Calibri" pitchFamily="34" charset="-120"/>
               </a:rPr>
-              <a:t>Her curriculum contribution slots directly into LLA's six pillars. Gibson Clark's expertise — strength training, 100–130g of protein daily, VO2-max and Zone 2 conditioning, sauna and cold, and disciplined 7–8-hour sleep — maps onto the Exercise &amp; Movement, Nutrition, Sleep, and Stress Management pillars of the 18-week program.
+              <a:t>Her masterclasses draw on LLA's six pillars. Gibson Clark's expertise — strength training, 100–130g of protein daily, VO2-max and Zone 2 conditioning, sauna and cold, and disciplined 7–8-hour sleep — spans the Exercise &amp; Movement, Nutrition, Sleep, and Stress Management pillars.
 </a:t>
             </a:r>
             <a:pPr indent="0" marL="0">
@@ -14107,7 +14107,7 @@
                 <a:ea typeface="Calibri" pitchFamily="34" charset="-122"/>
                 <a:cs typeface="Calibri" pitchFamily="34" charset="-120"/>
               </a:rPr>
-              <a:t>Within the four-phase Longevity Blueprint, she'll guide small cohorts of 8–15 as they move from Foundation through Data &amp; Discovery — the phase where each student's Abbott Lingo glucose monitor arrives before Lesson 5 — to a written protocol tested against their own biology.</a:t>
+              <a:t>In her live masterclasses she'll guide students through the same fundamentals she lives by, showing how everyday habits — not exotic interventions — produced her results.</a:t>
             </a:r>
             <a:endParaRPr lang="en-US" sz="980" dirty="0"/>
           </a:p>
@@ -14280,7 +14280,7 @@
                 <a:ea typeface="Calibri" pitchFamily="34" charset="-122"/>
                 <a:cs typeface="Calibri" pitchFamily="34" charset="-120"/>
               </a:rPr>
-              <a:t>HIGHLIGHTED QUOTE  ·  JULIE GIBSON CLARK, LLA Faculty</a:t>
+              <a:t>HIGHLIGHTED QUOTE  ·  JULIE GIBSON CLARK, LLA Founding Faculty</a:t>
             </a:r>
             <a:endParaRPr lang="en-US" sz="800" dirty="0"/>
           </a:p>
@@ -14294,8 +14294,8 @@
         </p:nvSpPr>
         <p:spPr>
           <a:xfrm>
-            <a:off x="859536" y="5413248"/>
-            <a:ext cx="10509199" cy="402336"/>
+            <a:off x="859536" y="5431536"/>
+            <a:ext cx="10509199" cy="384048"/>
           </a:xfrm>
           <a:prstGeom prst="rect">
             <a:avLst/>
@@ -14309,7 +14309,7 @@
           <a:p>
             <a:pPr indent="0" marL="0">
               <a:lnSpc>
-                <a:spcPct val="106000"/>
+                <a:spcPct val="105000"/>
               </a:lnSpc>
               <a:buNone/>
             </a:pPr>
@@ -14583,7 +14583,7 @@
                 <a:ea typeface="Cambria" pitchFamily="34" charset="-122"/>
                 <a:cs typeface="Cambria" pitchFamily="34" charset="-120"/>
               </a:rPr>
-              <a:t>Longevity Life Academy Instructor Julie Gibson Clark Demonstrates Her $12-a-Day Longevity Routine Live</a:t>
+              <a:t>Longevity Life Academy Founding Faculty Member Julie Gibson Clark Demonstrates Her $12-a-Day Longevity Routine Live</a:t>
             </a:r>
             <a:endParaRPr lang="en-US" sz="2600" dirty="0"/>
           </a:p>
@@ -14693,7 +14693,7 @@
                 <a:ea typeface="Calibri" pitchFamily="34" charset="-122"/>
                 <a:cs typeface="Calibri" pitchFamily="34" charset="-120"/>
               </a:rPr>
-              <a:t>PHOENIX — Julie Gibson Clark's story is tailor-made for broadcast: a 56-year-old Phoenix single mom and former structural engineer who ranked #2 on a global longevity leaderboard — ahead of Bryan Johnson — on roughly $100–150 a month, and who has now taken a live teaching role at eTeacher's Longevity Life Academy.
+              <a:t>PHOENIX — Julie Gibson Clark's story is tailor-made for broadcast: a 56-year-old Phoenix single mom and former structural engineer who ranked #2 on a global longevity leaderboard — ahead of Bryan Johnson — on roughly $100–150 a month, and who has now joined eTeacher's Longevity Life Academy as founding faculty, leading its live masterclasses.
 </a:t>
             </a:r>
             <a:pPr indent="0" marL="0">
@@ -14908,7 +14908,7 @@
                 <a:ea typeface="Calibri" pitchFamily="34" charset="-122"/>
                 <a:cs typeface="Calibri" pitchFamily="34" charset="-120"/>
               </a:rPr>
-              <a:t>HIGHLIGHTED QUOTE  ·  JULIE GIBSON CLARK, LLA Faculty</a:t>
+              <a:t>HIGHLIGHTED QUOTE  ·  JULIE GIBSON CLARK, LLA Founding Faculty</a:t>
             </a:r>
             <a:endParaRPr lang="en-US" sz="800" dirty="0"/>
           </a:p>
@@ -14922,8 +14922,8 @@
         </p:nvSpPr>
         <p:spPr>
           <a:xfrm>
-            <a:off x="859536" y="5413248"/>
-            <a:ext cx="10509199" cy="402336"/>
+            <a:off x="859536" y="5431536"/>
+            <a:ext cx="10509199" cy="384048"/>
           </a:xfrm>
           <a:prstGeom prst="rect">
             <a:avLst/>
@@ -14937,7 +14937,7 @@
           <a:p>
             <a:pPr indent="0" marL="0">
               <a:lnSpc>
-                <a:spcPct val="106000"/>
+                <a:spcPct val="105000"/>
               </a:lnSpc>
               <a:buNone/>
             </a:pPr>
@@ -15803,8 +15803,8 @@
         </p:nvSpPr>
         <p:spPr>
           <a:xfrm>
-            <a:off x="859536" y="5541264"/>
-            <a:ext cx="10472623" cy="219456"/>
+            <a:off x="859536" y="5559552"/>
+            <a:ext cx="10472623" cy="201168"/>
           </a:xfrm>
           <a:prstGeom prst="rect">
             <a:avLst/>
@@ -15818,7 +15818,7 @@
           <a:p>
             <a:pPr indent="0" marL="0">
               <a:lnSpc>
-                <a:spcPct val="108000"/>
+                <a:spcPct val="105000"/>
               </a:lnSpc>
               <a:buNone/>
             </a:pPr>
@@ -16431,8 +16431,8 @@
         </p:nvSpPr>
         <p:spPr>
           <a:xfrm>
-            <a:off x="859536" y="5541264"/>
-            <a:ext cx="10472623" cy="219456"/>
+            <a:off x="859536" y="5559552"/>
+            <a:ext cx="10472623" cy="201168"/>
           </a:xfrm>
           <a:prstGeom prst="rect">
             <a:avLst/>
@@ -16446,7 +16446,7 @@
           <a:p>
             <a:pPr indent="0" marL="0">
               <a:lnSpc>
-                <a:spcPct val="108000"/>
+                <a:spcPct val="105000"/>
               </a:lnSpc>
               <a:buNone/>
             </a:pPr>
@@ -17312,8 +17312,8 @@
         </p:nvSpPr>
         <p:spPr>
           <a:xfrm>
-            <a:off x="859536" y="5541264"/>
-            <a:ext cx="10472623" cy="219456"/>
+            <a:off x="859536" y="5559552"/>
+            <a:ext cx="10472623" cy="201168"/>
           </a:xfrm>
           <a:prstGeom prst="rect">
             <a:avLst/>
@@ -17327,7 +17327,7 @@
           <a:p>
             <a:pPr indent="0" marL="0">
               <a:lnSpc>
-                <a:spcPct val="108000"/>
+                <a:spcPct val="105000"/>
               </a:lnSpc>
               <a:buNone/>
             </a:pPr>
@@ -18663,8 +18663,8 @@
         </p:nvSpPr>
         <p:spPr>
           <a:xfrm>
-            <a:off x="859536" y="5541264"/>
-            <a:ext cx="10472623" cy="219456"/>
+            <a:off x="859536" y="5559552"/>
+            <a:ext cx="10472623" cy="201168"/>
           </a:xfrm>
           <a:prstGeom prst="rect">
             <a:avLst/>
@@ -18678,7 +18678,7 @@
           <a:p>
             <a:pPr indent="0" marL="0">
               <a:lnSpc>
-                <a:spcPct val="108000"/>
+                <a:spcPct val="105000"/>
               </a:lnSpc>
               <a:buNone/>
             </a:pPr>
@@ -19544,8 +19544,8 @@
         </p:nvSpPr>
         <p:spPr>
           <a:xfrm>
-            <a:off x="859536" y="5541264"/>
-            <a:ext cx="10472623" cy="219456"/>
+            <a:off x="859536" y="5559552"/>
+            <a:ext cx="10472623" cy="201168"/>
           </a:xfrm>
           <a:prstGeom prst="rect">
             <a:avLst/>
@@ -19559,7 +19559,7 @@
           <a:p>
             <a:pPr indent="0" marL="0">
               <a:lnSpc>
-                <a:spcPct val="108000"/>
+                <a:spcPct val="105000"/>
               </a:lnSpc>
               <a:buNone/>
             </a:pPr>
@@ -20172,8 +20172,8 @@
         </p:nvSpPr>
         <p:spPr>
           <a:xfrm>
-            <a:off x="859536" y="5541264"/>
-            <a:ext cx="10472623" cy="219456"/>
+            <a:off x="859536" y="5559552"/>
+            <a:ext cx="10472623" cy="201168"/>
           </a:xfrm>
           <a:prstGeom prst="rect">
             <a:avLst/>
@@ -20187,7 +20187,7 @@
           <a:p>
             <a:pPr indent="0" marL="0">
               <a:lnSpc>
-                <a:spcPct val="108000"/>
+                <a:spcPct val="105000"/>
               </a:lnSpc>
               <a:buNone/>
             </a:pPr>
@@ -20503,7 +20503,7 @@
                 <a:ea typeface="Calibri" pitchFamily="34" charset="-122"/>
                 <a:cs typeface="Calibri" pitchFamily="34" charset="-120"/>
               </a:rPr>
-              <a:t>Longevity Life Academy student-turned-instructor Julie Gibson Clark once ranked second in the Rejuvenation Olympics — ahead of Bryan Johnson — on a fraction of the budget. As Johnson faces a hard diagnosis, her story shows what consistency can do.</a:t>
+              <a:t>Longevity Life Academy founding faculty member Julie Gibson Clark once ranked second in the Rejuvenation Olympics — ahead of Bryan Johnson — on a fraction of the budget. As Johnson faces a hard diagnosis, her story shows what consistency can do.</a:t>
             </a:r>
             <a:endParaRPr lang="en-US" sz="1350" dirty="0"/>
           </a:p>
@@ -20613,7 +20613,7 @@
                 <a:ea typeface="Calibri" pitchFamily="34" charset="-122"/>
                 <a:cs typeface="Calibri" pitchFamily="34" charset="-120"/>
               </a:rPr>
-              <a:t>That is precisely what Longevity Life Academy teaches, and why the company brought Julie in as an instructor. The academy's 18-week live course, taught in groups of 8–15 with an Abbott Lingo glucose monitor shipped to every US student, turns the fundamentals she lives by into a protocol any motivated adult can learn and keep.</a:t>
+              <a:t>That is precisely what Longevity Life Academy teaches, and why the company brought Julie on as founding faculty for its live masterclasses. The academy's 18-week course, taught in groups of 8–15 with an Abbott Lingo glucose monitor shipped to every US student, turns the fundamentals she lives by into a protocol any motivated adult can learn and keep.</a:t>
             </a:r>
             <a:endParaRPr lang="en-US" sz="980" dirty="0"/>
           </a:p>
@@ -20800,8 +20800,8 @@
         </p:nvSpPr>
         <p:spPr>
           <a:xfrm>
-            <a:off x="859536" y="5541264"/>
-            <a:ext cx="10472623" cy="219456"/>
+            <a:off x="859536" y="5559552"/>
+            <a:ext cx="10472623" cy="201168"/>
           </a:xfrm>
           <a:prstGeom prst="rect">
             <a:avLst/>
@@ -20815,7 +20815,7 @@
           <a:p>
             <a:pPr indent="0" marL="0">
               <a:lnSpc>
-                <a:spcPct val="108000"/>
+                <a:spcPct val="105000"/>
               </a:lnSpc>
               <a:buNone/>
             </a:pPr>
@@ -21428,8 +21428,8 @@
         </p:nvSpPr>
         <p:spPr>
           <a:xfrm>
-            <a:off x="859536" y="5541264"/>
-            <a:ext cx="10472623" cy="219456"/>
+            <a:off x="859536" y="5559552"/>
+            <a:ext cx="10472623" cy="201168"/>
           </a:xfrm>
           <a:prstGeom prst="rect">
             <a:avLst/>
@@ -21443,7 +21443,7 @@
           <a:p>
             <a:pPr indent="0" marL="0">
               <a:lnSpc>
-                <a:spcPct val="108000"/>
+                <a:spcPct val="105000"/>
               </a:lnSpc>
               <a:buNone/>
             </a:pPr>
@@ -22056,8 +22056,8 @@
         </p:nvSpPr>
         <p:spPr>
           <a:xfrm>
-            <a:off x="859536" y="5541264"/>
-            <a:ext cx="10472623" cy="219456"/>
+            <a:off x="859536" y="5559552"/>
+            <a:ext cx="10472623" cy="201168"/>
           </a:xfrm>
           <a:prstGeom prst="rect">
             <a:avLst/>
@@ -22071,7 +22071,7 @@
           <a:p>
             <a:pPr indent="0" marL="0">
               <a:lnSpc>
-                <a:spcPct val="108000"/>
+                <a:spcPct val="105000"/>
               </a:lnSpc>
               <a:buNone/>
             </a:pPr>
@@ -22355,7 +22355,7 @@
                 <a:ea typeface="Calibri" pitchFamily="34" charset="-122"/>
                 <a:cs typeface="Calibri" pitchFamily="34" charset="-120"/>
               </a:rPr>
-              <a:t>2.  Confirm the Julie Gibson Clark quotes and finalize her instructor agreement and title. Note: her #2 ranking is stated in the past tense throughout — she held #2 for over a year before a 2024 rule change — so every claim stays accurate if a reporter checks the live leaderboard.
+              <a:t>2.  Confirm the Julie Gibson Clark quotes and finalize her founding-faculty agreement and title (she teaches the live masterclasses, not the Longevity Blueprint course). Note: her #2 ranking is stated in the past tense throughout — she held #2 for over a year before a 2024 rule change — so every claim stays accurate if a reporter checks the live leaderboard.
 </a:t>
             </a:r>
             <a:pPr indent="0" marL="0">

</xml_diff>